<commit_message>
incluir hora (datetimefromparts) nos movimentos de pneu
</commit_message>
<xml_diff>
--- a/tempimento.pptx
+++ b/tempimento.pptx
@@ -197,7 +197,7 @@
           <a:p>
             <a:fld id="{A584E3A2-E8EA-4705-A613-CFE9F6F5D3B4}" type="datetimeFigureOut">
               <a:rPr lang="pt-BR" smtClean="0"/>
-              <a:t>19/09/2022</a:t>
+              <a:t>26/09/2022</a:t>
             </a:fld>
             <a:endParaRPr lang="pt-BR"/>
           </a:p>
@@ -680,7 +680,7 @@
           <a:p>
             <a:fld id="{52231B9D-E9F6-4612-9B82-E89961B389AC}" type="datetimeFigureOut">
               <a:rPr lang="pt-BR" smtClean="0"/>
-              <a:t>19/09/2022</a:t>
+              <a:t>26/09/2022</a:t>
             </a:fld>
             <a:endParaRPr lang="pt-BR"/>
           </a:p>
@@ -850,7 +850,7 @@
           <a:p>
             <a:fld id="{52231B9D-E9F6-4612-9B82-E89961B389AC}" type="datetimeFigureOut">
               <a:rPr lang="pt-BR" smtClean="0"/>
-              <a:t>19/09/2022</a:t>
+              <a:t>26/09/2022</a:t>
             </a:fld>
             <a:endParaRPr lang="pt-BR"/>
           </a:p>
@@ -1030,7 +1030,7 @@
           <a:p>
             <a:fld id="{52231B9D-E9F6-4612-9B82-E89961B389AC}" type="datetimeFigureOut">
               <a:rPr lang="pt-BR" smtClean="0"/>
-              <a:t>19/09/2022</a:t>
+              <a:t>26/09/2022</a:t>
             </a:fld>
             <a:endParaRPr lang="pt-BR"/>
           </a:p>
@@ -1200,7 +1200,7 @@
           <a:p>
             <a:fld id="{52231B9D-E9F6-4612-9B82-E89961B389AC}" type="datetimeFigureOut">
               <a:rPr lang="pt-BR" smtClean="0"/>
-              <a:t>19/09/2022</a:t>
+              <a:t>26/09/2022</a:t>
             </a:fld>
             <a:endParaRPr lang="pt-BR"/>
           </a:p>
@@ -1446,7 +1446,7 @@
           <a:p>
             <a:fld id="{52231B9D-E9F6-4612-9B82-E89961B389AC}" type="datetimeFigureOut">
               <a:rPr lang="pt-BR" smtClean="0"/>
-              <a:t>19/09/2022</a:t>
+              <a:t>26/09/2022</a:t>
             </a:fld>
             <a:endParaRPr lang="pt-BR"/>
           </a:p>
@@ -1678,7 +1678,7 @@
           <a:p>
             <a:fld id="{52231B9D-E9F6-4612-9B82-E89961B389AC}" type="datetimeFigureOut">
               <a:rPr lang="pt-BR" smtClean="0"/>
-              <a:t>19/09/2022</a:t>
+              <a:t>26/09/2022</a:t>
             </a:fld>
             <a:endParaRPr lang="pt-BR"/>
           </a:p>
@@ -2045,7 +2045,7 @@
           <a:p>
             <a:fld id="{52231B9D-E9F6-4612-9B82-E89961B389AC}" type="datetimeFigureOut">
               <a:rPr lang="pt-BR" smtClean="0"/>
-              <a:t>19/09/2022</a:t>
+              <a:t>26/09/2022</a:t>
             </a:fld>
             <a:endParaRPr lang="pt-BR"/>
           </a:p>
@@ -2163,7 +2163,7 @@
           <a:p>
             <a:fld id="{52231B9D-E9F6-4612-9B82-E89961B389AC}" type="datetimeFigureOut">
               <a:rPr lang="pt-BR" smtClean="0"/>
-              <a:t>19/09/2022</a:t>
+              <a:t>26/09/2022</a:t>
             </a:fld>
             <a:endParaRPr lang="pt-BR"/>
           </a:p>
@@ -2258,7 +2258,7 @@
           <a:p>
             <a:fld id="{52231B9D-E9F6-4612-9B82-E89961B389AC}" type="datetimeFigureOut">
               <a:rPr lang="pt-BR" smtClean="0"/>
-              <a:t>19/09/2022</a:t>
+              <a:t>26/09/2022</a:t>
             </a:fld>
             <a:endParaRPr lang="pt-BR"/>
           </a:p>
@@ -2535,7 +2535,7 @@
           <a:p>
             <a:fld id="{52231B9D-E9F6-4612-9B82-E89961B389AC}" type="datetimeFigureOut">
               <a:rPr lang="pt-BR" smtClean="0"/>
-              <a:t>19/09/2022</a:t>
+              <a:t>26/09/2022</a:t>
             </a:fld>
             <a:endParaRPr lang="pt-BR"/>
           </a:p>
@@ -2788,7 +2788,7 @@
           <a:p>
             <a:fld id="{52231B9D-E9F6-4612-9B82-E89961B389AC}" type="datetimeFigureOut">
               <a:rPr lang="pt-BR" smtClean="0"/>
-              <a:t>19/09/2022</a:t>
+              <a:t>26/09/2022</a:t>
             </a:fld>
             <a:endParaRPr lang="pt-BR"/>
           </a:p>
@@ -3001,7 +3001,7 @@
           <a:p>
             <a:fld id="{52231B9D-E9F6-4612-9B82-E89961B389AC}" type="datetimeFigureOut">
               <a:rPr lang="pt-BR" smtClean="0"/>
-              <a:t>19/09/2022</a:t>
+              <a:t>26/09/2022</a:t>
             </a:fld>
             <a:endParaRPr lang="pt-BR"/>
           </a:p>
@@ -3665,7 +3665,17 @@
                   </a:schemeClr>
                 </a:solidFill>
               </a:rPr>
-              <a:t>18/09/2022</a:t>
+              <a:t>25</a:t>
+            </a:r>
+            <a:r>
+              <a:rPr lang="pt-BR" sz="1600" dirty="0" smtClean="0">
+                <a:solidFill>
+                  <a:schemeClr val="bg2">
+                    <a:lumMod val="90000"/>
+                  </a:schemeClr>
+                </a:solidFill>
+              </a:rPr>
+              <a:t>/09/2022</a:t>
             </a:r>
             <a:endParaRPr lang="pt-BR" sz="1600" dirty="0">
               <a:solidFill>

</xml_diff>

<commit_message>
manutenção padrão e ajustes consulta de compras
</commit_message>
<xml_diff>
--- a/tempimento.pptx
+++ b/tempimento.pptx
@@ -197,7 +197,7 @@
           <a:p>
             <a:fld id="{A584E3A2-E8EA-4705-A613-CFE9F6F5D3B4}" type="datetimeFigureOut">
               <a:rPr lang="pt-BR" smtClean="0"/>
-              <a:t>26/09/2022</a:t>
+              <a:t>04/10/2022</a:t>
             </a:fld>
             <a:endParaRPr lang="pt-BR"/>
           </a:p>
@@ -680,7 +680,7 @@
           <a:p>
             <a:fld id="{52231B9D-E9F6-4612-9B82-E89961B389AC}" type="datetimeFigureOut">
               <a:rPr lang="pt-BR" smtClean="0"/>
-              <a:t>26/09/2022</a:t>
+              <a:t>04/10/2022</a:t>
             </a:fld>
             <a:endParaRPr lang="pt-BR"/>
           </a:p>
@@ -850,7 +850,7 @@
           <a:p>
             <a:fld id="{52231B9D-E9F6-4612-9B82-E89961B389AC}" type="datetimeFigureOut">
               <a:rPr lang="pt-BR" smtClean="0"/>
-              <a:t>26/09/2022</a:t>
+              <a:t>04/10/2022</a:t>
             </a:fld>
             <a:endParaRPr lang="pt-BR"/>
           </a:p>
@@ -1030,7 +1030,7 @@
           <a:p>
             <a:fld id="{52231B9D-E9F6-4612-9B82-E89961B389AC}" type="datetimeFigureOut">
               <a:rPr lang="pt-BR" smtClean="0"/>
-              <a:t>26/09/2022</a:t>
+              <a:t>04/10/2022</a:t>
             </a:fld>
             <a:endParaRPr lang="pt-BR"/>
           </a:p>
@@ -1200,7 +1200,7 @@
           <a:p>
             <a:fld id="{52231B9D-E9F6-4612-9B82-E89961B389AC}" type="datetimeFigureOut">
               <a:rPr lang="pt-BR" smtClean="0"/>
-              <a:t>26/09/2022</a:t>
+              <a:t>04/10/2022</a:t>
             </a:fld>
             <a:endParaRPr lang="pt-BR"/>
           </a:p>
@@ -1446,7 +1446,7 @@
           <a:p>
             <a:fld id="{52231B9D-E9F6-4612-9B82-E89961B389AC}" type="datetimeFigureOut">
               <a:rPr lang="pt-BR" smtClean="0"/>
-              <a:t>26/09/2022</a:t>
+              <a:t>04/10/2022</a:t>
             </a:fld>
             <a:endParaRPr lang="pt-BR"/>
           </a:p>
@@ -1678,7 +1678,7 @@
           <a:p>
             <a:fld id="{52231B9D-E9F6-4612-9B82-E89961B389AC}" type="datetimeFigureOut">
               <a:rPr lang="pt-BR" smtClean="0"/>
-              <a:t>26/09/2022</a:t>
+              <a:t>04/10/2022</a:t>
             </a:fld>
             <a:endParaRPr lang="pt-BR"/>
           </a:p>
@@ -2045,7 +2045,7 @@
           <a:p>
             <a:fld id="{52231B9D-E9F6-4612-9B82-E89961B389AC}" type="datetimeFigureOut">
               <a:rPr lang="pt-BR" smtClean="0"/>
-              <a:t>26/09/2022</a:t>
+              <a:t>04/10/2022</a:t>
             </a:fld>
             <a:endParaRPr lang="pt-BR"/>
           </a:p>
@@ -2163,7 +2163,7 @@
           <a:p>
             <a:fld id="{52231B9D-E9F6-4612-9B82-E89961B389AC}" type="datetimeFigureOut">
               <a:rPr lang="pt-BR" smtClean="0"/>
-              <a:t>26/09/2022</a:t>
+              <a:t>04/10/2022</a:t>
             </a:fld>
             <a:endParaRPr lang="pt-BR"/>
           </a:p>
@@ -2258,7 +2258,7 @@
           <a:p>
             <a:fld id="{52231B9D-E9F6-4612-9B82-E89961B389AC}" type="datetimeFigureOut">
               <a:rPr lang="pt-BR" smtClean="0"/>
-              <a:t>26/09/2022</a:t>
+              <a:t>04/10/2022</a:t>
             </a:fld>
             <a:endParaRPr lang="pt-BR"/>
           </a:p>
@@ -2535,7 +2535,7 @@
           <a:p>
             <a:fld id="{52231B9D-E9F6-4612-9B82-E89961B389AC}" type="datetimeFigureOut">
               <a:rPr lang="pt-BR" smtClean="0"/>
-              <a:t>26/09/2022</a:t>
+              <a:t>04/10/2022</a:t>
             </a:fld>
             <a:endParaRPr lang="pt-BR"/>
           </a:p>
@@ -2788,7 +2788,7 @@
           <a:p>
             <a:fld id="{52231B9D-E9F6-4612-9B82-E89961B389AC}" type="datetimeFigureOut">
               <a:rPr lang="pt-BR" smtClean="0"/>
-              <a:t>26/09/2022</a:t>
+              <a:t>04/10/2022</a:t>
             </a:fld>
             <a:endParaRPr lang="pt-BR"/>
           </a:p>
@@ -3001,7 +3001,7 @@
           <a:p>
             <a:fld id="{52231B9D-E9F6-4612-9B82-E89961B389AC}" type="datetimeFigureOut">
               <a:rPr lang="pt-BR" smtClean="0"/>
-              <a:t>26/09/2022</a:t>
+              <a:t>04/10/2022</a:t>
             </a:fld>
             <a:endParaRPr lang="pt-BR"/>
           </a:p>
@@ -3665,7 +3665,7 @@
                   </a:schemeClr>
                 </a:solidFill>
               </a:rPr>
-              <a:t>25</a:t>
+              <a:t>02</a:t>
             </a:r>
             <a:r>
               <a:rPr lang="pt-BR" sz="1600" dirty="0" smtClean="0">
@@ -3675,7 +3675,7 @@
                   </a:schemeClr>
                 </a:solidFill>
               </a:rPr>
-              <a:t>/09/2022</a:t>
+              <a:t>/10/2022</a:t>
             </a:r>
             <a:endParaRPr lang="pt-BR" sz="1600" dirty="0">
               <a:solidFill>

</xml_diff>

<commit_message>
add diárias, sem vínculo mot
</commit_message>
<xml_diff>
--- a/tempimento.pptx
+++ b/tempimento.pptx
@@ -197,7 +197,7 @@
           <a:p>
             <a:fld id="{A584E3A2-E8EA-4705-A613-CFE9F6F5D3B4}" type="datetimeFigureOut">
               <a:rPr lang="pt-BR" smtClean="0"/>
-              <a:t>04/10/2022</a:t>
+              <a:t>10/10/2022</a:t>
             </a:fld>
             <a:endParaRPr lang="pt-BR"/>
           </a:p>
@@ -680,7 +680,7 @@
           <a:p>
             <a:fld id="{52231B9D-E9F6-4612-9B82-E89961B389AC}" type="datetimeFigureOut">
               <a:rPr lang="pt-BR" smtClean="0"/>
-              <a:t>04/10/2022</a:t>
+              <a:t>10/10/2022</a:t>
             </a:fld>
             <a:endParaRPr lang="pt-BR"/>
           </a:p>
@@ -850,7 +850,7 @@
           <a:p>
             <a:fld id="{52231B9D-E9F6-4612-9B82-E89961B389AC}" type="datetimeFigureOut">
               <a:rPr lang="pt-BR" smtClean="0"/>
-              <a:t>04/10/2022</a:t>
+              <a:t>10/10/2022</a:t>
             </a:fld>
             <a:endParaRPr lang="pt-BR"/>
           </a:p>
@@ -1030,7 +1030,7 @@
           <a:p>
             <a:fld id="{52231B9D-E9F6-4612-9B82-E89961B389AC}" type="datetimeFigureOut">
               <a:rPr lang="pt-BR" smtClean="0"/>
-              <a:t>04/10/2022</a:t>
+              <a:t>10/10/2022</a:t>
             </a:fld>
             <a:endParaRPr lang="pt-BR"/>
           </a:p>
@@ -1200,7 +1200,7 @@
           <a:p>
             <a:fld id="{52231B9D-E9F6-4612-9B82-E89961B389AC}" type="datetimeFigureOut">
               <a:rPr lang="pt-BR" smtClean="0"/>
-              <a:t>04/10/2022</a:t>
+              <a:t>10/10/2022</a:t>
             </a:fld>
             <a:endParaRPr lang="pt-BR"/>
           </a:p>
@@ -1446,7 +1446,7 @@
           <a:p>
             <a:fld id="{52231B9D-E9F6-4612-9B82-E89961B389AC}" type="datetimeFigureOut">
               <a:rPr lang="pt-BR" smtClean="0"/>
-              <a:t>04/10/2022</a:t>
+              <a:t>10/10/2022</a:t>
             </a:fld>
             <a:endParaRPr lang="pt-BR"/>
           </a:p>
@@ -1678,7 +1678,7 @@
           <a:p>
             <a:fld id="{52231B9D-E9F6-4612-9B82-E89961B389AC}" type="datetimeFigureOut">
               <a:rPr lang="pt-BR" smtClean="0"/>
-              <a:t>04/10/2022</a:t>
+              <a:t>10/10/2022</a:t>
             </a:fld>
             <a:endParaRPr lang="pt-BR"/>
           </a:p>
@@ -2045,7 +2045,7 @@
           <a:p>
             <a:fld id="{52231B9D-E9F6-4612-9B82-E89961B389AC}" type="datetimeFigureOut">
               <a:rPr lang="pt-BR" smtClean="0"/>
-              <a:t>04/10/2022</a:t>
+              <a:t>10/10/2022</a:t>
             </a:fld>
             <a:endParaRPr lang="pt-BR"/>
           </a:p>
@@ -2163,7 +2163,7 @@
           <a:p>
             <a:fld id="{52231B9D-E9F6-4612-9B82-E89961B389AC}" type="datetimeFigureOut">
               <a:rPr lang="pt-BR" smtClean="0"/>
-              <a:t>04/10/2022</a:t>
+              <a:t>10/10/2022</a:t>
             </a:fld>
             <a:endParaRPr lang="pt-BR"/>
           </a:p>
@@ -2258,7 +2258,7 @@
           <a:p>
             <a:fld id="{52231B9D-E9F6-4612-9B82-E89961B389AC}" type="datetimeFigureOut">
               <a:rPr lang="pt-BR" smtClean="0"/>
-              <a:t>04/10/2022</a:t>
+              <a:t>10/10/2022</a:t>
             </a:fld>
             <a:endParaRPr lang="pt-BR"/>
           </a:p>
@@ -2535,7 +2535,7 @@
           <a:p>
             <a:fld id="{52231B9D-E9F6-4612-9B82-E89961B389AC}" type="datetimeFigureOut">
               <a:rPr lang="pt-BR" smtClean="0"/>
-              <a:t>04/10/2022</a:t>
+              <a:t>10/10/2022</a:t>
             </a:fld>
             <a:endParaRPr lang="pt-BR"/>
           </a:p>
@@ -2788,7 +2788,7 @@
           <a:p>
             <a:fld id="{52231B9D-E9F6-4612-9B82-E89961B389AC}" type="datetimeFigureOut">
               <a:rPr lang="pt-BR" smtClean="0"/>
-              <a:t>04/10/2022</a:t>
+              <a:t>10/10/2022</a:t>
             </a:fld>
             <a:endParaRPr lang="pt-BR"/>
           </a:p>
@@ -3001,7 +3001,7 @@
           <a:p>
             <a:fld id="{52231B9D-E9F6-4612-9B82-E89961B389AC}" type="datetimeFigureOut">
               <a:rPr lang="pt-BR" smtClean="0"/>
-              <a:t>04/10/2022</a:t>
+              <a:t>10/10/2022</a:t>
             </a:fld>
             <a:endParaRPr lang="pt-BR"/>
           </a:p>
@@ -3665,17 +3665,7 @@
                   </a:schemeClr>
                 </a:solidFill>
               </a:rPr>
-              <a:t>02</a:t>
-            </a:r>
-            <a:r>
-              <a:rPr lang="pt-BR" sz="1600" dirty="0" smtClean="0">
-                <a:solidFill>
-                  <a:schemeClr val="bg2">
-                    <a:lumMod val="90000"/>
-                  </a:schemeClr>
-                </a:solidFill>
-              </a:rPr>
-              <a:t>/10/2022</a:t>
+              <a:t>09/10/2022</a:t>
             </a:r>
             <a:endParaRPr lang="pt-BR" sz="1600" dirty="0">
               <a:solidFill>

</xml_diff>

<commit_message>
VER PARA O MÊS
</commit_message>
<xml_diff>
--- a/tempimento.pptx
+++ b/tempimento.pptx
@@ -197,7 +197,7 @@
           <a:p>
             <a:fld id="{A584E3A2-E8EA-4705-A613-CFE9F6F5D3B4}" type="datetimeFigureOut">
               <a:rPr lang="pt-BR" smtClean="0"/>
-              <a:t>10/10/2022</a:t>
+              <a:t>18/10/2022</a:t>
             </a:fld>
             <a:endParaRPr lang="pt-BR"/>
           </a:p>
@@ -680,7 +680,7 @@
           <a:p>
             <a:fld id="{52231B9D-E9F6-4612-9B82-E89961B389AC}" type="datetimeFigureOut">
               <a:rPr lang="pt-BR" smtClean="0"/>
-              <a:t>10/10/2022</a:t>
+              <a:t>18/10/2022</a:t>
             </a:fld>
             <a:endParaRPr lang="pt-BR"/>
           </a:p>
@@ -850,7 +850,7 @@
           <a:p>
             <a:fld id="{52231B9D-E9F6-4612-9B82-E89961B389AC}" type="datetimeFigureOut">
               <a:rPr lang="pt-BR" smtClean="0"/>
-              <a:t>10/10/2022</a:t>
+              <a:t>18/10/2022</a:t>
             </a:fld>
             <a:endParaRPr lang="pt-BR"/>
           </a:p>
@@ -1030,7 +1030,7 @@
           <a:p>
             <a:fld id="{52231B9D-E9F6-4612-9B82-E89961B389AC}" type="datetimeFigureOut">
               <a:rPr lang="pt-BR" smtClean="0"/>
-              <a:t>10/10/2022</a:t>
+              <a:t>18/10/2022</a:t>
             </a:fld>
             <a:endParaRPr lang="pt-BR"/>
           </a:p>
@@ -1200,7 +1200,7 @@
           <a:p>
             <a:fld id="{52231B9D-E9F6-4612-9B82-E89961B389AC}" type="datetimeFigureOut">
               <a:rPr lang="pt-BR" smtClean="0"/>
-              <a:t>10/10/2022</a:t>
+              <a:t>18/10/2022</a:t>
             </a:fld>
             <a:endParaRPr lang="pt-BR"/>
           </a:p>
@@ -1446,7 +1446,7 @@
           <a:p>
             <a:fld id="{52231B9D-E9F6-4612-9B82-E89961B389AC}" type="datetimeFigureOut">
               <a:rPr lang="pt-BR" smtClean="0"/>
-              <a:t>10/10/2022</a:t>
+              <a:t>18/10/2022</a:t>
             </a:fld>
             <a:endParaRPr lang="pt-BR"/>
           </a:p>
@@ -1678,7 +1678,7 @@
           <a:p>
             <a:fld id="{52231B9D-E9F6-4612-9B82-E89961B389AC}" type="datetimeFigureOut">
               <a:rPr lang="pt-BR" smtClean="0"/>
-              <a:t>10/10/2022</a:t>
+              <a:t>18/10/2022</a:t>
             </a:fld>
             <a:endParaRPr lang="pt-BR"/>
           </a:p>
@@ -2045,7 +2045,7 @@
           <a:p>
             <a:fld id="{52231B9D-E9F6-4612-9B82-E89961B389AC}" type="datetimeFigureOut">
               <a:rPr lang="pt-BR" smtClean="0"/>
-              <a:t>10/10/2022</a:t>
+              <a:t>18/10/2022</a:t>
             </a:fld>
             <a:endParaRPr lang="pt-BR"/>
           </a:p>
@@ -2163,7 +2163,7 @@
           <a:p>
             <a:fld id="{52231B9D-E9F6-4612-9B82-E89961B389AC}" type="datetimeFigureOut">
               <a:rPr lang="pt-BR" smtClean="0"/>
-              <a:t>10/10/2022</a:t>
+              <a:t>18/10/2022</a:t>
             </a:fld>
             <a:endParaRPr lang="pt-BR"/>
           </a:p>
@@ -2258,7 +2258,7 @@
           <a:p>
             <a:fld id="{52231B9D-E9F6-4612-9B82-E89961B389AC}" type="datetimeFigureOut">
               <a:rPr lang="pt-BR" smtClean="0"/>
-              <a:t>10/10/2022</a:t>
+              <a:t>18/10/2022</a:t>
             </a:fld>
             <a:endParaRPr lang="pt-BR"/>
           </a:p>
@@ -2535,7 +2535,7 @@
           <a:p>
             <a:fld id="{52231B9D-E9F6-4612-9B82-E89961B389AC}" type="datetimeFigureOut">
               <a:rPr lang="pt-BR" smtClean="0"/>
-              <a:t>10/10/2022</a:t>
+              <a:t>18/10/2022</a:t>
             </a:fld>
             <a:endParaRPr lang="pt-BR"/>
           </a:p>
@@ -2788,7 +2788,7 @@
           <a:p>
             <a:fld id="{52231B9D-E9F6-4612-9B82-E89961B389AC}" type="datetimeFigureOut">
               <a:rPr lang="pt-BR" smtClean="0"/>
-              <a:t>10/10/2022</a:t>
+              <a:t>18/10/2022</a:t>
             </a:fld>
             <a:endParaRPr lang="pt-BR"/>
           </a:p>
@@ -3001,7 +3001,7 @@
           <a:p>
             <a:fld id="{52231B9D-E9F6-4612-9B82-E89961B389AC}" type="datetimeFigureOut">
               <a:rPr lang="pt-BR" smtClean="0"/>
-              <a:t>10/10/2022</a:t>
+              <a:t>18/10/2022</a:t>
             </a:fld>
             <a:endParaRPr lang="pt-BR"/>
           </a:p>
@@ -3665,7 +3665,17 @@
                   </a:schemeClr>
                 </a:solidFill>
               </a:rPr>
-              <a:t>09/10/2022</a:t>
+              <a:t>16</a:t>
+            </a:r>
+            <a:r>
+              <a:rPr lang="pt-BR" sz="1600" dirty="0" smtClean="0">
+                <a:solidFill>
+                  <a:schemeClr val="bg2">
+                    <a:lumMod val="90000"/>
+                  </a:schemeClr>
+                </a:solidFill>
+              </a:rPr>
+              <a:t>/10/2022</a:t>
             </a:r>
             <a:endParaRPr lang="pt-BR" sz="1600" dirty="0">
               <a:solidFill>

</xml_diff>

<commit_message>
não imprime com linha do tempo
</commit_message>
<xml_diff>
--- a/tempimento.pptx
+++ b/tempimento.pptx
@@ -11,7 +11,7 @@
     <p:sldId id="256" r:id="rId2"/>
   </p:sldIdLst>
   <p:sldSz cx="12192000" cy="6858000"/>
-  <p:notesSz cx="7104063" cy="10234613"/>
+  <p:notesSz cx="6888163" cy="9671050"/>
   <p:defaultTextStyle>
     <a:defPPr>
       <a:defRPr lang="pt-BR"/>
@@ -149,18 +149,18 @@
         </p:nvSpPr>
         <p:spPr>
           <a:xfrm>
-            <a:off x="1" y="1"/>
-            <a:ext cx="3078851" cy="512763"/>
+            <a:off x="2" y="1"/>
+            <a:ext cx="2985281" cy="484528"/>
           </a:xfrm>
           <a:prstGeom prst="rect">
             <a:avLst/>
           </a:prstGeom>
         </p:spPr>
         <p:txBody>
-          <a:bodyPr vert="horz" lIns="91440" tIns="45720" rIns="91440" bIns="45720" rtlCol="0"/>
+          <a:bodyPr vert="horz" lIns="87325" tIns="43663" rIns="87325" bIns="43663" rtlCol="0"/>
           <a:lstStyle>
             <a:lvl1pPr algn="l">
-              <a:defRPr sz="1200"/>
+              <a:defRPr sz="1100"/>
             </a:lvl1pPr>
           </a:lstStyle>
           <a:p>
@@ -180,24 +180,24 @@
         </p:nvSpPr>
         <p:spPr>
           <a:xfrm>
-            <a:off x="4023625" y="1"/>
-            <a:ext cx="3078851" cy="512763"/>
+            <a:off x="3901343" y="1"/>
+            <a:ext cx="2985281" cy="484528"/>
           </a:xfrm>
           <a:prstGeom prst="rect">
             <a:avLst/>
           </a:prstGeom>
         </p:spPr>
         <p:txBody>
-          <a:bodyPr vert="horz" lIns="91440" tIns="45720" rIns="91440" bIns="45720" rtlCol="0"/>
+          <a:bodyPr vert="horz" lIns="87325" tIns="43663" rIns="87325" bIns="43663" rtlCol="0"/>
           <a:lstStyle>
             <a:lvl1pPr algn="r">
-              <a:defRPr sz="1200"/>
+              <a:defRPr sz="1100"/>
             </a:lvl1pPr>
           </a:lstStyle>
           <a:p>
             <a:fld id="{A584E3A2-E8EA-4705-A613-CFE9F6F5D3B4}" type="datetimeFigureOut">
               <a:rPr lang="pt-BR" smtClean="0"/>
-              <a:t>18/10/2022</a:t>
+              <a:t>19/10/2022</a:t>
             </a:fld>
             <a:endParaRPr lang="pt-BR"/>
           </a:p>
@@ -215,8 +215,8 @@
         </p:nvSpPr>
         <p:spPr>
           <a:xfrm>
-            <a:off x="481013" y="1279525"/>
-            <a:ext cx="6142037" cy="3454400"/>
+            <a:off x="542925" y="1209675"/>
+            <a:ext cx="5802313" cy="3263900"/>
           </a:xfrm>
           <a:prstGeom prst="rect">
             <a:avLst/>
@@ -229,7 +229,7 @@
           </a:ln>
         </p:spPr>
         <p:txBody>
-          <a:bodyPr vert="horz" lIns="91440" tIns="45720" rIns="91440" bIns="45720" rtlCol="0" anchor="ctr"/>
+          <a:bodyPr vert="horz" lIns="87325" tIns="43663" rIns="87325" bIns="43663" rtlCol="0" anchor="ctr"/>
           <a:lstStyle/>
           <a:p>
             <a:endParaRPr lang="pt-BR"/>
@@ -248,15 +248,15 @@
         </p:nvSpPr>
         <p:spPr>
           <a:xfrm>
-            <a:off x="709772" y="4926014"/>
-            <a:ext cx="5684521" cy="4029075"/>
+            <a:off x="688202" y="4654767"/>
+            <a:ext cx="5511762" cy="3807216"/>
           </a:xfrm>
           <a:prstGeom prst="rect">
             <a:avLst/>
           </a:prstGeom>
         </p:spPr>
         <p:txBody>
-          <a:bodyPr vert="horz" lIns="91440" tIns="45720" rIns="91440" bIns="45720" rtlCol="0"/>
+          <a:bodyPr vert="horz" lIns="87325" tIns="43663" rIns="87325" bIns="43663" rtlCol="0"/>
           <a:lstStyle/>
           <a:p>
             <a:pPr lvl="0"/>
@@ -308,18 +308,18 @@
         </p:nvSpPr>
         <p:spPr>
           <a:xfrm>
-            <a:off x="1" y="9721851"/>
-            <a:ext cx="3078851" cy="512763"/>
+            <a:off x="2" y="9186523"/>
+            <a:ext cx="2985281" cy="484528"/>
           </a:xfrm>
           <a:prstGeom prst="rect">
             <a:avLst/>
           </a:prstGeom>
         </p:spPr>
         <p:txBody>
-          <a:bodyPr vert="horz" lIns="91440" tIns="45720" rIns="91440" bIns="45720" rtlCol="0" anchor="b"/>
+          <a:bodyPr vert="horz" lIns="87325" tIns="43663" rIns="87325" bIns="43663" rtlCol="0" anchor="b"/>
           <a:lstStyle>
             <a:lvl1pPr algn="l">
-              <a:defRPr sz="1200"/>
+              <a:defRPr sz="1100"/>
             </a:lvl1pPr>
           </a:lstStyle>
           <a:p>
@@ -339,18 +339,18 @@
         </p:nvSpPr>
         <p:spPr>
           <a:xfrm>
-            <a:off x="4023625" y="9721851"/>
-            <a:ext cx="3078851" cy="512763"/>
+            <a:off x="3901343" y="9186523"/>
+            <a:ext cx="2985281" cy="484528"/>
           </a:xfrm>
           <a:prstGeom prst="rect">
             <a:avLst/>
           </a:prstGeom>
         </p:spPr>
         <p:txBody>
-          <a:bodyPr vert="horz" lIns="91440" tIns="45720" rIns="91440" bIns="45720" rtlCol="0" anchor="b"/>
+          <a:bodyPr vert="horz" lIns="87325" tIns="43663" rIns="87325" bIns="43663" rtlCol="0" anchor="b"/>
           <a:lstStyle>
             <a:lvl1pPr algn="r">
-              <a:defRPr sz="1200"/>
+              <a:defRPr sz="1100"/>
             </a:lvl1pPr>
           </a:lstStyle>
           <a:p>
@@ -680,7 +680,7 @@
           <a:p>
             <a:fld id="{52231B9D-E9F6-4612-9B82-E89961B389AC}" type="datetimeFigureOut">
               <a:rPr lang="pt-BR" smtClean="0"/>
-              <a:t>18/10/2022</a:t>
+              <a:t>19/10/2022</a:t>
             </a:fld>
             <a:endParaRPr lang="pt-BR"/>
           </a:p>
@@ -850,7 +850,7 @@
           <a:p>
             <a:fld id="{52231B9D-E9F6-4612-9B82-E89961B389AC}" type="datetimeFigureOut">
               <a:rPr lang="pt-BR" smtClean="0"/>
-              <a:t>18/10/2022</a:t>
+              <a:t>19/10/2022</a:t>
             </a:fld>
             <a:endParaRPr lang="pt-BR"/>
           </a:p>
@@ -1030,7 +1030,7 @@
           <a:p>
             <a:fld id="{52231B9D-E9F6-4612-9B82-E89961B389AC}" type="datetimeFigureOut">
               <a:rPr lang="pt-BR" smtClean="0"/>
-              <a:t>18/10/2022</a:t>
+              <a:t>19/10/2022</a:t>
             </a:fld>
             <a:endParaRPr lang="pt-BR"/>
           </a:p>
@@ -1200,7 +1200,7 @@
           <a:p>
             <a:fld id="{52231B9D-E9F6-4612-9B82-E89961B389AC}" type="datetimeFigureOut">
               <a:rPr lang="pt-BR" smtClean="0"/>
-              <a:t>18/10/2022</a:t>
+              <a:t>19/10/2022</a:t>
             </a:fld>
             <a:endParaRPr lang="pt-BR"/>
           </a:p>
@@ -1446,7 +1446,7 @@
           <a:p>
             <a:fld id="{52231B9D-E9F6-4612-9B82-E89961B389AC}" type="datetimeFigureOut">
               <a:rPr lang="pt-BR" smtClean="0"/>
-              <a:t>18/10/2022</a:t>
+              <a:t>19/10/2022</a:t>
             </a:fld>
             <a:endParaRPr lang="pt-BR"/>
           </a:p>
@@ -1678,7 +1678,7 @@
           <a:p>
             <a:fld id="{52231B9D-E9F6-4612-9B82-E89961B389AC}" type="datetimeFigureOut">
               <a:rPr lang="pt-BR" smtClean="0"/>
-              <a:t>18/10/2022</a:t>
+              <a:t>19/10/2022</a:t>
             </a:fld>
             <a:endParaRPr lang="pt-BR"/>
           </a:p>
@@ -2045,7 +2045,7 @@
           <a:p>
             <a:fld id="{52231B9D-E9F6-4612-9B82-E89961B389AC}" type="datetimeFigureOut">
               <a:rPr lang="pt-BR" smtClean="0"/>
-              <a:t>18/10/2022</a:t>
+              <a:t>19/10/2022</a:t>
             </a:fld>
             <a:endParaRPr lang="pt-BR"/>
           </a:p>
@@ -2163,7 +2163,7 @@
           <a:p>
             <a:fld id="{52231B9D-E9F6-4612-9B82-E89961B389AC}" type="datetimeFigureOut">
               <a:rPr lang="pt-BR" smtClean="0"/>
-              <a:t>18/10/2022</a:t>
+              <a:t>19/10/2022</a:t>
             </a:fld>
             <a:endParaRPr lang="pt-BR"/>
           </a:p>
@@ -2258,7 +2258,7 @@
           <a:p>
             <a:fld id="{52231B9D-E9F6-4612-9B82-E89961B389AC}" type="datetimeFigureOut">
               <a:rPr lang="pt-BR" smtClean="0"/>
-              <a:t>18/10/2022</a:t>
+              <a:t>19/10/2022</a:t>
             </a:fld>
             <a:endParaRPr lang="pt-BR"/>
           </a:p>
@@ -2535,7 +2535,7 @@
           <a:p>
             <a:fld id="{52231B9D-E9F6-4612-9B82-E89961B389AC}" type="datetimeFigureOut">
               <a:rPr lang="pt-BR" smtClean="0"/>
-              <a:t>18/10/2022</a:t>
+              <a:t>19/10/2022</a:t>
             </a:fld>
             <a:endParaRPr lang="pt-BR"/>
           </a:p>
@@ -2788,7 +2788,7 @@
           <a:p>
             <a:fld id="{52231B9D-E9F6-4612-9B82-E89961B389AC}" type="datetimeFigureOut">
               <a:rPr lang="pt-BR" smtClean="0"/>
-              <a:t>18/10/2022</a:t>
+              <a:t>19/10/2022</a:t>
             </a:fld>
             <a:endParaRPr lang="pt-BR"/>
           </a:p>
@@ -3001,7 +3001,7 @@
           <a:p>
             <a:fld id="{52231B9D-E9F6-4612-9B82-E89961B389AC}" type="datetimeFigureOut">
               <a:rPr lang="pt-BR" smtClean="0"/>
-              <a:t>18/10/2022</a:t>
+              <a:t>19/10/2022</a:t>
             </a:fld>
             <a:endParaRPr lang="pt-BR"/>
           </a:p>

</xml_diff>

<commit_message>
compras com NF e pedido encerrado; consumo de insumos
</commit_message>
<xml_diff>
--- a/tempimento.pptx
+++ b/tempimento.pptx
@@ -11,7 +11,7 @@
     <p:sldId id="256" r:id="rId2"/>
   </p:sldIdLst>
   <p:sldSz cx="12192000" cy="6858000"/>
-  <p:notesSz cx="6888163" cy="9671050"/>
+  <p:notesSz cx="7104063" cy="10234613"/>
   <p:defaultTextStyle>
     <a:defPPr>
       <a:defRPr lang="pt-BR"/>
@@ -150,17 +150,17 @@
         <p:spPr>
           <a:xfrm>
             <a:off x="2" y="1"/>
-            <a:ext cx="2985281" cy="484528"/>
+            <a:ext cx="3078851" cy="512763"/>
           </a:xfrm>
           <a:prstGeom prst="rect">
             <a:avLst/>
           </a:prstGeom>
         </p:spPr>
         <p:txBody>
-          <a:bodyPr vert="horz" lIns="87325" tIns="43663" rIns="87325" bIns="43663" rtlCol="0"/>
+          <a:bodyPr vert="horz" lIns="91429" tIns="45715" rIns="91429" bIns="45715" rtlCol="0"/>
           <a:lstStyle>
             <a:lvl1pPr algn="l">
-              <a:defRPr sz="1100"/>
+              <a:defRPr sz="1200"/>
             </a:lvl1pPr>
           </a:lstStyle>
           <a:p>
@@ -180,24 +180,24 @@
         </p:nvSpPr>
         <p:spPr>
           <a:xfrm>
-            <a:off x="3901343" y="1"/>
-            <a:ext cx="2985281" cy="484528"/>
+            <a:off x="4023626" y="1"/>
+            <a:ext cx="3078851" cy="512763"/>
           </a:xfrm>
           <a:prstGeom prst="rect">
             <a:avLst/>
           </a:prstGeom>
         </p:spPr>
         <p:txBody>
-          <a:bodyPr vert="horz" lIns="87325" tIns="43663" rIns="87325" bIns="43663" rtlCol="0"/>
+          <a:bodyPr vert="horz" lIns="91429" tIns="45715" rIns="91429" bIns="45715" rtlCol="0"/>
           <a:lstStyle>
             <a:lvl1pPr algn="r">
-              <a:defRPr sz="1100"/>
+              <a:defRPr sz="1200"/>
             </a:lvl1pPr>
           </a:lstStyle>
           <a:p>
             <a:fld id="{A584E3A2-E8EA-4705-A613-CFE9F6F5D3B4}" type="datetimeFigureOut">
               <a:rPr lang="pt-BR" smtClean="0"/>
-              <a:t>19/10/2022</a:t>
+              <a:t>24/10/2022</a:t>
             </a:fld>
             <a:endParaRPr lang="pt-BR"/>
           </a:p>
@@ -215,8 +215,8 @@
         </p:nvSpPr>
         <p:spPr>
           <a:xfrm>
-            <a:off x="542925" y="1209675"/>
-            <a:ext cx="5802313" cy="3263900"/>
+            <a:off x="482600" y="1279525"/>
+            <a:ext cx="6138863" cy="3454400"/>
           </a:xfrm>
           <a:prstGeom prst="rect">
             <a:avLst/>
@@ -229,7 +229,7 @@
           </a:ln>
         </p:spPr>
         <p:txBody>
-          <a:bodyPr vert="horz" lIns="87325" tIns="43663" rIns="87325" bIns="43663" rtlCol="0" anchor="ctr"/>
+          <a:bodyPr vert="horz" lIns="91429" tIns="45715" rIns="91429" bIns="45715" rtlCol="0" anchor="ctr"/>
           <a:lstStyle/>
           <a:p>
             <a:endParaRPr lang="pt-BR"/>
@@ -248,15 +248,15 @@
         </p:nvSpPr>
         <p:spPr>
           <a:xfrm>
-            <a:off x="688202" y="4654767"/>
-            <a:ext cx="5511762" cy="3807216"/>
+            <a:off x="709773" y="4926015"/>
+            <a:ext cx="5684521" cy="4029075"/>
           </a:xfrm>
           <a:prstGeom prst="rect">
             <a:avLst/>
           </a:prstGeom>
         </p:spPr>
         <p:txBody>
-          <a:bodyPr vert="horz" lIns="87325" tIns="43663" rIns="87325" bIns="43663" rtlCol="0"/>
+          <a:bodyPr vert="horz" lIns="91429" tIns="45715" rIns="91429" bIns="45715" rtlCol="0"/>
           <a:lstStyle/>
           <a:p>
             <a:pPr lvl="0"/>
@@ -308,18 +308,18 @@
         </p:nvSpPr>
         <p:spPr>
           <a:xfrm>
-            <a:off x="2" y="9186523"/>
-            <a:ext cx="2985281" cy="484528"/>
+            <a:off x="2" y="9721851"/>
+            <a:ext cx="3078851" cy="512763"/>
           </a:xfrm>
           <a:prstGeom prst="rect">
             <a:avLst/>
           </a:prstGeom>
         </p:spPr>
         <p:txBody>
-          <a:bodyPr vert="horz" lIns="87325" tIns="43663" rIns="87325" bIns="43663" rtlCol="0" anchor="b"/>
+          <a:bodyPr vert="horz" lIns="91429" tIns="45715" rIns="91429" bIns="45715" rtlCol="0" anchor="b"/>
           <a:lstStyle>
             <a:lvl1pPr algn="l">
-              <a:defRPr sz="1100"/>
+              <a:defRPr sz="1200"/>
             </a:lvl1pPr>
           </a:lstStyle>
           <a:p>
@@ -339,18 +339,18 @@
         </p:nvSpPr>
         <p:spPr>
           <a:xfrm>
-            <a:off x="3901343" y="9186523"/>
-            <a:ext cx="2985281" cy="484528"/>
+            <a:off x="4023626" y="9721851"/>
+            <a:ext cx="3078851" cy="512763"/>
           </a:xfrm>
           <a:prstGeom prst="rect">
             <a:avLst/>
           </a:prstGeom>
         </p:spPr>
         <p:txBody>
-          <a:bodyPr vert="horz" lIns="87325" tIns="43663" rIns="87325" bIns="43663" rtlCol="0" anchor="b"/>
+          <a:bodyPr vert="horz" lIns="91429" tIns="45715" rIns="91429" bIns="45715" rtlCol="0" anchor="b"/>
           <a:lstStyle>
             <a:lvl1pPr algn="r">
-              <a:defRPr sz="1100"/>
+              <a:defRPr sz="1200"/>
             </a:lvl1pPr>
           </a:lstStyle>
           <a:p>
@@ -680,7 +680,7 @@
           <a:p>
             <a:fld id="{52231B9D-E9F6-4612-9B82-E89961B389AC}" type="datetimeFigureOut">
               <a:rPr lang="pt-BR" smtClean="0"/>
-              <a:t>19/10/2022</a:t>
+              <a:t>24/10/2022</a:t>
             </a:fld>
             <a:endParaRPr lang="pt-BR"/>
           </a:p>
@@ -850,7 +850,7 @@
           <a:p>
             <a:fld id="{52231B9D-E9F6-4612-9B82-E89961B389AC}" type="datetimeFigureOut">
               <a:rPr lang="pt-BR" smtClean="0"/>
-              <a:t>19/10/2022</a:t>
+              <a:t>24/10/2022</a:t>
             </a:fld>
             <a:endParaRPr lang="pt-BR"/>
           </a:p>
@@ -1030,7 +1030,7 @@
           <a:p>
             <a:fld id="{52231B9D-E9F6-4612-9B82-E89961B389AC}" type="datetimeFigureOut">
               <a:rPr lang="pt-BR" smtClean="0"/>
-              <a:t>19/10/2022</a:t>
+              <a:t>24/10/2022</a:t>
             </a:fld>
             <a:endParaRPr lang="pt-BR"/>
           </a:p>
@@ -1200,7 +1200,7 @@
           <a:p>
             <a:fld id="{52231B9D-E9F6-4612-9B82-E89961B389AC}" type="datetimeFigureOut">
               <a:rPr lang="pt-BR" smtClean="0"/>
-              <a:t>19/10/2022</a:t>
+              <a:t>24/10/2022</a:t>
             </a:fld>
             <a:endParaRPr lang="pt-BR"/>
           </a:p>
@@ -1446,7 +1446,7 @@
           <a:p>
             <a:fld id="{52231B9D-E9F6-4612-9B82-E89961B389AC}" type="datetimeFigureOut">
               <a:rPr lang="pt-BR" smtClean="0"/>
-              <a:t>19/10/2022</a:t>
+              <a:t>24/10/2022</a:t>
             </a:fld>
             <a:endParaRPr lang="pt-BR"/>
           </a:p>
@@ -1678,7 +1678,7 @@
           <a:p>
             <a:fld id="{52231B9D-E9F6-4612-9B82-E89961B389AC}" type="datetimeFigureOut">
               <a:rPr lang="pt-BR" smtClean="0"/>
-              <a:t>19/10/2022</a:t>
+              <a:t>24/10/2022</a:t>
             </a:fld>
             <a:endParaRPr lang="pt-BR"/>
           </a:p>
@@ -2045,7 +2045,7 @@
           <a:p>
             <a:fld id="{52231B9D-E9F6-4612-9B82-E89961B389AC}" type="datetimeFigureOut">
               <a:rPr lang="pt-BR" smtClean="0"/>
-              <a:t>19/10/2022</a:t>
+              <a:t>24/10/2022</a:t>
             </a:fld>
             <a:endParaRPr lang="pt-BR"/>
           </a:p>
@@ -2163,7 +2163,7 @@
           <a:p>
             <a:fld id="{52231B9D-E9F6-4612-9B82-E89961B389AC}" type="datetimeFigureOut">
               <a:rPr lang="pt-BR" smtClean="0"/>
-              <a:t>19/10/2022</a:t>
+              <a:t>24/10/2022</a:t>
             </a:fld>
             <a:endParaRPr lang="pt-BR"/>
           </a:p>
@@ -2258,7 +2258,7 @@
           <a:p>
             <a:fld id="{52231B9D-E9F6-4612-9B82-E89961B389AC}" type="datetimeFigureOut">
               <a:rPr lang="pt-BR" smtClean="0"/>
-              <a:t>19/10/2022</a:t>
+              <a:t>24/10/2022</a:t>
             </a:fld>
             <a:endParaRPr lang="pt-BR"/>
           </a:p>
@@ -2535,7 +2535,7 @@
           <a:p>
             <a:fld id="{52231B9D-E9F6-4612-9B82-E89961B389AC}" type="datetimeFigureOut">
               <a:rPr lang="pt-BR" smtClean="0"/>
-              <a:t>19/10/2022</a:t>
+              <a:t>24/10/2022</a:t>
             </a:fld>
             <a:endParaRPr lang="pt-BR"/>
           </a:p>
@@ -2788,7 +2788,7 @@
           <a:p>
             <a:fld id="{52231B9D-E9F6-4612-9B82-E89961B389AC}" type="datetimeFigureOut">
               <a:rPr lang="pt-BR" smtClean="0"/>
-              <a:t>19/10/2022</a:t>
+              <a:t>24/10/2022</a:t>
             </a:fld>
             <a:endParaRPr lang="pt-BR"/>
           </a:p>
@@ -3001,7 +3001,7 @@
           <a:p>
             <a:fld id="{52231B9D-E9F6-4612-9B82-E89961B389AC}" type="datetimeFigureOut">
               <a:rPr lang="pt-BR" smtClean="0"/>
-              <a:t>19/10/2022</a:t>
+              <a:t>24/10/2022</a:t>
             </a:fld>
             <a:endParaRPr lang="pt-BR"/>
           </a:p>
@@ -3665,7 +3665,17 @@
                   </a:schemeClr>
                 </a:solidFill>
               </a:rPr>
-              <a:t>16/10/2022</a:t>
+              <a:t>31</a:t>
+            </a:r>
+            <a:r>
+              <a:rPr lang="pt-BR" sz="1600" dirty="0" smtClean="0">
+                <a:solidFill>
+                  <a:schemeClr val="bg2">
+                    <a:lumMod val="90000"/>
+                  </a:schemeClr>
+                </a:solidFill>
+              </a:rPr>
+              <a:t>/10/2022</a:t>
             </a:r>
             <a:endParaRPr lang="pt-BR" sz="1600" dirty="0">
               <a:solidFill>

</xml_diff>

<commit_message>
validar vínculo func, dep e planos
</commit_message>
<xml_diff>
--- a/tempimento.pptx
+++ b/tempimento.pptx
@@ -197,7 +197,7 @@
           <a:p>
             <a:fld id="{A584E3A2-E8EA-4705-A613-CFE9F6F5D3B4}" type="datetimeFigureOut">
               <a:rPr lang="pt-BR" smtClean="0"/>
-              <a:t>24/10/2022</a:t>
+              <a:t>31/10/2022</a:t>
             </a:fld>
             <a:endParaRPr lang="pt-BR"/>
           </a:p>
@@ -680,7 +680,7 @@
           <a:p>
             <a:fld id="{52231B9D-E9F6-4612-9B82-E89961B389AC}" type="datetimeFigureOut">
               <a:rPr lang="pt-BR" smtClean="0"/>
-              <a:t>24/10/2022</a:t>
+              <a:t>31/10/2022</a:t>
             </a:fld>
             <a:endParaRPr lang="pt-BR"/>
           </a:p>
@@ -850,7 +850,7 @@
           <a:p>
             <a:fld id="{52231B9D-E9F6-4612-9B82-E89961B389AC}" type="datetimeFigureOut">
               <a:rPr lang="pt-BR" smtClean="0"/>
-              <a:t>24/10/2022</a:t>
+              <a:t>31/10/2022</a:t>
             </a:fld>
             <a:endParaRPr lang="pt-BR"/>
           </a:p>
@@ -1030,7 +1030,7 @@
           <a:p>
             <a:fld id="{52231B9D-E9F6-4612-9B82-E89961B389AC}" type="datetimeFigureOut">
               <a:rPr lang="pt-BR" smtClean="0"/>
-              <a:t>24/10/2022</a:t>
+              <a:t>31/10/2022</a:t>
             </a:fld>
             <a:endParaRPr lang="pt-BR"/>
           </a:p>
@@ -1200,7 +1200,7 @@
           <a:p>
             <a:fld id="{52231B9D-E9F6-4612-9B82-E89961B389AC}" type="datetimeFigureOut">
               <a:rPr lang="pt-BR" smtClean="0"/>
-              <a:t>24/10/2022</a:t>
+              <a:t>31/10/2022</a:t>
             </a:fld>
             <a:endParaRPr lang="pt-BR"/>
           </a:p>
@@ -1446,7 +1446,7 @@
           <a:p>
             <a:fld id="{52231B9D-E9F6-4612-9B82-E89961B389AC}" type="datetimeFigureOut">
               <a:rPr lang="pt-BR" smtClean="0"/>
-              <a:t>24/10/2022</a:t>
+              <a:t>31/10/2022</a:t>
             </a:fld>
             <a:endParaRPr lang="pt-BR"/>
           </a:p>
@@ -1678,7 +1678,7 @@
           <a:p>
             <a:fld id="{52231B9D-E9F6-4612-9B82-E89961B389AC}" type="datetimeFigureOut">
               <a:rPr lang="pt-BR" smtClean="0"/>
-              <a:t>24/10/2022</a:t>
+              <a:t>31/10/2022</a:t>
             </a:fld>
             <a:endParaRPr lang="pt-BR"/>
           </a:p>
@@ -2045,7 +2045,7 @@
           <a:p>
             <a:fld id="{52231B9D-E9F6-4612-9B82-E89961B389AC}" type="datetimeFigureOut">
               <a:rPr lang="pt-BR" smtClean="0"/>
-              <a:t>24/10/2022</a:t>
+              <a:t>31/10/2022</a:t>
             </a:fld>
             <a:endParaRPr lang="pt-BR"/>
           </a:p>
@@ -2163,7 +2163,7 @@
           <a:p>
             <a:fld id="{52231B9D-E9F6-4612-9B82-E89961B389AC}" type="datetimeFigureOut">
               <a:rPr lang="pt-BR" smtClean="0"/>
-              <a:t>24/10/2022</a:t>
+              <a:t>31/10/2022</a:t>
             </a:fld>
             <a:endParaRPr lang="pt-BR"/>
           </a:p>
@@ -2258,7 +2258,7 @@
           <a:p>
             <a:fld id="{52231B9D-E9F6-4612-9B82-E89961B389AC}" type="datetimeFigureOut">
               <a:rPr lang="pt-BR" smtClean="0"/>
-              <a:t>24/10/2022</a:t>
+              <a:t>31/10/2022</a:t>
             </a:fld>
             <a:endParaRPr lang="pt-BR"/>
           </a:p>
@@ -2535,7 +2535,7 @@
           <a:p>
             <a:fld id="{52231B9D-E9F6-4612-9B82-E89961B389AC}" type="datetimeFigureOut">
               <a:rPr lang="pt-BR" smtClean="0"/>
-              <a:t>24/10/2022</a:t>
+              <a:t>31/10/2022</a:t>
             </a:fld>
             <a:endParaRPr lang="pt-BR"/>
           </a:p>
@@ -2788,7 +2788,7 @@
           <a:p>
             <a:fld id="{52231B9D-E9F6-4612-9B82-E89961B389AC}" type="datetimeFigureOut">
               <a:rPr lang="pt-BR" smtClean="0"/>
-              <a:t>24/10/2022</a:t>
+              <a:t>31/10/2022</a:t>
             </a:fld>
             <a:endParaRPr lang="pt-BR"/>
           </a:p>
@@ -3001,7 +3001,7 @@
           <a:p>
             <a:fld id="{52231B9D-E9F6-4612-9B82-E89961B389AC}" type="datetimeFigureOut">
               <a:rPr lang="pt-BR" smtClean="0"/>
-              <a:t>24/10/2022</a:t>
+              <a:t>31/10/2022</a:t>
             </a:fld>
             <a:endParaRPr lang="pt-BR"/>
           </a:p>
@@ -3665,17 +3665,7 @@
                   </a:schemeClr>
                 </a:solidFill>
               </a:rPr>
-              <a:t>31</a:t>
-            </a:r>
-            <a:r>
-              <a:rPr lang="pt-BR" sz="1600" dirty="0" smtClean="0">
-                <a:solidFill>
-                  <a:schemeClr val="bg2">
-                    <a:lumMod val="90000"/>
-                  </a:schemeClr>
-                </a:solidFill>
-              </a:rPr>
-              <a:t>/10/2022</a:t>
+              <a:t>30/10/2022</a:t>
             </a:r>
             <a:endParaRPr lang="pt-BR" sz="1600" dirty="0">
               <a:solidFill>

</xml_diff>

<commit_message>
separação unimed e hapvida
</commit_message>
<xml_diff>
--- a/tempimento.pptx
+++ b/tempimento.pptx
@@ -197,7 +197,7 @@
           <a:p>
             <a:fld id="{A584E3A2-E8EA-4705-A613-CFE9F6F5D3B4}" type="datetimeFigureOut">
               <a:rPr lang="pt-BR" smtClean="0"/>
-              <a:t>31/10/2022</a:t>
+              <a:t>07/11/2022</a:t>
             </a:fld>
             <a:endParaRPr lang="pt-BR"/>
           </a:p>
@@ -680,7 +680,7 @@
           <a:p>
             <a:fld id="{52231B9D-E9F6-4612-9B82-E89961B389AC}" type="datetimeFigureOut">
               <a:rPr lang="pt-BR" smtClean="0"/>
-              <a:t>31/10/2022</a:t>
+              <a:t>07/11/2022</a:t>
             </a:fld>
             <a:endParaRPr lang="pt-BR"/>
           </a:p>
@@ -850,7 +850,7 @@
           <a:p>
             <a:fld id="{52231B9D-E9F6-4612-9B82-E89961B389AC}" type="datetimeFigureOut">
               <a:rPr lang="pt-BR" smtClean="0"/>
-              <a:t>31/10/2022</a:t>
+              <a:t>07/11/2022</a:t>
             </a:fld>
             <a:endParaRPr lang="pt-BR"/>
           </a:p>
@@ -1030,7 +1030,7 @@
           <a:p>
             <a:fld id="{52231B9D-E9F6-4612-9B82-E89961B389AC}" type="datetimeFigureOut">
               <a:rPr lang="pt-BR" smtClean="0"/>
-              <a:t>31/10/2022</a:t>
+              <a:t>07/11/2022</a:t>
             </a:fld>
             <a:endParaRPr lang="pt-BR"/>
           </a:p>
@@ -1200,7 +1200,7 @@
           <a:p>
             <a:fld id="{52231B9D-E9F6-4612-9B82-E89961B389AC}" type="datetimeFigureOut">
               <a:rPr lang="pt-BR" smtClean="0"/>
-              <a:t>31/10/2022</a:t>
+              <a:t>07/11/2022</a:t>
             </a:fld>
             <a:endParaRPr lang="pt-BR"/>
           </a:p>
@@ -1446,7 +1446,7 @@
           <a:p>
             <a:fld id="{52231B9D-E9F6-4612-9B82-E89961B389AC}" type="datetimeFigureOut">
               <a:rPr lang="pt-BR" smtClean="0"/>
-              <a:t>31/10/2022</a:t>
+              <a:t>07/11/2022</a:t>
             </a:fld>
             <a:endParaRPr lang="pt-BR"/>
           </a:p>
@@ -1678,7 +1678,7 @@
           <a:p>
             <a:fld id="{52231B9D-E9F6-4612-9B82-E89961B389AC}" type="datetimeFigureOut">
               <a:rPr lang="pt-BR" smtClean="0"/>
-              <a:t>31/10/2022</a:t>
+              <a:t>07/11/2022</a:t>
             </a:fld>
             <a:endParaRPr lang="pt-BR"/>
           </a:p>
@@ -2045,7 +2045,7 @@
           <a:p>
             <a:fld id="{52231B9D-E9F6-4612-9B82-E89961B389AC}" type="datetimeFigureOut">
               <a:rPr lang="pt-BR" smtClean="0"/>
-              <a:t>31/10/2022</a:t>
+              <a:t>07/11/2022</a:t>
             </a:fld>
             <a:endParaRPr lang="pt-BR"/>
           </a:p>
@@ -2163,7 +2163,7 @@
           <a:p>
             <a:fld id="{52231B9D-E9F6-4612-9B82-E89961B389AC}" type="datetimeFigureOut">
               <a:rPr lang="pt-BR" smtClean="0"/>
-              <a:t>31/10/2022</a:t>
+              <a:t>07/11/2022</a:t>
             </a:fld>
             <a:endParaRPr lang="pt-BR"/>
           </a:p>
@@ -2258,7 +2258,7 @@
           <a:p>
             <a:fld id="{52231B9D-E9F6-4612-9B82-E89961B389AC}" type="datetimeFigureOut">
               <a:rPr lang="pt-BR" smtClean="0"/>
-              <a:t>31/10/2022</a:t>
+              <a:t>07/11/2022</a:t>
             </a:fld>
             <a:endParaRPr lang="pt-BR"/>
           </a:p>
@@ -2535,7 +2535,7 @@
           <a:p>
             <a:fld id="{52231B9D-E9F6-4612-9B82-E89961B389AC}" type="datetimeFigureOut">
               <a:rPr lang="pt-BR" smtClean="0"/>
-              <a:t>31/10/2022</a:t>
+              <a:t>07/11/2022</a:t>
             </a:fld>
             <a:endParaRPr lang="pt-BR"/>
           </a:p>
@@ -2788,7 +2788,7 @@
           <a:p>
             <a:fld id="{52231B9D-E9F6-4612-9B82-E89961B389AC}" type="datetimeFigureOut">
               <a:rPr lang="pt-BR" smtClean="0"/>
-              <a:t>31/10/2022</a:t>
+              <a:t>07/11/2022</a:t>
             </a:fld>
             <a:endParaRPr lang="pt-BR"/>
           </a:p>
@@ -3001,7 +3001,7 @@
           <a:p>
             <a:fld id="{52231B9D-E9F6-4612-9B82-E89961B389AC}" type="datetimeFigureOut">
               <a:rPr lang="pt-BR" smtClean="0"/>
-              <a:t>31/10/2022</a:t>
+              <a:t>07/11/2022</a:t>
             </a:fld>
             <a:endParaRPr lang="pt-BR"/>
           </a:p>
@@ -3665,7 +3665,17 @@
                   </a:schemeClr>
                 </a:solidFill>
               </a:rPr>
-              <a:t>30/10/2022</a:t>
+              <a:t>06</a:t>
+            </a:r>
+            <a:r>
+              <a:rPr lang="pt-BR" sz="1600" dirty="0" smtClean="0">
+                <a:solidFill>
+                  <a:schemeClr val="bg2">
+                    <a:lumMod val="90000"/>
+                  </a:schemeClr>
+                </a:solidFill>
+              </a:rPr>
+              <a:t>/11/2022</a:t>
             </a:r>
             <a:endParaRPr lang="pt-BR" sz="1600" dirty="0">
               <a:solidFill>

</xml_diff>

<commit_message>
consulta dim veículos ok
</commit_message>
<xml_diff>
--- a/tempimento.pptx
+++ b/tempimento.pptx
@@ -197,7 +197,7 @@
           <a:p>
             <a:fld id="{A584E3A2-E8EA-4705-A613-CFE9F6F5D3B4}" type="datetimeFigureOut">
               <a:rPr lang="pt-BR" smtClean="0"/>
-              <a:t>07/11/2022</a:t>
+              <a:t>14/11/2022</a:t>
             </a:fld>
             <a:endParaRPr lang="pt-BR"/>
           </a:p>
@@ -680,7 +680,7 @@
           <a:p>
             <a:fld id="{52231B9D-E9F6-4612-9B82-E89961B389AC}" type="datetimeFigureOut">
               <a:rPr lang="pt-BR" smtClean="0"/>
-              <a:t>07/11/2022</a:t>
+              <a:t>14/11/2022</a:t>
             </a:fld>
             <a:endParaRPr lang="pt-BR"/>
           </a:p>
@@ -850,7 +850,7 @@
           <a:p>
             <a:fld id="{52231B9D-E9F6-4612-9B82-E89961B389AC}" type="datetimeFigureOut">
               <a:rPr lang="pt-BR" smtClean="0"/>
-              <a:t>07/11/2022</a:t>
+              <a:t>14/11/2022</a:t>
             </a:fld>
             <a:endParaRPr lang="pt-BR"/>
           </a:p>
@@ -1030,7 +1030,7 @@
           <a:p>
             <a:fld id="{52231B9D-E9F6-4612-9B82-E89961B389AC}" type="datetimeFigureOut">
               <a:rPr lang="pt-BR" smtClean="0"/>
-              <a:t>07/11/2022</a:t>
+              <a:t>14/11/2022</a:t>
             </a:fld>
             <a:endParaRPr lang="pt-BR"/>
           </a:p>
@@ -1200,7 +1200,7 @@
           <a:p>
             <a:fld id="{52231B9D-E9F6-4612-9B82-E89961B389AC}" type="datetimeFigureOut">
               <a:rPr lang="pt-BR" smtClean="0"/>
-              <a:t>07/11/2022</a:t>
+              <a:t>14/11/2022</a:t>
             </a:fld>
             <a:endParaRPr lang="pt-BR"/>
           </a:p>
@@ -1446,7 +1446,7 @@
           <a:p>
             <a:fld id="{52231B9D-E9F6-4612-9B82-E89961B389AC}" type="datetimeFigureOut">
               <a:rPr lang="pt-BR" smtClean="0"/>
-              <a:t>07/11/2022</a:t>
+              <a:t>14/11/2022</a:t>
             </a:fld>
             <a:endParaRPr lang="pt-BR"/>
           </a:p>
@@ -1678,7 +1678,7 @@
           <a:p>
             <a:fld id="{52231B9D-E9F6-4612-9B82-E89961B389AC}" type="datetimeFigureOut">
               <a:rPr lang="pt-BR" smtClean="0"/>
-              <a:t>07/11/2022</a:t>
+              <a:t>14/11/2022</a:t>
             </a:fld>
             <a:endParaRPr lang="pt-BR"/>
           </a:p>
@@ -2045,7 +2045,7 @@
           <a:p>
             <a:fld id="{52231B9D-E9F6-4612-9B82-E89961B389AC}" type="datetimeFigureOut">
               <a:rPr lang="pt-BR" smtClean="0"/>
-              <a:t>07/11/2022</a:t>
+              <a:t>14/11/2022</a:t>
             </a:fld>
             <a:endParaRPr lang="pt-BR"/>
           </a:p>
@@ -2163,7 +2163,7 @@
           <a:p>
             <a:fld id="{52231B9D-E9F6-4612-9B82-E89961B389AC}" type="datetimeFigureOut">
               <a:rPr lang="pt-BR" smtClean="0"/>
-              <a:t>07/11/2022</a:t>
+              <a:t>14/11/2022</a:t>
             </a:fld>
             <a:endParaRPr lang="pt-BR"/>
           </a:p>
@@ -2258,7 +2258,7 @@
           <a:p>
             <a:fld id="{52231B9D-E9F6-4612-9B82-E89961B389AC}" type="datetimeFigureOut">
               <a:rPr lang="pt-BR" smtClean="0"/>
-              <a:t>07/11/2022</a:t>
+              <a:t>14/11/2022</a:t>
             </a:fld>
             <a:endParaRPr lang="pt-BR"/>
           </a:p>
@@ -2535,7 +2535,7 @@
           <a:p>
             <a:fld id="{52231B9D-E9F6-4612-9B82-E89961B389AC}" type="datetimeFigureOut">
               <a:rPr lang="pt-BR" smtClean="0"/>
-              <a:t>07/11/2022</a:t>
+              <a:t>14/11/2022</a:t>
             </a:fld>
             <a:endParaRPr lang="pt-BR"/>
           </a:p>
@@ -2788,7 +2788,7 @@
           <a:p>
             <a:fld id="{52231B9D-E9F6-4612-9B82-E89961B389AC}" type="datetimeFigureOut">
               <a:rPr lang="pt-BR" smtClean="0"/>
-              <a:t>07/11/2022</a:t>
+              <a:t>14/11/2022</a:t>
             </a:fld>
             <a:endParaRPr lang="pt-BR"/>
           </a:p>
@@ -3001,7 +3001,7 @@
           <a:p>
             <a:fld id="{52231B9D-E9F6-4612-9B82-E89961B389AC}" type="datetimeFigureOut">
               <a:rPr lang="pt-BR" smtClean="0"/>
-              <a:t>07/11/2022</a:t>
+              <a:t>14/11/2022</a:t>
             </a:fld>
             <a:endParaRPr lang="pt-BR"/>
           </a:p>
@@ -3665,7 +3665,7 @@
                   </a:schemeClr>
                 </a:solidFill>
               </a:rPr>
-              <a:t>06</a:t>
+              <a:t>13</a:t>
             </a:r>
             <a:r>
               <a:rPr lang="pt-BR" sz="1600" dirty="0" smtClean="0">

</xml_diff>

<commit_message>
formatação consulta pedido de compra
</commit_message>
<xml_diff>
--- a/tempimento.pptx
+++ b/tempimento.pptx
@@ -149,7 +149,7 @@
         </p:nvSpPr>
         <p:spPr>
           <a:xfrm>
-            <a:off x="2" y="1"/>
+            <a:off x="3" y="1"/>
             <a:ext cx="3078851" cy="512763"/>
           </a:xfrm>
           <a:prstGeom prst="rect">
@@ -157,7 +157,7 @@
           </a:prstGeom>
         </p:spPr>
         <p:txBody>
-          <a:bodyPr vert="horz" lIns="91429" tIns="45715" rIns="91429" bIns="45715" rtlCol="0"/>
+          <a:bodyPr vert="horz" lIns="91419" tIns="45710" rIns="91419" bIns="45710" rtlCol="0"/>
           <a:lstStyle>
             <a:lvl1pPr algn="l">
               <a:defRPr sz="1200"/>
@@ -180,7 +180,7 @@
         </p:nvSpPr>
         <p:spPr>
           <a:xfrm>
-            <a:off x="4023626" y="1"/>
+            <a:off x="4023627" y="1"/>
             <a:ext cx="3078851" cy="512763"/>
           </a:xfrm>
           <a:prstGeom prst="rect">
@@ -188,7 +188,7 @@
           </a:prstGeom>
         </p:spPr>
         <p:txBody>
-          <a:bodyPr vert="horz" lIns="91429" tIns="45715" rIns="91429" bIns="45715" rtlCol="0"/>
+          <a:bodyPr vert="horz" lIns="91419" tIns="45710" rIns="91419" bIns="45710" rtlCol="0"/>
           <a:lstStyle>
             <a:lvl1pPr algn="r">
               <a:defRPr sz="1200"/>
@@ -197,7 +197,7 @@
           <a:p>
             <a:fld id="{A584E3A2-E8EA-4705-A613-CFE9F6F5D3B4}" type="datetimeFigureOut">
               <a:rPr lang="pt-BR" smtClean="0"/>
-              <a:t>14/11/2022</a:t>
+              <a:t>21/11/2022</a:t>
             </a:fld>
             <a:endParaRPr lang="pt-BR"/>
           </a:p>
@@ -229,7 +229,7 @@
           </a:ln>
         </p:spPr>
         <p:txBody>
-          <a:bodyPr vert="horz" lIns="91429" tIns="45715" rIns="91429" bIns="45715" rtlCol="0" anchor="ctr"/>
+          <a:bodyPr vert="horz" lIns="91419" tIns="45710" rIns="91419" bIns="45710" rtlCol="0" anchor="ctr"/>
           <a:lstStyle/>
           <a:p>
             <a:endParaRPr lang="pt-BR"/>
@@ -248,7 +248,7 @@
         </p:nvSpPr>
         <p:spPr>
           <a:xfrm>
-            <a:off x="709773" y="4926015"/>
+            <a:off x="709774" y="4926015"/>
             <a:ext cx="5684521" cy="4029075"/>
           </a:xfrm>
           <a:prstGeom prst="rect">
@@ -256,7 +256,7 @@
           </a:prstGeom>
         </p:spPr>
         <p:txBody>
-          <a:bodyPr vert="horz" lIns="91429" tIns="45715" rIns="91429" bIns="45715" rtlCol="0"/>
+          <a:bodyPr vert="horz" lIns="91419" tIns="45710" rIns="91419" bIns="45710" rtlCol="0"/>
           <a:lstStyle/>
           <a:p>
             <a:pPr lvl="0"/>
@@ -308,7 +308,7 @@
         </p:nvSpPr>
         <p:spPr>
           <a:xfrm>
-            <a:off x="2" y="9721851"/>
+            <a:off x="3" y="9721851"/>
             <a:ext cx="3078851" cy="512763"/>
           </a:xfrm>
           <a:prstGeom prst="rect">
@@ -316,7 +316,7 @@
           </a:prstGeom>
         </p:spPr>
         <p:txBody>
-          <a:bodyPr vert="horz" lIns="91429" tIns="45715" rIns="91429" bIns="45715" rtlCol="0" anchor="b"/>
+          <a:bodyPr vert="horz" lIns="91419" tIns="45710" rIns="91419" bIns="45710" rtlCol="0" anchor="b"/>
           <a:lstStyle>
             <a:lvl1pPr algn="l">
               <a:defRPr sz="1200"/>
@@ -339,7 +339,7 @@
         </p:nvSpPr>
         <p:spPr>
           <a:xfrm>
-            <a:off x="4023626" y="9721851"/>
+            <a:off x="4023627" y="9721851"/>
             <a:ext cx="3078851" cy="512763"/>
           </a:xfrm>
           <a:prstGeom prst="rect">
@@ -347,7 +347,7 @@
           </a:prstGeom>
         </p:spPr>
         <p:txBody>
-          <a:bodyPr vert="horz" lIns="91429" tIns="45715" rIns="91429" bIns="45715" rtlCol="0" anchor="b"/>
+          <a:bodyPr vert="horz" lIns="91419" tIns="45710" rIns="91419" bIns="45710" rtlCol="0" anchor="b"/>
           <a:lstStyle>
             <a:lvl1pPr algn="r">
               <a:defRPr sz="1200"/>
@@ -680,7 +680,7 @@
           <a:p>
             <a:fld id="{52231B9D-E9F6-4612-9B82-E89961B389AC}" type="datetimeFigureOut">
               <a:rPr lang="pt-BR" smtClean="0"/>
-              <a:t>14/11/2022</a:t>
+              <a:t>21/11/2022</a:t>
             </a:fld>
             <a:endParaRPr lang="pt-BR"/>
           </a:p>
@@ -850,7 +850,7 @@
           <a:p>
             <a:fld id="{52231B9D-E9F6-4612-9B82-E89961B389AC}" type="datetimeFigureOut">
               <a:rPr lang="pt-BR" smtClean="0"/>
-              <a:t>14/11/2022</a:t>
+              <a:t>21/11/2022</a:t>
             </a:fld>
             <a:endParaRPr lang="pt-BR"/>
           </a:p>
@@ -1030,7 +1030,7 @@
           <a:p>
             <a:fld id="{52231B9D-E9F6-4612-9B82-E89961B389AC}" type="datetimeFigureOut">
               <a:rPr lang="pt-BR" smtClean="0"/>
-              <a:t>14/11/2022</a:t>
+              <a:t>21/11/2022</a:t>
             </a:fld>
             <a:endParaRPr lang="pt-BR"/>
           </a:p>
@@ -1200,7 +1200,7 @@
           <a:p>
             <a:fld id="{52231B9D-E9F6-4612-9B82-E89961B389AC}" type="datetimeFigureOut">
               <a:rPr lang="pt-BR" smtClean="0"/>
-              <a:t>14/11/2022</a:t>
+              <a:t>21/11/2022</a:t>
             </a:fld>
             <a:endParaRPr lang="pt-BR"/>
           </a:p>
@@ -1446,7 +1446,7 @@
           <a:p>
             <a:fld id="{52231B9D-E9F6-4612-9B82-E89961B389AC}" type="datetimeFigureOut">
               <a:rPr lang="pt-BR" smtClean="0"/>
-              <a:t>14/11/2022</a:t>
+              <a:t>21/11/2022</a:t>
             </a:fld>
             <a:endParaRPr lang="pt-BR"/>
           </a:p>
@@ -1678,7 +1678,7 @@
           <a:p>
             <a:fld id="{52231B9D-E9F6-4612-9B82-E89961B389AC}" type="datetimeFigureOut">
               <a:rPr lang="pt-BR" smtClean="0"/>
-              <a:t>14/11/2022</a:t>
+              <a:t>21/11/2022</a:t>
             </a:fld>
             <a:endParaRPr lang="pt-BR"/>
           </a:p>
@@ -2045,7 +2045,7 @@
           <a:p>
             <a:fld id="{52231B9D-E9F6-4612-9B82-E89961B389AC}" type="datetimeFigureOut">
               <a:rPr lang="pt-BR" smtClean="0"/>
-              <a:t>14/11/2022</a:t>
+              <a:t>21/11/2022</a:t>
             </a:fld>
             <a:endParaRPr lang="pt-BR"/>
           </a:p>
@@ -2163,7 +2163,7 @@
           <a:p>
             <a:fld id="{52231B9D-E9F6-4612-9B82-E89961B389AC}" type="datetimeFigureOut">
               <a:rPr lang="pt-BR" smtClean="0"/>
-              <a:t>14/11/2022</a:t>
+              <a:t>21/11/2022</a:t>
             </a:fld>
             <a:endParaRPr lang="pt-BR"/>
           </a:p>
@@ -2258,7 +2258,7 @@
           <a:p>
             <a:fld id="{52231B9D-E9F6-4612-9B82-E89961B389AC}" type="datetimeFigureOut">
               <a:rPr lang="pt-BR" smtClean="0"/>
-              <a:t>14/11/2022</a:t>
+              <a:t>21/11/2022</a:t>
             </a:fld>
             <a:endParaRPr lang="pt-BR"/>
           </a:p>
@@ -2535,7 +2535,7 @@
           <a:p>
             <a:fld id="{52231B9D-E9F6-4612-9B82-E89961B389AC}" type="datetimeFigureOut">
               <a:rPr lang="pt-BR" smtClean="0"/>
-              <a:t>14/11/2022</a:t>
+              <a:t>21/11/2022</a:t>
             </a:fld>
             <a:endParaRPr lang="pt-BR"/>
           </a:p>
@@ -2788,7 +2788,7 @@
           <a:p>
             <a:fld id="{52231B9D-E9F6-4612-9B82-E89961B389AC}" type="datetimeFigureOut">
               <a:rPr lang="pt-BR" smtClean="0"/>
-              <a:t>14/11/2022</a:t>
+              <a:t>21/11/2022</a:t>
             </a:fld>
             <a:endParaRPr lang="pt-BR"/>
           </a:p>
@@ -3001,7 +3001,7 @@
           <a:p>
             <a:fld id="{52231B9D-E9F6-4612-9B82-E89961B389AC}" type="datetimeFigureOut">
               <a:rPr lang="pt-BR" smtClean="0"/>
-              <a:t>14/11/2022</a:t>
+              <a:t>21/11/2022</a:t>
             </a:fld>
             <a:endParaRPr lang="pt-BR"/>
           </a:p>
@@ -3665,7 +3665,7 @@
                   </a:schemeClr>
                 </a:solidFill>
               </a:rPr>
-              <a:t>13</a:t>
+              <a:t>20</a:t>
             </a:r>
             <a:r>
               <a:rPr lang="pt-BR" sz="1600" dirty="0" smtClean="0">

</xml_diff>

<commit_message>
padronização relatório admitidos e demitidos
</commit_message>
<xml_diff>
--- a/tempimento.pptx
+++ b/tempimento.pptx
@@ -197,7 +197,7 @@
           <a:p>
             <a:fld id="{A584E3A2-E8EA-4705-A613-CFE9F6F5D3B4}" type="datetimeFigureOut">
               <a:rPr lang="pt-BR" smtClean="0"/>
-              <a:t>28/11/2022</a:t>
+              <a:t>05/12/2022</a:t>
             </a:fld>
             <a:endParaRPr lang="pt-BR"/>
           </a:p>
@@ -680,7 +680,7 @@
           <a:p>
             <a:fld id="{52231B9D-E9F6-4612-9B82-E89961B389AC}" type="datetimeFigureOut">
               <a:rPr lang="pt-BR" smtClean="0"/>
-              <a:t>28/11/2022</a:t>
+              <a:t>05/12/2022</a:t>
             </a:fld>
             <a:endParaRPr lang="pt-BR"/>
           </a:p>
@@ -850,7 +850,7 @@
           <a:p>
             <a:fld id="{52231B9D-E9F6-4612-9B82-E89961B389AC}" type="datetimeFigureOut">
               <a:rPr lang="pt-BR" smtClean="0"/>
-              <a:t>28/11/2022</a:t>
+              <a:t>05/12/2022</a:t>
             </a:fld>
             <a:endParaRPr lang="pt-BR"/>
           </a:p>
@@ -1030,7 +1030,7 @@
           <a:p>
             <a:fld id="{52231B9D-E9F6-4612-9B82-E89961B389AC}" type="datetimeFigureOut">
               <a:rPr lang="pt-BR" smtClean="0"/>
-              <a:t>28/11/2022</a:t>
+              <a:t>05/12/2022</a:t>
             </a:fld>
             <a:endParaRPr lang="pt-BR"/>
           </a:p>
@@ -1200,7 +1200,7 @@
           <a:p>
             <a:fld id="{52231B9D-E9F6-4612-9B82-E89961B389AC}" type="datetimeFigureOut">
               <a:rPr lang="pt-BR" smtClean="0"/>
-              <a:t>28/11/2022</a:t>
+              <a:t>05/12/2022</a:t>
             </a:fld>
             <a:endParaRPr lang="pt-BR"/>
           </a:p>
@@ -1446,7 +1446,7 @@
           <a:p>
             <a:fld id="{52231B9D-E9F6-4612-9B82-E89961B389AC}" type="datetimeFigureOut">
               <a:rPr lang="pt-BR" smtClean="0"/>
-              <a:t>28/11/2022</a:t>
+              <a:t>05/12/2022</a:t>
             </a:fld>
             <a:endParaRPr lang="pt-BR"/>
           </a:p>
@@ -1678,7 +1678,7 @@
           <a:p>
             <a:fld id="{52231B9D-E9F6-4612-9B82-E89961B389AC}" type="datetimeFigureOut">
               <a:rPr lang="pt-BR" smtClean="0"/>
-              <a:t>28/11/2022</a:t>
+              <a:t>05/12/2022</a:t>
             </a:fld>
             <a:endParaRPr lang="pt-BR"/>
           </a:p>
@@ -2045,7 +2045,7 @@
           <a:p>
             <a:fld id="{52231B9D-E9F6-4612-9B82-E89961B389AC}" type="datetimeFigureOut">
               <a:rPr lang="pt-BR" smtClean="0"/>
-              <a:t>28/11/2022</a:t>
+              <a:t>05/12/2022</a:t>
             </a:fld>
             <a:endParaRPr lang="pt-BR"/>
           </a:p>
@@ -2163,7 +2163,7 @@
           <a:p>
             <a:fld id="{52231B9D-E9F6-4612-9B82-E89961B389AC}" type="datetimeFigureOut">
               <a:rPr lang="pt-BR" smtClean="0"/>
-              <a:t>28/11/2022</a:t>
+              <a:t>05/12/2022</a:t>
             </a:fld>
             <a:endParaRPr lang="pt-BR"/>
           </a:p>
@@ -2258,7 +2258,7 @@
           <a:p>
             <a:fld id="{52231B9D-E9F6-4612-9B82-E89961B389AC}" type="datetimeFigureOut">
               <a:rPr lang="pt-BR" smtClean="0"/>
-              <a:t>28/11/2022</a:t>
+              <a:t>05/12/2022</a:t>
             </a:fld>
             <a:endParaRPr lang="pt-BR"/>
           </a:p>
@@ -2535,7 +2535,7 @@
           <a:p>
             <a:fld id="{52231B9D-E9F6-4612-9B82-E89961B389AC}" type="datetimeFigureOut">
               <a:rPr lang="pt-BR" smtClean="0"/>
-              <a:t>28/11/2022</a:t>
+              <a:t>05/12/2022</a:t>
             </a:fld>
             <a:endParaRPr lang="pt-BR"/>
           </a:p>
@@ -2788,7 +2788,7 @@
           <a:p>
             <a:fld id="{52231B9D-E9F6-4612-9B82-E89961B389AC}" type="datetimeFigureOut">
               <a:rPr lang="pt-BR" smtClean="0"/>
-              <a:t>28/11/2022</a:t>
+              <a:t>05/12/2022</a:t>
             </a:fld>
             <a:endParaRPr lang="pt-BR"/>
           </a:p>
@@ -3001,7 +3001,7 @@
           <a:p>
             <a:fld id="{52231B9D-E9F6-4612-9B82-E89961B389AC}" type="datetimeFigureOut">
               <a:rPr lang="pt-BR" smtClean="0"/>
-              <a:t>28/11/2022</a:t>
+              <a:t>05/12/2022</a:t>
             </a:fld>
             <a:endParaRPr lang="pt-BR"/>
           </a:p>
@@ -3665,7 +3665,17 @@
                   </a:schemeClr>
                 </a:solidFill>
               </a:rPr>
-              <a:t>27/11/2022</a:t>
+              <a:t>04</a:t>
+            </a:r>
+            <a:r>
+              <a:rPr lang="pt-BR" sz="1600" dirty="0" smtClean="0">
+                <a:solidFill>
+                  <a:schemeClr val="bg2">
+                    <a:lumMod val="90000"/>
+                  </a:schemeClr>
+                </a:solidFill>
+              </a:rPr>
+              <a:t>/12/2022</a:t>
             </a:r>
             <a:endParaRPr lang="pt-BR" sz="1600" dirty="0">
               <a:solidFill>

</xml_diff>

<commit_message>
alteração da DATA para fim viagem em vez de data DOC
</commit_message>
<xml_diff>
--- a/tempimento.pptx
+++ b/tempimento.pptx
@@ -11,7 +11,7 @@
     <p:sldId id="256" r:id="rId2"/>
   </p:sldIdLst>
   <p:sldSz cx="12192000" cy="6858000"/>
-  <p:notesSz cx="7104063" cy="10234613"/>
+  <p:notesSz cx="6889750" cy="9671050"/>
   <p:defaultTextStyle>
     <a:defPPr>
       <a:defRPr lang="pt-BR"/>
@@ -149,18 +149,18 @@
         </p:nvSpPr>
         <p:spPr>
           <a:xfrm>
-            <a:off x="3" y="1"/>
-            <a:ext cx="3078851" cy="512763"/>
+            <a:off x="4" y="1"/>
+            <a:ext cx="2985969" cy="484528"/>
           </a:xfrm>
           <a:prstGeom prst="rect">
             <a:avLst/>
           </a:prstGeom>
         </p:spPr>
         <p:txBody>
-          <a:bodyPr vert="horz" lIns="91419" tIns="45710" rIns="91419" bIns="45710" rtlCol="0"/>
+          <a:bodyPr vert="horz" lIns="87314" tIns="43658" rIns="87314" bIns="43658" rtlCol="0"/>
           <a:lstStyle>
             <a:lvl1pPr algn="l">
-              <a:defRPr sz="1200"/>
+              <a:defRPr sz="1100"/>
             </a:lvl1pPr>
           </a:lstStyle>
           <a:p>
@@ -180,24 +180,24 @@
         </p:nvSpPr>
         <p:spPr>
           <a:xfrm>
-            <a:off x="4023627" y="1"/>
-            <a:ext cx="3078851" cy="512763"/>
+            <a:off x="3902244" y="1"/>
+            <a:ext cx="2985969" cy="484528"/>
           </a:xfrm>
           <a:prstGeom prst="rect">
             <a:avLst/>
           </a:prstGeom>
         </p:spPr>
         <p:txBody>
-          <a:bodyPr vert="horz" lIns="91419" tIns="45710" rIns="91419" bIns="45710" rtlCol="0"/>
+          <a:bodyPr vert="horz" lIns="87314" tIns="43658" rIns="87314" bIns="43658" rtlCol="0"/>
           <a:lstStyle>
             <a:lvl1pPr algn="r">
-              <a:defRPr sz="1200"/>
+              <a:defRPr sz="1100"/>
             </a:lvl1pPr>
           </a:lstStyle>
           <a:p>
             <a:fld id="{A584E3A2-E8EA-4705-A613-CFE9F6F5D3B4}" type="datetimeFigureOut">
               <a:rPr lang="pt-BR" smtClean="0"/>
-              <a:t>05/12/2022</a:t>
+              <a:t>12/12/2022</a:t>
             </a:fld>
             <a:endParaRPr lang="pt-BR"/>
           </a:p>
@@ -215,8 +215,8 @@
         </p:nvSpPr>
         <p:spPr>
           <a:xfrm>
-            <a:off x="482600" y="1279525"/>
-            <a:ext cx="6138863" cy="3454400"/>
+            <a:off x="542925" y="1209675"/>
+            <a:ext cx="5803900" cy="3263900"/>
           </a:xfrm>
           <a:prstGeom prst="rect">
             <a:avLst/>
@@ -229,7 +229,7 @@
           </a:ln>
         </p:spPr>
         <p:txBody>
-          <a:bodyPr vert="horz" lIns="91419" tIns="45710" rIns="91419" bIns="45710" rtlCol="0" anchor="ctr"/>
+          <a:bodyPr vert="horz" lIns="87314" tIns="43658" rIns="87314" bIns="43658" rtlCol="0" anchor="ctr"/>
           <a:lstStyle/>
           <a:p>
             <a:endParaRPr lang="pt-BR"/>
@@ -248,15 +248,15 @@
         </p:nvSpPr>
         <p:spPr>
           <a:xfrm>
-            <a:off x="709774" y="4926015"/>
-            <a:ext cx="5684521" cy="4029075"/>
+            <a:off x="688362" y="4654767"/>
+            <a:ext cx="5513032" cy="3807216"/>
           </a:xfrm>
           <a:prstGeom prst="rect">
             <a:avLst/>
           </a:prstGeom>
         </p:spPr>
         <p:txBody>
-          <a:bodyPr vert="horz" lIns="91419" tIns="45710" rIns="91419" bIns="45710" rtlCol="0"/>
+          <a:bodyPr vert="horz" lIns="87314" tIns="43658" rIns="87314" bIns="43658" rtlCol="0"/>
           <a:lstStyle/>
           <a:p>
             <a:pPr lvl="0"/>
@@ -308,18 +308,18 @@
         </p:nvSpPr>
         <p:spPr>
           <a:xfrm>
-            <a:off x="3" y="9721851"/>
-            <a:ext cx="3078851" cy="512763"/>
+            <a:off x="4" y="9186523"/>
+            <a:ext cx="2985969" cy="484528"/>
           </a:xfrm>
           <a:prstGeom prst="rect">
             <a:avLst/>
           </a:prstGeom>
         </p:spPr>
         <p:txBody>
-          <a:bodyPr vert="horz" lIns="91419" tIns="45710" rIns="91419" bIns="45710" rtlCol="0" anchor="b"/>
+          <a:bodyPr vert="horz" lIns="87314" tIns="43658" rIns="87314" bIns="43658" rtlCol="0" anchor="b"/>
           <a:lstStyle>
             <a:lvl1pPr algn="l">
-              <a:defRPr sz="1200"/>
+              <a:defRPr sz="1100"/>
             </a:lvl1pPr>
           </a:lstStyle>
           <a:p>
@@ -339,18 +339,18 @@
         </p:nvSpPr>
         <p:spPr>
           <a:xfrm>
-            <a:off x="4023627" y="9721851"/>
-            <a:ext cx="3078851" cy="512763"/>
+            <a:off x="3902244" y="9186523"/>
+            <a:ext cx="2985969" cy="484528"/>
           </a:xfrm>
           <a:prstGeom prst="rect">
             <a:avLst/>
           </a:prstGeom>
         </p:spPr>
         <p:txBody>
-          <a:bodyPr vert="horz" lIns="91419" tIns="45710" rIns="91419" bIns="45710" rtlCol="0" anchor="b"/>
+          <a:bodyPr vert="horz" lIns="87314" tIns="43658" rIns="87314" bIns="43658" rtlCol="0" anchor="b"/>
           <a:lstStyle>
             <a:lvl1pPr algn="r">
-              <a:defRPr sz="1200"/>
+              <a:defRPr sz="1100"/>
             </a:lvl1pPr>
           </a:lstStyle>
           <a:p>
@@ -680,7 +680,7 @@
           <a:p>
             <a:fld id="{52231B9D-E9F6-4612-9B82-E89961B389AC}" type="datetimeFigureOut">
               <a:rPr lang="pt-BR" smtClean="0"/>
-              <a:t>05/12/2022</a:t>
+              <a:t>12/12/2022</a:t>
             </a:fld>
             <a:endParaRPr lang="pt-BR"/>
           </a:p>
@@ -850,7 +850,7 @@
           <a:p>
             <a:fld id="{52231B9D-E9F6-4612-9B82-E89961B389AC}" type="datetimeFigureOut">
               <a:rPr lang="pt-BR" smtClean="0"/>
-              <a:t>05/12/2022</a:t>
+              <a:t>12/12/2022</a:t>
             </a:fld>
             <a:endParaRPr lang="pt-BR"/>
           </a:p>
@@ -1030,7 +1030,7 @@
           <a:p>
             <a:fld id="{52231B9D-E9F6-4612-9B82-E89961B389AC}" type="datetimeFigureOut">
               <a:rPr lang="pt-BR" smtClean="0"/>
-              <a:t>05/12/2022</a:t>
+              <a:t>12/12/2022</a:t>
             </a:fld>
             <a:endParaRPr lang="pt-BR"/>
           </a:p>
@@ -1200,7 +1200,7 @@
           <a:p>
             <a:fld id="{52231B9D-E9F6-4612-9B82-E89961B389AC}" type="datetimeFigureOut">
               <a:rPr lang="pt-BR" smtClean="0"/>
-              <a:t>05/12/2022</a:t>
+              <a:t>12/12/2022</a:t>
             </a:fld>
             <a:endParaRPr lang="pt-BR"/>
           </a:p>
@@ -1446,7 +1446,7 @@
           <a:p>
             <a:fld id="{52231B9D-E9F6-4612-9B82-E89961B389AC}" type="datetimeFigureOut">
               <a:rPr lang="pt-BR" smtClean="0"/>
-              <a:t>05/12/2022</a:t>
+              <a:t>12/12/2022</a:t>
             </a:fld>
             <a:endParaRPr lang="pt-BR"/>
           </a:p>
@@ -1678,7 +1678,7 @@
           <a:p>
             <a:fld id="{52231B9D-E9F6-4612-9B82-E89961B389AC}" type="datetimeFigureOut">
               <a:rPr lang="pt-BR" smtClean="0"/>
-              <a:t>05/12/2022</a:t>
+              <a:t>12/12/2022</a:t>
             </a:fld>
             <a:endParaRPr lang="pt-BR"/>
           </a:p>
@@ -2045,7 +2045,7 @@
           <a:p>
             <a:fld id="{52231B9D-E9F6-4612-9B82-E89961B389AC}" type="datetimeFigureOut">
               <a:rPr lang="pt-BR" smtClean="0"/>
-              <a:t>05/12/2022</a:t>
+              <a:t>12/12/2022</a:t>
             </a:fld>
             <a:endParaRPr lang="pt-BR"/>
           </a:p>
@@ -2163,7 +2163,7 @@
           <a:p>
             <a:fld id="{52231B9D-E9F6-4612-9B82-E89961B389AC}" type="datetimeFigureOut">
               <a:rPr lang="pt-BR" smtClean="0"/>
-              <a:t>05/12/2022</a:t>
+              <a:t>12/12/2022</a:t>
             </a:fld>
             <a:endParaRPr lang="pt-BR"/>
           </a:p>
@@ -2258,7 +2258,7 @@
           <a:p>
             <a:fld id="{52231B9D-E9F6-4612-9B82-E89961B389AC}" type="datetimeFigureOut">
               <a:rPr lang="pt-BR" smtClean="0"/>
-              <a:t>05/12/2022</a:t>
+              <a:t>12/12/2022</a:t>
             </a:fld>
             <a:endParaRPr lang="pt-BR"/>
           </a:p>
@@ -2535,7 +2535,7 @@
           <a:p>
             <a:fld id="{52231B9D-E9F6-4612-9B82-E89961B389AC}" type="datetimeFigureOut">
               <a:rPr lang="pt-BR" smtClean="0"/>
-              <a:t>05/12/2022</a:t>
+              <a:t>12/12/2022</a:t>
             </a:fld>
             <a:endParaRPr lang="pt-BR"/>
           </a:p>
@@ -2788,7 +2788,7 @@
           <a:p>
             <a:fld id="{52231B9D-E9F6-4612-9B82-E89961B389AC}" type="datetimeFigureOut">
               <a:rPr lang="pt-BR" smtClean="0"/>
-              <a:t>05/12/2022</a:t>
+              <a:t>12/12/2022</a:t>
             </a:fld>
             <a:endParaRPr lang="pt-BR"/>
           </a:p>
@@ -3001,7 +3001,7 @@
           <a:p>
             <a:fld id="{52231B9D-E9F6-4612-9B82-E89961B389AC}" type="datetimeFigureOut">
               <a:rPr lang="pt-BR" smtClean="0"/>
-              <a:t>05/12/2022</a:t>
+              <a:t>12/12/2022</a:t>
             </a:fld>
             <a:endParaRPr lang="pt-BR"/>
           </a:p>
@@ -3665,17 +3665,7 @@
                   </a:schemeClr>
                 </a:solidFill>
               </a:rPr>
-              <a:t>04</a:t>
-            </a:r>
-            <a:r>
-              <a:rPr lang="pt-BR" sz="1600" dirty="0" smtClean="0">
-                <a:solidFill>
-                  <a:schemeClr val="bg2">
-                    <a:lumMod val="90000"/>
-                  </a:schemeClr>
-                </a:solidFill>
-              </a:rPr>
-              <a:t>/12/2022</a:t>
+              <a:t>01/01/2023</a:t>
             </a:r>
             <a:endParaRPr lang="pt-BR" sz="1600" dirty="0">
               <a:solidFill>

</xml_diff>

<commit_message>
reformat E/S CLIDEV, data/hora do sistema
</commit_message>
<xml_diff>
--- a/tempimento.pptx
+++ b/tempimento.pptx
@@ -197,7 +197,7 @@
           <a:p>
             <a:fld id="{A584E3A2-E8EA-4705-A613-CFE9F6F5D3B4}" type="datetimeFigureOut">
               <a:rPr lang="pt-BR" smtClean="0"/>
-              <a:t>09/01/2023</a:t>
+              <a:t>17/01/2023</a:t>
             </a:fld>
             <a:endParaRPr lang="pt-BR"/>
           </a:p>
@@ -680,7 +680,7 @@
           <a:p>
             <a:fld id="{52231B9D-E9F6-4612-9B82-E89961B389AC}" type="datetimeFigureOut">
               <a:rPr lang="pt-BR" smtClean="0"/>
-              <a:t>09/01/2023</a:t>
+              <a:t>17/01/2023</a:t>
             </a:fld>
             <a:endParaRPr lang="pt-BR"/>
           </a:p>
@@ -850,7 +850,7 @@
           <a:p>
             <a:fld id="{52231B9D-E9F6-4612-9B82-E89961B389AC}" type="datetimeFigureOut">
               <a:rPr lang="pt-BR" smtClean="0"/>
-              <a:t>09/01/2023</a:t>
+              <a:t>17/01/2023</a:t>
             </a:fld>
             <a:endParaRPr lang="pt-BR"/>
           </a:p>
@@ -1030,7 +1030,7 @@
           <a:p>
             <a:fld id="{52231B9D-E9F6-4612-9B82-E89961B389AC}" type="datetimeFigureOut">
               <a:rPr lang="pt-BR" smtClean="0"/>
-              <a:t>09/01/2023</a:t>
+              <a:t>17/01/2023</a:t>
             </a:fld>
             <a:endParaRPr lang="pt-BR"/>
           </a:p>
@@ -1200,7 +1200,7 @@
           <a:p>
             <a:fld id="{52231B9D-E9F6-4612-9B82-E89961B389AC}" type="datetimeFigureOut">
               <a:rPr lang="pt-BR" smtClean="0"/>
-              <a:t>09/01/2023</a:t>
+              <a:t>17/01/2023</a:t>
             </a:fld>
             <a:endParaRPr lang="pt-BR"/>
           </a:p>
@@ -1446,7 +1446,7 @@
           <a:p>
             <a:fld id="{52231B9D-E9F6-4612-9B82-E89961B389AC}" type="datetimeFigureOut">
               <a:rPr lang="pt-BR" smtClean="0"/>
-              <a:t>09/01/2023</a:t>
+              <a:t>17/01/2023</a:t>
             </a:fld>
             <a:endParaRPr lang="pt-BR"/>
           </a:p>
@@ -1678,7 +1678,7 @@
           <a:p>
             <a:fld id="{52231B9D-E9F6-4612-9B82-E89961B389AC}" type="datetimeFigureOut">
               <a:rPr lang="pt-BR" smtClean="0"/>
-              <a:t>09/01/2023</a:t>
+              <a:t>17/01/2023</a:t>
             </a:fld>
             <a:endParaRPr lang="pt-BR"/>
           </a:p>
@@ -2045,7 +2045,7 @@
           <a:p>
             <a:fld id="{52231B9D-E9F6-4612-9B82-E89961B389AC}" type="datetimeFigureOut">
               <a:rPr lang="pt-BR" smtClean="0"/>
-              <a:t>09/01/2023</a:t>
+              <a:t>17/01/2023</a:t>
             </a:fld>
             <a:endParaRPr lang="pt-BR"/>
           </a:p>
@@ -2163,7 +2163,7 @@
           <a:p>
             <a:fld id="{52231B9D-E9F6-4612-9B82-E89961B389AC}" type="datetimeFigureOut">
               <a:rPr lang="pt-BR" smtClean="0"/>
-              <a:t>09/01/2023</a:t>
+              <a:t>17/01/2023</a:t>
             </a:fld>
             <a:endParaRPr lang="pt-BR"/>
           </a:p>
@@ -2258,7 +2258,7 @@
           <a:p>
             <a:fld id="{52231B9D-E9F6-4612-9B82-E89961B389AC}" type="datetimeFigureOut">
               <a:rPr lang="pt-BR" smtClean="0"/>
-              <a:t>09/01/2023</a:t>
+              <a:t>17/01/2023</a:t>
             </a:fld>
             <a:endParaRPr lang="pt-BR"/>
           </a:p>
@@ -2535,7 +2535,7 @@
           <a:p>
             <a:fld id="{52231B9D-E9F6-4612-9B82-E89961B389AC}" type="datetimeFigureOut">
               <a:rPr lang="pt-BR" smtClean="0"/>
-              <a:t>09/01/2023</a:t>
+              <a:t>17/01/2023</a:t>
             </a:fld>
             <a:endParaRPr lang="pt-BR"/>
           </a:p>
@@ -2788,7 +2788,7 @@
           <a:p>
             <a:fld id="{52231B9D-E9F6-4612-9B82-E89961B389AC}" type="datetimeFigureOut">
               <a:rPr lang="pt-BR" smtClean="0"/>
-              <a:t>09/01/2023</a:t>
+              <a:t>17/01/2023</a:t>
             </a:fld>
             <a:endParaRPr lang="pt-BR"/>
           </a:p>
@@ -3001,7 +3001,7 @@
           <a:p>
             <a:fld id="{52231B9D-E9F6-4612-9B82-E89961B389AC}" type="datetimeFigureOut">
               <a:rPr lang="pt-BR" smtClean="0"/>
-              <a:t>09/01/2023</a:t>
+              <a:t>17/01/2023</a:t>
             </a:fld>
             <a:endParaRPr lang="pt-BR"/>
           </a:p>
@@ -3665,7 +3665,17 @@
                   </a:schemeClr>
                 </a:solidFill>
               </a:rPr>
-              <a:t>08/01/2023</a:t>
+              <a:t>15</a:t>
+            </a:r>
+            <a:r>
+              <a:rPr lang="pt-BR" sz="1600" dirty="0" smtClean="0">
+                <a:solidFill>
+                  <a:schemeClr val="bg2">
+                    <a:lumMod val="90000"/>
+                  </a:schemeClr>
+                </a:solidFill>
+              </a:rPr>
+              <a:t>/01/2023</a:t>
             </a:r>
             <a:endParaRPr lang="pt-BR" sz="1600" dirty="0">
               <a:solidFill>

</xml_diff>

<commit_message>
campo data/hora com concat ainda com erro
</commit_message>
<xml_diff>
--- a/tempimento.pptx
+++ b/tempimento.pptx
@@ -197,7 +197,7 @@
           <a:p>
             <a:fld id="{A584E3A2-E8EA-4705-A613-CFE9F6F5D3B4}" type="datetimeFigureOut">
               <a:rPr lang="pt-BR" smtClean="0"/>
-              <a:t>17/01/2023</a:t>
+              <a:t>23/01/2023</a:t>
             </a:fld>
             <a:endParaRPr lang="pt-BR"/>
           </a:p>
@@ -680,7 +680,7 @@
           <a:p>
             <a:fld id="{52231B9D-E9F6-4612-9B82-E89961B389AC}" type="datetimeFigureOut">
               <a:rPr lang="pt-BR" smtClean="0"/>
-              <a:t>17/01/2023</a:t>
+              <a:t>23/01/2023</a:t>
             </a:fld>
             <a:endParaRPr lang="pt-BR"/>
           </a:p>
@@ -850,7 +850,7 @@
           <a:p>
             <a:fld id="{52231B9D-E9F6-4612-9B82-E89961B389AC}" type="datetimeFigureOut">
               <a:rPr lang="pt-BR" smtClean="0"/>
-              <a:t>17/01/2023</a:t>
+              <a:t>23/01/2023</a:t>
             </a:fld>
             <a:endParaRPr lang="pt-BR"/>
           </a:p>
@@ -1030,7 +1030,7 @@
           <a:p>
             <a:fld id="{52231B9D-E9F6-4612-9B82-E89961B389AC}" type="datetimeFigureOut">
               <a:rPr lang="pt-BR" smtClean="0"/>
-              <a:t>17/01/2023</a:t>
+              <a:t>23/01/2023</a:t>
             </a:fld>
             <a:endParaRPr lang="pt-BR"/>
           </a:p>
@@ -1200,7 +1200,7 @@
           <a:p>
             <a:fld id="{52231B9D-E9F6-4612-9B82-E89961B389AC}" type="datetimeFigureOut">
               <a:rPr lang="pt-BR" smtClean="0"/>
-              <a:t>17/01/2023</a:t>
+              <a:t>23/01/2023</a:t>
             </a:fld>
             <a:endParaRPr lang="pt-BR"/>
           </a:p>
@@ -1446,7 +1446,7 @@
           <a:p>
             <a:fld id="{52231B9D-E9F6-4612-9B82-E89961B389AC}" type="datetimeFigureOut">
               <a:rPr lang="pt-BR" smtClean="0"/>
-              <a:t>17/01/2023</a:t>
+              <a:t>23/01/2023</a:t>
             </a:fld>
             <a:endParaRPr lang="pt-BR"/>
           </a:p>
@@ -1678,7 +1678,7 @@
           <a:p>
             <a:fld id="{52231B9D-E9F6-4612-9B82-E89961B389AC}" type="datetimeFigureOut">
               <a:rPr lang="pt-BR" smtClean="0"/>
-              <a:t>17/01/2023</a:t>
+              <a:t>23/01/2023</a:t>
             </a:fld>
             <a:endParaRPr lang="pt-BR"/>
           </a:p>
@@ -2045,7 +2045,7 @@
           <a:p>
             <a:fld id="{52231B9D-E9F6-4612-9B82-E89961B389AC}" type="datetimeFigureOut">
               <a:rPr lang="pt-BR" smtClean="0"/>
-              <a:t>17/01/2023</a:t>
+              <a:t>23/01/2023</a:t>
             </a:fld>
             <a:endParaRPr lang="pt-BR"/>
           </a:p>
@@ -2163,7 +2163,7 @@
           <a:p>
             <a:fld id="{52231B9D-E9F6-4612-9B82-E89961B389AC}" type="datetimeFigureOut">
               <a:rPr lang="pt-BR" smtClean="0"/>
-              <a:t>17/01/2023</a:t>
+              <a:t>23/01/2023</a:t>
             </a:fld>
             <a:endParaRPr lang="pt-BR"/>
           </a:p>
@@ -2258,7 +2258,7 @@
           <a:p>
             <a:fld id="{52231B9D-E9F6-4612-9B82-E89961B389AC}" type="datetimeFigureOut">
               <a:rPr lang="pt-BR" smtClean="0"/>
-              <a:t>17/01/2023</a:t>
+              <a:t>23/01/2023</a:t>
             </a:fld>
             <a:endParaRPr lang="pt-BR"/>
           </a:p>
@@ -2535,7 +2535,7 @@
           <a:p>
             <a:fld id="{52231B9D-E9F6-4612-9B82-E89961B389AC}" type="datetimeFigureOut">
               <a:rPr lang="pt-BR" smtClean="0"/>
-              <a:t>17/01/2023</a:t>
+              <a:t>23/01/2023</a:t>
             </a:fld>
             <a:endParaRPr lang="pt-BR"/>
           </a:p>
@@ -2788,7 +2788,7 @@
           <a:p>
             <a:fld id="{52231B9D-E9F6-4612-9B82-E89961B389AC}" type="datetimeFigureOut">
               <a:rPr lang="pt-BR" smtClean="0"/>
-              <a:t>17/01/2023</a:t>
+              <a:t>23/01/2023</a:t>
             </a:fld>
             <a:endParaRPr lang="pt-BR"/>
           </a:p>
@@ -3001,7 +3001,7 @@
           <a:p>
             <a:fld id="{52231B9D-E9F6-4612-9B82-E89961B389AC}" type="datetimeFigureOut">
               <a:rPr lang="pt-BR" smtClean="0"/>
-              <a:t>17/01/2023</a:t>
+              <a:t>23/01/2023</a:t>
             </a:fld>
             <a:endParaRPr lang="pt-BR"/>
           </a:p>
@@ -3665,7 +3665,7 @@
                   </a:schemeClr>
                 </a:solidFill>
               </a:rPr>
-              <a:t>15</a:t>
+              <a:t>22</a:t>
             </a:r>
             <a:r>
               <a:rPr lang="pt-BR" sz="1600" dirty="0" smtClean="0">

</xml_diff>

<commit_message>
data/hora chegada de viagem para data/hora do sistema
</commit_message>
<xml_diff>
--- a/tempimento.pptx
+++ b/tempimento.pptx
@@ -197,7 +197,7 @@
           <a:p>
             <a:fld id="{A584E3A2-E8EA-4705-A613-CFE9F6F5D3B4}" type="datetimeFigureOut">
               <a:rPr lang="pt-BR" smtClean="0"/>
-              <a:t>23/01/2023</a:t>
+              <a:t>30/01/2023</a:t>
             </a:fld>
             <a:endParaRPr lang="pt-BR"/>
           </a:p>
@@ -680,7 +680,7 @@
           <a:p>
             <a:fld id="{52231B9D-E9F6-4612-9B82-E89961B389AC}" type="datetimeFigureOut">
               <a:rPr lang="pt-BR" smtClean="0"/>
-              <a:t>23/01/2023</a:t>
+              <a:t>30/01/2023</a:t>
             </a:fld>
             <a:endParaRPr lang="pt-BR"/>
           </a:p>
@@ -850,7 +850,7 @@
           <a:p>
             <a:fld id="{52231B9D-E9F6-4612-9B82-E89961B389AC}" type="datetimeFigureOut">
               <a:rPr lang="pt-BR" smtClean="0"/>
-              <a:t>23/01/2023</a:t>
+              <a:t>30/01/2023</a:t>
             </a:fld>
             <a:endParaRPr lang="pt-BR"/>
           </a:p>
@@ -1030,7 +1030,7 @@
           <a:p>
             <a:fld id="{52231B9D-E9F6-4612-9B82-E89961B389AC}" type="datetimeFigureOut">
               <a:rPr lang="pt-BR" smtClean="0"/>
-              <a:t>23/01/2023</a:t>
+              <a:t>30/01/2023</a:t>
             </a:fld>
             <a:endParaRPr lang="pt-BR"/>
           </a:p>
@@ -1200,7 +1200,7 @@
           <a:p>
             <a:fld id="{52231B9D-E9F6-4612-9B82-E89961B389AC}" type="datetimeFigureOut">
               <a:rPr lang="pt-BR" smtClean="0"/>
-              <a:t>23/01/2023</a:t>
+              <a:t>30/01/2023</a:t>
             </a:fld>
             <a:endParaRPr lang="pt-BR"/>
           </a:p>
@@ -1446,7 +1446,7 @@
           <a:p>
             <a:fld id="{52231B9D-E9F6-4612-9B82-E89961B389AC}" type="datetimeFigureOut">
               <a:rPr lang="pt-BR" smtClean="0"/>
-              <a:t>23/01/2023</a:t>
+              <a:t>30/01/2023</a:t>
             </a:fld>
             <a:endParaRPr lang="pt-BR"/>
           </a:p>
@@ -1678,7 +1678,7 @@
           <a:p>
             <a:fld id="{52231B9D-E9F6-4612-9B82-E89961B389AC}" type="datetimeFigureOut">
               <a:rPr lang="pt-BR" smtClean="0"/>
-              <a:t>23/01/2023</a:t>
+              <a:t>30/01/2023</a:t>
             </a:fld>
             <a:endParaRPr lang="pt-BR"/>
           </a:p>
@@ -2045,7 +2045,7 @@
           <a:p>
             <a:fld id="{52231B9D-E9F6-4612-9B82-E89961B389AC}" type="datetimeFigureOut">
               <a:rPr lang="pt-BR" smtClean="0"/>
-              <a:t>23/01/2023</a:t>
+              <a:t>30/01/2023</a:t>
             </a:fld>
             <a:endParaRPr lang="pt-BR"/>
           </a:p>
@@ -2163,7 +2163,7 @@
           <a:p>
             <a:fld id="{52231B9D-E9F6-4612-9B82-E89961B389AC}" type="datetimeFigureOut">
               <a:rPr lang="pt-BR" smtClean="0"/>
-              <a:t>23/01/2023</a:t>
+              <a:t>30/01/2023</a:t>
             </a:fld>
             <a:endParaRPr lang="pt-BR"/>
           </a:p>
@@ -2258,7 +2258,7 @@
           <a:p>
             <a:fld id="{52231B9D-E9F6-4612-9B82-E89961B389AC}" type="datetimeFigureOut">
               <a:rPr lang="pt-BR" smtClean="0"/>
-              <a:t>23/01/2023</a:t>
+              <a:t>30/01/2023</a:t>
             </a:fld>
             <a:endParaRPr lang="pt-BR"/>
           </a:p>
@@ -2535,7 +2535,7 @@
           <a:p>
             <a:fld id="{52231B9D-E9F6-4612-9B82-E89961B389AC}" type="datetimeFigureOut">
               <a:rPr lang="pt-BR" smtClean="0"/>
-              <a:t>23/01/2023</a:t>
+              <a:t>30/01/2023</a:t>
             </a:fld>
             <a:endParaRPr lang="pt-BR"/>
           </a:p>
@@ -2788,7 +2788,7 @@
           <a:p>
             <a:fld id="{52231B9D-E9F6-4612-9B82-E89961B389AC}" type="datetimeFigureOut">
               <a:rPr lang="pt-BR" smtClean="0"/>
-              <a:t>23/01/2023</a:t>
+              <a:t>30/01/2023</a:t>
             </a:fld>
             <a:endParaRPr lang="pt-BR"/>
           </a:p>
@@ -3001,7 +3001,7 @@
           <a:p>
             <a:fld id="{52231B9D-E9F6-4612-9B82-E89961B389AC}" type="datetimeFigureOut">
               <a:rPr lang="pt-BR" smtClean="0"/>
-              <a:t>23/01/2023</a:t>
+              <a:t>30/01/2023</a:t>
             </a:fld>
             <a:endParaRPr lang="pt-BR"/>
           </a:p>
@@ -3658,17 +3658,17 @@
           <a:lstStyle/>
           <a:p>
             <a:r>
-              <a:rPr lang="pt-BR" sz="1600" dirty="0" smtClean="0">
+              <a:rPr lang="pt-BR" sz="1600" smtClean="0">
                 <a:solidFill>
                   <a:schemeClr val="bg2">
                     <a:lumMod val="90000"/>
                   </a:schemeClr>
                 </a:solidFill>
               </a:rPr>
-              <a:t>22</a:t>
-            </a:r>
-            <a:r>
-              <a:rPr lang="pt-BR" sz="1600" dirty="0" smtClean="0">
+              <a:t>29</a:t>
+            </a:r>
+            <a:r>
+              <a:rPr lang="pt-BR" sz="1600" smtClean="0">
                 <a:solidFill>
                   <a:schemeClr val="bg2">
                     <a:lumMod val="90000"/>

</xml_diff>

<commit_message>
número do movimento interno de estoque
</commit_message>
<xml_diff>
--- a/tempimento.pptx
+++ b/tempimento.pptx
@@ -197,7 +197,7 @@
           <a:p>
             <a:fld id="{A584E3A2-E8EA-4705-A613-CFE9F6F5D3B4}" type="datetimeFigureOut">
               <a:rPr lang="pt-BR" smtClean="0"/>
-              <a:t>30/01/2023</a:t>
+              <a:t>07/02/2023</a:t>
             </a:fld>
             <a:endParaRPr lang="pt-BR"/>
           </a:p>
@@ -680,7 +680,7 @@
           <a:p>
             <a:fld id="{52231B9D-E9F6-4612-9B82-E89961B389AC}" type="datetimeFigureOut">
               <a:rPr lang="pt-BR" smtClean="0"/>
-              <a:t>30/01/2023</a:t>
+              <a:t>07/02/2023</a:t>
             </a:fld>
             <a:endParaRPr lang="pt-BR"/>
           </a:p>
@@ -850,7 +850,7 @@
           <a:p>
             <a:fld id="{52231B9D-E9F6-4612-9B82-E89961B389AC}" type="datetimeFigureOut">
               <a:rPr lang="pt-BR" smtClean="0"/>
-              <a:t>30/01/2023</a:t>
+              <a:t>07/02/2023</a:t>
             </a:fld>
             <a:endParaRPr lang="pt-BR"/>
           </a:p>
@@ -1030,7 +1030,7 @@
           <a:p>
             <a:fld id="{52231B9D-E9F6-4612-9B82-E89961B389AC}" type="datetimeFigureOut">
               <a:rPr lang="pt-BR" smtClean="0"/>
-              <a:t>30/01/2023</a:t>
+              <a:t>07/02/2023</a:t>
             </a:fld>
             <a:endParaRPr lang="pt-BR"/>
           </a:p>
@@ -1200,7 +1200,7 @@
           <a:p>
             <a:fld id="{52231B9D-E9F6-4612-9B82-E89961B389AC}" type="datetimeFigureOut">
               <a:rPr lang="pt-BR" smtClean="0"/>
-              <a:t>30/01/2023</a:t>
+              <a:t>07/02/2023</a:t>
             </a:fld>
             <a:endParaRPr lang="pt-BR"/>
           </a:p>
@@ -1446,7 +1446,7 @@
           <a:p>
             <a:fld id="{52231B9D-E9F6-4612-9B82-E89961B389AC}" type="datetimeFigureOut">
               <a:rPr lang="pt-BR" smtClean="0"/>
-              <a:t>30/01/2023</a:t>
+              <a:t>07/02/2023</a:t>
             </a:fld>
             <a:endParaRPr lang="pt-BR"/>
           </a:p>
@@ -1678,7 +1678,7 @@
           <a:p>
             <a:fld id="{52231B9D-E9F6-4612-9B82-E89961B389AC}" type="datetimeFigureOut">
               <a:rPr lang="pt-BR" smtClean="0"/>
-              <a:t>30/01/2023</a:t>
+              <a:t>07/02/2023</a:t>
             </a:fld>
             <a:endParaRPr lang="pt-BR"/>
           </a:p>
@@ -2045,7 +2045,7 @@
           <a:p>
             <a:fld id="{52231B9D-E9F6-4612-9B82-E89961B389AC}" type="datetimeFigureOut">
               <a:rPr lang="pt-BR" smtClean="0"/>
-              <a:t>30/01/2023</a:t>
+              <a:t>07/02/2023</a:t>
             </a:fld>
             <a:endParaRPr lang="pt-BR"/>
           </a:p>
@@ -2163,7 +2163,7 @@
           <a:p>
             <a:fld id="{52231B9D-E9F6-4612-9B82-E89961B389AC}" type="datetimeFigureOut">
               <a:rPr lang="pt-BR" smtClean="0"/>
-              <a:t>30/01/2023</a:t>
+              <a:t>07/02/2023</a:t>
             </a:fld>
             <a:endParaRPr lang="pt-BR"/>
           </a:p>
@@ -2258,7 +2258,7 @@
           <a:p>
             <a:fld id="{52231B9D-E9F6-4612-9B82-E89961B389AC}" type="datetimeFigureOut">
               <a:rPr lang="pt-BR" smtClean="0"/>
-              <a:t>30/01/2023</a:t>
+              <a:t>07/02/2023</a:t>
             </a:fld>
             <a:endParaRPr lang="pt-BR"/>
           </a:p>
@@ -2535,7 +2535,7 @@
           <a:p>
             <a:fld id="{52231B9D-E9F6-4612-9B82-E89961B389AC}" type="datetimeFigureOut">
               <a:rPr lang="pt-BR" smtClean="0"/>
-              <a:t>30/01/2023</a:t>
+              <a:t>07/02/2023</a:t>
             </a:fld>
             <a:endParaRPr lang="pt-BR"/>
           </a:p>
@@ -2788,7 +2788,7 @@
           <a:p>
             <a:fld id="{52231B9D-E9F6-4612-9B82-E89961B389AC}" type="datetimeFigureOut">
               <a:rPr lang="pt-BR" smtClean="0"/>
-              <a:t>30/01/2023</a:t>
+              <a:t>07/02/2023</a:t>
             </a:fld>
             <a:endParaRPr lang="pt-BR"/>
           </a:p>
@@ -3001,7 +3001,7 @@
           <a:p>
             <a:fld id="{52231B9D-E9F6-4612-9B82-E89961B389AC}" type="datetimeFigureOut">
               <a:rPr lang="pt-BR" smtClean="0"/>
-              <a:t>30/01/2023</a:t>
+              <a:t>07/02/2023</a:t>
             </a:fld>
             <a:endParaRPr lang="pt-BR"/>
           </a:p>
@@ -3658,24 +3658,24 @@
           <a:lstStyle/>
           <a:p>
             <a:r>
-              <a:rPr lang="pt-BR" sz="1600" smtClean="0">
+              <a:rPr lang="pt-BR" sz="1600" dirty="0" smtClean="0">
                 <a:solidFill>
                   <a:schemeClr val="bg2">
                     <a:lumMod val="90000"/>
                   </a:schemeClr>
                 </a:solidFill>
               </a:rPr>
-              <a:t>29</a:t>
-            </a:r>
-            <a:r>
-              <a:rPr lang="pt-BR" sz="1600" smtClean="0">
+              <a:t>05</a:t>
+            </a:r>
+            <a:r>
+              <a:rPr lang="pt-BR" sz="1600" dirty="0" smtClean="0">
                 <a:solidFill>
                   <a:schemeClr val="bg2">
                     <a:lumMod val="90000"/>
                   </a:schemeClr>
                 </a:solidFill>
               </a:rPr>
-              <a:t>/01/2023</a:t>
+              <a:t>/02/2023</a:t>
             </a:r>
             <a:endParaRPr lang="pt-BR" sz="1600" dirty="0">
               <a:solidFill>

</xml_diff>

<commit_message>
km ini e fim são informações da viagem
</commit_message>
<xml_diff>
--- a/tempimento.pptx
+++ b/tempimento.pptx
@@ -11,7 +11,7 @@
     <p:sldId id="256" r:id="rId2"/>
   </p:sldIdLst>
   <p:sldSz cx="12192000" cy="6858000"/>
-  <p:notesSz cx="7104063" cy="10234613"/>
+  <p:notesSz cx="6889750" cy="9671050"/>
   <p:defaultTextStyle>
     <a:defPPr>
       <a:defRPr lang="pt-BR"/>
@@ -150,17 +150,17 @@
         <p:spPr>
           <a:xfrm>
             <a:off x="5" y="1"/>
-            <a:ext cx="3078851" cy="512763"/>
+            <a:ext cx="2985969" cy="484528"/>
           </a:xfrm>
           <a:prstGeom prst="rect">
             <a:avLst/>
           </a:prstGeom>
         </p:spPr>
         <p:txBody>
-          <a:bodyPr vert="horz" lIns="91409" tIns="45706" rIns="91409" bIns="45706" rtlCol="0"/>
+          <a:bodyPr vert="horz" lIns="87305" tIns="43654" rIns="87305" bIns="43654" rtlCol="0"/>
           <a:lstStyle>
             <a:lvl1pPr algn="l">
-              <a:defRPr sz="1200"/>
+              <a:defRPr sz="1100"/>
             </a:lvl1pPr>
           </a:lstStyle>
           <a:p>
@@ -180,24 +180,24 @@
         </p:nvSpPr>
         <p:spPr>
           <a:xfrm>
-            <a:off x="4023628" y="1"/>
-            <a:ext cx="3078851" cy="512763"/>
+            <a:off x="3902245" y="1"/>
+            <a:ext cx="2985969" cy="484528"/>
           </a:xfrm>
           <a:prstGeom prst="rect">
             <a:avLst/>
           </a:prstGeom>
         </p:spPr>
         <p:txBody>
-          <a:bodyPr vert="horz" lIns="91409" tIns="45706" rIns="91409" bIns="45706" rtlCol="0"/>
+          <a:bodyPr vert="horz" lIns="87305" tIns="43654" rIns="87305" bIns="43654" rtlCol="0"/>
           <a:lstStyle>
             <a:lvl1pPr algn="r">
-              <a:defRPr sz="1200"/>
+              <a:defRPr sz="1100"/>
             </a:lvl1pPr>
           </a:lstStyle>
           <a:p>
             <a:fld id="{A584E3A2-E8EA-4705-A613-CFE9F6F5D3B4}" type="datetimeFigureOut">
               <a:rPr lang="pt-BR" smtClean="0"/>
-              <a:t>07/02/2023</a:t>
+              <a:t>15/02/2023</a:t>
             </a:fld>
             <a:endParaRPr lang="pt-BR"/>
           </a:p>
@@ -215,8 +215,8 @@
         </p:nvSpPr>
         <p:spPr>
           <a:xfrm>
-            <a:off x="482600" y="1279525"/>
-            <a:ext cx="6138863" cy="3454400"/>
+            <a:off x="542925" y="1209675"/>
+            <a:ext cx="5803900" cy="3263900"/>
           </a:xfrm>
           <a:prstGeom prst="rect">
             <a:avLst/>
@@ -229,7 +229,7 @@
           </a:ln>
         </p:spPr>
         <p:txBody>
-          <a:bodyPr vert="horz" lIns="91409" tIns="45706" rIns="91409" bIns="45706" rtlCol="0" anchor="ctr"/>
+          <a:bodyPr vert="horz" lIns="87305" tIns="43654" rIns="87305" bIns="43654" rtlCol="0" anchor="ctr"/>
           <a:lstStyle/>
           <a:p>
             <a:endParaRPr lang="pt-BR"/>
@@ -248,15 +248,15 @@
         </p:nvSpPr>
         <p:spPr>
           <a:xfrm>
-            <a:off x="709774" y="4926015"/>
-            <a:ext cx="5684521" cy="4029075"/>
+            <a:off x="688362" y="4654767"/>
+            <a:ext cx="5513032" cy="3807216"/>
           </a:xfrm>
           <a:prstGeom prst="rect">
             <a:avLst/>
           </a:prstGeom>
         </p:spPr>
         <p:txBody>
-          <a:bodyPr vert="horz" lIns="91409" tIns="45706" rIns="91409" bIns="45706" rtlCol="0"/>
+          <a:bodyPr vert="horz" lIns="87305" tIns="43654" rIns="87305" bIns="43654" rtlCol="0"/>
           <a:lstStyle/>
           <a:p>
             <a:pPr lvl="0"/>
@@ -308,18 +308,18 @@
         </p:nvSpPr>
         <p:spPr>
           <a:xfrm>
-            <a:off x="5" y="9721851"/>
-            <a:ext cx="3078851" cy="512763"/>
+            <a:off x="5" y="9186523"/>
+            <a:ext cx="2985969" cy="484528"/>
           </a:xfrm>
           <a:prstGeom prst="rect">
             <a:avLst/>
           </a:prstGeom>
         </p:spPr>
         <p:txBody>
-          <a:bodyPr vert="horz" lIns="91409" tIns="45706" rIns="91409" bIns="45706" rtlCol="0" anchor="b"/>
+          <a:bodyPr vert="horz" lIns="87305" tIns="43654" rIns="87305" bIns="43654" rtlCol="0" anchor="b"/>
           <a:lstStyle>
             <a:lvl1pPr algn="l">
-              <a:defRPr sz="1200"/>
+              <a:defRPr sz="1100"/>
             </a:lvl1pPr>
           </a:lstStyle>
           <a:p>
@@ -339,18 +339,18 @@
         </p:nvSpPr>
         <p:spPr>
           <a:xfrm>
-            <a:off x="4023628" y="9721851"/>
-            <a:ext cx="3078851" cy="512763"/>
+            <a:off x="3902245" y="9186523"/>
+            <a:ext cx="2985969" cy="484528"/>
           </a:xfrm>
           <a:prstGeom prst="rect">
             <a:avLst/>
           </a:prstGeom>
         </p:spPr>
         <p:txBody>
-          <a:bodyPr vert="horz" lIns="91409" tIns="45706" rIns="91409" bIns="45706" rtlCol="0" anchor="b"/>
+          <a:bodyPr vert="horz" lIns="87305" tIns="43654" rIns="87305" bIns="43654" rtlCol="0" anchor="b"/>
           <a:lstStyle>
             <a:lvl1pPr algn="r">
-              <a:defRPr sz="1200"/>
+              <a:defRPr sz="1100"/>
             </a:lvl1pPr>
           </a:lstStyle>
           <a:p>
@@ -680,7 +680,7 @@
           <a:p>
             <a:fld id="{52231B9D-E9F6-4612-9B82-E89961B389AC}" type="datetimeFigureOut">
               <a:rPr lang="pt-BR" smtClean="0"/>
-              <a:t>07/02/2023</a:t>
+              <a:t>15/02/2023</a:t>
             </a:fld>
             <a:endParaRPr lang="pt-BR"/>
           </a:p>
@@ -850,7 +850,7 @@
           <a:p>
             <a:fld id="{52231B9D-E9F6-4612-9B82-E89961B389AC}" type="datetimeFigureOut">
               <a:rPr lang="pt-BR" smtClean="0"/>
-              <a:t>07/02/2023</a:t>
+              <a:t>15/02/2023</a:t>
             </a:fld>
             <a:endParaRPr lang="pt-BR"/>
           </a:p>
@@ -1030,7 +1030,7 @@
           <a:p>
             <a:fld id="{52231B9D-E9F6-4612-9B82-E89961B389AC}" type="datetimeFigureOut">
               <a:rPr lang="pt-BR" smtClean="0"/>
-              <a:t>07/02/2023</a:t>
+              <a:t>15/02/2023</a:t>
             </a:fld>
             <a:endParaRPr lang="pt-BR"/>
           </a:p>
@@ -1200,7 +1200,7 @@
           <a:p>
             <a:fld id="{52231B9D-E9F6-4612-9B82-E89961B389AC}" type="datetimeFigureOut">
               <a:rPr lang="pt-BR" smtClean="0"/>
-              <a:t>07/02/2023</a:t>
+              <a:t>15/02/2023</a:t>
             </a:fld>
             <a:endParaRPr lang="pt-BR"/>
           </a:p>
@@ -1446,7 +1446,7 @@
           <a:p>
             <a:fld id="{52231B9D-E9F6-4612-9B82-E89961B389AC}" type="datetimeFigureOut">
               <a:rPr lang="pt-BR" smtClean="0"/>
-              <a:t>07/02/2023</a:t>
+              <a:t>15/02/2023</a:t>
             </a:fld>
             <a:endParaRPr lang="pt-BR"/>
           </a:p>
@@ -1678,7 +1678,7 @@
           <a:p>
             <a:fld id="{52231B9D-E9F6-4612-9B82-E89961B389AC}" type="datetimeFigureOut">
               <a:rPr lang="pt-BR" smtClean="0"/>
-              <a:t>07/02/2023</a:t>
+              <a:t>15/02/2023</a:t>
             </a:fld>
             <a:endParaRPr lang="pt-BR"/>
           </a:p>
@@ -2045,7 +2045,7 @@
           <a:p>
             <a:fld id="{52231B9D-E9F6-4612-9B82-E89961B389AC}" type="datetimeFigureOut">
               <a:rPr lang="pt-BR" smtClean="0"/>
-              <a:t>07/02/2023</a:t>
+              <a:t>15/02/2023</a:t>
             </a:fld>
             <a:endParaRPr lang="pt-BR"/>
           </a:p>
@@ -2163,7 +2163,7 @@
           <a:p>
             <a:fld id="{52231B9D-E9F6-4612-9B82-E89961B389AC}" type="datetimeFigureOut">
               <a:rPr lang="pt-BR" smtClean="0"/>
-              <a:t>07/02/2023</a:t>
+              <a:t>15/02/2023</a:t>
             </a:fld>
             <a:endParaRPr lang="pt-BR"/>
           </a:p>
@@ -2258,7 +2258,7 @@
           <a:p>
             <a:fld id="{52231B9D-E9F6-4612-9B82-E89961B389AC}" type="datetimeFigureOut">
               <a:rPr lang="pt-BR" smtClean="0"/>
-              <a:t>07/02/2023</a:t>
+              <a:t>15/02/2023</a:t>
             </a:fld>
             <a:endParaRPr lang="pt-BR"/>
           </a:p>
@@ -2535,7 +2535,7 @@
           <a:p>
             <a:fld id="{52231B9D-E9F6-4612-9B82-E89961B389AC}" type="datetimeFigureOut">
               <a:rPr lang="pt-BR" smtClean="0"/>
-              <a:t>07/02/2023</a:t>
+              <a:t>15/02/2023</a:t>
             </a:fld>
             <a:endParaRPr lang="pt-BR"/>
           </a:p>
@@ -2788,7 +2788,7 @@
           <a:p>
             <a:fld id="{52231B9D-E9F6-4612-9B82-E89961B389AC}" type="datetimeFigureOut">
               <a:rPr lang="pt-BR" smtClean="0"/>
-              <a:t>07/02/2023</a:t>
+              <a:t>15/02/2023</a:t>
             </a:fld>
             <a:endParaRPr lang="pt-BR"/>
           </a:p>
@@ -3001,7 +3001,7 @@
           <a:p>
             <a:fld id="{52231B9D-E9F6-4612-9B82-E89961B389AC}" type="datetimeFigureOut">
               <a:rPr lang="pt-BR" smtClean="0"/>
-              <a:t>07/02/2023</a:t>
+              <a:t>15/02/2023</a:t>
             </a:fld>
             <a:endParaRPr lang="pt-BR"/>
           </a:p>
@@ -3658,24 +3658,14 @@
           <a:lstStyle/>
           <a:p>
             <a:r>
-              <a:rPr lang="pt-BR" sz="1600" dirty="0" smtClean="0">
+              <a:rPr lang="pt-BR" sz="1600" smtClean="0">
                 <a:solidFill>
                   <a:schemeClr val="bg2">
                     <a:lumMod val="90000"/>
                   </a:schemeClr>
                 </a:solidFill>
               </a:rPr>
-              <a:t>05</a:t>
-            </a:r>
-            <a:r>
-              <a:rPr lang="pt-BR" sz="1600" dirty="0" smtClean="0">
-                <a:solidFill>
-                  <a:schemeClr val="bg2">
-                    <a:lumMod val="90000"/>
-                  </a:schemeClr>
-                </a:solidFill>
-              </a:rPr>
-              <a:t>/02/2023</a:t>
+              <a:t>19/02/2023</a:t>
             </a:r>
             <a:endParaRPr lang="pt-BR" sz="1600" dirty="0">
               <a:solidFill>

</xml_diff>

<commit_message>
erro na carga; consulta compras devolução muito longa
</commit_message>
<xml_diff>
--- a/tempimento.pptx
+++ b/tempimento.pptx
@@ -11,7 +11,7 @@
     <p:sldId id="256" r:id="rId2"/>
   </p:sldIdLst>
   <p:sldSz cx="12192000" cy="6858000"/>
-  <p:notesSz cx="6889750" cy="9671050"/>
+  <p:notesSz cx="7104063" cy="10234613"/>
   <p:defaultTextStyle>
     <a:defPPr>
       <a:defRPr lang="pt-BR"/>
@@ -149,18 +149,18 @@
         </p:nvSpPr>
         <p:spPr>
           <a:xfrm>
-            <a:off x="5" y="1"/>
-            <a:ext cx="2985969" cy="484528"/>
+            <a:off x="6" y="1"/>
+            <a:ext cx="3078851" cy="512763"/>
           </a:xfrm>
           <a:prstGeom prst="rect">
             <a:avLst/>
           </a:prstGeom>
         </p:spPr>
         <p:txBody>
-          <a:bodyPr vert="horz" lIns="87305" tIns="43654" rIns="87305" bIns="43654" rtlCol="0"/>
+          <a:bodyPr vert="horz" lIns="91400" tIns="45701" rIns="91400" bIns="45701" rtlCol="0"/>
           <a:lstStyle>
             <a:lvl1pPr algn="l">
-              <a:defRPr sz="1100"/>
+              <a:defRPr sz="1200"/>
             </a:lvl1pPr>
           </a:lstStyle>
           <a:p>
@@ -180,24 +180,24 @@
         </p:nvSpPr>
         <p:spPr>
           <a:xfrm>
-            <a:off x="3902245" y="1"/>
-            <a:ext cx="2985969" cy="484528"/>
+            <a:off x="4023629" y="1"/>
+            <a:ext cx="3078851" cy="512763"/>
           </a:xfrm>
           <a:prstGeom prst="rect">
             <a:avLst/>
           </a:prstGeom>
         </p:spPr>
         <p:txBody>
-          <a:bodyPr vert="horz" lIns="87305" tIns="43654" rIns="87305" bIns="43654" rtlCol="0"/>
+          <a:bodyPr vert="horz" lIns="91400" tIns="45701" rIns="91400" bIns="45701" rtlCol="0"/>
           <a:lstStyle>
             <a:lvl1pPr algn="r">
-              <a:defRPr sz="1100"/>
+              <a:defRPr sz="1200"/>
             </a:lvl1pPr>
           </a:lstStyle>
           <a:p>
             <a:fld id="{A584E3A2-E8EA-4705-A613-CFE9F6F5D3B4}" type="datetimeFigureOut">
               <a:rPr lang="pt-BR" smtClean="0"/>
-              <a:t>15/02/2023</a:t>
+              <a:t>27/02/2023</a:t>
             </a:fld>
             <a:endParaRPr lang="pt-BR"/>
           </a:p>
@@ -215,8 +215,8 @@
         </p:nvSpPr>
         <p:spPr>
           <a:xfrm>
-            <a:off x="542925" y="1209675"/>
-            <a:ext cx="5803900" cy="3263900"/>
+            <a:off x="482600" y="1279525"/>
+            <a:ext cx="6138863" cy="3454400"/>
           </a:xfrm>
           <a:prstGeom prst="rect">
             <a:avLst/>
@@ -229,7 +229,7 @@
           </a:ln>
         </p:spPr>
         <p:txBody>
-          <a:bodyPr vert="horz" lIns="87305" tIns="43654" rIns="87305" bIns="43654" rtlCol="0" anchor="ctr"/>
+          <a:bodyPr vert="horz" lIns="91400" tIns="45701" rIns="91400" bIns="45701" rtlCol="0" anchor="ctr"/>
           <a:lstStyle/>
           <a:p>
             <a:endParaRPr lang="pt-BR"/>
@@ -248,15 +248,15 @@
         </p:nvSpPr>
         <p:spPr>
           <a:xfrm>
-            <a:off x="688362" y="4654767"/>
-            <a:ext cx="5513032" cy="3807216"/>
+            <a:off x="709774" y="4926015"/>
+            <a:ext cx="5684521" cy="4029075"/>
           </a:xfrm>
           <a:prstGeom prst="rect">
             <a:avLst/>
           </a:prstGeom>
         </p:spPr>
         <p:txBody>
-          <a:bodyPr vert="horz" lIns="87305" tIns="43654" rIns="87305" bIns="43654" rtlCol="0"/>
+          <a:bodyPr vert="horz" lIns="91400" tIns="45701" rIns="91400" bIns="45701" rtlCol="0"/>
           <a:lstStyle/>
           <a:p>
             <a:pPr lvl="0"/>
@@ -308,18 +308,18 @@
         </p:nvSpPr>
         <p:spPr>
           <a:xfrm>
-            <a:off x="5" y="9186523"/>
-            <a:ext cx="2985969" cy="484528"/>
+            <a:off x="6" y="9721851"/>
+            <a:ext cx="3078851" cy="512763"/>
           </a:xfrm>
           <a:prstGeom prst="rect">
             <a:avLst/>
           </a:prstGeom>
         </p:spPr>
         <p:txBody>
-          <a:bodyPr vert="horz" lIns="87305" tIns="43654" rIns="87305" bIns="43654" rtlCol="0" anchor="b"/>
+          <a:bodyPr vert="horz" lIns="91400" tIns="45701" rIns="91400" bIns="45701" rtlCol="0" anchor="b"/>
           <a:lstStyle>
             <a:lvl1pPr algn="l">
-              <a:defRPr sz="1100"/>
+              <a:defRPr sz="1200"/>
             </a:lvl1pPr>
           </a:lstStyle>
           <a:p>
@@ -339,18 +339,18 @@
         </p:nvSpPr>
         <p:spPr>
           <a:xfrm>
-            <a:off x="3902245" y="9186523"/>
-            <a:ext cx="2985969" cy="484528"/>
+            <a:off x="4023629" y="9721851"/>
+            <a:ext cx="3078851" cy="512763"/>
           </a:xfrm>
           <a:prstGeom prst="rect">
             <a:avLst/>
           </a:prstGeom>
         </p:spPr>
         <p:txBody>
-          <a:bodyPr vert="horz" lIns="87305" tIns="43654" rIns="87305" bIns="43654" rtlCol="0" anchor="b"/>
+          <a:bodyPr vert="horz" lIns="91400" tIns="45701" rIns="91400" bIns="45701" rtlCol="0" anchor="b"/>
           <a:lstStyle>
             <a:lvl1pPr algn="r">
-              <a:defRPr sz="1100"/>
+              <a:defRPr sz="1200"/>
             </a:lvl1pPr>
           </a:lstStyle>
           <a:p>
@@ -680,7 +680,7 @@
           <a:p>
             <a:fld id="{52231B9D-E9F6-4612-9B82-E89961B389AC}" type="datetimeFigureOut">
               <a:rPr lang="pt-BR" smtClean="0"/>
-              <a:t>15/02/2023</a:t>
+              <a:t>27/02/2023</a:t>
             </a:fld>
             <a:endParaRPr lang="pt-BR"/>
           </a:p>
@@ -850,7 +850,7 @@
           <a:p>
             <a:fld id="{52231B9D-E9F6-4612-9B82-E89961B389AC}" type="datetimeFigureOut">
               <a:rPr lang="pt-BR" smtClean="0"/>
-              <a:t>15/02/2023</a:t>
+              <a:t>27/02/2023</a:t>
             </a:fld>
             <a:endParaRPr lang="pt-BR"/>
           </a:p>
@@ -1030,7 +1030,7 @@
           <a:p>
             <a:fld id="{52231B9D-E9F6-4612-9B82-E89961B389AC}" type="datetimeFigureOut">
               <a:rPr lang="pt-BR" smtClean="0"/>
-              <a:t>15/02/2023</a:t>
+              <a:t>27/02/2023</a:t>
             </a:fld>
             <a:endParaRPr lang="pt-BR"/>
           </a:p>
@@ -1200,7 +1200,7 @@
           <a:p>
             <a:fld id="{52231B9D-E9F6-4612-9B82-E89961B389AC}" type="datetimeFigureOut">
               <a:rPr lang="pt-BR" smtClean="0"/>
-              <a:t>15/02/2023</a:t>
+              <a:t>27/02/2023</a:t>
             </a:fld>
             <a:endParaRPr lang="pt-BR"/>
           </a:p>
@@ -1446,7 +1446,7 @@
           <a:p>
             <a:fld id="{52231B9D-E9F6-4612-9B82-E89961B389AC}" type="datetimeFigureOut">
               <a:rPr lang="pt-BR" smtClean="0"/>
-              <a:t>15/02/2023</a:t>
+              <a:t>27/02/2023</a:t>
             </a:fld>
             <a:endParaRPr lang="pt-BR"/>
           </a:p>
@@ -1678,7 +1678,7 @@
           <a:p>
             <a:fld id="{52231B9D-E9F6-4612-9B82-E89961B389AC}" type="datetimeFigureOut">
               <a:rPr lang="pt-BR" smtClean="0"/>
-              <a:t>15/02/2023</a:t>
+              <a:t>27/02/2023</a:t>
             </a:fld>
             <a:endParaRPr lang="pt-BR"/>
           </a:p>
@@ -2045,7 +2045,7 @@
           <a:p>
             <a:fld id="{52231B9D-E9F6-4612-9B82-E89961B389AC}" type="datetimeFigureOut">
               <a:rPr lang="pt-BR" smtClean="0"/>
-              <a:t>15/02/2023</a:t>
+              <a:t>27/02/2023</a:t>
             </a:fld>
             <a:endParaRPr lang="pt-BR"/>
           </a:p>
@@ -2163,7 +2163,7 @@
           <a:p>
             <a:fld id="{52231B9D-E9F6-4612-9B82-E89961B389AC}" type="datetimeFigureOut">
               <a:rPr lang="pt-BR" smtClean="0"/>
-              <a:t>15/02/2023</a:t>
+              <a:t>27/02/2023</a:t>
             </a:fld>
             <a:endParaRPr lang="pt-BR"/>
           </a:p>
@@ -2258,7 +2258,7 @@
           <a:p>
             <a:fld id="{52231B9D-E9F6-4612-9B82-E89961B389AC}" type="datetimeFigureOut">
               <a:rPr lang="pt-BR" smtClean="0"/>
-              <a:t>15/02/2023</a:t>
+              <a:t>27/02/2023</a:t>
             </a:fld>
             <a:endParaRPr lang="pt-BR"/>
           </a:p>
@@ -2535,7 +2535,7 @@
           <a:p>
             <a:fld id="{52231B9D-E9F6-4612-9B82-E89961B389AC}" type="datetimeFigureOut">
               <a:rPr lang="pt-BR" smtClean="0"/>
-              <a:t>15/02/2023</a:t>
+              <a:t>27/02/2023</a:t>
             </a:fld>
             <a:endParaRPr lang="pt-BR"/>
           </a:p>
@@ -2788,7 +2788,7 @@
           <a:p>
             <a:fld id="{52231B9D-E9F6-4612-9B82-E89961B389AC}" type="datetimeFigureOut">
               <a:rPr lang="pt-BR" smtClean="0"/>
-              <a:t>15/02/2023</a:t>
+              <a:t>27/02/2023</a:t>
             </a:fld>
             <a:endParaRPr lang="pt-BR"/>
           </a:p>
@@ -3001,7 +3001,7 @@
           <a:p>
             <a:fld id="{52231B9D-E9F6-4612-9B82-E89961B389AC}" type="datetimeFigureOut">
               <a:rPr lang="pt-BR" smtClean="0"/>
-              <a:t>15/02/2023</a:t>
+              <a:t>27/02/2023</a:t>
             </a:fld>
             <a:endParaRPr lang="pt-BR"/>
           </a:p>
@@ -3658,14 +3658,24 @@
           <a:lstStyle/>
           <a:p>
             <a:r>
-              <a:rPr lang="pt-BR" sz="1600" smtClean="0">
+              <a:rPr lang="pt-BR" sz="1600" dirty="0" smtClean="0">
                 <a:solidFill>
                   <a:schemeClr val="bg2">
                     <a:lumMod val="90000"/>
                   </a:schemeClr>
                 </a:solidFill>
               </a:rPr>
-              <a:t>19/02/2023</a:t>
+              <a:t>26</a:t>
+            </a:r>
+            <a:r>
+              <a:rPr lang="pt-BR" sz="1600" dirty="0" smtClean="0">
+                <a:solidFill>
+                  <a:schemeClr val="bg2">
+                    <a:lumMod val="90000"/>
+                  </a:schemeClr>
+                </a:solidFill>
+              </a:rPr>
+              <a:t>/02/2023</a:t>
             </a:r>
             <a:endParaRPr lang="pt-BR" sz="1600" dirty="0">
               <a:solidFill>

</xml_diff>

<commit_message>
inclusão de ativdade eliminou os parciais
</commit_message>
<xml_diff>
--- a/tempimento.pptx
+++ b/tempimento.pptx
@@ -197,7 +197,7 @@
           <a:p>
             <a:fld id="{A584E3A2-E8EA-4705-A613-CFE9F6F5D3B4}" type="datetimeFigureOut">
               <a:rPr lang="pt-BR" smtClean="0"/>
-              <a:t>27/02/2023</a:t>
+              <a:t>06/03/2023</a:t>
             </a:fld>
             <a:endParaRPr lang="pt-BR"/>
           </a:p>
@@ -680,7 +680,7 @@
           <a:p>
             <a:fld id="{52231B9D-E9F6-4612-9B82-E89961B389AC}" type="datetimeFigureOut">
               <a:rPr lang="pt-BR" smtClean="0"/>
-              <a:t>27/02/2023</a:t>
+              <a:t>06/03/2023</a:t>
             </a:fld>
             <a:endParaRPr lang="pt-BR"/>
           </a:p>
@@ -850,7 +850,7 @@
           <a:p>
             <a:fld id="{52231B9D-E9F6-4612-9B82-E89961B389AC}" type="datetimeFigureOut">
               <a:rPr lang="pt-BR" smtClean="0"/>
-              <a:t>27/02/2023</a:t>
+              <a:t>06/03/2023</a:t>
             </a:fld>
             <a:endParaRPr lang="pt-BR"/>
           </a:p>
@@ -1030,7 +1030,7 @@
           <a:p>
             <a:fld id="{52231B9D-E9F6-4612-9B82-E89961B389AC}" type="datetimeFigureOut">
               <a:rPr lang="pt-BR" smtClean="0"/>
-              <a:t>27/02/2023</a:t>
+              <a:t>06/03/2023</a:t>
             </a:fld>
             <a:endParaRPr lang="pt-BR"/>
           </a:p>
@@ -1200,7 +1200,7 @@
           <a:p>
             <a:fld id="{52231B9D-E9F6-4612-9B82-E89961B389AC}" type="datetimeFigureOut">
               <a:rPr lang="pt-BR" smtClean="0"/>
-              <a:t>27/02/2023</a:t>
+              <a:t>06/03/2023</a:t>
             </a:fld>
             <a:endParaRPr lang="pt-BR"/>
           </a:p>
@@ -1446,7 +1446,7 @@
           <a:p>
             <a:fld id="{52231B9D-E9F6-4612-9B82-E89961B389AC}" type="datetimeFigureOut">
               <a:rPr lang="pt-BR" smtClean="0"/>
-              <a:t>27/02/2023</a:t>
+              <a:t>06/03/2023</a:t>
             </a:fld>
             <a:endParaRPr lang="pt-BR"/>
           </a:p>
@@ -1678,7 +1678,7 @@
           <a:p>
             <a:fld id="{52231B9D-E9F6-4612-9B82-E89961B389AC}" type="datetimeFigureOut">
               <a:rPr lang="pt-BR" smtClean="0"/>
-              <a:t>27/02/2023</a:t>
+              <a:t>06/03/2023</a:t>
             </a:fld>
             <a:endParaRPr lang="pt-BR"/>
           </a:p>
@@ -2045,7 +2045,7 @@
           <a:p>
             <a:fld id="{52231B9D-E9F6-4612-9B82-E89961B389AC}" type="datetimeFigureOut">
               <a:rPr lang="pt-BR" smtClean="0"/>
-              <a:t>27/02/2023</a:t>
+              <a:t>06/03/2023</a:t>
             </a:fld>
             <a:endParaRPr lang="pt-BR"/>
           </a:p>
@@ -2163,7 +2163,7 @@
           <a:p>
             <a:fld id="{52231B9D-E9F6-4612-9B82-E89961B389AC}" type="datetimeFigureOut">
               <a:rPr lang="pt-BR" smtClean="0"/>
-              <a:t>27/02/2023</a:t>
+              <a:t>06/03/2023</a:t>
             </a:fld>
             <a:endParaRPr lang="pt-BR"/>
           </a:p>
@@ -2258,7 +2258,7 @@
           <a:p>
             <a:fld id="{52231B9D-E9F6-4612-9B82-E89961B389AC}" type="datetimeFigureOut">
               <a:rPr lang="pt-BR" smtClean="0"/>
-              <a:t>27/02/2023</a:t>
+              <a:t>06/03/2023</a:t>
             </a:fld>
             <a:endParaRPr lang="pt-BR"/>
           </a:p>
@@ -2535,7 +2535,7 @@
           <a:p>
             <a:fld id="{52231B9D-E9F6-4612-9B82-E89961B389AC}" type="datetimeFigureOut">
               <a:rPr lang="pt-BR" smtClean="0"/>
-              <a:t>27/02/2023</a:t>
+              <a:t>06/03/2023</a:t>
             </a:fld>
             <a:endParaRPr lang="pt-BR"/>
           </a:p>
@@ -2788,7 +2788,7 @@
           <a:p>
             <a:fld id="{52231B9D-E9F6-4612-9B82-E89961B389AC}" type="datetimeFigureOut">
               <a:rPr lang="pt-BR" smtClean="0"/>
-              <a:t>27/02/2023</a:t>
+              <a:t>06/03/2023</a:t>
             </a:fld>
             <a:endParaRPr lang="pt-BR"/>
           </a:p>
@@ -3001,7 +3001,7 @@
           <a:p>
             <a:fld id="{52231B9D-E9F6-4612-9B82-E89961B389AC}" type="datetimeFigureOut">
               <a:rPr lang="pt-BR" smtClean="0"/>
-              <a:t>27/02/2023</a:t>
+              <a:t>06/03/2023</a:t>
             </a:fld>
             <a:endParaRPr lang="pt-BR"/>
           </a:p>
@@ -3665,7 +3665,7 @@
                   </a:schemeClr>
                 </a:solidFill>
               </a:rPr>
-              <a:t>26</a:t>
+              <a:t>0</a:t>
             </a:r>
             <a:r>
               <a:rPr lang="pt-BR" sz="1600" dirty="0" smtClean="0">
@@ -3675,7 +3675,7 @@
                   </a:schemeClr>
                 </a:solidFill>
               </a:rPr>
-              <a:t>/02/2023</a:t>
+              <a:t>6/03/2023</a:t>
             </a:r>
             <a:endParaRPr lang="pt-BR" sz="1600" dirty="0">
               <a:solidFill>

</xml_diff>

<commit_message>
validar relatório com pré-requisições
</commit_message>
<xml_diff>
--- a/tempimento.pptx
+++ b/tempimento.pptx
@@ -197,7 +197,7 @@
           <a:p>
             <a:fld id="{A584E3A2-E8EA-4705-A613-CFE9F6F5D3B4}" type="datetimeFigureOut">
               <a:rPr lang="pt-BR" smtClean="0"/>
-              <a:t>06/03/2023</a:t>
+              <a:t>13/03/2023</a:t>
             </a:fld>
             <a:endParaRPr lang="pt-BR"/>
           </a:p>
@@ -680,7 +680,7 @@
           <a:p>
             <a:fld id="{52231B9D-E9F6-4612-9B82-E89961B389AC}" type="datetimeFigureOut">
               <a:rPr lang="pt-BR" smtClean="0"/>
-              <a:t>06/03/2023</a:t>
+              <a:t>13/03/2023</a:t>
             </a:fld>
             <a:endParaRPr lang="pt-BR"/>
           </a:p>
@@ -850,7 +850,7 @@
           <a:p>
             <a:fld id="{52231B9D-E9F6-4612-9B82-E89961B389AC}" type="datetimeFigureOut">
               <a:rPr lang="pt-BR" smtClean="0"/>
-              <a:t>06/03/2023</a:t>
+              <a:t>13/03/2023</a:t>
             </a:fld>
             <a:endParaRPr lang="pt-BR"/>
           </a:p>
@@ -1030,7 +1030,7 @@
           <a:p>
             <a:fld id="{52231B9D-E9F6-4612-9B82-E89961B389AC}" type="datetimeFigureOut">
               <a:rPr lang="pt-BR" smtClean="0"/>
-              <a:t>06/03/2023</a:t>
+              <a:t>13/03/2023</a:t>
             </a:fld>
             <a:endParaRPr lang="pt-BR"/>
           </a:p>
@@ -1200,7 +1200,7 @@
           <a:p>
             <a:fld id="{52231B9D-E9F6-4612-9B82-E89961B389AC}" type="datetimeFigureOut">
               <a:rPr lang="pt-BR" smtClean="0"/>
-              <a:t>06/03/2023</a:t>
+              <a:t>13/03/2023</a:t>
             </a:fld>
             <a:endParaRPr lang="pt-BR"/>
           </a:p>
@@ -1446,7 +1446,7 @@
           <a:p>
             <a:fld id="{52231B9D-E9F6-4612-9B82-E89961B389AC}" type="datetimeFigureOut">
               <a:rPr lang="pt-BR" smtClean="0"/>
-              <a:t>06/03/2023</a:t>
+              <a:t>13/03/2023</a:t>
             </a:fld>
             <a:endParaRPr lang="pt-BR"/>
           </a:p>
@@ -1678,7 +1678,7 @@
           <a:p>
             <a:fld id="{52231B9D-E9F6-4612-9B82-E89961B389AC}" type="datetimeFigureOut">
               <a:rPr lang="pt-BR" smtClean="0"/>
-              <a:t>06/03/2023</a:t>
+              <a:t>13/03/2023</a:t>
             </a:fld>
             <a:endParaRPr lang="pt-BR"/>
           </a:p>
@@ -2045,7 +2045,7 @@
           <a:p>
             <a:fld id="{52231B9D-E9F6-4612-9B82-E89961B389AC}" type="datetimeFigureOut">
               <a:rPr lang="pt-BR" smtClean="0"/>
-              <a:t>06/03/2023</a:t>
+              <a:t>13/03/2023</a:t>
             </a:fld>
             <a:endParaRPr lang="pt-BR"/>
           </a:p>
@@ -2163,7 +2163,7 @@
           <a:p>
             <a:fld id="{52231B9D-E9F6-4612-9B82-E89961B389AC}" type="datetimeFigureOut">
               <a:rPr lang="pt-BR" smtClean="0"/>
-              <a:t>06/03/2023</a:t>
+              <a:t>13/03/2023</a:t>
             </a:fld>
             <a:endParaRPr lang="pt-BR"/>
           </a:p>
@@ -2258,7 +2258,7 @@
           <a:p>
             <a:fld id="{52231B9D-E9F6-4612-9B82-E89961B389AC}" type="datetimeFigureOut">
               <a:rPr lang="pt-BR" smtClean="0"/>
-              <a:t>06/03/2023</a:t>
+              <a:t>13/03/2023</a:t>
             </a:fld>
             <a:endParaRPr lang="pt-BR"/>
           </a:p>
@@ -2535,7 +2535,7 @@
           <a:p>
             <a:fld id="{52231B9D-E9F6-4612-9B82-E89961B389AC}" type="datetimeFigureOut">
               <a:rPr lang="pt-BR" smtClean="0"/>
-              <a:t>06/03/2023</a:t>
+              <a:t>13/03/2023</a:t>
             </a:fld>
             <a:endParaRPr lang="pt-BR"/>
           </a:p>
@@ -2788,7 +2788,7 @@
           <a:p>
             <a:fld id="{52231B9D-E9F6-4612-9B82-E89961B389AC}" type="datetimeFigureOut">
               <a:rPr lang="pt-BR" smtClean="0"/>
-              <a:t>06/03/2023</a:t>
+              <a:t>13/03/2023</a:t>
             </a:fld>
             <a:endParaRPr lang="pt-BR"/>
           </a:p>
@@ -3001,7 +3001,7 @@
           <a:p>
             <a:fld id="{52231B9D-E9F6-4612-9B82-E89961B389AC}" type="datetimeFigureOut">
               <a:rPr lang="pt-BR" smtClean="0"/>
-              <a:t>06/03/2023</a:t>
+              <a:t>13/03/2023</a:t>
             </a:fld>
             <a:endParaRPr lang="pt-BR"/>
           </a:p>
@@ -3665,7 +3665,7 @@
                   </a:schemeClr>
                 </a:solidFill>
               </a:rPr>
-              <a:t>0</a:t>
+              <a:t>12</a:t>
             </a:r>
             <a:r>
               <a:rPr lang="pt-BR" sz="1600" dirty="0" smtClean="0">
@@ -3675,7 +3675,7 @@
                   </a:schemeClr>
                 </a:solidFill>
               </a:rPr>
-              <a:t>6/03/2023</a:t>
+              <a:t>/03/2023</a:t>
             </a:r>
             <a:endParaRPr lang="pt-BR" sz="1600" dirty="0">
               <a:solidFill>

</xml_diff>

<commit_message>
primeira carga teste custo veículos
</commit_message>
<xml_diff>
--- a/tempimento.pptx
+++ b/tempimento.pptx
@@ -11,7 +11,7 @@
     <p:sldId id="256" r:id="rId2"/>
   </p:sldIdLst>
   <p:sldSz cx="12192000" cy="6858000"/>
-  <p:notesSz cx="7104063" cy="10234613"/>
+  <p:notesSz cx="6889750" cy="9671050"/>
   <p:defaultTextStyle>
     <a:defPPr>
       <a:defRPr lang="pt-BR"/>
@@ -150,17 +150,17 @@
         <p:spPr>
           <a:xfrm>
             <a:off x="6" y="1"/>
-            <a:ext cx="3078851" cy="512763"/>
+            <a:ext cx="2985969" cy="484528"/>
           </a:xfrm>
           <a:prstGeom prst="rect">
             <a:avLst/>
           </a:prstGeom>
         </p:spPr>
         <p:txBody>
-          <a:bodyPr vert="horz" lIns="91400" tIns="45701" rIns="91400" bIns="45701" rtlCol="0"/>
+          <a:bodyPr vert="horz" lIns="87296" tIns="43649" rIns="87296" bIns="43649" rtlCol="0"/>
           <a:lstStyle>
             <a:lvl1pPr algn="l">
-              <a:defRPr sz="1200"/>
+              <a:defRPr sz="1100"/>
             </a:lvl1pPr>
           </a:lstStyle>
           <a:p>
@@ -180,24 +180,24 @@
         </p:nvSpPr>
         <p:spPr>
           <a:xfrm>
-            <a:off x="4023629" y="1"/>
-            <a:ext cx="3078851" cy="512763"/>
+            <a:off x="3902246" y="1"/>
+            <a:ext cx="2985969" cy="484528"/>
           </a:xfrm>
           <a:prstGeom prst="rect">
             <a:avLst/>
           </a:prstGeom>
         </p:spPr>
         <p:txBody>
-          <a:bodyPr vert="horz" lIns="91400" tIns="45701" rIns="91400" bIns="45701" rtlCol="0"/>
+          <a:bodyPr vert="horz" lIns="87296" tIns="43649" rIns="87296" bIns="43649" rtlCol="0"/>
           <a:lstStyle>
             <a:lvl1pPr algn="r">
-              <a:defRPr sz="1200"/>
+              <a:defRPr sz="1100"/>
             </a:lvl1pPr>
           </a:lstStyle>
           <a:p>
             <a:fld id="{A584E3A2-E8EA-4705-A613-CFE9F6F5D3B4}" type="datetimeFigureOut">
               <a:rPr lang="pt-BR" smtClean="0"/>
-              <a:t>13/03/2023</a:t>
+              <a:t>21/03/2023</a:t>
             </a:fld>
             <a:endParaRPr lang="pt-BR"/>
           </a:p>
@@ -215,8 +215,8 @@
         </p:nvSpPr>
         <p:spPr>
           <a:xfrm>
-            <a:off x="482600" y="1279525"/>
-            <a:ext cx="6138863" cy="3454400"/>
+            <a:off x="542925" y="1209675"/>
+            <a:ext cx="5803900" cy="3263900"/>
           </a:xfrm>
           <a:prstGeom prst="rect">
             <a:avLst/>
@@ -229,7 +229,7 @@
           </a:ln>
         </p:spPr>
         <p:txBody>
-          <a:bodyPr vert="horz" lIns="91400" tIns="45701" rIns="91400" bIns="45701" rtlCol="0" anchor="ctr"/>
+          <a:bodyPr vert="horz" lIns="87296" tIns="43649" rIns="87296" bIns="43649" rtlCol="0" anchor="ctr"/>
           <a:lstStyle/>
           <a:p>
             <a:endParaRPr lang="pt-BR"/>
@@ -248,15 +248,15 @@
         </p:nvSpPr>
         <p:spPr>
           <a:xfrm>
-            <a:off x="709774" y="4926015"/>
-            <a:ext cx="5684521" cy="4029075"/>
+            <a:off x="688362" y="4654767"/>
+            <a:ext cx="5513032" cy="3807216"/>
           </a:xfrm>
           <a:prstGeom prst="rect">
             <a:avLst/>
           </a:prstGeom>
         </p:spPr>
         <p:txBody>
-          <a:bodyPr vert="horz" lIns="91400" tIns="45701" rIns="91400" bIns="45701" rtlCol="0"/>
+          <a:bodyPr vert="horz" lIns="87296" tIns="43649" rIns="87296" bIns="43649" rtlCol="0"/>
           <a:lstStyle/>
           <a:p>
             <a:pPr lvl="0"/>
@@ -308,18 +308,18 @@
         </p:nvSpPr>
         <p:spPr>
           <a:xfrm>
-            <a:off x="6" y="9721851"/>
-            <a:ext cx="3078851" cy="512763"/>
+            <a:off x="6" y="9186523"/>
+            <a:ext cx="2985969" cy="484528"/>
           </a:xfrm>
           <a:prstGeom prst="rect">
             <a:avLst/>
           </a:prstGeom>
         </p:spPr>
         <p:txBody>
-          <a:bodyPr vert="horz" lIns="91400" tIns="45701" rIns="91400" bIns="45701" rtlCol="0" anchor="b"/>
+          <a:bodyPr vert="horz" lIns="87296" tIns="43649" rIns="87296" bIns="43649" rtlCol="0" anchor="b"/>
           <a:lstStyle>
             <a:lvl1pPr algn="l">
-              <a:defRPr sz="1200"/>
+              <a:defRPr sz="1100"/>
             </a:lvl1pPr>
           </a:lstStyle>
           <a:p>
@@ -339,18 +339,18 @@
         </p:nvSpPr>
         <p:spPr>
           <a:xfrm>
-            <a:off x="4023629" y="9721851"/>
-            <a:ext cx="3078851" cy="512763"/>
+            <a:off x="3902246" y="9186523"/>
+            <a:ext cx="2985969" cy="484528"/>
           </a:xfrm>
           <a:prstGeom prst="rect">
             <a:avLst/>
           </a:prstGeom>
         </p:spPr>
         <p:txBody>
-          <a:bodyPr vert="horz" lIns="91400" tIns="45701" rIns="91400" bIns="45701" rtlCol="0" anchor="b"/>
+          <a:bodyPr vert="horz" lIns="87296" tIns="43649" rIns="87296" bIns="43649" rtlCol="0" anchor="b"/>
           <a:lstStyle>
             <a:lvl1pPr algn="r">
-              <a:defRPr sz="1200"/>
+              <a:defRPr sz="1100"/>
             </a:lvl1pPr>
           </a:lstStyle>
           <a:p>
@@ -680,7 +680,7 @@
           <a:p>
             <a:fld id="{52231B9D-E9F6-4612-9B82-E89961B389AC}" type="datetimeFigureOut">
               <a:rPr lang="pt-BR" smtClean="0"/>
-              <a:t>13/03/2023</a:t>
+              <a:t>21/03/2023</a:t>
             </a:fld>
             <a:endParaRPr lang="pt-BR"/>
           </a:p>
@@ -850,7 +850,7 @@
           <a:p>
             <a:fld id="{52231B9D-E9F6-4612-9B82-E89961B389AC}" type="datetimeFigureOut">
               <a:rPr lang="pt-BR" smtClean="0"/>
-              <a:t>13/03/2023</a:t>
+              <a:t>21/03/2023</a:t>
             </a:fld>
             <a:endParaRPr lang="pt-BR"/>
           </a:p>
@@ -1030,7 +1030,7 @@
           <a:p>
             <a:fld id="{52231B9D-E9F6-4612-9B82-E89961B389AC}" type="datetimeFigureOut">
               <a:rPr lang="pt-BR" smtClean="0"/>
-              <a:t>13/03/2023</a:t>
+              <a:t>21/03/2023</a:t>
             </a:fld>
             <a:endParaRPr lang="pt-BR"/>
           </a:p>
@@ -1200,7 +1200,7 @@
           <a:p>
             <a:fld id="{52231B9D-E9F6-4612-9B82-E89961B389AC}" type="datetimeFigureOut">
               <a:rPr lang="pt-BR" smtClean="0"/>
-              <a:t>13/03/2023</a:t>
+              <a:t>21/03/2023</a:t>
             </a:fld>
             <a:endParaRPr lang="pt-BR"/>
           </a:p>
@@ -1446,7 +1446,7 @@
           <a:p>
             <a:fld id="{52231B9D-E9F6-4612-9B82-E89961B389AC}" type="datetimeFigureOut">
               <a:rPr lang="pt-BR" smtClean="0"/>
-              <a:t>13/03/2023</a:t>
+              <a:t>21/03/2023</a:t>
             </a:fld>
             <a:endParaRPr lang="pt-BR"/>
           </a:p>
@@ -1678,7 +1678,7 @@
           <a:p>
             <a:fld id="{52231B9D-E9F6-4612-9B82-E89961B389AC}" type="datetimeFigureOut">
               <a:rPr lang="pt-BR" smtClean="0"/>
-              <a:t>13/03/2023</a:t>
+              <a:t>21/03/2023</a:t>
             </a:fld>
             <a:endParaRPr lang="pt-BR"/>
           </a:p>
@@ -2045,7 +2045,7 @@
           <a:p>
             <a:fld id="{52231B9D-E9F6-4612-9B82-E89961B389AC}" type="datetimeFigureOut">
               <a:rPr lang="pt-BR" smtClean="0"/>
-              <a:t>13/03/2023</a:t>
+              <a:t>21/03/2023</a:t>
             </a:fld>
             <a:endParaRPr lang="pt-BR"/>
           </a:p>
@@ -2163,7 +2163,7 @@
           <a:p>
             <a:fld id="{52231B9D-E9F6-4612-9B82-E89961B389AC}" type="datetimeFigureOut">
               <a:rPr lang="pt-BR" smtClean="0"/>
-              <a:t>13/03/2023</a:t>
+              <a:t>21/03/2023</a:t>
             </a:fld>
             <a:endParaRPr lang="pt-BR"/>
           </a:p>
@@ -2258,7 +2258,7 @@
           <a:p>
             <a:fld id="{52231B9D-E9F6-4612-9B82-E89961B389AC}" type="datetimeFigureOut">
               <a:rPr lang="pt-BR" smtClean="0"/>
-              <a:t>13/03/2023</a:t>
+              <a:t>21/03/2023</a:t>
             </a:fld>
             <a:endParaRPr lang="pt-BR"/>
           </a:p>
@@ -2535,7 +2535,7 @@
           <a:p>
             <a:fld id="{52231B9D-E9F6-4612-9B82-E89961B389AC}" type="datetimeFigureOut">
               <a:rPr lang="pt-BR" smtClean="0"/>
-              <a:t>13/03/2023</a:t>
+              <a:t>21/03/2023</a:t>
             </a:fld>
             <a:endParaRPr lang="pt-BR"/>
           </a:p>
@@ -2788,7 +2788,7 @@
           <a:p>
             <a:fld id="{52231B9D-E9F6-4612-9B82-E89961B389AC}" type="datetimeFigureOut">
               <a:rPr lang="pt-BR" smtClean="0"/>
-              <a:t>13/03/2023</a:t>
+              <a:t>21/03/2023</a:t>
             </a:fld>
             <a:endParaRPr lang="pt-BR"/>
           </a:p>
@@ -3001,7 +3001,7 @@
           <a:p>
             <a:fld id="{52231B9D-E9F6-4612-9B82-E89961B389AC}" type="datetimeFigureOut">
               <a:rPr lang="pt-BR" smtClean="0"/>
-              <a:t>13/03/2023</a:t>
+              <a:t>21/03/2023</a:t>
             </a:fld>
             <a:endParaRPr lang="pt-BR"/>
           </a:p>
@@ -3658,17 +3658,17 @@
           <a:lstStyle/>
           <a:p>
             <a:r>
-              <a:rPr lang="pt-BR" sz="1600" dirty="0" smtClean="0">
+              <a:rPr lang="pt-BR" sz="1600" smtClean="0">
                 <a:solidFill>
                   <a:schemeClr val="bg2">
                     <a:lumMod val="90000"/>
                   </a:schemeClr>
                 </a:solidFill>
               </a:rPr>
-              <a:t>12</a:t>
-            </a:r>
-            <a:r>
-              <a:rPr lang="pt-BR" sz="1600" dirty="0" smtClean="0">
+              <a:t>26</a:t>
+            </a:r>
+            <a:r>
+              <a:rPr lang="pt-BR" sz="1600" smtClean="0">
                 <a:solidFill>
                   <a:schemeClr val="bg2">
                     <a:lumMod val="90000"/>

</xml_diff>

<commit_message>
erro drill chamado controladoria 16393995
</commit_message>
<xml_diff>
--- a/tempimento.pptx
+++ b/tempimento.pptx
@@ -197,7 +197,7 @@
           <a:p>
             <a:fld id="{A584E3A2-E8EA-4705-A613-CFE9F6F5D3B4}" type="datetimeFigureOut">
               <a:rPr lang="pt-BR" smtClean="0"/>
-              <a:t>21/03/2023</a:t>
+              <a:t>04/04/2023</a:t>
             </a:fld>
             <a:endParaRPr lang="pt-BR"/>
           </a:p>
@@ -680,7 +680,7 @@
           <a:p>
             <a:fld id="{52231B9D-E9F6-4612-9B82-E89961B389AC}" type="datetimeFigureOut">
               <a:rPr lang="pt-BR" smtClean="0"/>
-              <a:t>21/03/2023</a:t>
+              <a:t>04/04/2023</a:t>
             </a:fld>
             <a:endParaRPr lang="pt-BR"/>
           </a:p>
@@ -850,7 +850,7 @@
           <a:p>
             <a:fld id="{52231B9D-E9F6-4612-9B82-E89961B389AC}" type="datetimeFigureOut">
               <a:rPr lang="pt-BR" smtClean="0"/>
-              <a:t>21/03/2023</a:t>
+              <a:t>04/04/2023</a:t>
             </a:fld>
             <a:endParaRPr lang="pt-BR"/>
           </a:p>
@@ -1030,7 +1030,7 @@
           <a:p>
             <a:fld id="{52231B9D-E9F6-4612-9B82-E89961B389AC}" type="datetimeFigureOut">
               <a:rPr lang="pt-BR" smtClean="0"/>
-              <a:t>21/03/2023</a:t>
+              <a:t>04/04/2023</a:t>
             </a:fld>
             <a:endParaRPr lang="pt-BR"/>
           </a:p>
@@ -1200,7 +1200,7 @@
           <a:p>
             <a:fld id="{52231B9D-E9F6-4612-9B82-E89961B389AC}" type="datetimeFigureOut">
               <a:rPr lang="pt-BR" smtClean="0"/>
-              <a:t>21/03/2023</a:t>
+              <a:t>04/04/2023</a:t>
             </a:fld>
             <a:endParaRPr lang="pt-BR"/>
           </a:p>
@@ -1446,7 +1446,7 @@
           <a:p>
             <a:fld id="{52231B9D-E9F6-4612-9B82-E89961B389AC}" type="datetimeFigureOut">
               <a:rPr lang="pt-BR" smtClean="0"/>
-              <a:t>21/03/2023</a:t>
+              <a:t>04/04/2023</a:t>
             </a:fld>
             <a:endParaRPr lang="pt-BR"/>
           </a:p>
@@ -1678,7 +1678,7 @@
           <a:p>
             <a:fld id="{52231B9D-E9F6-4612-9B82-E89961B389AC}" type="datetimeFigureOut">
               <a:rPr lang="pt-BR" smtClean="0"/>
-              <a:t>21/03/2023</a:t>
+              <a:t>04/04/2023</a:t>
             </a:fld>
             <a:endParaRPr lang="pt-BR"/>
           </a:p>
@@ -2045,7 +2045,7 @@
           <a:p>
             <a:fld id="{52231B9D-E9F6-4612-9B82-E89961B389AC}" type="datetimeFigureOut">
               <a:rPr lang="pt-BR" smtClean="0"/>
-              <a:t>21/03/2023</a:t>
+              <a:t>04/04/2023</a:t>
             </a:fld>
             <a:endParaRPr lang="pt-BR"/>
           </a:p>
@@ -2163,7 +2163,7 @@
           <a:p>
             <a:fld id="{52231B9D-E9F6-4612-9B82-E89961B389AC}" type="datetimeFigureOut">
               <a:rPr lang="pt-BR" smtClean="0"/>
-              <a:t>21/03/2023</a:t>
+              <a:t>04/04/2023</a:t>
             </a:fld>
             <a:endParaRPr lang="pt-BR"/>
           </a:p>
@@ -2258,7 +2258,7 @@
           <a:p>
             <a:fld id="{52231B9D-E9F6-4612-9B82-E89961B389AC}" type="datetimeFigureOut">
               <a:rPr lang="pt-BR" smtClean="0"/>
-              <a:t>21/03/2023</a:t>
+              <a:t>04/04/2023</a:t>
             </a:fld>
             <a:endParaRPr lang="pt-BR"/>
           </a:p>
@@ -2535,7 +2535,7 @@
           <a:p>
             <a:fld id="{52231B9D-E9F6-4612-9B82-E89961B389AC}" type="datetimeFigureOut">
               <a:rPr lang="pt-BR" smtClean="0"/>
-              <a:t>21/03/2023</a:t>
+              <a:t>04/04/2023</a:t>
             </a:fld>
             <a:endParaRPr lang="pt-BR"/>
           </a:p>
@@ -2788,7 +2788,7 @@
           <a:p>
             <a:fld id="{52231B9D-E9F6-4612-9B82-E89961B389AC}" type="datetimeFigureOut">
               <a:rPr lang="pt-BR" smtClean="0"/>
-              <a:t>21/03/2023</a:t>
+              <a:t>04/04/2023</a:t>
             </a:fld>
             <a:endParaRPr lang="pt-BR"/>
           </a:p>
@@ -3001,7 +3001,7 @@
           <a:p>
             <a:fld id="{52231B9D-E9F6-4612-9B82-E89961B389AC}" type="datetimeFigureOut">
               <a:rPr lang="pt-BR" smtClean="0"/>
-              <a:t>21/03/2023</a:t>
+              <a:t>04/04/2023</a:t>
             </a:fld>
             <a:endParaRPr lang="pt-BR"/>
           </a:p>
@@ -3658,24 +3658,24 @@
           <a:lstStyle/>
           <a:p>
             <a:r>
-              <a:rPr lang="pt-BR" sz="1600" smtClean="0">
+              <a:rPr lang="pt-BR" sz="1600" dirty="0" smtClean="0">
                 <a:solidFill>
                   <a:schemeClr val="bg2">
                     <a:lumMod val="90000"/>
                   </a:schemeClr>
                 </a:solidFill>
               </a:rPr>
-              <a:t>26</a:t>
-            </a:r>
-            <a:r>
-              <a:rPr lang="pt-BR" sz="1600" smtClean="0">
+              <a:t>09</a:t>
+            </a:r>
+            <a:r>
+              <a:rPr lang="pt-BR" sz="1600" dirty="0" smtClean="0">
                 <a:solidFill>
                   <a:schemeClr val="bg2">
                     <a:lumMod val="90000"/>
                   </a:schemeClr>
                 </a:solidFill>
               </a:rPr>
-              <a:t>/03/2023</a:t>
+              <a:t>/04/2023</a:t>
             </a:r>
             <a:endParaRPr lang="pt-BR" sz="1600" dirty="0">
               <a:solidFill>

</xml_diff>

<commit_message>
modelo local igual ao modelo do servidor
</commit_message>
<xml_diff>
--- a/tempimento.pptx
+++ b/tempimento.pptx
@@ -197,7 +197,7 @@
           <a:p>
             <a:fld id="{A584E3A2-E8EA-4705-A613-CFE9F6F5D3B4}" type="datetimeFigureOut">
               <a:rPr lang="pt-BR" smtClean="0"/>
-              <a:t>04/04/2023</a:t>
+              <a:t>18/04/2023</a:t>
             </a:fld>
             <a:endParaRPr lang="pt-BR"/>
           </a:p>
@@ -680,7 +680,7 @@
           <a:p>
             <a:fld id="{52231B9D-E9F6-4612-9B82-E89961B389AC}" type="datetimeFigureOut">
               <a:rPr lang="pt-BR" smtClean="0"/>
-              <a:t>04/04/2023</a:t>
+              <a:t>18/04/2023</a:t>
             </a:fld>
             <a:endParaRPr lang="pt-BR"/>
           </a:p>
@@ -850,7 +850,7 @@
           <a:p>
             <a:fld id="{52231B9D-E9F6-4612-9B82-E89961B389AC}" type="datetimeFigureOut">
               <a:rPr lang="pt-BR" smtClean="0"/>
-              <a:t>04/04/2023</a:t>
+              <a:t>18/04/2023</a:t>
             </a:fld>
             <a:endParaRPr lang="pt-BR"/>
           </a:p>
@@ -1030,7 +1030,7 @@
           <a:p>
             <a:fld id="{52231B9D-E9F6-4612-9B82-E89961B389AC}" type="datetimeFigureOut">
               <a:rPr lang="pt-BR" smtClean="0"/>
-              <a:t>04/04/2023</a:t>
+              <a:t>18/04/2023</a:t>
             </a:fld>
             <a:endParaRPr lang="pt-BR"/>
           </a:p>
@@ -1200,7 +1200,7 @@
           <a:p>
             <a:fld id="{52231B9D-E9F6-4612-9B82-E89961B389AC}" type="datetimeFigureOut">
               <a:rPr lang="pt-BR" smtClean="0"/>
-              <a:t>04/04/2023</a:t>
+              <a:t>18/04/2023</a:t>
             </a:fld>
             <a:endParaRPr lang="pt-BR"/>
           </a:p>
@@ -1446,7 +1446,7 @@
           <a:p>
             <a:fld id="{52231B9D-E9F6-4612-9B82-E89961B389AC}" type="datetimeFigureOut">
               <a:rPr lang="pt-BR" smtClean="0"/>
-              <a:t>04/04/2023</a:t>
+              <a:t>18/04/2023</a:t>
             </a:fld>
             <a:endParaRPr lang="pt-BR"/>
           </a:p>
@@ -1678,7 +1678,7 @@
           <a:p>
             <a:fld id="{52231B9D-E9F6-4612-9B82-E89961B389AC}" type="datetimeFigureOut">
               <a:rPr lang="pt-BR" smtClean="0"/>
-              <a:t>04/04/2023</a:t>
+              <a:t>18/04/2023</a:t>
             </a:fld>
             <a:endParaRPr lang="pt-BR"/>
           </a:p>
@@ -2045,7 +2045,7 @@
           <a:p>
             <a:fld id="{52231B9D-E9F6-4612-9B82-E89961B389AC}" type="datetimeFigureOut">
               <a:rPr lang="pt-BR" smtClean="0"/>
-              <a:t>04/04/2023</a:t>
+              <a:t>18/04/2023</a:t>
             </a:fld>
             <a:endParaRPr lang="pt-BR"/>
           </a:p>
@@ -2163,7 +2163,7 @@
           <a:p>
             <a:fld id="{52231B9D-E9F6-4612-9B82-E89961B389AC}" type="datetimeFigureOut">
               <a:rPr lang="pt-BR" smtClean="0"/>
-              <a:t>04/04/2023</a:t>
+              <a:t>18/04/2023</a:t>
             </a:fld>
             <a:endParaRPr lang="pt-BR"/>
           </a:p>
@@ -2258,7 +2258,7 @@
           <a:p>
             <a:fld id="{52231B9D-E9F6-4612-9B82-E89961B389AC}" type="datetimeFigureOut">
               <a:rPr lang="pt-BR" smtClean="0"/>
-              <a:t>04/04/2023</a:t>
+              <a:t>18/04/2023</a:t>
             </a:fld>
             <a:endParaRPr lang="pt-BR"/>
           </a:p>
@@ -2535,7 +2535,7 @@
           <a:p>
             <a:fld id="{52231B9D-E9F6-4612-9B82-E89961B389AC}" type="datetimeFigureOut">
               <a:rPr lang="pt-BR" smtClean="0"/>
-              <a:t>04/04/2023</a:t>
+              <a:t>18/04/2023</a:t>
             </a:fld>
             <a:endParaRPr lang="pt-BR"/>
           </a:p>
@@ -2788,7 +2788,7 @@
           <a:p>
             <a:fld id="{52231B9D-E9F6-4612-9B82-E89961B389AC}" type="datetimeFigureOut">
               <a:rPr lang="pt-BR" smtClean="0"/>
-              <a:t>04/04/2023</a:t>
+              <a:t>18/04/2023</a:t>
             </a:fld>
             <a:endParaRPr lang="pt-BR"/>
           </a:p>
@@ -3001,7 +3001,7 @@
           <a:p>
             <a:fld id="{52231B9D-E9F6-4612-9B82-E89961B389AC}" type="datetimeFigureOut">
               <a:rPr lang="pt-BR" smtClean="0"/>
-              <a:t>04/04/2023</a:t>
+              <a:t>18/04/2023</a:t>
             </a:fld>
             <a:endParaRPr lang="pt-BR"/>
           </a:p>
@@ -3665,17 +3665,7 @@
                   </a:schemeClr>
                 </a:solidFill>
               </a:rPr>
-              <a:t>09</a:t>
-            </a:r>
-            <a:r>
-              <a:rPr lang="pt-BR" sz="1600" dirty="0" smtClean="0">
-                <a:solidFill>
-                  <a:schemeClr val="bg2">
-                    <a:lumMod val="90000"/>
-                  </a:schemeClr>
-                </a:solidFill>
-              </a:rPr>
-              <a:t>/04/2023</a:t>
+              <a:t>16/04/2023</a:t>
             </a:r>
             <a:endParaRPr lang="pt-BR" sz="1600" dirty="0">
               <a:solidFill>

</xml_diff>

<commit_message>
fazer ETL do status da oportunidade
</commit_message>
<xml_diff>
--- a/tempimento.pptx
+++ b/tempimento.pptx
@@ -197,7 +197,7 @@
           <a:p>
             <a:fld id="{A584E3A2-E8EA-4705-A613-CFE9F6F5D3B4}" type="datetimeFigureOut">
               <a:rPr lang="pt-BR" smtClean="0"/>
-              <a:t>18/04/2023</a:t>
+              <a:t>28/04/2023</a:t>
             </a:fld>
             <a:endParaRPr lang="pt-BR"/>
           </a:p>
@@ -680,7 +680,7 @@
           <a:p>
             <a:fld id="{52231B9D-E9F6-4612-9B82-E89961B389AC}" type="datetimeFigureOut">
               <a:rPr lang="pt-BR" smtClean="0"/>
-              <a:t>18/04/2023</a:t>
+              <a:t>28/04/2023</a:t>
             </a:fld>
             <a:endParaRPr lang="pt-BR"/>
           </a:p>
@@ -850,7 +850,7 @@
           <a:p>
             <a:fld id="{52231B9D-E9F6-4612-9B82-E89961B389AC}" type="datetimeFigureOut">
               <a:rPr lang="pt-BR" smtClean="0"/>
-              <a:t>18/04/2023</a:t>
+              <a:t>28/04/2023</a:t>
             </a:fld>
             <a:endParaRPr lang="pt-BR"/>
           </a:p>
@@ -1030,7 +1030,7 @@
           <a:p>
             <a:fld id="{52231B9D-E9F6-4612-9B82-E89961B389AC}" type="datetimeFigureOut">
               <a:rPr lang="pt-BR" smtClean="0"/>
-              <a:t>18/04/2023</a:t>
+              <a:t>28/04/2023</a:t>
             </a:fld>
             <a:endParaRPr lang="pt-BR"/>
           </a:p>
@@ -1200,7 +1200,7 @@
           <a:p>
             <a:fld id="{52231B9D-E9F6-4612-9B82-E89961B389AC}" type="datetimeFigureOut">
               <a:rPr lang="pt-BR" smtClean="0"/>
-              <a:t>18/04/2023</a:t>
+              <a:t>28/04/2023</a:t>
             </a:fld>
             <a:endParaRPr lang="pt-BR"/>
           </a:p>
@@ -1446,7 +1446,7 @@
           <a:p>
             <a:fld id="{52231B9D-E9F6-4612-9B82-E89961B389AC}" type="datetimeFigureOut">
               <a:rPr lang="pt-BR" smtClean="0"/>
-              <a:t>18/04/2023</a:t>
+              <a:t>28/04/2023</a:t>
             </a:fld>
             <a:endParaRPr lang="pt-BR"/>
           </a:p>
@@ -1678,7 +1678,7 @@
           <a:p>
             <a:fld id="{52231B9D-E9F6-4612-9B82-E89961B389AC}" type="datetimeFigureOut">
               <a:rPr lang="pt-BR" smtClean="0"/>
-              <a:t>18/04/2023</a:t>
+              <a:t>28/04/2023</a:t>
             </a:fld>
             <a:endParaRPr lang="pt-BR"/>
           </a:p>
@@ -2045,7 +2045,7 @@
           <a:p>
             <a:fld id="{52231B9D-E9F6-4612-9B82-E89961B389AC}" type="datetimeFigureOut">
               <a:rPr lang="pt-BR" smtClean="0"/>
-              <a:t>18/04/2023</a:t>
+              <a:t>28/04/2023</a:t>
             </a:fld>
             <a:endParaRPr lang="pt-BR"/>
           </a:p>
@@ -2163,7 +2163,7 @@
           <a:p>
             <a:fld id="{52231B9D-E9F6-4612-9B82-E89961B389AC}" type="datetimeFigureOut">
               <a:rPr lang="pt-BR" smtClean="0"/>
-              <a:t>18/04/2023</a:t>
+              <a:t>28/04/2023</a:t>
             </a:fld>
             <a:endParaRPr lang="pt-BR"/>
           </a:p>
@@ -2258,7 +2258,7 @@
           <a:p>
             <a:fld id="{52231B9D-E9F6-4612-9B82-E89961B389AC}" type="datetimeFigureOut">
               <a:rPr lang="pt-BR" smtClean="0"/>
-              <a:t>18/04/2023</a:t>
+              <a:t>28/04/2023</a:t>
             </a:fld>
             <a:endParaRPr lang="pt-BR"/>
           </a:p>
@@ -2535,7 +2535,7 @@
           <a:p>
             <a:fld id="{52231B9D-E9F6-4612-9B82-E89961B389AC}" type="datetimeFigureOut">
               <a:rPr lang="pt-BR" smtClean="0"/>
-              <a:t>18/04/2023</a:t>
+              <a:t>28/04/2023</a:t>
             </a:fld>
             <a:endParaRPr lang="pt-BR"/>
           </a:p>
@@ -2788,7 +2788,7 @@
           <a:p>
             <a:fld id="{52231B9D-E9F6-4612-9B82-E89961B389AC}" type="datetimeFigureOut">
               <a:rPr lang="pt-BR" smtClean="0"/>
-              <a:t>18/04/2023</a:t>
+              <a:t>28/04/2023</a:t>
             </a:fld>
             <a:endParaRPr lang="pt-BR"/>
           </a:p>
@@ -3001,7 +3001,7 @@
           <a:p>
             <a:fld id="{52231B9D-E9F6-4612-9B82-E89961B389AC}" type="datetimeFigureOut">
               <a:rPr lang="pt-BR" smtClean="0"/>
-              <a:t>18/04/2023</a:t>
+              <a:t>28/04/2023</a:t>
             </a:fld>
             <a:endParaRPr lang="pt-BR"/>
           </a:p>
@@ -3665,7 +3665,17 @@
                   </a:schemeClr>
                 </a:solidFill>
               </a:rPr>
-              <a:t>16/04/2023</a:t>
+              <a:t>23</a:t>
+            </a:r>
+            <a:r>
+              <a:rPr lang="pt-BR" sz="1600" dirty="0" smtClean="0">
+                <a:solidFill>
+                  <a:schemeClr val="bg2">
+                    <a:lumMod val="90000"/>
+                  </a:schemeClr>
+                </a:solidFill>
+              </a:rPr>
+              <a:t>/04/2023</a:t>
             </a:r>
             <a:endParaRPr lang="pt-BR" sz="1600" dirty="0">
               <a:solidFill>

</xml_diff>

<commit_message>
ajustes outras receitas e performance de atendimento
ver metadados grafo última carga e rever dados de outras receitas
</commit_message>
<xml_diff>
--- a/tempimento.pptx
+++ b/tempimento.pptx
@@ -197,7 +197,7 @@
           <a:p>
             <a:fld id="{A584E3A2-E8EA-4705-A613-CFE9F6F5D3B4}" type="datetimeFigureOut">
               <a:rPr lang="pt-BR" smtClean="0"/>
-              <a:t>28/04/2023</a:t>
+              <a:t>02/05/2023</a:t>
             </a:fld>
             <a:endParaRPr lang="pt-BR"/>
           </a:p>
@@ -680,7 +680,7 @@
           <a:p>
             <a:fld id="{52231B9D-E9F6-4612-9B82-E89961B389AC}" type="datetimeFigureOut">
               <a:rPr lang="pt-BR" smtClean="0"/>
-              <a:t>28/04/2023</a:t>
+              <a:t>02/05/2023</a:t>
             </a:fld>
             <a:endParaRPr lang="pt-BR"/>
           </a:p>
@@ -850,7 +850,7 @@
           <a:p>
             <a:fld id="{52231B9D-E9F6-4612-9B82-E89961B389AC}" type="datetimeFigureOut">
               <a:rPr lang="pt-BR" smtClean="0"/>
-              <a:t>28/04/2023</a:t>
+              <a:t>02/05/2023</a:t>
             </a:fld>
             <a:endParaRPr lang="pt-BR"/>
           </a:p>
@@ -1030,7 +1030,7 @@
           <a:p>
             <a:fld id="{52231B9D-E9F6-4612-9B82-E89961B389AC}" type="datetimeFigureOut">
               <a:rPr lang="pt-BR" smtClean="0"/>
-              <a:t>28/04/2023</a:t>
+              <a:t>02/05/2023</a:t>
             </a:fld>
             <a:endParaRPr lang="pt-BR"/>
           </a:p>
@@ -1200,7 +1200,7 @@
           <a:p>
             <a:fld id="{52231B9D-E9F6-4612-9B82-E89961B389AC}" type="datetimeFigureOut">
               <a:rPr lang="pt-BR" smtClean="0"/>
-              <a:t>28/04/2023</a:t>
+              <a:t>02/05/2023</a:t>
             </a:fld>
             <a:endParaRPr lang="pt-BR"/>
           </a:p>
@@ -1446,7 +1446,7 @@
           <a:p>
             <a:fld id="{52231B9D-E9F6-4612-9B82-E89961B389AC}" type="datetimeFigureOut">
               <a:rPr lang="pt-BR" smtClean="0"/>
-              <a:t>28/04/2023</a:t>
+              <a:t>02/05/2023</a:t>
             </a:fld>
             <a:endParaRPr lang="pt-BR"/>
           </a:p>
@@ -1678,7 +1678,7 @@
           <a:p>
             <a:fld id="{52231B9D-E9F6-4612-9B82-E89961B389AC}" type="datetimeFigureOut">
               <a:rPr lang="pt-BR" smtClean="0"/>
-              <a:t>28/04/2023</a:t>
+              <a:t>02/05/2023</a:t>
             </a:fld>
             <a:endParaRPr lang="pt-BR"/>
           </a:p>
@@ -2045,7 +2045,7 @@
           <a:p>
             <a:fld id="{52231B9D-E9F6-4612-9B82-E89961B389AC}" type="datetimeFigureOut">
               <a:rPr lang="pt-BR" smtClean="0"/>
-              <a:t>28/04/2023</a:t>
+              <a:t>02/05/2023</a:t>
             </a:fld>
             <a:endParaRPr lang="pt-BR"/>
           </a:p>
@@ -2163,7 +2163,7 @@
           <a:p>
             <a:fld id="{52231B9D-E9F6-4612-9B82-E89961B389AC}" type="datetimeFigureOut">
               <a:rPr lang="pt-BR" smtClean="0"/>
-              <a:t>28/04/2023</a:t>
+              <a:t>02/05/2023</a:t>
             </a:fld>
             <a:endParaRPr lang="pt-BR"/>
           </a:p>
@@ -2258,7 +2258,7 @@
           <a:p>
             <a:fld id="{52231B9D-E9F6-4612-9B82-E89961B389AC}" type="datetimeFigureOut">
               <a:rPr lang="pt-BR" smtClean="0"/>
-              <a:t>28/04/2023</a:t>
+              <a:t>02/05/2023</a:t>
             </a:fld>
             <a:endParaRPr lang="pt-BR"/>
           </a:p>
@@ -2535,7 +2535,7 @@
           <a:p>
             <a:fld id="{52231B9D-E9F6-4612-9B82-E89961B389AC}" type="datetimeFigureOut">
               <a:rPr lang="pt-BR" smtClean="0"/>
-              <a:t>28/04/2023</a:t>
+              <a:t>02/05/2023</a:t>
             </a:fld>
             <a:endParaRPr lang="pt-BR"/>
           </a:p>
@@ -2788,7 +2788,7 @@
           <a:p>
             <a:fld id="{52231B9D-E9F6-4612-9B82-E89961B389AC}" type="datetimeFigureOut">
               <a:rPr lang="pt-BR" smtClean="0"/>
-              <a:t>28/04/2023</a:t>
+              <a:t>02/05/2023</a:t>
             </a:fld>
             <a:endParaRPr lang="pt-BR"/>
           </a:p>
@@ -3001,7 +3001,7 @@
           <a:p>
             <a:fld id="{52231B9D-E9F6-4612-9B82-E89961B389AC}" type="datetimeFigureOut">
               <a:rPr lang="pt-BR" smtClean="0"/>
-              <a:t>28/04/2023</a:t>
+              <a:t>02/05/2023</a:t>
             </a:fld>
             <a:endParaRPr lang="pt-BR"/>
           </a:p>
@@ -3665,7 +3665,7 @@
                   </a:schemeClr>
                 </a:solidFill>
               </a:rPr>
-              <a:t>23</a:t>
+              <a:t>30</a:t>
             </a:r>
             <a:r>
               <a:rPr lang="pt-BR" sz="1600" dirty="0" smtClean="0">

</xml_diff>

<commit_message>
novo processo projeto em branco MNT
</commit_message>
<xml_diff>
--- a/tempimento.pptx
+++ b/tempimento.pptx
@@ -11,7 +11,7 @@
     <p:sldId id="256" r:id="rId2"/>
   </p:sldIdLst>
   <p:sldSz cx="12192000" cy="6858000"/>
-  <p:notesSz cx="6889750" cy="9671050"/>
+  <p:notesSz cx="6797675" cy="9872663"/>
   <p:defaultTextStyle>
     <a:defPPr>
       <a:defRPr lang="pt-BR"/>
@@ -150,7 +150,7 @@
         <p:spPr>
           <a:xfrm>
             <a:off x="6" y="1"/>
-            <a:ext cx="2985969" cy="484528"/>
+            <a:ext cx="2946065" cy="494629"/>
           </a:xfrm>
           <a:prstGeom prst="rect">
             <a:avLst/>
@@ -180,8 +180,8 @@
         </p:nvSpPr>
         <p:spPr>
           <a:xfrm>
-            <a:off x="3902246" y="1"/>
-            <a:ext cx="2985969" cy="484528"/>
+            <a:off x="3850097" y="1"/>
+            <a:ext cx="2946065" cy="494629"/>
           </a:xfrm>
           <a:prstGeom prst="rect">
             <a:avLst/>
@@ -197,7 +197,7 @@
           <a:p>
             <a:fld id="{A584E3A2-E8EA-4705-A613-CFE9F6F5D3B4}" type="datetimeFigureOut">
               <a:rPr lang="pt-BR" smtClean="0"/>
-              <a:t>02/05/2023</a:t>
+              <a:t>08/05/2023</a:t>
             </a:fld>
             <a:endParaRPr lang="pt-BR"/>
           </a:p>
@@ -215,8 +215,8 @@
         </p:nvSpPr>
         <p:spPr>
           <a:xfrm>
-            <a:off x="542925" y="1209675"/>
-            <a:ext cx="5803900" cy="3263900"/>
+            <a:off x="438150" y="1235075"/>
+            <a:ext cx="5921375" cy="3330575"/>
           </a:xfrm>
           <a:prstGeom prst="rect">
             <a:avLst/>
@@ -248,8 +248,8 @@
         </p:nvSpPr>
         <p:spPr>
           <a:xfrm>
-            <a:off x="688362" y="4654767"/>
-            <a:ext cx="5513032" cy="3807216"/>
+            <a:off x="679163" y="4751805"/>
+            <a:ext cx="5439356" cy="3886586"/>
           </a:xfrm>
           <a:prstGeom prst="rect">
             <a:avLst/>
@@ -308,8 +308,8 @@
         </p:nvSpPr>
         <p:spPr>
           <a:xfrm>
-            <a:off x="6" y="9186523"/>
-            <a:ext cx="2985969" cy="484528"/>
+            <a:off x="6" y="9378036"/>
+            <a:ext cx="2946065" cy="494629"/>
           </a:xfrm>
           <a:prstGeom prst="rect">
             <a:avLst/>
@@ -339,8 +339,8 @@
         </p:nvSpPr>
         <p:spPr>
           <a:xfrm>
-            <a:off x="3902246" y="9186523"/>
-            <a:ext cx="2985969" cy="484528"/>
+            <a:off x="3850097" y="9378036"/>
+            <a:ext cx="2946065" cy="494629"/>
           </a:xfrm>
           <a:prstGeom prst="rect">
             <a:avLst/>
@@ -680,7 +680,7 @@
           <a:p>
             <a:fld id="{52231B9D-E9F6-4612-9B82-E89961B389AC}" type="datetimeFigureOut">
               <a:rPr lang="pt-BR" smtClean="0"/>
-              <a:t>02/05/2023</a:t>
+              <a:t>08/05/2023</a:t>
             </a:fld>
             <a:endParaRPr lang="pt-BR"/>
           </a:p>
@@ -850,7 +850,7 @@
           <a:p>
             <a:fld id="{52231B9D-E9F6-4612-9B82-E89961B389AC}" type="datetimeFigureOut">
               <a:rPr lang="pt-BR" smtClean="0"/>
-              <a:t>02/05/2023</a:t>
+              <a:t>08/05/2023</a:t>
             </a:fld>
             <a:endParaRPr lang="pt-BR"/>
           </a:p>
@@ -1030,7 +1030,7 @@
           <a:p>
             <a:fld id="{52231B9D-E9F6-4612-9B82-E89961B389AC}" type="datetimeFigureOut">
               <a:rPr lang="pt-BR" smtClean="0"/>
-              <a:t>02/05/2023</a:t>
+              <a:t>08/05/2023</a:t>
             </a:fld>
             <a:endParaRPr lang="pt-BR"/>
           </a:p>
@@ -1200,7 +1200,7 @@
           <a:p>
             <a:fld id="{52231B9D-E9F6-4612-9B82-E89961B389AC}" type="datetimeFigureOut">
               <a:rPr lang="pt-BR" smtClean="0"/>
-              <a:t>02/05/2023</a:t>
+              <a:t>08/05/2023</a:t>
             </a:fld>
             <a:endParaRPr lang="pt-BR"/>
           </a:p>
@@ -1446,7 +1446,7 @@
           <a:p>
             <a:fld id="{52231B9D-E9F6-4612-9B82-E89961B389AC}" type="datetimeFigureOut">
               <a:rPr lang="pt-BR" smtClean="0"/>
-              <a:t>02/05/2023</a:t>
+              <a:t>08/05/2023</a:t>
             </a:fld>
             <a:endParaRPr lang="pt-BR"/>
           </a:p>
@@ -1678,7 +1678,7 @@
           <a:p>
             <a:fld id="{52231B9D-E9F6-4612-9B82-E89961B389AC}" type="datetimeFigureOut">
               <a:rPr lang="pt-BR" smtClean="0"/>
-              <a:t>02/05/2023</a:t>
+              <a:t>08/05/2023</a:t>
             </a:fld>
             <a:endParaRPr lang="pt-BR"/>
           </a:p>
@@ -2045,7 +2045,7 @@
           <a:p>
             <a:fld id="{52231B9D-E9F6-4612-9B82-E89961B389AC}" type="datetimeFigureOut">
               <a:rPr lang="pt-BR" smtClean="0"/>
-              <a:t>02/05/2023</a:t>
+              <a:t>08/05/2023</a:t>
             </a:fld>
             <a:endParaRPr lang="pt-BR"/>
           </a:p>
@@ -2163,7 +2163,7 @@
           <a:p>
             <a:fld id="{52231B9D-E9F6-4612-9B82-E89961B389AC}" type="datetimeFigureOut">
               <a:rPr lang="pt-BR" smtClean="0"/>
-              <a:t>02/05/2023</a:t>
+              <a:t>08/05/2023</a:t>
             </a:fld>
             <a:endParaRPr lang="pt-BR"/>
           </a:p>
@@ -2258,7 +2258,7 @@
           <a:p>
             <a:fld id="{52231B9D-E9F6-4612-9B82-E89961B389AC}" type="datetimeFigureOut">
               <a:rPr lang="pt-BR" smtClean="0"/>
-              <a:t>02/05/2023</a:t>
+              <a:t>08/05/2023</a:t>
             </a:fld>
             <a:endParaRPr lang="pt-BR"/>
           </a:p>
@@ -2535,7 +2535,7 @@
           <a:p>
             <a:fld id="{52231B9D-E9F6-4612-9B82-E89961B389AC}" type="datetimeFigureOut">
               <a:rPr lang="pt-BR" smtClean="0"/>
-              <a:t>02/05/2023</a:t>
+              <a:t>08/05/2023</a:t>
             </a:fld>
             <a:endParaRPr lang="pt-BR"/>
           </a:p>
@@ -2788,7 +2788,7 @@
           <a:p>
             <a:fld id="{52231B9D-E9F6-4612-9B82-E89961B389AC}" type="datetimeFigureOut">
               <a:rPr lang="pt-BR" smtClean="0"/>
-              <a:t>02/05/2023</a:t>
+              <a:t>08/05/2023</a:t>
             </a:fld>
             <a:endParaRPr lang="pt-BR"/>
           </a:p>
@@ -3001,7 +3001,7 @@
           <a:p>
             <a:fld id="{52231B9D-E9F6-4612-9B82-E89961B389AC}" type="datetimeFigureOut">
               <a:rPr lang="pt-BR" smtClean="0"/>
-              <a:t>02/05/2023</a:t>
+              <a:t>08/05/2023</a:t>
             </a:fld>
             <a:endParaRPr lang="pt-BR"/>
           </a:p>
@@ -3665,7 +3665,7 @@
                   </a:schemeClr>
                 </a:solidFill>
               </a:rPr>
-              <a:t>30</a:t>
+              <a:t>28</a:t>
             </a:r>
             <a:r>
               <a:rPr lang="pt-BR" sz="1600" dirty="0" smtClean="0">
@@ -3675,7 +3675,7 @@
                   </a:schemeClr>
                 </a:solidFill>
               </a:rPr>
-              <a:t>/04/2023</a:t>
+              <a:t>/05/2023</a:t>
             </a:r>
             <a:endParaRPr lang="pt-BR" sz="1600" dirty="0">
               <a:solidFill>

</xml_diff>

<commit_message>
att gráfico pós cancelamento do dia 13/05/2023
</commit_message>
<xml_diff>
--- a/tempimento.pptx
+++ b/tempimento.pptx
@@ -11,7 +11,7 @@
     <p:sldId id="256" r:id="rId2"/>
   </p:sldIdLst>
   <p:sldSz cx="12192000" cy="6858000"/>
-  <p:notesSz cx="6797675" cy="9872663"/>
+  <p:notesSz cx="6889750" cy="9671050"/>
   <p:defaultTextStyle>
     <a:defPPr>
       <a:defRPr lang="pt-BR"/>
@@ -150,7 +150,7 @@
         <p:spPr>
           <a:xfrm>
             <a:off x="6" y="1"/>
-            <a:ext cx="2946065" cy="494629"/>
+            <a:ext cx="2985970" cy="484528"/>
           </a:xfrm>
           <a:prstGeom prst="rect">
             <a:avLst/>
@@ -180,8 +180,8 @@
         </p:nvSpPr>
         <p:spPr>
           <a:xfrm>
-            <a:off x="3850097" y="1"/>
-            <a:ext cx="2946065" cy="494629"/>
+            <a:off x="3902247" y="1"/>
+            <a:ext cx="2985970" cy="484528"/>
           </a:xfrm>
           <a:prstGeom prst="rect">
             <a:avLst/>
@@ -197,7 +197,7 @@
           <a:p>
             <a:fld id="{A584E3A2-E8EA-4705-A613-CFE9F6F5D3B4}" type="datetimeFigureOut">
               <a:rPr lang="pt-BR" smtClean="0"/>
-              <a:t>08/05/2023</a:t>
+              <a:t>16/05/2023</a:t>
             </a:fld>
             <a:endParaRPr lang="pt-BR"/>
           </a:p>
@@ -215,8 +215,8 @@
         </p:nvSpPr>
         <p:spPr>
           <a:xfrm>
-            <a:off x="438150" y="1235075"/>
-            <a:ext cx="5921375" cy="3330575"/>
+            <a:off x="544513" y="1209675"/>
+            <a:ext cx="5800725" cy="3262313"/>
           </a:xfrm>
           <a:prstGeom prst="rect">
             <a:avLst/>
@@ -248,8 +248,8 @@
         </p:nvSpPr>
         <p:spPr>
           <a:xfrm>
-            <a:off x="679163" y="4751805"/>
-            <a:ext cx="5439356" cy="3886586"/>
+            <a:off x="688363" y="4654767"/>
+            <a:ext cx="5513032" cy="3807217"/>
           </a:xfrm>
           <a:prstGeom prst="rect">
             <a:avLst/>
@@ -308,8 +308,8 @@
         </p:nvSpPr>
         <p:spPr>
           <a:xfrm>
-            <a:off x="6" y="9378036"/>
-            <a:ext cx="2946065" cy="494629"/>
+            <a:off x="6" y="9186524"/>
+            <a:ext cx="2985970" cy="484528"/>
           </a:xfrm>
           <a:prstGeom prst="rect">
             <a:avLst/>
@@ -339,8 +339,8 @@
         </p:nvSpPr>
         <p:spPr>
           <a:xfrm>
-            <a:off x="3850097" y="9378036"/>
-            <a:ext cx="2946065" cy="494629"/>
+            <a:off x="3902247" y="9186524"/>
+            <a:ext cx="2985970" cy="484528"/>
           </a:xfrm>
           <a:prstGeom prst="rect">
             <a:avLst/>
@@ -680,7 +680,7 @@
           <a:p>
             <a:fld id="{52231B9D-E9F6-4612-9B82-E89961B389AC}" type="datetimeFigureOut">
               <a:rPr lang="pt-BR" smtClean="0"/>
-              <a:t>08/05/2023</a:t>
+              <a:t>16/05/2023</a:t>
             </a:fld>
             <a:endParaRPr lang="pt-BR"/>
           </a:p>
@@ -850,7 +850,7 @@
           <a:p>
             <a:fld id="{52231B9D-E9F6-4612-9B82-E89961B389AC}" type="datetimeFigureOut">
               <a:rPr lang="pt-BR" smtClean="0"/>
-              <a:t>08/05/2023</a:t>
+              <a:t>16/05/2023</a:t>
             </a:fld>
             <a:endParaRPr lang="pt-BR"/>
           </a:p>
@@ -1030,7 +1030,7 @@
           <a:p>
             <a:fld id="{52231B9D-E9F6-4612-9B82-E89961B389AC}" type="datetimeFigureOut">
               <a:rPr lang="pt-BR" smtClean="0"/>
-              <a:t>08/05/2023</a:t>
+              <a:t>16/05/2023</a:t>
             </a:fld>
             <a:endParaRPr lang="pt-BR"/>
           </a:p>
@@ -1200,7 +1200,7 @@
           <a:p>
             <a:fld id="{52231B9D-E9F6-4612-9B82-E89961B389AC}" type="datetimeFigureOut">
               <a:rPr lang="pt-BR" smtClean="0"/>
-              <a:t>08/05/2023</a:t>
+              <a:t>16/05/2023</a:t>
             </a:fld>
             <a:endParaRPr lang="pt-BR"/>
           </a:p>
@@ -1446,7 +1446,7 @@
           <a:p>
             <a:fld id="{52231B9D-E9F6-4612-9B82-E89961B389AC}" type="datetimeFigureOut">
               <a:rPr lang="pt-BR" smtClean="0"/>
-              <a:t>08/05/2023</a:t>
+              <a:t>16/05/2023</a:t>
             </a:fld>
             <a:endParaRPr lang="pt-BR"/>
           </a:p>
@@ -1678,7 +1678,7 @@
           <a:p>
             <a:fld id="{52231B9D-E9F6-4612-9B82-E89961B389AC}" type="datetimeFigureOut">
               <a:rPr lang="pt-BR" smtClean="0"/>
-              <a:t>08/05/2023</a:t>
+              <a:t>16/05/2023</a:t>
             </a:fld>
             <a:endParaRPr lang="pt-BR"/>
           </a:p>
@@ -2045,7 +2045,7 @@
           <a:p>
             <a:fld id="{52231B9D-E9F6-4612-9B82-E89961B389AC}" type="datetimeFigureOut">
               <a:rPr lang="pt-BR" smtClean="0"/>
-              <a:t>08/05/2023</a:t>
+              <a:t>16/05/2023</a:t>
             </a:fld>
             <a:endParaRPr lang="pt-BR"/>
           </a:p>
@@ -2163,7 +2163,7 @@
           <a:p>
             <a:fld id="{52231B9D-E9F6-4612-9B82-E89961B389AC}" type="datetimeFigureOut">
               <a:rPr lang="pt-BR" smtClean="0"/>
-              <a:t>08/05/2023</a:t>
+              <a:t>16/05/2023</a:t>
             </a:fld>
             <a:endParaRPr lang="pt-BR"/>
           </a:p>
@@ -2258,7 +2258,7 @@
           <a:p>
             <a:fld id="{52231B9D-E9F6-4612-9B82-E89961B389AC}" type="datetimeFigureOut">
               <a:rPr lang="pt-BR" smtClean="0"/>
-              <a:t>08/05/2023</a:t>
+              <a:t>16/05/2023</a:t>
             </a:fld>
             <a:endParaRPr lang="pt-BR"/>
           </a:p>
@@ -2535,7 +2535,7 @@
           <a:p>
             <a:fld id="{52231B9D-E9F6-4612-9B82-E89961B389AC}" type="datetimeFigureOut">
               <a:rPr lang="pt-BR" smtClean="0"/>
-              <a:t>08/05/2023</a:t>
+              <a:t>16/05/2023</a:t>
             </a:fld>
             <a:endParaRPr lang="pt-BR"/>
           </a:p>
@@ -2788,7 +2788,7 @@
           <a:p>
             <a:fld id="{52231B9D-E9F6-4612-9B82-E89961B389AC}" type="datetimeFigureOut">
               <a:rPr lang="pt-BR" smtClean="0"/>
-              <a:t>08/05/2023</a:t>
+              <a:t>16/05/2023</a:t>
             </a:fld>
             <a:endParaRPr lang="pt-BR"/>
           </a:p>
@@ -3001,7 +3001,7 @@
           <a:p>
             <a:fld id="{52231B9D-E9F6-4612-9B82-E89961B389AC}" type="datetimeFigureOut">
               <a:rPr lang="pt-BR" smtClean="0"/>
-              <a:t>08/05/2023</a:t>
+              <a:t>16/05/2023</a:t>
             </a:fld>
             <a:endParaRPr lang="pt-BR"/>
           </a:p>
@@ -3665,17 +3665,7 @@
                   </a:schemeClr>
                 </a:solidFill>
               </a:rPr>
-              <a:t>28</a:t>
-            </a:r>
-            <a:r>
-              <a:rPr lang="pt-BR" sz="1600" dirty="0" smtClean="0">
-                <a:solidFill>
-                  <a:schemeClr val="bg2">
-                    <a:lumMod val="90000"/>
-                  </a:schemeClr>
-                </a:solidFill>
-              </a:rPr>
-              <a:t>/05/2023</a:t>
+              <a:t>14/05/2023</a:t>
             </a:r>
             <a:endParaRPr lang="pt-BR" sz="1600" dirty="0">
               <a:solidFill>

</xml_diff>

<commit_message>
diagnóstico erro ETL custo viagem
</commit_message>
<xml_diff>
--- a/tempimento.pptx
+++ b/tempimento.pptx
@@ -197,7 +197,7 @@
           <a:p>
             <a:fld id="{A584E3A2-E8EA-4705-A613-CFE9F6F5D3B4}" type="datetimeFigureOut">
               <a:rPr lang="pt-BR" smtClean="0"/>
-              <a:t>16/05/2023</a:t>
+              <a:t>05/06/2023</a:t>
             </a:fld>
             <a:endParaRPr lang="pt-BR"/>
           </a:p>
@@ -680,7 +680,7 @@
           <a:p>
             <a:fld id="{52231B9D-E9F6-4612-9B82-E89961B389AC}" type="datetimeFigureOut">
               <a:rPr lang="pt-BR" smtClean="0"/>
-              <a:t>16/05/2023</a:t>
+              <a:t>05/06/2023</a:t>
             </a:fld>
             <a:endParaRPr lang="pt-BR"/>
           </a:p>
@@ -850,7 +850,7 @@
           <a:p>
             <a:fld id="{52231B9D-E9F6-4612-9B82-E89961B389AC}" type="datetimeFigureOut">
               <a:rPr lang="pt-BR" smtClean="0"/>
-              <a:t>16/05/2023</a:t>
+              <a:t>05/06/2023</a:t>
             </a:fld>
             <a:endParaRPr lang="pt-BR"/>
           </a:p>
@@ -1030,7 +1030,7 @@
           <a:p>
             <a:fld id="{52231B9D-E9F6-4612-9B82-E89961B389AC}" type="datetimeFigureOut">
               <a:rPr lang="pt-BR" smtClean="0"/>
-              <a:t>16/05/2023</a:t>
+              <a:t>05/06/2023</a:t>
             </a:fld>
             <a:endParaRPr lang="pt-BR"/>
           </a:p>
@@ -1200,7 +1200,7 @@
           <a:p>
             <a:fld id="{52231B9D-E9F6-4612-9B82-E89961B389AC}" type="datetimeFigureOut">
               <a:rPr lang="pt-BR" smtClean="0"/>
-              <a:t>16/05/2023</a:t>
+              <a:t>05/06/2023</a:t>
             </a:fld>
             <a:endParaRPr lang="pt-BR"/>
           </a:p>
@@ -1446,7 +1446,7 @@
           <a:p>
             <a:fld id="{52231B9D-E9F6-4612-9B82-E89961B389AC}" type="datetimeFigureOut">
               <a:rPr lang="pt-BR" smtClean="0"/>
-              <a:t>16/05/2023</a:t>
+              <a:t>05/06/2023</a:t>
             </a:fld>
             <a:endParaRPr lang="pt-BR"/>
           </a:p>
@@ -1678,7 +1678,7 @@
           <a:p>
             <a:fld id="{52231B9D-E9F6-4612-9B82-E89961B389AC}" type="datetimeFigureOut">
               <a:rPr lang="pt-BR" smtClean="0"/>
-              <a:t>16/05/2023</a:t>
+              <a:t>05/06/2023</a:t>
             </a:fld>
             <a:endParaRPr lang="pt-BR"/>
           </a:p>
@@ -2045,7 +2045,7 @@
           <a:p>
             <a:fld id="{52231B9D-E9F6-4612-9B82-E89961B389AC}" type="datetimeFigureOut">
               <a:rPr lang="pt-BR" smtClean="0"/>
-              <a:t>16/05/2023</a:t>
+              <a:t>05/06/2023</a:t>
             </a:fld>
             <a:endParaRPr lang="pt-BR"/>
           </a:p>
@@ -2163,7 +2163,7 @@
           <a:p>
             <a:fld id="{52231B9D-E9F6-4612-9B82-E89961B389AC}" type="datetimeFigureOut">
               <a:rPr lang="pt-BR" smtClean="0"/>
-              <a:t>16/05/2023</a:t>
+              <a:t>05/06/2023</a:t>
             </a:fld>
             <a:endParaRPr lang="pt-BR"/>
           </a:p>
@@ -2258,7 +2258,7 @@
           <a:p>
             <a:fld id="{52231B9D-E9F6-4612-9B82-E89961B389AC}" type="datetimeFigureOut">
               <a:rPr lang="pt-BR" smtClean="0"/>
-              <a:t>16/05/2023</a:t>
+              <a:t>05/06/2023</a:t>
             </a:fld>
             <a:endParaRPr lang="pt-BR"/>
           </a:p>
@@ -2535,7 +2535,7 @@
           <a:p>
             <a:fld id="{52231B9D-E9F6-4612-9B82-E89961B389AC}" type="datetimeFigureOut">
               <a:rPr lang="pt-BR" smtClean="0"/>
-              <a:t>16/05/2023</a:t>
+              <a:t>05/06/2023</a:t>
             </a:fld>
             <a:endParaRPr lang="pt-BR"/>
           </a:p>
@@ -2788,7 +2788,7 @@
           <a:p>
             <a:fld id="{52231B9D-E9F6-4612-9B82-E89961B389AC}" type="datetimeFigureOut">
               <a:rPr lang="pt-BR" smtClean="0"/>
-              <a:t>16/05/2023</a:t>
+              <a:t>05/06/2023</a:t>
             </a:fld>
             <a:endParaRPr lang="pt-BR"/>
           </a:p>
@@ -3001,7 +3001,7 @@
           <a:p>
             <a:fld id="{52231B9D-E9F6-4612-9B82-E89961B389AC}" type="datetimeFigureOut">
               <a:rPr lang="pt-BR" smtClean="0"/>
-              <a:t>16/05/2023</a:t>
+              <a:t>05/06/2023</a:t>
             </a:fld>
             <a:endParaRPr lang="pt-BR"/>
           </a:p>
@@ -3665,7 +3665,17 @@
                   </a:schemeClr>
                 </a:solidFill>
               </a:rPr>
-              <a:t>14/05/2023</a:t>
+              <a:t>04</a:t>
+            </a:r>
+            <a:r>
+              <a:rPr lang="pt-BR" sz="1600" dirty="0" smtClean="0">
+                <a:solidFill>
+                  <a:schemeClr val="bg2">
+                    <a:lumMod val="90000"/>
+                  </a:schemeClr>
+                </a:solidFill>
+              </a:rPr>
+              <a:t>/06/2023</a:t>
             </a:r>
             <a:endParaRPr lang="pt-BR" sz="1600" dirty="0">
               <a:solidFill>

</xml_diff>

<commit_message>
criar dimensões solicitação e pedido de compra
</commit_message>
<xml_diff>
--- a/tempimento.pptx
+++ b/tempimento.pptx
@@ -197,7 +197,7 @@
           <a:p>
             <a:fld id="{A584E3A2-E8EA-4705-A613-CFE9F6F5D3B4}" type="datetimeFigureOut">
               <a:rPr lang="pt-BR" smtClean="0"/>
-              <a:t>05/06/2023</a:t>
+              <a:t>10/06/2023</a:t>
             </a:fld>
             <a:endParaRPr lang="pt-BR"/>
           </a:p>
@@ -680,7 +680,7 @@
           <a:p>
             <a:fld id="{52231B9D-E9F6-4612-9B82-E89961B389AC}" type="datetimeFigureOut">
               <a:rPr lang="pt-BR" smtClean="0"/>
-              <a:t>05/06/2023</a:t>
+              <a:t>10/06/2023</a:t>
             </a:fld>
             <a:endParaRPr lang="pt-BR"/>
           </a:p>
@@ -850,7 +850,7 @@
           <a:p>
             <a:fld id="{52231B9D-E9F6-4612-9B82-E89961B389AC}" type="datetimeFigureOut">
               <a:rPr lang="pt-BR" smtClean="0"/>
-              <a:t>05/06/2023</a:t>
+              <a:t>10/06/2023</a:t>
             </a:fld>
             <a:endParaRPr lang="pt-BR"/>
           </a:p>
@@ -1030,7 +1030,7 @@
           <a:p>
             <a:fld id="{52231B9D-E9F6-4612-9B82-E89961B389AC}" type="datetimeFigureOut">
               <a:rPr lang="pt-BR" smtClean="0"/>
-              <a:t>05/06/2023</a:t>
+              <a:t>10/06/2023</a:t>
             </a:fld>
             <a:endParaRPr lang="pt-BR"/>
           </a:p>
@@ -1200,7 +1200,7 @@
           <a:p>
             <a:fld id="{52231B9D-E9F6-4612-9B82-E89961B389AC}" type="datetimeFigureOut">
               <a:rPr lang="pt-BR" smtClean="0"/>
-              <a:t>05/06/2023</a:t>
+              <a:t>10/06/2023</a:t>
             </a:fld>
             <a:endParaRPr lang="pt-BR"/>
           </a:p>
@@ -1446,7 +1446,7 @@
           <a:p>
             <a:fld id="{52231B9D-E9F6-4612-9B82-E89961B389AC}" type="datetimeFigureOut">
               <a:rPr lang="pt-BR" smtClean="0"/>
-              <a:t>05/06/2023</a:t>
+              <a:t>10/06/2023</a:t>
             </a:fld>
             <a:endParaRPr lang="pt-BR"/>
           </a:p>
@@ -1678,7 +1678,7 @@
           <a:p>
             <a:fld id="{52231B9D-E9F6-4612-9B82-E89961B389AC}" type="datetimeFigureOut">
               <a:rPr lang="pt-BR" smtClean="0"/>
-              <a:t>05/06/2023</a:t>
+              <a:t>10/06/2023</a:t>
             </a:fld>
             <a:endParaRPr lang="pt-BR"/>
           </a:p>
@@ -2045,7 +2045,7 @@
           <a:p>
             <a:fld id="{52231B9D-E9F6-4612-9B82-E89961B389AC}" type="datetimeFigureOut">
               <a:rPr lang="pt-BR" smtClean="0"/>
-              <a:t>05/06/2023</a:t>
+              <a:t>10/06/2023</a:t>
             </a:fld>
             <a:endParaRPr lang="pt-BR"/>
           </a:p>
@@ -2163,7 +2163,7 @@
           <a:p>
             <a:fld id="{52231B9D-E9F6-4612-9B82-E89961B389AC}" type="datetimeFigureOut">
               <a:rPr lang="pt-BR" smtClean="0"/>
-              <a:t>05/06/2023</a:t>
+              <a:t>10/06/2023</a:t>
             </a:fld>
             <a:endParaRPr lang="pt-BR"/>
           </a:p>
@@ -2258,7 +2258,7 @@
           <a:p>
             <a:fld id="{52231B9D-E9F6-4612-9B82-E89961B389AC}" type="datetimeFigureOut">
               <a:rPr lang="pt-BR" smtClean="0"/>
-              <a:t>05/06/2023</a:t>
+              <a:t>10/06/2023</a:t>
             </a:fld>
             <a:endParaRPr lang="pt-BR"/>
           </a:p>
@@ -2535,7 +2535,7 @@
           <a:p>
             <a:fld id="{52231B9D-E9F6-4612-9B82-E89961B389AC}" type="datetimeFigureOut">
               <a:rPr lang="pt-BR" smtClean="0"/>
-              <a:t>05/06/2023</a:t>
+              <a:t>10/06/2023</a:t>
             </a:fld>
             <a:endParaRPr lang="pt-BR"/>
           </a:p>
@@ -2788,7 +2788,7 @@
           <a:p>
             <a:fld id="{52231B9D-E9F6-4612-9B82-E89961B389AC}" type="datetimeFigureOut">
               <a:rPr lang="pt-BR" smtClean="0"/>
-              <a:t>05/06/2023</a:t>
+              <a:t>10/06/2023</a:t>
             </a:fld>
             <a:endParaRPr lang="pt-BR"/>
           </a:p>
@@ -3001,7 +3001,7 @@
           <a:p>
             <a:fld id="{52231B9D-E9F6-4612-9B82-E89961B389AC}" type="datetimeFigureOut">
               <a:rPr lang="pt-BR" smtClean="0"/>
-              <a:t>05/06/2023</a:t>
+              <a:t>10/06/2023</a:t>
             </a:fld>
             <a:endParaRPr lang="pt-BR"/>
           </a:p>
@@ -3665,7 +3665,7 @@
                   </a:schemeClr>
                 </a:solidFill>
               </a:rPr>
-              <a:t>04</a:t>
+              <a:t>11</a:t>
             </a:r>
             <a:r>
               <a:rPr lang="pt-BR" sz="1600" dirty="0" smtClean="0">

</xml_diff>

<commit_message>
separação número OS e ano; modelar devolução
</commit_message>
<xml_diff>
--- a/tempimento.pptx
+++ b/tempimento.pptx
@@ -11,7 +11,7 @@
     <p:sldId id="256" r:id="rId2"/>
   </p:sldIdLst>
   <p:sldSz cx="12192000" cy="6858000"/>
-  <p:notesSz cx="6889750" cy="9671050"/>
+  <p:notesSz cx="6797675" cy="9872663"/>
   <p:defaultTextStyle>
     <a:defPPr>
       <a:defRPr lang="pt-BR"/>
@@ -150,7 +150,7 @@
         <p:spPr>
           <a:xfrm>
             <a:off x="6" y="1"/>
-            <a:ext cx="2985970" cy="484528"/>
+            <a:ext cx="2946065" cy="494629"/>
           </a:xfrm>
           <a:prstGeom prst="rect">
             <a:avLst/>
@@ -180,8 +180,8 @@
         </p:nvSpPr>
         <p:spPr>
           <a:xfrm>
-            <a:off x="3902247" y="1"/>
-            <a:ext cx="2985970" cy="484528"/>
+            <a:off x="3850097" y="1"/>
+            <a:ext cx="2946065" cy="494629"/>
           </a:xfrm>
           <a:prstGeom prst="rect">
             <a:avLst/>
@@ -197,7 +197,7 @@
           <a:p>
             <a:fld id="{A584E3A2-E8EA-4705-A613-CFE9F6F5D3B4}" type="datetimeFigureOut">
               <a:rPr lang="pt-BR" smtClean="0"/>
-              <a:t>19/06/2023</a:t>
+              <a:t>23/06/2023</a:t>
             </a:fld>
             <a:endParaRPr lang="pt-BR"/>
           </a:p>
@@ -215,8 +215,8 @@
         </p:nvSpPr>
         <p:spPr>
           <a:xfrm>
-            <a:off x="544513" y="1209675"/>
-            <a:ext cx="5800725" cy="3262313"/>
+            <a:off x="439738" y="1235075"/>
+            <a:ext cx="5918200" cy="3330575"/>
           </a:xfrm>
           <a:prstGeom prst="rect">
             <a:avLst/>
@@ -248,8 +248,8 @@
         </p:nvSpPr>
         <p:spPr>
           <a:xfrm>
-            <a:off x="688363" y="4654767"/>
-            <a:ext cx="5513032" cy="3807217"/>
+            <a:off x="679163" y="4751806"/>
+            <a:ext cx="5439356" cy="3886586"/>
           </a:xfrm>
           <a:prstGeom prst="rect">
             <a:avLst/>
@@ -308,8 +308,8 @@
         </p:nvSpPr>
         <p:spPr>
           <a:xfrm>
-            <a:off x="6" y="9186524"/>
-            <a:ext cx="2985970" cy="484528"/>
+            <a:off x="6" y="9378036"/>
+            <a:ext cx="2946065" cy="494629"/>
           </a:xfrm>
           <a:prstGeom prst="rect">
             <a:avLst/>
@@ -339,8 +339,8 @@
         </p:nvSpPr>
         <p:spPr>
           <a:xfrm>
-            <a:off x="3902247" y="9186524"/>
-            <a:ext cx="2985970" cy="484528"/>
+            <a:off x="3850097" y="9378036"/>
+            <a:ext cx="2946065" cy="494629"/>
           </a:xfrm>
           <a:prstGeom prst="rect">
             <a:avLst/>
@@ -680,7 +680,7 @@
           <a:p>
             <a:fld id="{52231B9D-E9F6-4612-9B82-E89961B389AC}" type="datetimeFigureOut">
               <a:rPr lang="pt-BR" smtClean="0"/>
-              <a:t>19/06/2023</a:t>
+              <a:t>23/06/2023</a:t>
             </a:fld>
             <a:endParaRPr lang="pt-BR"/>
           </a:p>
@@ -850,7 +850,7 @@
           <a:p>
             <a:fld id="{52231B9D-E9F6-4612-9B82-E89961B389AC}" type="datetimeFigureOut">
               <a:rPr lang="pt-BR" smtClean="0"/>
-              <a:t>19/06/2023</a:t>
+              <a:t>23/06/2023</a:t>
             </a:fld>
             <a:endParaRPr lang="pt-BR"/>
           </a:p>
@@ -1030,7 +1030,7 @@
           <a:p>
             <a:fld id="{52231B9D-E9F6-4612-9B82-E89961B389AC}" type="datetimeFigureOut">
               <a:rPr lang="pt-BR" smtClean="0"/>
-              <a:t>19/06/2023</a:t>
+              <a:t>23/06/2023</a:t>
             </a:fld>
             <a:endParaRPr lang="pt-BR"/>
           </a:p>
@@ -1200,7 +1200,7 @@
           <a:p>
             <a:fld id="{52231B9D-E9F6-4612-9B82-E89961B389AC}" type="datetimeFigureOut">
               <a:rPr lang="pt-BR" smtClean="0"/>
-              <a:t>19/06/2023</a:t>
+              <a:t>23/06/2023</a:t>
             </a:fld>
             <a:endParaRPr lang="pt-BR"/>
           </a:p>
@@ -1446,7 +1446,7 @@
           <a:p>
             <a:fld id="{52231B9D-E9F6-4612-9B82-E89961B389AC}" type="datetimeFigureOut">
               <a:rPr lang="pt-BR" smtClean="0"/>
-              <a:t>19/06/2023</a:t>
+              <a:t>23/06/2023</a:t>
             </a:fld>
             <a:endParaRPr lang="pt-BR"/>
           </a:p>
@@ -1678,7 +1678,7 @@
           <a:p>
             <a:fld id="{52231B9D-E9F6-4612-9B82-E89961B389AC}" type="datetimeFigureOut">
               <a:rPr lang="pt-BR" smtClean="0"/>
-              <a:t>19/06/2023</a:t>
+              <a:t>23/06/2023</a:t>
             </a:fld>
             <a:endParaRPr lang="pt-BR"/>
           </a:p>
@@ -2045,7 +2045,7 @@
           <a:p>
             <a:fld id="{52231B9D-E9F6-4612-9B82-E89961B389AC}" type="datetimeFigureOut">
               <a:rPr lang="pt-BR" smtClean="0"/>
-              <a:t>19/06/2023</a:t>
+              <a:t>23/06/2023</a:t>
             </a:fld>
             <a:endParaRPr lang="pt-BR"/>
           </a:p>
@@ -2163,7 +2163,7 @@
           <a:p>
             <a:fld id="{52231B9D-E9F6-4612-9B82-E89961B389AC}" type="datetimeFigureOut">
               <a:rPr lang="pt-BR" smtClean="0"/>
-              <a:t>19/06/2023</a:t>
+              <a:t>23/06/2023</a:t>
             </a:fld>
             <a:endParaRPr lang="pt-BR"/>
           </a:p>
@@ -2258,7 +2258,7 @@
           <a:p>
             <a:fld id="{52231B9D-E9F6-4612-9B82-E89961B389AC}" type="datetimeFigureOut">
               <a:rPr lang="pt-BR" smtClean="0"/>
-              <a:t>19/06/2023</a:t>
+              <a:t>23/06/2023</a:t>
             </a:fld>
             <a:endParaRPr lang="pt-BR"/>
           </a:p>
@@ -2535,7 +2535,7 @@
           <a:p>
             <a:fld id="{52231B9D-E9F6-4612-9B82-E89961B389AC}" type="datetimeFigureOut">
               <a:rPr lang="pt-BR" smtClean="0"/>
-              <a:t>19/06/2023</a:t>
+              <a:t>23/06/2023</a:t>
             </a:fld>
             <a:endParaRPr lang="pt-BR"/>
           </a:p>
@@ -2788,7 +2788,7 @@
           <a:p>
             <a:fld id="{52231B9D-E9F6-4612-9B82-E89961B389AC}" type="datetimeFigureOut">
               <a:rPr lang="pt-BR" smtClean="0"/>
-              <a:t>19/06/2023</a:t>
+              <a:t>23/06/2023</a:t>
             </a:fld>
             <a:endParaRPr lang="pt-BR"/>
           </a:p>
@@ -3001,7 +3001,7 @@
           <a:p>
             <a:fld id="{52231B9D-E9F6-4612-9B82-E89961B389AC}" type="datetimeFigureOut">
               <a:rPr lang="pt-BR" smtClean="0"/>
-              <a:t>19/06/2023</a:t>
+              <a:t>23/06/2023</a:t>
             </a:fld>
             <a:endParaRPr lang="pt-BR"/>
           </a:p>
@@ -3665,7 +3665,17 @@
                   </a:schemeClr>
                 </a:solidFill>
               </a:rPr>
-              <a:t>18/06/2023</a:t>
+              <a:t>31</a:t>
+            </a:r>
+            <a:r>
+              <a:rPr lang="pt-BR" sz="1600" dirty="0" smtClean="0">
+                <a:solidFill>
+                  <a:schemeClr val="bg2">
+                    <a:lumMod val="90000"/>
+                  </a:schemeClr>
+                </a:solidFill>
+              </a:rPr>
+              <a:t>/07/2023</a:t>
             </a:r>
             <a:endParaRPr lang="pt-BR" sz="1600" dirty="0">
               <a:solidFill>

</xml_diff>

<commit_message>
consulta atendimento de OS para todos os insumos
</commit_message>
<xml_diff>
--- a/tempimento.pptx
+++ b/tempimento.pptx
@@ -197,7 +197,7 @@
           <a:p>
             <a:fld id="{A584E3A2-E8EA-4705-A613-CFE9F6F5D3B4}" type="datetimeFigureOut">
               <a:rPr lang="pt-BR" smtClean="0"/>
-              <a:t>23/06/2023</a:t>
+              <a:t>07/07/2023</a:t>
             </a:fld>
             <a:endParaRPr lang="pt-BR"/>
           </a:p>
@@ -680,7 +680,7 @@
           <a:p>
             <a:fld id="{52231B9D-E9F6-4612-9B82-E89961B389AC}" type="datetimeFigureOut">
               <a:rPr lang="pt-BR" smtClean="0"/>
-              <a:t>23/06/2023</a:t>
+              <a:t>07/07/2023</a:t>
             </a:fld>
             <a:endParaRPr lang="pt-BR"/>
           </a:p>
@@ -850,7 +850,7 @@
           <a:p>
             <a:fld id="{52231B9D-E9F6-4612-9B82-E89961B389AC}" type="datetimeFigureOut">
               <a:rPr lang="pt-BR" smtClean="0"/>
-              <a:t>23/06/2023</a:t>
+              <a:t>07/07/2023</a:t>
             </a:fld>
             <a:endParaRPr lang="pt-BR"/>
           </a:p>
@@ -1030,7 +1030,7 @@
           <a:p>
             <a:fld id="{52231B9D-E9F6-4612-9B82-E89961B389AC}" type="datetimeFigureOut">
               <a:rPr lang="pt-BR" smtClean="0"/>
-              <a:t>23/06/2023</a:t>
+              <a:t>07/07/2023</a:t>
             </a:fld>
             <a:endParaRPr lang="pt-BR"/>
           </a:p>
@@ -1200,7 +1200,7 @@
           <a:p>
             <a:fld id="{52231B9D-E9F6-4612-9B82-E89961B389AC}" type="datetimeFigureOut">
               <a:rPr lang="pt-BR" smtClean="0"/>
-              <a:t>23/06/2023</a:t>
+              <a:t>07/07/2023</a:t>
             </a:fld>
             <a:endParaRPr lang="pt-BR"/>
           </a:p>
@@ -1446,7 +1446,7 @@
           <a:p>
             <a:fld id="{52231B9D-E9F6-4612-9B82-E89961B389AC}" type="datetimeFigureOut">
               <a:rPr lang="pt-BR" smtClean="0"/>
-              <a:t>23/06/2023</a:t>
+              <a:t>07/07/2023</a:t>
             </a:fld>
             <a:endParaRPr lang="pt-BR"/>
           </a:p>
@@ -1678,7 +1678,7 @@
           <a:p>
             <a:fld id="{52231B9D-E9F6-4612-9B82-E89961B389AC}" type="datetimeFigureOut">
               <a:rPr lang="pt-BR" smtClean="0"/>
-              <a:t>23/06/2023</a:t>
+              <a:t>07/07/2023</a:t>
             </a:fld>
             <a:endParaRPr lang="pt-BR"/>
           </a:p>
@@ -2045,7 +2045,7 @@
           <a:p>
             <a:fld id="{52231B9D-E9F6-4612-9B82-E89961B389AC}" type="datetimeFigureOut">
               <a:rPr lang="pt-BR" smtClean="0"/>
-              <a:t>23/06/2023</a:t>
+              <a:t>07/07/2023</a:t>
             </a:fld>
             <a:endParaRPr lang="pt-BR"/>
           </a:p>
@@ -2163,7 +2163,7 @@
           <a:p>
             <a:fld id="{52231B9D-E9F6-4612-9B82-E89961B389AC}" type="datetimeFigureOut">
               <a:rPr lang="pt-BR" smtClean="0"/>
-              <a:t>23/06/2023</a:t>
+              <a:t>07/07/2023</a:t>
             </a:fld>
             <a:endParaRPr lang="pt-BR"/>
           </a:p>
@@ -2258,7 +2258,7 @@
           <a:p>
             <a:fld id="{52231B9D-E9F6-4612-9B82-E89961B389AC}" type="datetimeFigureOut">
               <a:rPr lang="pt-BR" smtClean="0"/>
-              <a:t>23/06/2023</a:t>
+              <a:t>07/07/2023</a:t>
             </a:fld>
             <a:endParaRPr lang="pt-BR"/>
           </a:p>
@@ -2535,7 +2535,7 @@
           <a:p>
             <a:fld id="{52231B9D-E9F6-4612-9B82-E89961B389AC}" type="datetimeFigureOut">
               <a:rPr lang="pt-BR" smtClean="0"/>
-              <a:t>23/06/2023</a:t>
+              <a:t>07/07/2023</a:t>
             </a:fld>
             <a:endParaRPr lang="pt-BR"/>
           </a:p>
@@ -2788,7 +2788,7 @@
           <a:p>
             <a:fld id="{52231B9D-E9F6-4612-9B82-E89961B389AC}" type="datetimeFigureOut">
               <a:rPr lang="pt-BR" smtClean="0"/>
-              <a:t>23/06/2023</a:t>
+              <a:t>07/07/2023</a:t>
             </a:fld>
             <a:endParaRPr lang="pt-BR"/>
           </a:p>
@@ -3001,7 +3001,7 @@
           <a:p>
             <a:fld id="{52231B9D-E9F6-4612-9B82-E89961B389AC}" type="datetimeFigureOut">
               <a:rPr lang="pt-BR" smtClean="0"/>
-              <a:t>23/06/2023</a:t>
+              <a:t>07/07/2023</a:t>
             </a:fld>
             <a:endParaRPr lang="pt-BR"/>
           </a:p>
@@ -3665,7 +3665,7 @@
                   </a:schemeClr>
                 </a:solidFill>
               </a:rPr>
-              <a:t>31</a:t>
+              <a:t>13</a:t>
             </a:r>
             <a:r>
               <a:rPr lang="pt-BR" sz="1600" dirty="0" smtClean="0">
@@ -3675,7 +3675,7 @@
                   </a:schemeClr>
                 </a:solidFill>
               </a:rPr>
-              <a:t>/07/2023</a:t>
+              <a:t>/08/2023</a:t>
             </a:r>
             <a:endParaRPr lang="pt-BR" sz="1600" dirty="0">
               <a:solidFill>

</xml_diff>

<commit_message>
separação de contadores funcionário e lançamento
</commit_message>
<xml_diff>
--- a/tempimento.pptx
+++ b/tempimento.pptx
@@ -11,7 +11,7 @@
     <p:sldId id="256" r:id="rId2"/>
   </p:sldIdLst>
   <p:sldSz cx="12192000" cy="6858000"/>
-  <p:notesSz cx="6797675" cy="9872663"/>
+  <p:notesSz cx="6889750" cy="9671050"/>
   <p:defaultTextStyle>
     <a:defPPr>
       <a:defRPr lang="pt-BR"/>
@@ -150,7 +150,7 @@
         <p:spPr>
           <a:xfrm>
             <a:off x="6" y="1"/>
-            <a:ext cx="2946065" cy="494629"/>
+            <a:ext cx="2985970" cy="484528"/>
           </a:xfrm>
           <a:prstGeom prst="rect">
             <a:avLst/>
@@ -180,8 +180,8 @@
         </p:nvSpPr>
         <p:spPr>
           <a:xfrm>
-            <a:off x="3850097" y="1"/>
-            <a:ext cx="2946065" cy="494629"/>
+            <a:off x="3902247" y="1"/>
+            <a:ext cx="2985970" cy="484528"/>
           </a:xfrm>
           <a:prstGeom prst="rect">
             <a:avLst/>
@@ -197,7 +197,7 @@
           <a:p>
             <a:fld id="{A584E3A2-E8EA-4705-A613-CFE9F6F5D3B4}" type="datetimeFigureOut">
               <a:rPr lang="pt-BR" smtClean="0"/>
-              <a:t>07/07/2023</a:t>
+              <a:t>24/08/2023</a:t>
             </a:fld>
             <a:endParaRPr lang="pt-BR"/>
           </a:p>
@@ -215,8 +215,8 @@
         </p:nvSpPr>
         <p:spPr>
           <a:xfrm>
-            <a:off x="439738" y="1235075"/>
-            <a:ext cx="5918200" cy="3330575"/>
+            <a:off x="544513" y="1209675"/>
+            <a:ext cx="5800725" cy="3262313"/>
           </a:xfrm>
           <a:prstGeom prst="rect">
             <a:avLst/>
@@ -248,8 +248,8 @@
         </p:nvSpPr>
         <p:spPr>
           <a:xfrm>
-            <a:off x="679163" y="4751806"/>
-            <a:ext cx="5439356" cy="3886586"/>
+            <a:off x="688363" y="4654768"/>
+            <a:ext cx="5513032" cy="3807217"/>
           </a:xfrm>
           <a:prstGeom prst="rect">
             <a:avLst/>
@@ -308,8 +308,8 @@
         </p:nvSpPr>
         <p:spPr>
           <a:xfrm>
-            <a:off x="6" y="9378036"/>
-            <a:ext cx="2946065" cy="494629"/>
+            <a:off x="6" y="9186524"/>
+            <a:ext cx="2985970" cy="484528"/>
           </a:xfrm>
           <a:prstGeom prst="rect">
             <a:avLst/>
@@ -339,8 +339,8 @@
         </p:nvSpPr>
         <p:spPr>
           <a:xfrm>
-            <a:off x="3850097" y="9378036"/>
-            <a:ext cx="2946065" cy="494629"/>
+            <a:off x="3902247" y="9186524"/>
+            <a:ext cx="2985970" cy="484528"/>
           </a:xfrm>
           <a:prstGeom prst="rect">
             <a:avLst/>
@@ -680,7 +680,7 @@
           <a:p>
             <a:fld id="{52231B9D-E9F6-4612-9B82-E89961B389AC}" type="datetimeFigureOut">
               <a:rPr lang="pt-BR" smtClean="0"/>
-              <a:t>07/07/2023</a:t>
+              <a:t>24/08/2023</a:t>
             </a:fld>
             <a:endParaRPr lang="pt-BR"/>
           </a:p>
@@ -850,7 +850,7 @@
           <a:p>
             <a:fld id="{52231B9D-E9F6-4612-9B82-E89961B389AC}" type="datetimeFigureOut">
               <a:rPr lang="pt-BR" smtClean="0"/>
-              <a:t>07/07/2023</a:t>
+              <a:t>24/08/2023</a:t>
             </a:fld>
             <a:endParaRPr lang="pt-BR"/>
           </a:p>
@@ -1030,7 +1030,7 @@
           <a:p>
             <a:fld id="{52231B9D-E9F6-4612-9B82-E89961B389AC}" type="datetimeFigureOut">
               <a:rPr lang="pt-BR" smtClean="0"/>
-              <a:t>07/07/2023</a:t>
+              <a:t>24/08/2023</a:t>
             </a:fld>
             <a:endParaRPr lang="pt-BR"/>
           </a:p>
@@ -1200,7 +1200,7 @@
           <a:p>
             <a:fld id="{52231B9D-E9F6-4612-9B82-E89961B389AC}" type="datetimeFigureOut">
               <a:rPr lang="pt-BR" smtClean="0"/>
-              <a:t>07/07/2023</a:t>
+              <a:t>24/08/2023</a:t>
             </a:fld>
             <a:endParaRPr lang="pt-BR"/>
           </a:p>
@@ -1446,7 +1446,7 @@
           <a:p>
             <a:fld id="{52231B9D-E9F6-4612-9B82-E89961B389AC}" type="datetimeFigureOut">
               <a:rPr lang="pt-BR" smtClean="0"/>
-              <a:t>07/07/2023</a:t>
+              <a:t>24/08/2023</a:t>
             </a:fld>
             <a:endParaRPr lang="pt-BR"/>
           </a:p>
@@ -1678,7 +1678,7 @@
           <a:p>
             <a:fld id="{52231B9D-E9F6-4612-9B82-E89961B389AC}" type="datetimeFigureOut">
               <a:rPr lang="pt-BR" smtClean="0"/>
-              <a:t>07/07/2023</a:t>
+              <a:t>24/08/2023</a:t>
             </a:fld>
             <a:endParaRPr lang="pt-BR"/>
           </a:p>
@@ -2045,7 +2045,7 @@
           <a:p>
             <a:fld id="{52231B9D-E9F6-4612-9B82-E89961B389AC}" type="datetimeFigureOut">
               <a:rPr lang="pt-BR" smtClean="0"/>
-              <a:t>07/07/2023</a:t>
+              <a:t>24/08/2023</a:t>
             </a:fld>
             <a:endParaRPr lang="pt-BR"/>
           </a:p>
@@ -2163,7 +2163,7 @@
           <a:p>
             <a:fld id="{52231B9D-E9F6-4612-9B82-E89961B389AC}" type="datetimeFigureOut">
               <a:rPr lang="pt-BR" smtClean="0"/>
-              <a:t>07/07/2023</a:t>
+              <a:t>24/08/2023</a:t>
             </a:fld>
             <a:endParaRPr lang="pt-BR"/>
           </a:p>
@@ -2258,7 +2258,7 @@
           <a:p>
             <a:fld id="{52231B9D-E9F6-4612-9B82-E89961B389AC}" type="datetimeFigureOut">
               <a:rPr lang="pt-BR" smtClean="0"/>
-              <a:t>07/07/2023</a:t>
+              <a:t>24/08/2023</a:t>
             </a:fld>
             <a:endParaRPr lang="pt-BR"/>
           </a:p>
@@ -2535,7 +2535,7 @@
           <a:p>
             <a:fld id="{52231B9D-E9F6-4612-9B82-E89961B389AC}" type="datetimeFigureOut">
               <a:rPr lang="pt-BR" smtClean="0"/>
-              <a:t>07/07/2023</a:t>
+              <a:t>24/08/2023</a:t>
             </a:fld>
             <a:endParaRPr lang="pt-BR"/>
           </a:p>
@@ -2788,7 +2788,7 @@
           <a:p>
             <a:fld id="{52231B9D-E9F6-4612-9B82-E89961B389AC}" type="datetimeFigureOut">
               <a:rPr lang="pt-BR" smtClean="0"/>
-              <a:t>07/07/2023</a:t>
+              <a:t>24/08/2023</a:t>
             </a:fld>
             <a:endParaRPr lang="pt-BR"/>
           </a:p>
@@ -3001,7 +3001,7 @@
           <a:p>
             <a:fld id="{52231B9D-E9F6-4612-9B82-E89961B389AC}" type="datetimeFigureOut">
               <a:rPr lang="pt-BR" smtClean="0"/>
-              <a:t>07/07/2023</a:t>
+              <a:t>24/08/2023</a:t>
             </a:fld>
             <a:endParaRPr lang="pt-BR"/>
           </a:p>
@@ -3665,17 +3665,7 @@
                   </a:schemeClr>
                 </a:solidFill>
               </a:rPr>
-              <a:t>13</a:t>
-            </a:r>
-            <a:r>
-              <a:rPr lang="pt-BR" sz="1600" dirty="0" smtClean="0">
-                <a:solidFill>
-                  <a:schemeClr val="bg2">
-                    <a:lumMod val="90000"/>
-                  </a:schemeClr>
-                </a:solidFill>
-              </a:rPr>
-              <a:t>/08/2023</a:t>
+              <a:t>20/08/2023</a:t>
             </a:r>
             <a:endParaRPr lang="pt-BR" sz="1600" dirty="0">
               <a:solidFill>

</xml_diff>

<commit_message>
atualização do status da aprovação da SA
</commit_message>
<xml_diff>
--- a/tempimento.pptx
+++ b/tempimento.pptx
@@ -197,7 +197,7 @@
           <a:p>
             <a:fld id="{A584E3A2-E8EA-4705-A613-CFE9F6F5D3B4}" type="datetimeFigureOut">
               <a:rPr lang="pt-BR" smtClean="0"/>
-              <a:t>24/08/2023</a:t>
+              <a:t>29/08/2023</a:t>
             </a:fld>
             <a:endParaRPr lang="pt-BR"/>
           </a:p>
@@ -680,7 +680,7 @@
           <a:p>
             <a:fld id="{52231B9D-E9F6-4612-9B82-E89961B389AC}" type="datetimeFigureOut">
               <a:rPr lang="pt-BR" smtClean="0"/>
-              <a:t>24/08/2023</a:t>
+              <a:t>29/08/2023</a:t>
             </a:fld>
             <a:endParaRPr lang="pt-BR"/>
           </a:p>
@@ -850,7 +850,7 @@
           <a:p>
             <a:fld id="{52231B9D-E9F6-4612-9B82-E89961B389AC}" type="datetimeFigureOut">
               <a:rPr lang="pt-BR" smtClean="0"/>
-              <a:t>24/08/2023</a:t>
+              <a:t>29/08/2023</a:t>
             </a:fld>
             <a:endParaRPr lang="pt-BR"/>
           </a:p>
@@ -1030,7 +1030,7 @@
           <a:p>
             <a:fld id="{52231B9D-E9F6-4612-9B82-E89961B389AC}" type="datetimeFigureOut">
               <a:rPr lang="pt-BR" smtClean="0"/>
-              <a:t>24/08/2023</a:t>
+              <a:t>29/08/2023</a:t>
             </a:fld>
             <a:endParaRPr lang="pt-BR"/>
           </a:p>
@@ -1200,7 +1200,7 @@
           <a:p>
             <a:fld id="{52231B9D-E9F6-4612-9B82-E89961B389AC}" type="datetimeFigureOut">
               <a:rPr lang="pt-BR" smtClean="0"/>
-              <a:t>24/08/2023</a:t>
+              <a:t>29/08/2023</a:t>
             </a:fld>
             <a:endParaRPr lang="pt-BR"/>
           </a:p>
@@ -1446,7 +1446,7 @@
           <a:p>
             <a:fld id="{52231B9D-E9F6-4612-9B82-E89961B389AC}" type="datetimeFigureOut">
               <a:rPr lang="pt-BR" smtClean="0"/>
-              <a:t>24/08/2023</a:t>
+              <a:t>29/08/2023</a:t>
             </a:fld>
             <a:endParaRPr lang="pt-BR"/>
           </a:p>
@@ -1678,7 +1678,7 @@
           <a:p>
             <a:fld id="{52231B9D-E9F6-4612-9B82-E89961B389AC}" type="datetimeFigureOut">
               <a:rPr lang="pt-BR" smtClean="0"/>
-              <a:t>24/08/2023</a:t>
+              <a:t>29/08/2023</a:t>
             </a:fld>
             <a:endParaRPr lang="pt-BR"/>
           </a:p>
@@ -2045,7 +2045,7 @@
           <a:p>
             <a:fld id="{52231B9D-E9F6-4612-9B82-E89961B389AC}" type="datetimeFigureOut">
               <a:rPr lang="pt-BR" smtClean="0"/>
-              <a:t>24/08/2023</a:t>
+              <a:t>29/08/2023</a:t>
             </a:fld>
             <a:endParaRPr lang="pt-BR"/>
           </a:p>
@@ -2163,7 +2163,7 @@
           <a:p>
             <a:fld id="{52231B9D-E9F6-4612-9B82-E89961B389AC}" type="datetimeFigureOut">
               <a:rPr lang="pt-BR" smtClean="0"/>
-              <a:t>24/08/2023</a:t>
+              <a:t>29/08/2023</a:t>
             </a:fld>
             <a:endParaRPr lang="pt-BR"/>
           </a:p>
@@ -2258,7 +2258,7 @@
           <a:p>
             <a:fld id="{52231B9D-E9F6-4612-9B82-E89961B389AC}" type="datetimeFigureOut">
               <a:rPr lang="pt-BR" smtClean="0"/>
-              <a:t>24/08/2023</a:t>
+              <a:t>29/08/2023</a:t>
             </a:fld>
             <a:endParaRPr lang="pt-BR"/>
           </a:p>
@@ -2535,7 +2535,7 @@
           <a:p>
             <a:fld id="{52231B9D-E9F6-4612-9B82-E89961B389AC}" type="datetimeFigureOut">
               <a:rPr lang="pt-BR" smtClean="0"/>
-              <a:t>24/08/2023</a:t>
+              <a:t>29/08/2023</a:t>
             </a:fld>
             <a:endParaRPr lang="pt-BR"/>
           </a:p>
@@ -2788,7 +2788,7 @@
           <a:p>
             <a:fld id="{52231B9D-E9F6-4612-9B82-E89961B389AC}" type="datetimeFigureOut">
               <a:rPr lang="pt-BR" smtClean="0"/>
-              <a:t>24/08/2023</a:t>
+              <a:t>29/08/2023</a:t>
             </a:fld>
             <a:endParaRPr lang="pt-BR"/>
           </a:p>
@@ -3001,7 +3001,7 @@
           <a:p>
             <a:fld id="{52231B9D-E9F6-4612-9B82-E89961B389AC}" type="datetimeFigureOut">
               <a:rPr lang="pt-BR" smtClean="0"/>
-              <a:t>24/08/2023</a:t>
+              <a:t>29/08/2023</a:t>
             </a:fld>
             <a:endParaRPr lang="pt-BR"/>
           </a:p>
@@ -3665,7 +3665,7 @@
                   </a:schemeClr>
                 </a:solidFill>
               </a:rPr>
-              <a:t>20/08/2023</a:t>
+              <a:t>27/08/2023</a:t>
             </a:r>
             <a:endParaRPr lang="pt-BR" sz="1600" dirty="0">
               <a:solidFill>

</xml_diff>

<commit_message>
add saldo inicial e documentos de saída
</commit_message>
<xml_diff>
--- a/tempimento.pptx
+++ b/tempimento.pptx
@@ -197,7 +197,7 @@
           <a:p>
             <a:fld id="{A584E3A2-E8EA-4705-A613-CFE9F6F5D3B4}" type="datetimeFigureOut">
               <a:rPr lang="pt-BR" smtClean="0"/>
-              <a:t>29/08/2023</a:t>
+              <a:t>04/09/2023</a:t>
             </a:fld>
             <a:endParaRPr lang="pt-BR"/>
           </a:p>
@@ -680,7 +680,7 @@
           <a:p>
             <a:fld id="{52231B9D-E9F6-4612-9B82-E89961B389AC}" type="datetimeFigureOut">
               <a:rPr lang="pt-BR" smtClean="0"/>
-              <a:t>29/08/2023</a:t>
+              <a:t>04/09/2023</a:t>
             </a:fld>
             <a:endParaRPr lang="pt-BR"/>
           </a:p>
@@ -850,7 +850,7 @@
           <a:p>
             <a:fld id="{52231B9D-E9F6-4612-9B82-E89961B389AC}" type="datetimeFigureOut">
               <a:rPr lang="pt-BR" smtClean="0"/>
-              <a:t>29/08/2023</a:t>
+              <a:t>04/09/2023</a:t>
             </a:fld>
             <a:endParaRPr lang="pt-BR"/>
           </a:p>
@@ -1030,7 +1030,7 @@
           <a:p>
             <a:fld id="{52231B9D-E9F6-4612-9B82-E89961B389AC}" type="datetimeFigureOut">
               <a:rPr lang="pt-BR" smtClean="0"/>
-              <a:t>29/08/2023</a:t>
+              <a:t>04/09/2023</a:t>
             </a:fld>
             <a:endParaRPr lang="pt-BR"/>
           </a:p>
@@ -1200,7 +1200,7 @@
           <a:p>
             <a:fld id="{52231B9D-E9F6-4612-9B82-E89961B389AC}" type="datetimeFigureOut">
               <a:rPr lang="pt-BR" smtClean="0"/>
-              <a:t>29/08/2023</a:t>
+              <a:t>04/09/2023</a:t>
             </a:fld>
             <a:endParaRPr lang="pt-BR"/>
           </a:p>
@@ -1446,7 +1446,7 @@
           <a:p>
             <a:fld id="{52231B9D-E9F6-4612-9B82-E89961B389AC}" type="datetimeFigureOut">
               <a:rPr lang="pt-BR" smtClean="0"/>
-              <a:t>29/08/2023</a:t>
+              <a:t>04/09/2023</a:t>
             </a:fld>
             <a:endParaRPr lang="pt-BR"/>
           </a:p>
@@ -1678,7 +1678,7 @@
           <a:p>
             <a:fld id="{52231B9D-E9F6-4612-9B82-E89961B389AC}" type="datetimeFigureOut">
               <a:rPr lang="pt-BR" smtClean="0"/>
-              <a:t>29/08/2023</a:t>
+              <a:t>04/09/2023</a:t>
             </a:fld>
             <a:endParaRPr lang="pt-BR"/>
           </a:p>
@@ -2045,7 +2045,7 @@
           <a:p>
             <a:fld id="{52231B9D-E9F6-4612-9B82-E89961B389AC}" type="datetimeFigureOut">
               <a:rPr lang="pt-BR" smtClean="0"/>
-              <a:t>29/08/2023</a:t>
+              <a:t>04/09/2023</a:t>
             </a:fld>
             <a:endParaRPr lang="pt-BR"/>
           </a:p>
@@ -2163,7 +2163,7 @@
           <a:p>
             <a:fld id="{52231B9D-E9F6-4612-9B82-E89961B389AC}" type="datetimeFigureOut">
               <a:rPr lang="pt-BR" smtClean="0"/>
-              <a:t>29/08/2023</a:t>
+              <a:t>04/09/2023</a:t>
             </a:fld>
             <a:endParaRPr lang="pt-BR"/>
           </a:p>
@@ -2258,7 +2258,7 @@
           <a:p>
             <a:fld id="{52231B9D-E9F6-4612-9B82-E89961B389AC}" type="datetimeFigureOut">
               <a:rPr lang="pt-BR" smtClean="0"/>
-              <a:t>29/08/2023</a:t>
+              <a:t>04/09/2023</a:t>
             </a:fld>
             <a:endParaRPr lang="pt-BR"/>
           </a:p>
@@ -2535,7 +2535,7 @@
           <a:p>
             <a:fld id="{52231B9D-E9F6-4612-9B82-E89961B389AC}" type="datetimeFigureOut">
               <a:rPr lang="pt-BR" smtClean="0"/>
-              <a:t>29/08/2023</a:t>
+              <a:t>04/09/2023</a:t>
             </a:fld>
             <a:endParaRPr lang="pt-BR"/>
           </a:p>
@@ -2788,7 +2788,7 @@
           <a:p>
             <a:fld id="{52231B9D-E9F6-4612-9B82-E89961B389AC}" type="datetimeFigureOut">
               <a:rPr lang="pt-BR" smtClean="0"/>
-              <a:t>29/08/2023</a:t>
+              <a:t>04/09/2023</a:t>
             </a:fld>
             <a:endParaRPr lang="pt-BR"/>
           </a:p>
@@ -3001,7 +3001,7 @@
           <a:p>
             <a:fld id="{52231B9D-E9F6-4612-9B82-E89961B389AC}" type="datetimeFigureOut">
               <a:rPr lang="pt-BR" smtClean="0"/>
-              <a:t>29/08/2023</a:t>
+              <a:t>04/09/2023</a:t>
             </a:fld>
             <a:endParaRPr lang="pt-BR"/>
           </a:p>
@@ -3658,14 +3658,24 @@
           <a:lstStyle/>
           <a:p>
             <a:r>
-              <a:rPr lang="pt-BR" sz="1600" dirty="0" smtClean="0">
+              <a:rPr lang="pt-BR" sz="1600" smtClean="0">
                 <a:solidFill>
                   <a:schemeClr val="bg2">
                     <a:lumMod val="90000"/>
                   </a:schemeClr>
                 </a:solidFill>
               </a:rPr>
-              <a:t>27/08/2023</a:t>
+              <a:t>03</a:t>
+            </a:r>
+            <a:r>
+              <a:rPr lang="pt-BR" sz="1600" smtClean="0">
+                <a:solidFill>
+                  <a:schemeClr val="bg2">
+                    <a:lumMod val="90000"/>
+                  </a:schemeClr>
+                </a:solidFill>
+              </a:rPr>
+              <a:t>/09/2023</a:t>
             </a:r>
             <a:endParaRPr lang="pt-BR" sz="1600" dirty="0">
               <a:solidFill>

</xml_diff>

<commit_message>
com o fim do projeto de pneus, criar os indicadores
</commit_message>
<xml_diff>
--- a/tempimento.pptx
+++ b/tempimento.pptx
@@ -197,7 +197,7 @@
           <a:p>
             <a:fld id="{A584E3A2-E8EA-4705-A613-CFE9F6F5D3B4}" type="datetimeFigureOut">
               <a:rPr lang="pt-BR" smtClean="0"/>
-              <a:t>04/09/2023</a:t>
+              <a:t>14/09/2023</a:t>
             </a:fld>
             <a:endParaRPr lang="pt-BR"/>
           </a:p>
@@ -680,7 +680,7 @@
           <a:p>
             <a:fld id="{52231B9D-E9F6-4612-9B82-E89961B389AC}" type="datetimeFigureOut">
               <a:rPr lang="pt-BR" smtClean="0"/>
-              <a:t>04/09/2023</a:t>
+              <a:t>14/09/2023</a:t>
             </a:fld>
             <a:endParaRPr lang="pt-BR"/>
           </a:p>
@@ -850,7 +850,7 @@
           <a:p>
             <a:fld id="{52231B9D-E9F6-4612-9B82-E89961B389AC}" type="datetimeFigureOut">
               <a:rPr lang="pt-BR" smtClean="0"/>
-              <a:t>04/09/2023</a:t>
+              <a:t>14/09/2023</a:t>
             </a:fld>
             <a:endParaRPr lang="pt-BR"/>
           </a:p>
@@ -1030,7 +1030,7 @@
           <a:p>
             <a:fld id="{52231B9D-E9F6-4612-9B82-E89961B389AC}" type="datetimeFigureOut">
               <a:rPr lang="pt-BR" smtClean="0"/>
-              <a:t>04/09/2023</a:t>
+              <a:t>14/09/2023</a:t>
             </a:fld>
             <a:endParaRPr lang="pt-BR"/>
           </a:p>
@@ -1200,7 +1200,7 @@
           <a:p>
             <a:fld id="{52231B9D-E9F6-4612-9B82-E89961B389AC}" type="datetimeFigureOut">
               <a:rPr lang="pt-BR" smtClean="0"/>
-              <a:t>04/09/2023</a:t>
+              <a:t>14/09/2023</a:t>
             </a:fld>
             <a:endParaRPr lang="pt-BR"/>
           </a:p>
@@ -1446,7 +1446,7 @@
           <a:p>
             <a:fld id="{52231B9D-E9F6-4612-9B82-E89961B389AC}" type="datetimeFigureOut">
               <a:rPr lang="pt-BR" smtClean="0"/>
-              <a:t>04/09/2023</a:t>
+              <a:t>14/09/2023</a:t>
             </a:fld>
             <a:endParaRPr lang="pt-BR"/>
           </a:p>
@@ -1678,7 +1678,7 @@
           <a:p>
             <a:fld id="{52231B9D-E9F6-4612-9B82-E89961B389AC}" type="datetimeFigureOut">
               <a:rPr lang="pt-BR" smtClean="0"/>
-              <a:t>04/09/2023</a:t>
+              <a:t>14/09/2023</a:t>
             </a:fld>
             <a:endParaRPr lang="pt-BR"/>
           </a:p>
@@ -2045,7 +2045,7 @@
           <a:p>
             <a:fld id="{52231B9D-E9F6-4612-9B82-E89961B389AC}" type="datetimeFigureOut">
               <a:rPr lang="pt-BR" smtClean="0"/>
-              <a:t>04/09/2023</a:t>
+              <a:t>14/09/2023</a:t>
             </a:fld>
             <a:endParaRPr lang="pt-BR"/>
           </a:p>
@@ -2163,7 +2163,7 @@
           <a:p>
             <a:fld id="{52231B9D-E9F6-4612-9B82-E89961B389AC}" type="datetimeFigureOut">
               <a:rPr lang="pt-BR" smtClean="0"/>
-              <a:t>04/09/2023</a:t>
+              <a:t>14/09/2023</a:t>
             </a:fld>
             <a:endParaRPr lang="pt-BR"/>
           </a:p>
@@ -2258,7 +2258,7 @@
           <a:p>
             <a:fld id="{52231B9D-E9F6-4612-9B82-E89961B389AC}" type="datetimeFigureOut">
               <a:rPr lang="pt-BR" smtClean="0"/>
-              <a:t>04/09/2023</a:t>
+              <a:t>14/09/2023</a:t>
             </a:fld>
             <a:endParaRPr lang="pt-BR"/>
           </a:p>
@@ -2535,7 +2535,7 @@
           <a:p>
             <a:fld id="{52231B9D-E9F6-4612-9B82-E89961B389AC}" type="datetimeFigureOut">
               <a:rPr lang="pt-BR" smtClean="0"/>
-              <a:t>04/09/2023</a:t>
+              <a:t>14/09/2023</a:t>
             </a:fld>
             <a:endParaRPr lang="pt-BR"/>
           </a:p>
@@ -2788,7 +2788,7 @@
           <a:p>
             <a:fld id="{52231B9D-E9F6-4612-9B82-E89961B389AC}" type="datetimeFigureOut">
               <a:rPr lang="pt-BR" smtClean="0"/>
-              <a:t>04/09/2023</a:t>
+              <a:t>14/09/2023</a:t>
             </a:fld>
             <a:endParaRPr lang="pt-BR"/>
           </a:p>
@@ -3001,7 +3001,7 @@
           <a:p>
             <a:fld id="{52231B9D-E9F6-4612-9B82-E89961B389AC}" type="datetimeFigureOut">
               <a:rPr lang="pt-BR" smtClean="0"/>
-              <a:t>04/09/2023</a:t>
+              <a:t>14/09/2023</a:t>
             </a:fld>
             <a:endParaRPr lang="pt-BR"/>
           </a:p>
@@ -3658,17 +3658,17 @@
           <a:lstStyle/>
           <a:p>
             <a:r>
-              <a:rPr lang="pt-BR" sz="1600" smtClean="0">
+              <a:rPr lang="pt-BR" sz="1600" dirty="0" smtClean="0">
                 <a:solidFill>
                   <a:schemeClr val="bg2">
                     <a:lumMod val="90000"/>
                   </a:schemeClr>
                 </a:solidFill>
               </a:rPr>
-              <a:t>03</a:t>
-            </a:r>
-            <a:r>
-              <a:rPr lang="pt-BR" sz="1600" smtClean="0">
+              <a:t>10</a:t>
+            </a:r>
+            <a:r>
+              <a:rPr lang="pt-BR" sz="1600" dirty="0" smtClean="0">
                 <a:solidFill>
                   <a:schemeClr val="bg2">
                     <a:lumMod val="90000"/>

</xml_diff>

<commit_message>
estruturas com componentes ok
</commit_message>
<xml_diff>
--- a/tempimento.pptx
+++ b/tempimento.pptx
@@ -197,7 +197,7 @@
           <a:p>
             <a:fld id="{A584E3A2-E8EA-4705-A613-CFE9F6F5D3B4}" type="datetimeFigureOut">
               <a:rPr lang="pt-BR" smtClean="0"/>
-              <a:t>14/09/2023</a:t>
+              <a:t>18/09/2023</a:t>
             </a:fld>
             <a:endParaRPr lang="pt-BR"/>
           </a:p>
@@ -680,7 +680,7 @@
           <a:p>
             <a:fld id="{52231B9D-E9F6-4612-9B82-E89961B389AC}" type="datetimeFigureOut">
               <a:rPr lang="pt-BR" smtClean="0"/>
-              <a:t>14/09/2023</a:t>
+              <a:t>18/09/2023</a:t>
             </a:fld>
             <a:endParaRPr lang="pt-BR"/>
           </a:p>
@@ -850,7 +850,7 @@
           <a:p>
             <a:fld id="{52231B9D-E9F6-4612-9B82-E89961B389AC}" type="datetimeFigureOut">
               <a:rPr lang="pt-BR" smtClean="0"/>
-              <a:t>14/09/2023</a:t>
+              <a:t>18/09/2023</a:t>
             </a:fld>
             <a:endParaRPr lang="pt-BR"/>
           </a:p>
@@ -1030,7 +1030,7 @@
           <a:p>
             <a:fld id="{52231B9D-E9F6-4612-9B82-E89961B389AC}" type="datetimeFigureOut">
               <a:rPr lang="pt-BR" smtClean="0"/>
-              <a:t>14/09/2023</a:t>
+              <a:t>18/09/2023</a:t>
             </a:fld>
             <a:endParaRPr lang="pt-BR"/>
           </a:p>
@@ -1200,7 +1200,7 @@
           <a:p>
             <a:fld id="{52231B9D-E9F6-4612-9B82-E89961B389AC}" type="datetimeFigureOut">
               <a:rPr lang="pt-BR" smtClean="0"/>
-              <a:t>14/09/2023</a:t>
+              <a:t>18/09/2023</a:t>
             </a:fld>
             <a:endParaRPr lang="pt-BR"/>
           </a:p>
@@ -1446,7 +1446,7 @@
           <a:p>
             <a:fld id="{52231B9D-E9F6-4612-9B82-E89961B389AC}" type="datetimeFigureOut">
               <a:rPr lang="pt-BR" smtClean="0"/>
-              <a:t>14/09/2023</a:t>
+              <a:t>18/09/2023</a:t>
             </a:fld>
             <a:endParaRPr lang="pt-BR"/>
           </a:p>
@@ -1678,7 +1678,7 @@
           <a:p>
             <a:fld id="{52231B9D-E9F6-4612-9B82-E89961B389AC}" type="datetimeFigureOut">
               <a:rPr lang="pt-BR" smtClean="0"/>
-              <a:t>14/09/2023</a:t>
+              <a:t>18/09/2023</a:t>
             </a:fld>
             <a:endParaRPr lang="pt-BR"/>
           </a:p>
@@ -2045,7 +2045,7 @@
           <a:p>
             <a:fld id="{52231B9D-E9F6-4612-9B82-E89961B389AC}" type="datetimeFigureOut">
               <a:rPr lang="pt-BR" smtClean="0"/>
-              <a:t>14/09/2023</a:t>
+              <a:t>18/09/2023</a:t>
             </a:fld>
             <a:endParaRPr lang="pt-BR"/>
           </a:p>
@@ -2163,7 +2163,7 @@
           <a:p>
             <a:fld id="{52231B9D-E9F6-4612-9B82-E89961B389AC}" type="datetimeFigureOut">
               <a:rPr lang="pt-BR" smtClean="0"/>
-              <a:t>14/09/2023</a:t>
+              <a:t>18/09/2023</a:t>
             </a:fld>
             <a:endParaRPr lang="pt-BR"/>
           </a:p>
@@ -2258,7 +2258,7 @@
           <a:p>
             <a:fld id="{52231B9D-E9F6-4612-9B82-E89961B389AC}" type="datetimeFigureOut">
               <a:rPr lang="pt-BR" smtClean="0"/>
-              <a:t>14/09/2023</a:t>
+              <a:t>18/09/2023</a:t>
             </a:fld>
             <a:endParaRPr lang="pt-BR"/>
           </a:p>
@@ -2535,7 +2535,7 @@
           <a:p>
             <a:fld id="{52231B9D-E9F6-4612-9B82-E89961B389AC}" type="datetimeFigureOut">
               <a:rPr lang="pt-BR" smtClean="0"/>
-              <a:t>14/09/2023</a:t>
+              <a:t>18/09/2023</a:t>
             </a:fld>
             <a:endParaRPr lang="pt-BR"/>
           </a:p>
@@ -2788,7 +2788,7 @@
           <a:p>
             <a:fld id="{52231B9D-E9F6-4612-9B82-E89961B389AC}" type="datetimeFigureOut">
               <a:rPr lang="pt-BR" smtClean="0"/>
-              <a:t>14/09/2023</a:t>
+              <a:t>18/09/2023</a:t>
             </a:fld>
             <a:endParaRPr lang="pt-BR"/>
           </a:p>
@@ -3001,7 +3001,7 @@
           <a:p>
             <a:fld id="{52231B9D-E9F6-4612-9B82-E89961B389AC}" type="datetimeFigureOut">
               <a:rPr lang="pt-BR" smtClean="0"/>
-              <a:t>14/09/2023</a:t>
+              <a:t>18/09/2023</a:t>
             </a:fld>
             <a:endParaRPr lang="pt-BR"/>
           </a:p>
@@ -3658,24 +3658,14 @@
           <a:lstStyle/>
           <a:p>
             <a:r>
-              <a:rPr lang="pt-BR" sz="1600" dirty="0" smtClean="0">
+              <a:rPr lang="pt-BR" sz="1600" smtClean="0">
                 <a:solidFill>
                   <a:schemeClr val="bg2">
                     <a:lumMod val="90000"/>
                   </a:schemeClr>
                 </a:solidFill>
               </a:rPr>
-              <a:t>10</a:t>
-            </a:r>
-            <a:r>
-              <a:rPr lang="pt-BR" sz="1600" dirty="0" smtClean="0">
-                <a:solidFill>
-                  <a:schemeClr val="bg2">
-                    <a:lumMod val="90000"/>
-                  </a:schemeClr>
-                </a:solidFill>
-              </a:rPr>
-              <a:t>/09/2023</a:t>
+              <a:t>17/09/2023</a:t>
             </a:r>
             <a:endParaRPr lang="pt-BR" sz="1600" dirty="0">
               <a:solidFill>

</xml_diff>

<commit_message>
consulta para modelo e ETL análise do pneu
</commit_message>
<xml_diff>
--- a/tempimento.pptx
+++ b/tempimento.pptx
@@ -197,7 +197,7 @@
           <a:p>
             <a:fld id="{A584E3A2-E8EA-4705-A613-CFE9F6F5D3B4}" type="datetimeFigureOut">
               <a:rPr lang="pt-BR" smtClean="0"/>
-              <a:t>18/09/2023</a:t>
+              <a:t>25/09/2023</a:t>
             </a:fld>
             <a:endParaRPr lang="pt-BR"/>
           </a:p>
@@ -680,7 +680,7 @@
           <a:p>
             <a:fld id="{52231B9D-E9F6-4612-9B82-E89961B389AC}" type="datetimeFigureOut">
               <a:rPr lang="pt-BR" smtClean="0"/>
-              <a:t>18/09/2023</a:t>
+              <a:t>25/09/2023</a:t>
             </a:fld>
             <a:endParaRPr lang="pt-BR"/>
           </a:p>
@@ -850,7 +850,7 @@
           <a:p>
             <a:fld id="{52231B9D-E9F6-4612-9B82-E89961B389AC}" type="datetimeFigureOut">
               <a:rPr lang="pt-BR" smtClean="0"/>
-              <a:t>18/09/2023</a:t>
+              <a:t>25/09/2023</a:t>
             </a:fld>
             <a:endParaRPr lang="pt-BR"/>
           </a:p>
@@ -1030,7 +1030,7 @@
           <a:p>
             <a:fld id="{52231B9D-E9F6-4612-9B82-E89961B389AC}" type="datetimeFigureOut">
               <a:rPr lang="pt-BR" smtClean="0"/>
-              <a:t>18/09/2023</a:t>
+              <a:t>25/09/2023</a:t>
             </a:fld>
             <a:endParaRPr lang="pt-BR"/>
           </a:p>
@@ -1200,7 +1200,7 @@
           <a:p>
             <a:fld id="{52231B9D-E9F6-4612-9B82-E89961B389AC}" type="datetimeFigureOut">
               <a:rPr lang="pt-BR" smtClean="0"/>
-              <a:t>18/09/2023</a:t>
+              <a:t>25/09/2023</a:t>
             </a:fld>
             <a:endParaRPr lang="pt-BR"/>
           </a:p>
@@ -1446,7 +1446,7 @@
           <a:p>
             <a:fld id="{52231B9D-E9F6-4612-9B82-E89961B389AC}" type="datetimeFigureOut">
               <a:rPr lang="pt-BR" smtClean="0"/>
-              <a:t>18/09/2023</a:t>
+              <a:t>25/09/2023</a:t>
             </a:fld>
             <a:endParaRPr lang="pt-BR"/>
           </a:p>
@@ -1678,7 +1678,7 @@
           <a:p>
             <a:fld id="{52231B9D-E9F6-4612-9B82-E89961B389AC}" type="datetimeFigureOut">
               <a:rPr lang="pt-BR" smtClean="0"/>
-              <a:t>18/09/2023</a:t>
+              <a:t>25/09/2023</a:t>
             </a:fld>
             <a:endParaRPr lang="pt-BR"/>
           </a:p>
@@ -2045,7 +2045,7 @@
           <a:p>
             <a:fld id="{52231B9D-E9F6-4612-9B82-E89961B389AC}" type="datetimeFigureOut">
               <a:rPr lang="pt-BR" smtClean="0"/>
-              <a:t>18/09/2023</a:t>
+              <a:t>25/09/2023</a:t>
             </a:fld>
             <a:endParaRPr lang="pt-BR"/>
           </a:p>
@@ -2163,7 +2163,7 @@
           <a:p>
             <a:fld id="{52231B9D-E9F6-4612-9B82-E89961B389AC}" type="datetimeFigureOut">
               <a:rPr lang="pt-BR" smtClean="0"/>
-              <a:t>18/09/2023</a:t>
+              <a:t>25/09/2023</a:t>
             </a:fld>
             <a:endParaRPr lang="pt-BR"/>
           </a:p>
@@ -2258,7 +2258,7 @@
           <a:p>
             <a:fld id="{52231B9D-E9F6-4612-9B82-E89961B389AC}" type="datetimeFigureOut">
               <a:rPr lang="pt-BR" smtClean="0"/>
-              <a:t>18/09/2023</a:t>
+              <a:t>25/09/2023</a:t>
             </a:fld>
             <a:endParaRPr lang="pt-BR"/>
           </a:p>
@@ -2535,7 +2535,7 @@
           <a:p>
             <a:fld id="{52231B9D-E9F6-4612-9B82-E89961B389AC}" type="datetimeFigureOut">
               <a:rPr lang="pt-BR" smtClean="0"/>
-              <a:t>18/09/2023</a:t>
+              <a:t>25/09/2023</a:t>
             </a:fld>
             <a:endParaRPr lang="pt-BR"/>
           </a:p>
@@ -2788,7 +2788,7 @@
           <a:p>
             <a:fld id="{52231B9D-E9F6-4612-9B82-E89961B389AC}" type="datetimeFigureOut">
               <a:rPr lang="pt-BR" smtClean="0"/>
-              <a:t>18/09/2023</a:t>
+              <a:t>25/09/2023</a:t>
             </a:fld>
             <a:endParaRPr lang="pt-BR"/>
           </a:p>
@@ -3001,7 +3001,7 @@
           <a:p>
             <a:fld id="{52231B9D-E9F6-4612-9B82-E89961B389AC}" type="datetimeFigureOut">
               <a:rPr lang="pt-BR" smtClean="0"/>
-              <a:t>18/09/2023</a:t>
+              <a:t>25/09/2023</a:t>
             </a:fld>
             <a:endParaRPr lang="pt-BR"/>
           </a:p>
@@ -3658,14 +3658,14 @@
           <a:lstStyle/>
           <a:p>
             <a:r>
-              <a:rPr lang="pt-BR" sz="1600" smtClean="0">
+              <a:rPr lang="pt-BR" sz="1600" dirty="0" smtClean="0">
                 <a:solidFill>
                   <a:schemeClr val="bg2">
                     <a:lumMod val="90000"/>
                   </a:schemeClr>
                 </a:solidFill>
               </a:rPr>
-              <a:t>17/09/2023</a:t>
+              <a:t>01/10/2023</a:t>
             </a:r>
             <a:endParaRPr lang="pt-BR" sz="1600" dirty="0">
               <a:solidFill>

</xml_diff>

<commit_message>
reorganização antes de alteração da ordem das tabelas
</commit_message>
<xml_diff>
--- a/tempimento.pptx
+++ b/tempimento.pptx
@@ -197,7 +197,7 @@
           <a:p>
             <a:fld id="{A584E3A2-E8EA-4705-A613-CFE9F6F5D3B4}" type="datetimeFigureOut">
               <a:rPr lang="pt-BR" smtClean="0"/>
-              <a:t>25/09/2023</a:t>
+              <a:t>25/10/2023</a:t>
             </a:fld>
             <a:endParaRPr lang="pt-BR"/>
           </a:p>
@@ -680,7 +680,7 @@
           <a:p>
             <a:fld id="{52231B9D-E9F6-4612-9B82-E89961B389AC}" type="datetimeFigureOut">
               <a:rPr lang="pt-BR" smtClean="0"/>
-              <a:t>25/09/2023</a:t>
+              <a:t>25/10/2023</a:t>
             </a:fld>
             <a:endParaRPr lang="pt-BR"/>
           </a:p>
@@ -850,7 +850,7 @@
           <a:p>
             <a:fld id="{52231B9D-E9F6-4612-9B82-E89961B389AC}" type="datetimeFigureOut">
               <a:rPr lang="pt-BR" smtClean="0"/>
-              <a:t>25/09/2023</a:t>
+              <a:t>25/10/2023</a:t>
             </a:fld>
             <a:endParaRPr lang="pt-BR"/>
           </a:p>
@@ -1030,7 +1030,7 @@
           <a:p>
             <a:fld id="{52231B9D-E9F6-4612-9B82-E89961B389AC}" type="datetimeFigureOut">
               <a:rPr lang="pt-BR" smtClean="0"/>
-              <a:t>25/09/2023</a:t>
+              <a:t>25/10/2023</a:t>
             </a:fld>
             <a:endParaRPr lang="pt-BR"/>
           </a:p>
@@ -1200,7 +1200,7 @@
           <a:p>
             <a:fld id="{52231B9D-E9F6-4612-9B82-E89961B389AC}" type="datetimeFigureOut">
               <a:rPr lang="pt-BR" smtClean="0"/>
-              <a:t>25/09/2023</a:t>
+              <a:t>25/10/2023</a:t>
             </a:fld>
             <a:endParaRPr lang="pt-BR"/>
           </a:p>
@@ -1446,7 +1446,7 @@
           <a:p>
             <a:fld id="{52231B9D-E9F6-4612-9B82-E89961B389AC}" type="datetimeFigureOut">
               <a:rPr lang="pt-BR" smtClean="0"/>
-              <a:t>25/09/2023</a:t>
+              <a:t>25/10/2023</a:t>
             </a:fld>
             <a:endParaRPr lang="pt-BR"/>
           </a:p>
@@ -1678,7 +1678,7 @@
           <a:p>
             <a:fld id="{52231B9D-E9F6-4612-9B82-E89961B389AC}" type="datetimeFigureOut">
               <a:rPr lang="pt-BR" smtClean="0"/>
-              <a:t>25/09/2023</a:t>
+              <a:t>25/10/2023</a:t>
             </a:fld>
             <a:endParaRPr lang="pt-BR"/>
           </a:p>
@@ -2045,7 +2045,7 @@
           <a:p>
             <a:fld id="{52231B9D-E9F6-4612-9B82-E89961B389AC}" type="datetimeFigureOut">
               <a:rPr lang="pt-BR" smtClean="0"/>
-              <a:t>25/09/2023</a:t>
+              <a:t>25/10/2023</a:t>
             </a:fld>
             <a:endParaRPr lang="pt-BR"/>
           </a:p>
@@ -2163,7 +2163,7 @@
           <a:p>
             <a:fld id="{52231B9D-E9F6-4612-9B82-E89961B389AC}" type="datetimeFigureOut">
               <a:rPr lang="pt-BR" smtClean="0"/>
-              <a:t>25/09/2023</a:t>
+              <a:t>25/10/2023</a:t>
             </a:fld>
             <a:endParaRPr lang="pt-BR"/>
           </a:p>
@@ -2258,7 +2258,7 @@
           <a:p>
             <a:fld id="{52231B9D-E9F6-4612-9B82-E89961B389AC}" type="datetimeFigureOut">
               <a:rPr lang="pt-BR" smtClean="0"/>
-              <a:t>25/09/2023</a:t>
+              <a:t>25/10/2023</a:t>
             </a:fld>
             <a:endParaRPr lang="pt-BR"/>
           </a:p>
@@ -2535,7 +2535,7 @@
           <a:p>
             <a:fld id="{52231B9D-E9F6-4612-9B82-E89961B389AC}" type="datetimeFigureOut">
               <a:rPr lang="pt-BR" smtClean="0"/>
-              <a:t>25/09/2023</a:t>
+              <a:t>25/10/2023</a:t>
             </a:fld>
             <a:endParaRPr lang="pt-BR"/>
           </a:p>
@@ -2788,7 +2788,7 @@
           <a:p>
             <a:fld id="{52231B9D-E9F6-4612-9B82-E89961B389AC}" type="datetimeFigureOut">
               <a:rPr lang="pt-BR" smtClean="0"/>
-              <a:t>25/09/2023</a:t>
+              <a:t>25/10/2023</a:t>
             </a:fld>
             <a:endParaRPr lang="pt-BR"/>
           </a:p>
@@ -3001,7 +3001,7 @@
           <a:p>
             <a:fld id="{52231B9D-E9F6-4612-9B82-E89961B389AC}" type="datetimeFigureOut">
               <a:rPr lang="pt-BR" smtClean="0"/>
-              <a:t>25/09/2023</a:t>
+              <a:t>25/10/2023</a:t>
             </a:fld>
             <a:endParaRPr lang="pt-BR"/>
           </a:p>
@@ -3665,7 +3665,17 @@
                   </a:schemeClr>
                 </a:solidFill>
               </a:rPr>
-              <a:t>01/10/2023</a:t>
+              <a:t>22</a:t>
+            </a:r>
+            <a:r>
+              <a:rPr lang="pt-BR" sz="1600" dirty="0" smtClean="0">
+                <a:solidFill>
+                  <a:schemeClr val="bg2">
+                    <a:lumMod val="90000"/>
+                  </a:schemeClr>
+                </a:solidFill>
+              </a:rPr>
+              <a:t>/10/2023</a:t>
             </a:r>
             <a:endParaRPr lang="pt-BR" sz="1600" dirty="0">
               <a:solidFill>

</xml_diff>

<commit_message>
consulta gerencial de FA- movimentação ok
</commit_message>
<xml_diff>
--- a/tempimento.pptx
+++ b/tempimento.pptx
@@ -197,7 +197,7 @@
           <a:p>
             <a:fld id="{A584E3A2-E8EA-4705-A613-CFE9F6F5D3B4}" type="datetimeFigureOut">
               <a:rPr lang="pt-BR" smtClean="0"/>
-              <a:t>25/10/2023</a:t>
+              <a:t>26/10/2023</a:t>
             </a:fld>
             <a:endParaRPr lang="pt-BR"/>
           </a:p>
@@ -680,7 +680,7 @@
           <a:p>
             <a:fld id="{52231B9D-E9F6-4612-9B82-E89961B389AC}" type="datetimeFigureOut">
               <a:rPr lang="pt-BR" smtClean="0"/>
-              <a:t>25/10/2023</a:t>
+              <a:t>26/10/2023</a:t>
             </a:fld>
             <a:endParaRPr lang="pt-BR"/>
           </a:p>
@@ -850,7 +850,7 @@
           <a:p>
             <a:fld id="{52231B9D-E9F6-4612-9B82-E89961B389AC}" type="datetimeFigureOut">
               <a:rPr lang="pt-BR" smtClean="0"/>
-              <a:t>25/10/2023</a:t>
+              <a:t>26/10/2023</a:t>
             </a:fld>
             <a:endParaRPr lang="pt-BR"/>
           </a:p>
@@ -1030,7 +1030,7 @@
           <a:p>
             <a:fld id="{52231B9D-E9F6-4612-9B82-E89961B389AC}" type="datetimeFigureOut">
               <a:rPr lang="pt-BR" smtClean="0"/>
-              <a:t>25/10/2023</a:t>
+              <a:t>26/10/2023</a:t>
             </a:fld>
             <a:endParaRPr lang="pt-BR"/>
           </a:p>
@@ -1200,7 +1200,7 @@
           <a:p>
             <a:fld id="{52231B9D-E9F6-4612-9B82-E89961B389AC}" type="datetimeFigureOut">
               <a:rPr lang="pt-BR" smtClean="0"/>
-              <a:t>25/10/2023</a:t>
+              <a:t>26/10/2023</a:t>
             </a:fld>
             <a:endParaRPr lang="pt-BR"/>
           </a:p>
@@ -1446,7 +1446,7 @@
           <a:p>
             <a:fld id="{52231B9D-E9F6-4612-9B82-E89961B389AC}" type="datetimeFigureOut">
               <a:rPr lang="pt-BR" smtClean="0"/>
-              <a:t>25/10/2023</a:t>
+              <a:t>26/10/2023</a:t>
             </a:fld>
             <a:endParaRPr lang="pt-BR"/>
           </a:p>
@@ -1678,7 +1678,7 @@
           <a:p>
             <a:fld id="{52231B9D-E9F6-4612-9B82-E89961B389AC}" type="datetimeFigureOut">
               <a:rPr lang="pt-BR" smtClean="0"/>
-              <a:t>25/10/2023</a:t>
+              <a:t>26/10/2023</a:t>
             </a:fld>
             <a:endParaRPr lang="pt-BR"/>
           </a:p>
@@ -2045,7 +2045,7 @@
           <a:p>
             <a:fld id="{52231B9D-E9F6-4612-9B82-E89961B389AC}" type="datetimeFigureOut">
               <a:rPr lang="pt-BR" smtClean="0"/>
-              <a:t>25/10/2023</a:t>
+              <a:t>26/10/2023</a:t>
             </a:fld>
             <a:endParaRPr lang="pt-BR"/>
           </a:p>
@@ -2163,7 +2163,7 @@
           <a:p>
             <a:fld id="{52231B9D-E9F6-4612-9B82-E89961B389AC}" type="datetimeFigureOut">
               <a:rPr lang="pt-BR" smtClean="0"/>
-              <a:t>25/10/2023</a:t>
+              <a:t>26/10/2023</a:t>
             </a:fld>
             <a:endParaRPr lang="pt-BR"/>
           </a:p>
@@ -2258,7 +2258,7 @@
           <a:p>
             <a:fld id="{52231B9D-E9F6-4612-9B82-E89961B389AC}" type="datetimeFigureOut">
               <a:rPr lang="pt-BR" smtClean="0"/>
-              <a:t>25/10/2023</a:t>
+              <a:t>26/10/2023</a:t>
             </a:fld>
             <a:endParaRPr lang="pt-BR"/>
           </a:p>
@@ -2535,7 +2535,7 @@
           <a:p>
             <a:fld id="{52231B9D-E9F6-4612-9B82-E89961B389AC}" type="datetimeFigureOut">
               <a:rPr lang="pt-BR" smtClean="0"/>
-              <a:t>25/10/2023</a:t>
+              <a:t>26/10/2023</a:t>
             </a:fld>
             <a:endParaRPr lang="pt-BR"/>
           </a:p>
@@ -2788,7 +2788,7 @@
           <a:p>
             <a:fld id="{52231B9D-E9F6-4612-9B82-E89961B389AC}" type="datetimeFigureOut">
               <a:rPr lang="pt-BR" smtClean="0"/>
-              <a:t>25/10/2023</a:t>
+              <a:t>26/10/2023</a:t>
             </a:fld>
             <a:endParaRPr lang="pt-BR"/>
           </a:p>
@@ -3001,7 +3001,7 @@
           <a:p>
             <a:fld id="{52231B9D-E9F6-4612-9B82-E89961B389AC}" type="datetimeFigureOut">
               <a:rPr lang="pt-BR" smtClean="0"/>
-              <a:t>25/10/2023</a:t>
+              <a:t>26/10/2023</a:t>
             </a:fld>
             <a:endParaRPr lang="pt-BR"/>
           </a:p>
@@ -3658,24 +3658,14 @@
           <a:lstStyle/>
           <a:p>
             <a:r>
-              <a:rPr lang="pt-BR" sz="1600" dirty="0" smtClean="0">
+              <a:rPr lang="pt-BR" sz="1600" smtClean="0">
                 <a:solidFill>
                   <a:schemeClr val="bg2">
                     <a:lumMod val="90000"/>
                   </a:schemeClr>
                 </a:solidFill>
               </a:rPr>
-              <a:t>22</a:t>
-            </a:r>
-            <a:r>
-              <a:rPr lang="pt-BR" sz="1600" dirty="0" smtClean="0">
-                <a:solidFill>
-                  <a:schemeClr val="bg2">
-                    <a:lumMod val="90000"/>
-                  </a:schemeClr>
-                </a:solidFill>
-              </a:rPr>
-              <a:t>/10/2023</a:t>
+              <a:t>29/10/2023</a:t>
             </a:r>
             <a:endParaRPr lang="pt-BR" sz="1600" dirty="0">
               <a:solidFill>

</xml_diff>

<commit_message>
correção vínculo CC do func para CC do lançamento
</commit_message>
<xml_diff>
--- a/tempimento.pptx
+++ b/tempimento.pptx
@@ -197,7 +197,7 @@
           <a:p>
             <a:fld id="{A584E3A2-E8EA-4705-A613-CFE9F6F5D3B4}" type="datetimeFigureOut">
               <a:rPr lang="pt-BR" smtClean="0"/>
-              <a:t>26/10/2023</a:t>
+              <a:t>06/11/2023</a:t>
             </a:fld>
             <a:endParaRPr lang="pt-BR"/>
           </a:p>
@@ -680,7 +680,7 @@
           <a:p>
             <a:fld id="{52231B9D-E9F6-4612-9B82-E89961B389AC}" type="datetimeFigureOut">
               <a:rPr lang="pt-BR" smtClean="0"/>
-              <a:t>26/10/2023</a:t>
+              <a:t>06/11/2023</a:t>
             </a:fld>
             <a:endParaRPr lang="pt-BR"/>
           </a:p>
@@ -850,7 +850,7 @@
           <a:p>
             <a:fld id="{52231B9D-E9F6-4612-9B82-E89961B389AC}" type="datetimeFigureOut">
               <a:rPr lang="pt-BR" smtClean="0"/>
-              <a:t>26/10/2023</a:t>
+              <a:t>06/11/2023</a:t>
             </a:fld>
             <a:endParaRPr lang="pt-BR"/>
           </a:p>
@@ -1030,7 +1030,7 @@
           <a:p>
             <a:fld id="{52231B9D-E9F6-4612-9B82-E89961B389AC}" type="datetimeFigureOut">
               <a:rPr lang="pt-BR" smtClean="0"/>
-              <a:t>26/10/2023</a:t>
+              <a:t>06/11/2023</a:t>
             </a:fld>
             <a:endParaRPr lang="pt-BR"/>
           </a:p>
@@ -1200,7 +1200,7 @@
           <a:p>
             <a:fld id="{52231B9D-E9F6-4612-9B82-E89961B389AC}" type="datetimeFigureOut">
               <a:rPr lang="pt-BR" smtClean="0"/>
-              <a:t>26/10/2023</a:t>
+              <a:t>06/11/2023</a:t>
             </a:fld>
             <a:endParaRPr lang="pt-BR"/>
           </a:p>
@@ -1446,7 +1446,7 @@
           <a:p>
             <a:fld id="{52231B9D-E9F6-4612-9B82-E89961B389AC}" type="datetimeFigureOut">
               <a:rPr lang="pt-BR" smtClean="0"/>
-              <a:t>26/10/2023</a:t>
+              <a:t>06/11/2023</a:t>
             </a:fld>
             <a:endParaRPr lang="pt-BR"/>
           </a:p>
@@ -1678,7 +1678,7 @@
           <a:p>
             <a:fld id="{52231B9D-E9F6-4612-9B82-E89961B389AC}" type="datetimeFigureOut">
               <a:rPr lang="pt-BR" smtClean="0"/>
-              <a:t>26/10/2023</a:t>
+              <a:t>06/11/2023</a:t>
             </a:fld>
             <a:endParaRPr lang="pt-BR"/>
           </a:p>
@@ -2045,7 +2045,7 @@
           <a:p>
             <a:fld id="{52231B9D-E9F6-4612-9B82-E89961B389AC}" type="datetimeFigureOut">
               <a:rPr lang="pt-BR" smtClean="0"/>
-              <a:t>26/10/2023</a:t>
+              <a:t>06/11/2023</a:t>
             </a:fld>
             <a:endParaRPr lang="pt-BR"/>
           </a:p>
@@ -2163,7 +2163,7 @@
           <a:p>
             <a:fld id="{52231B9D-E9F6-4612-9B82-E89961B389AC}" type="datetimeFigureOut">
               <a:rPr lang="pt-BR" smtClean="0"/>
-              <a:t>26/10/2023</a:t>
+              <a:t>06/11/2023</a:t>
             </a:fld>
             <a:endParaRPr lang="pt-BR"/>
           </a:p>
@@ -2258,7 +2258,7 @@
           <a:p>
             <a:fld id="{52231B9D-E9F6-4612-9B82-E89961B389AC}" type="datetimeFigureOut">
               <a:rPr lang="pt-BR" smtClean="0"/>
-              <a:t>26/10/2023</a:t>
+              <a:t>06/11/2023</a:t>
             </a:fld>
             <a:endParaRPr lang="pt-BR"/>
           </a:p>
@@ -2535,7 +2535,7 @@
           <a:p>
             <a:fld id="{52231B9D-E9F6-4612-9B82-E89961B389AC}" type="datetimeFigureOut">
               <a:rPr lang="pt-BR" smtClean="0"/>
-              <a:t>26/10/2023</a:t>
+              <a:t>06/11/2023</a:t>
             </a:fld>
             <a:endParaRPr lang="pt-BR"/>
           </a:p>
@@ -2788,7 +2788,7 @@
           <a:p>
             <a:fld id="{52231B9D-E9F6-4612-9B82-E89961B389AC}" type="datetimeFigureOut">
               <a:rPr lang="pt-BR" smtClean="0"/>
-              <a:t>26/10/2023</a:t>
+              <a:t>06/11/2023</a:t>
             </a:fld>
             <a:endParaRPr lang="pt-BR"/>
           </a:p>
@@ -3001,7 +3001,7 @@
           <a:p>
             <a:fld id="{52231B9D-E9F6-4612-9B82-E89961B389AC}" type="datetimeFigureOut">
               <a:rPr lang="pt-BR" smtClean="0"/>
-              <a:t>26/10/2023</a:t>
+              <a:t>06/11/2023</a:t>
             </a:fld>
             <a:endParaRPr lang="pt-BR"/>
           </a:p>
@@ -3658,14 +3658,14 @@
           <a:lstStyle/>
           <a:p>
             <a:r>
-              <a:rPr lang="pt-BR" sz="1600" smtClean="0">
+              <a:rPr lang="pt-BR" sz="1600" dirty="0" smtClean="0">
                 <a:solidFill>
                   <a:schemeClr val="bg2">
                     <a:lumMod val="90000"/>
                   </a:schemeClr>
                 </a:solidFill>
               </a:rPr>
-              <a:t>29/10/2023</a:t>
+              <a:t>12/11/2023</a:t>
             </a:r>
             <a:endParaRPr lang="pt-BR" sz="1600" dirty="0">
               <a:solidFill>

</xml_diff>

<commit_message>
alterações fatos SC e PC e add resíduo
</commit_message>
<xml_diff>
--- a/tempimento.pptx
+++ b/tempimento.pptx
@@ -197,7 +197,7 @@
           <a:p>
             <a:fld id="{A584E3A2-E8EA-4705-A613-CFE9F6F5D3B4}" type="datetimeFigureOut">
               <a:rPr lang="pt-BR" smtClean="0"/>
-              <a:t>21/11/2023</a:t>
+              <a:t>27/11/2023</a:t>
             </a:fld>
             <a:endParaRPr lang="pt-BR"/>
           </a:p>
@@ -680,7 +680,7 @@
           <a:p>
             <a:fld id="{52231B9D-E9F6-4612-9B82-E89961B389AC}" type="datetimeFigureOut">
               <a:rPr lang="pt-BR" smtClean="0"/>
-              <a:t>21/11/2023</a:t>
+              <a:t>27/11/2023</a:t>
             </a:fld>
             <a:endParaRPr lang="pt-BR"/>
           </a:p>
@@ -850,7 +850,7 @@
           <a:p>
             <a:fld id="{52231B9D-E9F6-4612-9B82-E89961B389AC}" type="datetimeFigureOut">
               <a:rPr lang="pt-BR" smtClean="0"/>
-              <a:t>21/11/2023</a:t>
+              <a:t>27/11/2023</a:t>
             </a:fld>
             <a:endParaRPr lang="pt-BR"/>
           </a:p>
@@ -1030,7 +1030,7 @@
           <a:p>
             <a:fld id="{52231B9D-E9F6-4612-9B82-E89961B389AC}" type="datetimeFigureOut">
               <a:rPr lang="pt-BR" smtClean="0"/>
-              <a:t>21/11/2023</a:t>
+              <a:t>27/11/2023</a:t>
             </a:fld>
             <a:endParaRPr lang="pt-BR"/>
           </a:p>
@@ -1200,7 +1200,7 @@
           <a:p>
             <a:fld id="{52231B9D-E9F6-4612-9B82-E89961B389AC}" type="datetimeFigureOut">
               <a:rPr lang="pt-BR" smtClean="0"/>
-              <a:t>21/11/2023</a:t>
+              <a:t>27/11/2023</a:t>
             </a:fld>
             <a:endParaRPr lang="pt-BR"/>
           </a:p>
@@ -1446,7 +1446,7 @@
           <a:p>
             <a:fld id="{52231B9D-E9F6-4612-9B82-E89961B389AC}" type="datetimeFigureOut">
               <a:rPr lang="pt-BR" smtClean="0"/>
-              <a:t>21/11/2023</a:t>
+              <a:t>27/11/2023</a:t>
             </a:fld>
             <a:endParaRPr lang="pt-BR"/>
           </a:p>
@@ -1678,7 +1678,7 @@
           <a:p>
             <a:fld id="{52231B9D-E9F6-4612-9B82-E89961B389AC}" type="datetimeFigureOut">
               <a:rPr lang="pt-BR" smtClean="0"/>
-              <a:t>21/11/2023</a:t>
+              <a:t>27/11/2023</a:t>
             </a:fld>
             <a:endParaRPr lang="pt-BR"/>
           </a:p>
@@ -2045,7 +2045,7 @@
           <a:p>
             <a:fld id="{52231B9D-E9F6-4612-9B82-E89961B389AC}" type="datetimeFigureOut">
               <a:rPr lang="pt-BR" smtClean="0"/>
-              <a:t>21/11/2023</a:t>
+              <a:t>27/11/2023</a:t>
             </a:fld>
             <a:endParaRPr lang="pt-BR"/>
           </a:p>
@@ -2163,7 +2163,7 @@
           <a:p>
             <a:fld id="{52231B9D-E9F6-4612-9B82-E89961B389AC}" type="datetimeFigureOut">
               <a:rPr lang="pt-BR" smtClean="0"/>
-              <a:t>21/11/2023</a:t>
+              <a:t>27/11/2023</a:t>
             </a:fld>
             <a:endParaRPr lang="pt-BR"/>
           </a:p>
@@ -2258,7 +2258,7 @@
           <a:p>
             <a:fld id="{52231B9D-E9F6-4612-9B82-E89961B389AC}" type="datetimeFigureOut">
               <a:rPr lang="pt-BR" smtClean="0"/>
-              <a:t>21/11/2023</a:t>
+              <a:t>27/11/2023</a:t>
             </a:fld>
             <a:endParaRPr lang="pt-BR"/>
           </a:p>
@@ -2535,7 +2535,7 @@
           <a:p>
             <a:fld id="{52231B9D-E9F6-4612-9B82-E89961B389AC}" type="datetimeFigureOut">
               <a:rPr lang="pt-BR" smtClean="0"/>
-              <a:t>21/11/2023</a:t>
+              <a:t>27/11/2023</a:t>
             </a:fld>
             <a:endParaRPr lang="pt-BR"/>
           </a:p>
@@ -2788,7 +2788,7 @@
           <a:p>
             <a:fld id="{52231B9D-E9F6-4612-9B82-E89961B389AC}" type="datetimeFigureOut">
               <a:rPr lang="pt-BR" smtClean="0"/>
-              <a:t>21/11/2023</a:t>
+              <a:t>27/11/2023</a:t>
             </a:fld>
             <a:endParaRPr lang="pt-BR"/>
           </a:p>
@@ -3001,7 +3001,7 @@
           <a:p>
             <a:fld id="{52231B9D-E9F6-4612-9B82-E89961B389AC}" type="datetimeFigureOut">
               <a:rPr lang="pt-BR" smtClean="0"/>
-              <a:t>21/11/2023</a:t>
+              <a:t>27/11/2023</a:t>
             </a:fld>
             <a:endParaRPr lang="pt-BR"/>
           </a:p>
@@ -3665,7 +3665,17 @@
                   </a:schemeClr>
                 </a:solidFill>
               </a:rPr>
-              <a:t>19/11/2023</a:t>
+              <a:t>26</a:t>
+            </a:r>
+            <a:r>
+              <a:rPr lang="pt-BR" sz="1600" dirty="0" smtClean="0">
+                <a:solidFill>
+                  <a:schemeClr val="bg2">
+                    <a:lumMod val="90000"/>
+                  </a:schemeClr>
+                </a:solidFill>
+              </a:rPr>
+              <a:t>/11/2023</a:t>
             </a:r>
             <a:endParaRPr lang="pt-BR" sz="1600" dirty="0">
               <a:solidFill>

</xml_diff>

<commit_message>
rollback tratamento data prevista do agendamento
</commit_message>
<xml_diff>
--- a/tempimento.pptx
+++ b/tempimento.pptx
@@ -197,7 +197,7 @@
           <a:p>
             <a:fld id="{A584E3A2-E8EA-4705-A613-CFE9F6F5D3B4}" type="datetimeFigureOut">
               <a:rPr lang="pt-BR" smtClean="0"/>
-              <a:t>27/11/2023</a:t>
+              <a:t>09/12/2023</a:t>
             </a:fld>
             <a:endParaRPr lang="pt-BR"/>
           </a:p>
@@ -680,7 +680,7 @@
           <a:p>
             <a:fld id="{52231B9D-E9F6-4612-9B82-E89961B389AC}" type="datetimeFigureOut">
               <a:rPr lang="pt-BR" smtClean="0"/>
-              <a:t>27/11/2023</a:t>
+              <a:t>09/12/2023</a:t>
             </a:fld>
             <a:endParaRPr lang="pt-BR"/>
           </a:p>
@@ -850,7 +850,7 @@
           <a:p>
             <a:fld id="{52231B9D-E9F6-4612-9B82-E89961B389AC}" type="datetimeFigureOut">
               <a:rPr lang="pt-BR" smtClean="0"/>
-              <a:t>27/11/2023</a:t>
+              <a:t>09/12/2023</a:t>
             </a:fld>
             <a:endParaRPr lang="pt-BR"/>
           </a:p>
@@ -1030,7 +1030,7 @@
           <a:p>
             <a:fld id="{52231B9D-E9F6-4612-9B82-E89961B389AC}" type="datetimeFigureOut">
               <a:rPr lang="pt-BR" smtClean="0"/>
-              <a:t>27/11/2023</a:t>
+              <a:t>09/12/2023</a:t>
             </a:fld>
             <a:endParaRPr lang="pt-BR"/>
           </a:p>
@@ -1200,7 +1200,7 @@
           <a:p>
             <a:fld id="{52231B9D-E9F6-4612-9B82-E89961B389AC}" type="datetimeFigureOut">
               <a:rPr lang="pt-BR" smtClean="0"/>
-              <a:t>27/11/2023</a:t>
+              <a:t>09/12/2023</a:t>
             </a:fld>
             <a:endParaRPr lang="pt-BR"/>
           </a:p>
@@ -1446,7 +1446,7 @@
           <a:p>
             <a:fld id="{52231B9D-E9F6-4612-9B82-E89961B389AC}" type="datetimeFigureOut">
               <a:rPr lang="pt-BR" smtClean="0"/>
-              <a:t>27/11/2023</a:t>
+              <a:t>09/12/2023</a:t>
             </a:fld>
             <a:endParaRPr lang="pt-BR"/>
           </a:p>
@@ -1678,7 +1678,7 @@
           <a:p>
             <a:fld id="{52231B9D-E9F6-4612-9B82-E89961B389AC}" type="datetimeFigureOut">
               <a:rPr lang="pt-BR" smtClean="0"/>
-              <a:t>27/11/2023</a:t>
+              <a:t>09/12/2023</a:t>
             </a:fld>
             <a:endParaRPr lang="pt-BR"/>
           </a:p>
@@ -2045,7 +2045,7 @@
           <a:p>
             <a:fld id="{52231B9D-E9F6-4612-9B82-E89961B389AC}" type="datetimeFigureOut">
               <a:rPr lang="pt-BR" smtClean="0"/>
-              <a:t>27/11/2023</a:t>
+              <a:t>09/12/2023</a:t>
             </a:fld>
             <a:endParaRPr lang="pt-BR"/>
           </a:p>
@@ -2163,7 +2163,7 @@
           <a:p>
             <a:fld id="{52231B9D-E9F6-4612-9B82-E89961B389AC}" type="datetimeFigureOut">
               <a:rPr lang="pt-BR" smtClean="0"/>
-              <a:t>27/11/2023</a:t>
+              <a:t>09/12/2023</a:t>
             </a:fld>
             <a:endParaRPr lang="pt-BR"/>
           </a:p>
@@ -2258,7 +2258,7 @@
           <a:p>
             <a:fld id="{52231B9D-E9F6-4612-9B82-E89961B389AC}" type="datetimeFigureOut">
               <a:rPr lang="pt-BR" smtClean="0"/>
-              <a:t>27/11/2023</a:t>
+              <a:t>09/12/2023</a:t>
             </a:fld>
             <a:endParaRPr lang="pt-BR"/>
           </a:p>
@@ -2535,7 +2535,7 @@
           <a:p>
             <a:fld id="{52231B9D-E9F6-4612-9B82-E89961B389AC}" type="datetimeFigureOut">
               <a:rPr lang="pt-BR" smtClean="0"/>
-              <a:t>27/11/2023</a:t>
+              <a:t>09/12/2023</a:t>
             </a:fld>
             <a:endParaRPr lang="pt-BR"/>
           </a:p>
@@ -2788,7 +2788,7 @@
           <a:p>
             <a:fld id="{52231B9D-E9F6-4612-9B82-E89961B389AC}" type="datetimeFigureOut">
               <a:rPr lang="pt-BR" smtClean="0"/>
-              <a:t>27/11/2023</a:t>
+              <a:t>09/12/2023</a:t>
             </a:fld>
             <a:endParaRPr lang="pt-BR"/>
           </a:p>
@@ -3001,7 +3001,7 @@
           <a:p>
             <a:fld id="{52231B9D-E9F6-4612-9B82-E89961B389AC}" type="datetimeFigureOut">
               <a:rPr lang="pt-BR" smtClean="0"/>
-              <a:t>27/11/2023</a:t>
+              <a:t>09/12/2023</a:t>
             </a:fld>
             <a:endParaRPr lang="pt-BR"/>
           </a:p>
@@ -3665,17 +3665,7 @@
                   </a:schemeClr>
                 </a:solidFill>
               </a:rPr>
-              <a:t>26</a:t>
-            </a:r>
-            <a:r>
-              <a:rPr lang="pt-BR" sz="1600" dirty="0" smtClean="0">
-                <a:solidFill>
-                  <a:schemeClr val="bg2">
-                    <a:lumMod val="90000"/>
-                  </a:schemeClr>
-                </a:solidFill>
-              </a:rPr>
-              <a:t>/11/2023</a:t>
+              <a:t>30/12/2023</a:t>
             </a:r>
             <a:endParaRPr lang="pt-BR" sz="1600" dirty="0">
               <a:solidFill>

</xml_diff>

<commit_message>
alteração do codinome da tabela do pneu
</commit_message>
<xml_diff>
--- a/tempimento.pptx
+++ b/tempimento.pptx
@@ -197,7 +197,7 @@
           <a:p>
             <a:fld id="{A584E3A2-E8EA-4705-A613-CFE9F6F5D3B4}" type="datetimeFigureOut">
               <a:rPr lang="pt-BR" smtClean="0"/>
-              <a:t>09/12/2023</a:t>
+              <a:t>22/12/2023</a:t>
             </a:fld>
             <a:endParaRPr lang="pt-BR"/>
           </a:p>
@@ -680,7 +680,7 @@
           <a:p>
             <a:fld id="{52231B9D-E9F6-4612-9B82-E89961B389AC}" type="datetimeFigureOut">
               <a:rPr lang="pt-BR" smtClean="0"/>
-              <a:t>09/12/2023</a:t>
+              <a:t>22/12/2023</a:t>
             </a:fld>
             <a:endParaRPr lang="pt-BR"/>
           </a:p>
@@ -850,7 +850,7 @@
           <a:p>
             <a:fld id="{52231B9D-E9F6-4612-9B82-E89961B389AC}" type="datetimeFigureOut">
               <a:rPr lang="pt-BR" smtClean="0"/>
-              <a:t>09/12/2023</a:t>
+              <a:t>22/12/2023</a:t>
             </a:fld>
             <a:endParaRPr lang="pt-BR"/>
           </a:p>
@@ -1030,7 +1030,7 @@
           <a:p>
             <a:fld id="{52231B9D-E9F6-4612-9B82-E89961B389AC}" type="datetimeFigureOut">
               <a:rPr lang="pt-BR" smtClean="0"/>
-              <a:t>09/12/2023</a:t>
+              <a:t>22/12/2023</a:t>
             </a:fld>
             <a:endParaRPr lang="pt-BR"/>
           </a:p>
@@ -1200,7 +1200,7 @@
           <a:p>
             <a:fld id="{52231B9D-E9F6-4612-9B82-E89961B389AC}" type="datetimeFigureOut">
               <a:rPr lang="pt-BR" smtClean="0"/>
-              <a:t>09/12/2023</a:t>
+              <a:t>22/12/2023</a:t>
             </a:fld>
             <a:endParaRPr lang="pt-BR"/>
           </a:p>
@@ -1446,7 +1446,7 @@
           <a:p>
             <a:fld id="{52231B9D-E9F6-4612-9B82-E89961B389AC}" type="datetimeFigureOut">
               <a:rPr lang="pt-BR" smtClean="0"/>
-              <a:t>09/12/2023</a:t>
+              <a:t>22/12/2023</a:t>
             </a:fld>
             <a:endParaRPr lang="pt-BR"/>
           </a:p>
@@ -1678,7 +1678,7 @@
           <a:p>
             <a:fld id="{52231B9D-E9F6-4612-9B82-E89961B389AC}" type="datetimeFigureOut">
               <a:rPr lang="pt-BR" smtClean="0"/>
-              <a:t>09/12/2023</a:t>
+              <a:t>22/12/2023</a:t>
             </a:fld>
             <a:endParaRPr lang="pt-BR"/>
           </a:p>
@@ -2045,7 +2045,7 @@
           <a:p>
             <a:fld id="{52231B9D-E9F6-4612-9B82-E89961B389AC}" type="datetimeFigureOut">
               <a:rPr lang="pt-BR" smtClean="0"/>
-              <a:t>09/12/2023</a:t>
+              <a:t>22/12/2023</a:t>
             </a:fld>
             <a:endParaRPr lang="pt-BR"/>
           </a:p>
@@ -2163,7 +2163,7 @@
           <a:p>
             <a:fld id="{52231B9D-E9F6-4612-9B82-E89961B389AC}" type="datetimeFigureOut">
               <a:rPr lang="pt-BR" smtClean="0"/>
-              <a:t>09/12/2023</a:t>
+              <a:t>22/12/2023</a:t>
             </a:fld>
             <a:endParaRPr lang="pt-BR"/>
           </a:p>
@@ -2258,7 +2258,7 @@
           <a:p>
             <a:fld id="{52231B9D-E9F6-4612-9B82-E89961B389AC}" type="datetimeFigureOut">
               <a:rPr lang="pt-BR" smtClean="0"/>
-              <a:t>09/12/2023</a:t>
+              <a:t>22/12/2023</a:t>
             </a:fld>
             <a:endParaRPr lang="pt-BR"/>
           </a:p>
@@ -2535,7 +2535,7 @@
           <a:p>
             <a:fld id="{52231B9D-E9F6-4612-9B82-E89961B389AC}" type="datetimeFigureOut">
               <a:rPr lang="pt-BR" smtClean="0"/>
-              <a:t>09/12/2023</a:t>
+              <a:t>22/12/2023</a:t>
             </a:fld>
             <a:endParaRPr lang="pt-BR"/>
           </a:p>
@@ -2788,7 +2788,7 @@
           <a:p>
             <a:fld id="{52231B9D-E9F6-4612-9B82-E89961B389AC}" type="datetimeFigureOut">
               <a:rPr lang="pt-BR" smtClean="0"/>
-              <a:t>09/12/2023</a:t>
+              <a:t>22/12/2023</a:t>
             </a:fld>
             <a:endParaRPr lang="pt-BR"/>
           </a:p>
@@ -3001,7 +3001,7 @@
           <a:p>
             <a:fld id="{52231B9D-E9F6-4612-9B82-E89961B389AC}" type="datetimeFigureOut">
               <a:rPr lang="pt-BR" smtClean="0"/>
-              <a:t>09/12/2023</a:t>
+              <a:t>22/12/2023</a:t>
             </a:fld>
             <a:endParaRPr lang="pt-BR"/>
           </a:p>
@@ -3665,7 +3665,17 @@
                   </a:schemeClr>
                 </a:solidFill>
               </a:rPr>
-              <a:t>30/12/2023</a:t>
+              <a:t>17</a:t>
+            </a:r>
+            <a:r>
+              <a:rPr lang="pt-BR" sz="1600" dirty="0" smtClean="0">
+                <a:solidFill>
+                  <a:schemeClr val="bg2">
+                    <a:lumMod val="90000"/>
+                  </a:schemeClr>
+                </a:solidFill>
+              </a:rPr>
+              <a:t>/12/2023</a:t>
             </a:r>
             <a:endParaRPr lang="pt-BR" sz="1600" dirty="0">
               <a:solidFill>

</xml_diff>

<commit_message>
tratamento km manual quando sem km autotrac OK
</commit_message>
<xml_diff>
--- a/tempimento.pptx
+++ b/tempimento.pptx
@@ -197,7 +197,7 @@
           <a:p>
             <a:fld id="{A584E3A2-E8EA-4705-A613-CFE9F6F5D3B4}" type="datetimeFigureOut">
               <a:rPr lang="pt-BR" smtClean="0"/>
-              <a:t>22/12/2023</a:t>
+              <a:t>02/01/2024</a:t>
             </a:fld>
             <a:endParaRPr lang="pt-BR"/>
           </a:p>
@@ -680,7 +680,7 @@
           <a:p>
             <a:fld id="{52231B9D-E9F6-4612-9B82-E89961B389AC}" type="datetimeFigureOut">
               <a:rPr lang="pt-BR" smtClean="0"/>
-              <a:t>22/12/2023</a:t>
+              <a:t>02/01/2024</a:t>
             </a:fld>
             <a:endParaRPr lang="pt-BR"/>
           </a:p>
@@ -850,7 +850,7 @@
           <a:p>
             <a:fld id="{52231B9D-E9F6-4612-9B82-E89961B389AC}" type="datetimeFigureOut">
               <a:rPr lang="pt-BR" smtClean="0"/>
-              <a:t>22/12/2023</a:t>
+              <a:t>02/01/2024</a:t>
             </a:fld>
             <a:endParaRPr lang="pt-BR"/>
           </a:p>
@@ -1030,7 +1030,7 @@
           <a:p>
             <a:fld id="{52231B9D-E9F6-4612-9B82-E89961B389AC}" type="datetimeFigureOut">
               <a:rPr lang="pt-BR" smtClean="0"/>
-              <a:t>22/12/2023</a:t>
+              <a:t>02/01/2024</a:t>
             </a:fld>
             <a:endParaRPr lang="pt-BR"/>
           </a:p>
@@ -1200,7 +1200,7 @@
           <a:p>
             <a:fld id="{52231B9D-E9F6-4612-9B82-E89961B389AC}" type="datetimeFigureOut">
               <a:rPr lang="pt-BR" smtClean="0"/>
-              <a:t>22/12/2023</a:t>
+              <a:t>02/01/2024</a:t>
             </a:fld>
             <a:endParaRPr lang="pt-BR"/>
           </a:p>
@@ -1446,7 +1446,7 @@
           <a:p>
             <a:fld id="{52231B9D-E9F6-4612-9B82-E89961B389AC}" type="datetimeFigureOut">
               <a:rPr lang="pt-BR" smtClean="0"/>
-              <a:t>22/12/2023</a:t>
+              <a:t>02/01/2024</a:t>
             </a:fld>
             <a:endParaRPr lang="pt-BR"/>
           </a:p>
@@ -1678,7 +1678,7 @@
           <a:p>
             <a:fld id="{52231B9D-E9F6-4612-9B82-E89961B389AC}" type="datetimeFigureOut">
               <a:rPr lang="pt-BR" smtClean="0"/>
-              <a:t>22/12/2023</a:t>
+              <a:t>02/01/2024</a:t>
             </a:fld>
             <a:endParaRPr lang="pt-BR"/>
           </a:p>
@@ -2045,7 +2045,7 @@
           <a:p>
             <a:fld id="{52231B9D-E9F6-4612-9B82-E89961B389AC}" type="datetimeFigureOut">
               <a:rPr lang="pt-BR" smtClean="0"/>
-              <a:t>22/12/2023</a:t>
+              <a:t>02/01/2024</a:t>
             </a:fld>
             <a:endParaRPr lang="pt-BR"/>
           </a:p>
@@ -2163,7 +2163,7 @@
           <a:p>
             <a:fld id="{52231B9D-E9F6-4612-9B82-E89961B389AC}" type="datetimeFigureOut">
               <a:rPr lang="pt-BR" smtClean="0"/>
-              <a:t>22/12/2023</a:t>
+              <a:t>02/01/2024</a:t>
             </a:fld>
             <a:endParaRPr lang="pt-BR"/>
           </a:p>
@@ -2258,7 +2258,7 @@
           <a:p>
             <a:fld id="{52231B9D-E9F6-4612-9B82-E89961B389AC}" type="datetimeFigureOut">
               <a:rPr lang="pt-BR" smtClean="0"/>
-              <a:t>22/12/2023</a:t>
+              <a:t>02/01/2024</a:t>
             </a:fld>
             <a:endParaRPr lang="pt-BR"/>
           </a:p>
@@ -2535,7 +2535,7 @@
           <a:p>
             <a:fld id="{52231B9D-E9F6-4612-9B82-E89961B389AC}" type="datetimeFigureOut">
               <a:rPr lang="pt-BR" smtClean="0"/>
-              <a:t>22/12/2023</a:t>
+              <a:t>02/01/2024</a:t>
             </a:fld>
             <a:endParaRPr lang="pt-BR"/>
           </a:p>
@@ -2788,7 +2788,7 @@
           <a:p>
             <a:fld id="{52231B9D-E9F6-4612-9B82-E89961B389AC}" type="datetimeFigureOut">
               <a:rPr lang="pt-BR" smtClean="0"/>
-              <a:t>22/12/2023</a:t>
+              <a:t>02/01/2024</a:t>
             </a:fld>
             <a:endParaRPr lang="pt-BR"/>
           </a:p>
@@ -3001,7 +3001,7 @@
           <a:p>
             <a:fld id="{52231B9D-E9F6-4612-9B82-E89961B389AC}" type="datetimeFigureOut">
               <a:rPr lang="pt-BR" smtClean="0"/>
-              <a:t>22/12/2023</a:t>
+              <a:t>02/01/2024</a:t>
             </a:fld>
             <a:endParaRPr lang="pt-BR"/>
           </a:p>
@@ -3658,24 +3658,14 @@
           <a:lstStyle/>
           <a:p>
             <a:r>
-              <a:rPr lang="pt-BR" sz="1600" dirty="0" smtClean="0">
+              <a:rPr lang="pt-BR" sz="1600" smtClean="0">
                 <a:solidFill>
                   <a:schemeClr val="bg2">
                     <a:lumMod val="90000"/>
                   </a:schemeClr>
                 </a:solidFill>
               </a:rPr>
-              <a:t>17</a:t>
-            </a:r>
-            <a:r>
-              <a:rPr lang="pt-BR" sz="1600" dirty="0" smtClean="0">
-                <a:solidFill>
-                  <a:schemeClr val="bg2">
-                    <a:lumMod val="90000"/>
-                  </a:schemeClr>
-                </a:solidFill>
-              </a:rPr>
-              <a:t>/12/2023</a:t>
+              <a:t>31/12/2023</a:t>
             </a:r>
             <a:endParaRPr lang="pt-BR" sz="1600" dirty="0">
               <a:solidFill>

</xml_diff>

<commit_message>
consultas mconsult para custos operação portuária
</commit_message>
<xml_diff>
--- a/tempimento.pptx
+++ b/tempimento.pptx
@@ -197,7 +197,7 @@
           <a:p>
             <a:fld id="{A584E3A2-E8EA-4705-A613-CFE9F6F5D3B4}" type="datetimeFigureOut">
               <a:rPr lang="pt-BR" smtClean="0"/>
-              <a:t>02/01/2024</a:t>
+              <a:t>10/01/2024</a:t>
             </a:fld>
             <a:endParaRPr lang="pt-BR"/>
           </a:p>
@@ -680,7 +680,7 @@
           <a:p>
             <a:fld id="{52231B9D-E9F6-4612-9B82-E89961B389AC}" type="datetimeFigureOut">
               <a:rPr lang="pt-BR" smtClean="0"/>
-              <a:t>02/01/2024</a:t>
+              <a:t>10/01/2024</a:t>
             </a:fld>
             <a:endParaRPr lang="pt-BR"/>
           </a:p>
@@ -850,7 +850,7 @@
           <a:p>
             <a:fld id="{52231B9D-E9F6-4612-9B82-E89961B389AC}" type="datetimeFigureOut">
               <a:rPr lang="pt-BR" smtClean="0"/>
-              <a:t>02/01/2024</a:t>
+              <a:t>10/01/2024</a:t>
             </a:fld>
             <a:endParaRPr lang="pt-BR"/>
           </a:p>
@@ -1030,7 +1030,7 @@
           <a:p>
             <a:fld id="{52231B9D-E9F6-4612-9B82-E89961B389AC}" type="datetimeFigureOut">
               <a:rPr lang="pt-BR" smtClean="0"/>
-              <a:t>02/01/2024</a:t>
+              <a:t>10/01/2024</a:t>
             </a:fld>
             <a:endParaRPr lang="pt-BR"/>
           </a:p>
@@ -1200,7 +1200,7 @@
           <a:p>
             <a:fld id="{52231B9D-E9F6-4612-9B82-E89961B389AC}" type="datetimeFigureOut">
               <a:rPr lang="pt-BR" smtClean="0"/>
-              <a:t>02/01/2024</a:t>
+              <a:t>10/01/2024</a:t>
             </a:fld>
             <a:endParaRPr lang="pt-BR"/>
           </a:p>
@@ -1446,7 +1446,7 @@
           <a:p>
             <a:fld id="{52231B9D-E9F6-4612-9B82-E89961B389AC}" type="datetimeFigureOut">
               <a:rPr lang="pt-BR" smtClean="0"/>
-              <a:t>02/01/2024</a:t>
+              <a:t>10/01/2024</a:t>
             </a:fld>
             <a:endParaRPr lang="pt-BR"/>
           </a:p>
@@ -1678,7 +1678,7 @@
           <a:p>
             <a:fld id="{52231B9D-E9F6-4612-9B82-E89961B389AC}" type="datetimeFigureOut">
               <a:rPr lang="pt-BR" smtClean="0"/>
-              <a:t>02/01/2024</a:t>
+              <a:t>10/01/2024</a:t>
             </a:fld>
             <a:endParaRPr lang="pt-BR"/>
           </a:p>
@@ -2045,7 +2045,7 @@
           <a:p>
             <a:fld id="{52231B9D-E9F6-4612-9B82-E89961B389AC}" type="datetimeFigureOut">
               <a:rPr lang="pt-BR" smtClean="0"/>
-              <a:t>02/01/2024</a:t>
+              <a:t>10/01/2024</a:t>
             </a:fld>
             <a:endParaRPr lang="pt-BR"/>
           </a:p>
@@ -2163,7 +2163,7 @@
           <a:p>
             <a:fld id="{52231B9D-E9F6-4612-9B82-E89961B389AC}" type="datetimeFigureOut">
               <a:rPr lang="pt-BR" smtClean="0"/>
-              <a:t>02/01/2024</a:t>
+              <a:t>10/01/2024</a:t>
             </a:fld>
             <a:endParaRPr lang="pt-BR"/>
           </a:p>
@@ -2258,7 +2258,7 @@
           <a:p>
             <a:fld id="{52231B9D-E9F6-4612-9B82-E89961B389AC}" type="datetimeFigureOut">
               <a:rPr lang="pt-BR" smtClean="0"/>
-              <a:t>02/01/2024</a:t>
+              <a:t>10/01/2024</a:t>
             </a:fld>
             <a:endParaRPr lang="pt-BR"/>
           </a:p>
@@ -2535,7 +2535,7 @@
           <a:p>
             <a:fld id="{52231B9D-E9F6-4612-9B82-E89961B389AC}" type="datetimeFigureOut">
               <a:rPr lang="pt-BR" smtClean="0"/>
-              <a:t>02/01/2024</a:t>
+              <a:t>10/01/2024</a:t>
             </a:fld>
             <a:endParaRPr lang="pt-BR"/>
           </a:p>
@@ -2788,7 +2788,7 @@
           <a:p>
             <a:fld id="{52231B9D-E9F6-4612-9B82-E89961B389AC}" type="datetimeFigureOut">
               <a:rPr lang="pt-BR" smtClean="0"/>
-              <a:t>02/01/2024</a:t>
+              <a:t>10/01/2024</a:t>
             </a:fld>
             <a:endParaRPr lang="pt-BR"/>
           </a:p>
@@ -3001,7 +3001,7 @@
           <a:p>
             <a:fld id="{52231B9D-E9F6-4612-9B82-E89961B389AC}" type="datetimeFigureOut">
               <a:rPr lang="pt-BR" smtClean="0"/>
-              <a:t>02/01/2024</a:t>
+              <a:t>10/01/2024</a:t>
             </a:fld>
             <a:endParaRPr lang="pt-BR"/>
           </a:p>
@@ -3658,14 +3658,14 @@
           <a:lstStyle/>
           <a:p>
             <a:r>
-              <a:rPr lang="pt-BR" sz="1600" smtClean="0">
+              <a:rPr lang="pt-BR" sz="1600" dirty="0" smtClean="0">
                 <a:solidFill>
                   <a:schemeClr val="bg2">
                     <a:lumMod val="90000"/>
                   </a:schemeClr>
                 </a:solidFill>
               </a:rPr>
-              <a:t>31/12/2023</a:t>
+              <a:t>07/01/2024</a:t>
             </a:r>
             <a:endParaRPr lang="pt-BR" sz="1600" dirty="0">
               <a:solidFill>

</xml_diff>

<commit_message>
erro nas consultas solicitação e pedido de compra
</commit_message>
<xml_diff>
--- a/tempimento.pptx
+++ b/tempimento.pptx
@@ -11,7 +11,7 @@
     <p:sldId id="256" r:id="rId2"/>
   </p:sldIdLst>
   <p:sldSz cx="12192000" cy="6858000"/>
-  <p:notesSz cx="6889750" cy="9671050"/>
+  <p:notesSz cx="6888163" cy="10021888"/>
   <p:defaultTextStyle>
     <a:defPPr>
       <a:defRPr lang="pt-BR"/>
@@ -150,7 +150,7 @@
         <p:spPr>
           <a:xfrm>
             <a:off x="6" y="1"/>
-            <a:ext cx="2985970" cy="484528"/>
+            <a:ext cx="2985282" cy="502105"/>
           </a:xfrm>
           <a:prstGeom prst="rect">
             <a:avLst/>
@@ -180,8 +180,8 @@
         </p:nvSpPr>
         <p:spPr>
           <a:xfrm>
-            <a:off x="3902247" y="1"/>
-            <a:ext cx="2985970" cy="484528"/>
+            <a:off x="3901348" y="1"/>
+            <a:ext cx="2985282" cy="502105"/>
           </a:xfrm>
           <a:prstGeom prst="rect">
             <a:avLst/>
@@ -197,7 +197,7 @@
           <a:p>
             <a:fld id="{A584E3A2-E8EA-4705-A613-CFE9F6F5D3B4}" type="datetimeFigureOut">
               <a:rPr lang="pt-BR" smtClean="0"/>
-              <a:t>10/01/2024</a:t>
+              <a:t>20/01/2024</a:t>
             </a:fld>
             <a:endParaRPr lang="pt-BR"/>
           </a:p>
@@ -215,8 +215,8 @@
         </p:nvSpPr>
         <p:spPr>
           <a:xfrm>
-            <a:off x="544513" y="1209675"/>
-            <a:ext cx="5800725" cy="3262313"/>
+            <a:off x="441325" y="1254125"/>
+            <a:ext cx="6005513" cy="3379788"/>
           </a:xfrm>
           <a:prstGeom prst="rect">
             <a:avLst/>
@@ -248,8 +248,8 @@
         </p:nvSpPr>
         <p:spPr>
           <a:xfrm>
-            <a:off x="688363" y="4654768"/>
-            <a:ext cx="5513032" cy="3807217"/>
+            <a:off x="688204" y="4823630"/>
+            <a:ext cx="5511762" cy="3945332"/>
           </a:xfrm>
           <a:prstGeom prst="rect">
             <a:avLst/>
@@ -308,8 +308,8 @@
         </p:nvSpPr>
         <p:spPr>
           <a:xfrm>
-            <a:off x="6" y="9186524"/>
-            <a:ext cx="2985970" cy="484528"/>
+            <a:off x="6" y="9519785"/>
+            <a:ext cx="2985282" cy="502105"/>
           </a:xfrm>
           <a:prstGeom prst="rect">
             <a:avLst/>
@@ -339,8 +339,8 @@
         </p:nvSpPr>
         <p:spPr>
           <a:xfrm>
-            <a:off x="3902247" y="9186524"/>
-            <a:ext cx="2985970" cy="484528"/>
+            <a:off x="3901348" y="9519785"/>
+            <a:ext cx="2985282" cy="502105"/>
           </a:xfrm>
           <a:prstGeom prst="rect">
             <a:avLst/>
@@ -680,7 +680,7 @@
           <a:p>
             <a:fld id="{52231B9D-E9F6-4612-9B82-E89961B389AC}" type="datetimeFigureOut">
               <a:rPr lang="pt-BR" smtClean="0"/>
-              <a:t>10/01/2024</a:t>
+              <a:t>20/01/2024</a:t>
             </a:fld>
             <a:endParaRPr lang="pt-BR"/>
           </a:p>
@@ -850,7 +850,7 @@
           <a:p>
             <a:fld id="{52231B9D-E9F6-4612-9B82-E89961B389AC}" type="datetimeFigureOut">
               <a:rPr lang="pt-BR" smtClean="0"/>
-              <a:t>10/01/2024</a:t>
+              <a:t>20/01/2024</a:t>
             </a:fld>
             <a:endParaRPr lang="pt-BR"/>
           </a:p>
@@ -1030,7 +1030,7 @@
           <a:p>
             <a:fld id="{52231B9D-E9F6-4612-9B82-E89961B389AC}" type="datetimeFigureOut">
               <a:rPr lang="pt-BR" smtClean="0"/>
-              <a:t>10/01/2024</a:t>
+              <a:t>20/01/2024</a:t>
             </a:fld>
             <a:endParaRPr lang="pt-BR"/>
           </a:p>
@@ -1200,7 +1200,7 @@
           <a:p>
             <a:fld id="{52231B9D-E9F6-4612-9B82-E89961B389AC}" type="datetimeFigureOut">
               <a:rPr lang="pt-BR" smtClean="0"/>
-              <a:t>10/01/2024</a:t>
+              <a:t>20/01/2024</a:t>
             </a:fld>
             <a:endParaRPr lang="pt-BR"/>
           </a:p>
@@ -1446,7 +1446,7 @@
           <a:p>
             <a:fld id="{52231B9D-E9F6-4612-9B82-E89961B389AC}" type="datetimeFigureOut">
               <a:rPr lang="pt-BR" smtClean="0"/>
-              <a:t>10/01/2024</a:t>
+              <a:t>20/01/2024</a:t>
             </a:fld>
             <a:endParaRPr lang="pt-BR"/>
           </a:p>
@@ -1678,7 +1678,7 @@
           <a:p>
             <a:fld id="{52231B9D-E9F6-4612-9B82-E89961B389AC}" type="datetimeFigureOut">
               <a:rPr lang="pt-BR" smtClean="0"/>
-              <a:t>10/01/2024</a:t>
+              <a:t>20/01/2024</a:t>
             </a:fld>
             <a:endParaRPr lang="pt-BR"/>
           </a:p>
@@ -2045,7 +2045,7 @@
           <a:p>
             <a:fld id="{52231B9D-E9F6-4612-9B82-E89961B389AC}" type="datetimeFigureOut">
               <a:rPr lang="pt-BR" smtClean="0"/>
-              <a:t>10/01/2024</a:t>
+              <a:t>20/01/2024</a:t>
             </a:fld>
             <a:endParaRPr lang="pt-BR"/>
           </a:p>
@@ -2163,7 +2163,7 @@
           <a:p>
             <a:fld id="{52231B9D-E9F6-4612-9B82-E89961B389AC}" type="datetimeFigureOut">
               <a:rPr lang="pt-BR" smtClean="0"/>
-              <a:t>10/01/2024</a:t>
+              <a:t>20/01/2024</a:t>
             </a:fld>
             <a:endParaRPr lang="pt-BR"/>
           </a:p>
@@ -2258,7 +2258,7 @@
           <a:p>
             <a:fld id="{52231B9D-E9F6-4612-9B82-E89961B389AC}" type="datetimeFigureOut">
               <a:rPr lang="pt-BR" smtClean="0"/>
-              <a:t>10/01/2024</a:t>
+              <a:t>20/01/2024</a:t>
             </a:fld>
             <a:endParaRPr lang="pt-BR"/>
           </a:p>
@@ -2535,7 +2535,7 @@
           <a:p>
             <a:fld id="{52231B9D-E9F6-4612-9B82-E89961B389AC}" type="datetimeFigureOut">
               <a:rPr lang="pt-BR" smtClean="0"/>
-              <a:t>10/01/2024</a:t>
+              <a:t>20/01/2024</a:t>
             </a:fld>
             <a:endParaRPr lang="pt-BR"/>
           </a:p>
@@ -2788,7 +2788,7 @@
           <a:p>
             <a:fld id="{52231B9D-E9F6-4612-9B82-E89961B389AC}" type="datetimeFigureOut">
               <a:rPr lang="pt-BR" smtClean="0"/>
-              <a:t>10/01/2024</a:t>
+              <a:t>20/01/2024</a:t>
             </a:fld>
             <a:endParaRPr lang="pt-BR"/>
           </a:p>
@@ -3001,7 +3001,7 @@
           <a:p>
             <a:fld id="{52231B9D-E9F6-4612-9B82-E89961B389AC}" type="datetimeFigureOut">
               <a:rPr lang="pt-BR" smtClean="0"/>
-              <a:t>10/01/2024</a:t>
+              <a:t>20/01/2024</a:t>
             </a:fld>
             <a:endParaRPr lang="pt-BR"/>
           </a:p>
@@ -3665,7 +3665,17 @@
                   </a:schemeClr>
                 </a:solidFill>
               </a:rPr>
-              <a:t>07/01/2024</a:t>
+              <a:t>21</a:t>
+            </a:r>
+            <a:r>
+              <a:rPr lang="pt-BR" sz="1600" dirty="0" smtClean="0">
+                <a:solidFill>
+                  <a:schemeClr val="bg2">
+                    <a:lumMod val="90000"/>
+                  </a:schemeClr>
+                </a:solidFill>
+              </a:rPr>
+              <a:t>/01/2024</a:t>
             </a:r>
             <a:endParaRPr lang="pt-BR" sz="1600" dirty="0">
               <a:solidFill>

</xml_diff>

<commit_message>
pendente custo folha; demais pendente validação
</commit_message>
<xml_diff>
--- a/tempimento.pptx
+++ b/tempimento.pptx
@@ -197,7 +197,7 @@
           <a:p>
             <a:fld id="{A584E3A2-E8EA-4705-A613-CFE9F6F5D3B4}" type="datetimeFigureOut">
               <a:rPr lang="pt-BR" smtClean="0"/>
-              <a:t>20/01/2024</a:t>
+              <a:t>29/01/2024</a:t>
             </a:fld>
             <a:endParaRPr lang="pt-BR"/>
           </a:p>
@@ -680,7 +680,7 @@
           <a:p>
             <a:fld id="{52231B9D-E9F6-4612-9B82-E89961B389AC}" type="datetimeFigureOut">
               <a:rPr lang="pt-BR" smtClean="0"/>
-              <a:t>20/01/2024</a:t>
+              <a:t>29/01/2024</a:t>
             </a:fld>
             <a:endParaRPr lang="pt-BR"/>
           </a:p>
@@ -850,7 +850,7 @@
           <a:p>
             <a:fld id="{52231B9D-E9F6-4612-9B82-E89961B389AC}" type="datetimeFigureOut">
               <a:rPr lang="pt-BR" smtClean="0"/>
-              <a:t>20/01/2024</a:t>
+              <a:t>29/01/2024</a:t>
             </a:fld>
             <a:endParaRPr lang="pt-BR"/>
           </a:p>
@@ -1030,7 +1030,7 @@
           <a:p>
             <a:fld id="{52231B9D-E9F6-4612-9B82-E89961B389AC}" type="datetimeFigureOut">
               <a:rPr lang="pt-BR" smtClean="0"/>
-              <a:t>20/01/2024</a:t>
+              <a:t>29/01/2024</a:t>
             </a:fld>
             <a:endParaRPr lang="pt-BR"/>
           </a:p>
@@ -1200,7 +1200,7 @@
           <a:p>
             <a:fld id="{52231B9D-E9F6-4612-9B82-E89961B389AC}" type="datetimeFigureOut">
               <a:rPr lang="pt-BR" smtClean="0"/>
-              <a:t>20/01/2024</a:t>
+              <a:t>29/01/2024</a:t>
             </a:fld>
             <a:endParaRPr lang="pt-BR"/>
           </a:p>
@@ -1446,7 +1446,7 @@
           <a:p>
             <a:fld id="{52231B9D-E9F6-4612-9B82-E89961B389AC}" type="datetimeFigureOut">
               <a:rPr lang="pt-BR" smtClean="0"/>
-              <a:t>20/01/2024</a:t>
+              <a:t>29/01/2024</a:t>
             </a:fld>
             <a:endParaRPr lang="pt-BR"/>
           </a:p>
@@ -1678,7 +1678,7 @@
           <a:p>
             <a:fld id="{52231B9D-E9F6-4612-9B82-E89961B389AC}" type="datetimeFigureOut">
               <a:rPr lang="pt-BR" smtClean="0"/>
-              <a:t>20/01/2024</a:t>
+              <a:t>29/01/2024</a:t>
             </a:fld>
             <a:endParaRPr lang="pt-BR"/>
           </a:p>
@@ -2045,7 +2045,7 @@
           <a:p>
             <a:fld id="{52231B9D-E9F6-4612-9B82-E89961B389AC}" type="datetimeFigureOut">
               <a:rPr lang="pt-BR" smtClean="0"/>
-              <a:t>20/01/2024</a:t>
+              <a:t>29/01/2024</a:t>
             </a:fld>
             <a:endParaRPr lang="pt-BR"/>
           </a:p>
@@ -2163,7 +2163,7 @@
           <a:p>
             <a:fld id="{52231B9D-E9F6-4612-9B82-E89961B389AC}" type="datetimeFigureOut">
               <a:rPr lang="pt-BR" smtClean="0"/>
-              <a:t>20/01/2024</a:t>
+              <a:t>29/01/2024</a:t>
             </a:fld>
             <a:endParaRPr lang="pt-BR"/>
           </a:p>
@@ -2258,7 +2258,7 @@
           <a:p>
             <a:fld id="{52231B9D-E9F6-4612-9B82-E89961B389AC}" type="datetimeFigureOut">
               <a:rPr lang="pt-BR" smtClean="0"/>
-              <a:t>20/01/2024</a:t>
+              <a:t>29/01/2024</a:t>
             </a:fld>
             <a:endParaRPr lang="pt-BR"/>
           </a:p>
@@ -2535,7 +2535,7 @@
           <a:p>
             <a:fld id="{52231B9D-E9F6-4612-9B82-E89961B389AC}" type="datetimeFigureOut">
               <a:rPr lang="pt-BR" smtClean="0"/>
-              <a:t>20/01/2024</a:t>
+              <a:t>29/01/2024</a:t>
             </a:fld>
             <a:endParaRPr lang="pt-BR"/>
           </a:p>
@@ -2788,7 +2788,7 @@
           <a:p>
             <a:fld id="{52231B9D-E9F6-4612-9B82-E89961B389AC}" type="datetimeFigureOut">
               <a:rPr lang="pt-BR" smtClean="0"/>
-              <a:t>20/01/2024</a:t>
+              <a:t>29/01/2024</a:t>
             </a:fld>
             <a:endParaRPr lang="pt-BR"/>
           </a:p>
@@ -3001,7 +3001,7 @@
           <a:p>
             <a:fld id="{52231B9D-E9F6-4612-9B82-E89961B389AC}" type="datetimeFigureOut">
               <a:rPr lang="pt-BR" smtClean="0"/>
-              <a:t>20/01/2024</a:t>
+              <a:t>29/01/2024</a:t>
             </a:fld>
             <a:endParaRPr lang="pt-BR"/>
           </a:p>
@@ -3665,7 +3665,7 @@
                   </a:schemeClr>
                 </a:solidFill>
               </a:rPr>
-              <a:t>21</a:t>
+              <a:t>04</a:t>
             </a:r>
             <a:r>
               <a:rPr lang="pt-BR" sz="1600" dirty="0" smtClean="0">
@@ -3675,7 +3675,7 @@
                   </a:schemeClr>
                 </a:solidFill>
               </a:rPr>
-              <a:t>/01/2024</a:t>
+              <a:t>/02/2024</a:t>
             </a:r>
             <a:endParaRPr lang="pt-BR" sz="1600" dirty="0">
               <a:solidFill>

</xml_diff>

<commit_message>
add rateio custo documentação e data período do item da OS
</commit_message>
<xml_diff>
--- a/tempimento.pptx
+++ b/tempimento.pptx
@@ -11,7 +11,7 @@
     <p:sldId id="256" r:id="rId2"/>
   </p:sldIdLst>
   <p:sldSz cx="12192000" cy="6858000"/>
-  <p:notesSz cx="6888163" cy="10021888"/>
+  <p:notesSz cx="6889750" cy="9671050"/>
   <p:defaultTextStyle>
     <a:defPPr>
       <a:defRPr lang="pt-BR"/>
@@ -150,7 +150,7 @@
         <p:spPr>
           <a:xfrm>
             <a:off x="6" y="1"/>
-            <a:ext cx="2985282" cy="502105"/>
+            <a:ext cx="2985970" cy="484528"/>
           </a:xfrm>
           <a:prstGeom prst="rect">
             <a:avLst/>
@@ -180,8 +180,8 @@
         </p:nvSpPr>
         <p:spPr>
           <a:xfrm>
-            <a:off x="3901348" y="1"/>
-            <a:ext cx="2985282" cy="502105"/>
+            <a:off x="3902247" y="1"/>
+            <a:ext cx="2985970" cy="484528"/>
           </a:xfrm>
           <a:prstGeom prst="rect">
             <a:avLst/>
@@ -197,7 +197,7 @@
           <a:p>
             <a:fld id="{A584E3A2-E8EA-4705-A613-CFE9F6F5D3B4}" type="datetimeFigureOut">
               <a:rPr lang="pt-BR" smtClean="0"/>
-              <a:t>29/01/2024</a:t>
+              <a:t>05/02/2024</a:t>
             </a:fld>
             <a:endParaRPr lang="pt-BR"/>
           </a:p>
@@ -215,8 +215,8 @@
         </p:nvSpPr>
         <p:spPr>
           <a:xfrm>
-            <a:off x="441325" y="1254125"/>
-            <a:ext cx="6005513" cy="3379788"/>
+            <a:off x="544513" y="1209675"/>
+            <a:ext cx="5800725" cy="3262313"/>
           </a:xfrm>
           <a:prstGeom prst="rect">
             <a:avLst/>
@@ -248,8 +248,8 @@
         </p:nvSpPr>
         <p:spPr>
           <a:xfrm>
-            <a:off x="688204" y="4823630"/>
-            <a:ext cx="5511762" cy="3945332"/>
+            <a:off x="688363" y="4654768"/>
+            <a:ext cx="5513032" cy="3807217"/>
           </a:xfrm>
           <a:prstGeom prst="rect">
             <a:avLst/>
@@ -308,8 +308,8 @@
         </p:nvSpPr>
         <p:spPr>
           <a:xfrm>
-            <a:off x="6" y="9519785"/>
-            <a:ext cx="2985282" cy="502105"/>
+            <a:off x="6" y="9186525"/>
+            <a:ext cx="2985970" cy="484528"/>
           </a:xfrm>
           <a:prstGeom prst="rect">
             <a:avLst/>
@@ -339,8 +339,8 @@
         </p:nvSpPr>
         <p:spPr>
           <a:xfrm>
-            <a:off x="3901348" y="9519785"/>
-            <a:ext cx="2985282" cy="502105"/>
+            <a:off x="3902247" y="9186525"/>
+            <a:ext cx="2985970" cy="484528"/>
           </a:xfrm>
           <a:prstGeom prst="rect">
             <a:avLst/>
@@ -680,7 +680,7 @@
           <a:p>
             <a:fld id="{52231B9D-E9F6-4612-9B82-E89961B389AC}" type="datetimeFigureOut">
               <a:rPr lang="pt-BR" smtClean="0"/>
-              <a:t>29/01/2024</a:t>
+              <a:t>05/02/2024</a:t>
             </a:fld>
             <a:endParaRPr lang="pt-BR"/>
           </a:p>
@@ -850,7 +850,7 @@
           <a:p>
             <a:fld id="{52231B9D-E9F6-4612-9B82-E89961B389AC}" type="datetimeFigureOut">
               <a:rPr lang="pt-BR" smtClean="0"/>
-              <a:t>29/01/2024</a:t>
+              <a:t>05/02/2024</a:t>
             </a:fld>
             <a:endParaRPr lang="pt-BR"/>
           </a:p>
@@ -1030,7 +1030,7 @@
           <a:p>
             <a:fld id="{52231B9D-E9F6-4612-9B82-E89961B389AC}" type="datetimeFigureOut">
               <a:rPr lang="pt-BR" smtClean="0"/>
-              <a:t>29/01/2024</a:t>
+              <a:t>05/02/2024</a:t>
             </a:fld>
             <a:endParaRPr lang="pt-BR"/>
           </a:p>
@@ -1200,7 +1200,7 @@
           <a:p>
             <a:fld id="{52231B9D-E9F6-4612-9B82-E89961B389AC}" type="datetimeFigureOut">
               <a:rPr lang="pt-BR" smtClean="0"/>
-              <a:t>29/01/2024</a:t>
+              <a:t>05/02/2024</a:t>
             </a:fld>
             <a:endParaRPr lang="pt-BR"/>
           </a:p>
@@ -1446,7 +1446,7 @@
           <a:p>
             <a:fld id="{52231B9D-E9F6-4612-9B82-E89961B389AC}" type="datetimeFigureOut">
               <a:rPr lang="pt-BR" smtClean="0"/>
-              <a:t>29/01/2024</a:t>
+              <a:t>05/02/2024</a:t>
             </a:fld>
             <a:endParaRPr lang="pt-BR"/>
           </a:p>
@@ -1678,7 +1678,7 @@
           <a:p>
             <a:fld id="{52231B9D-E9F6-4612-9B82-E89961B389AC}" type="datetimeFigureOut">
               <a:rPr lang="pt-BR" smtClean="0"/>
-              <a:t>29/01/2024</a:t>
+              <a:t>05/02/2024</a:t>
             </a:fld>
             <a:endParaRPr lang="pt-BR"/>
           </a:p>
@@ -2045,7 +2045,7 @@
           <a:p>
             <a:fld id="{52231B9D-E9F6-4612-9B82-E89961B389AC}" type="datetimeFigureOut">
               <a:rPr lang="pt-BR" smtClean="0"/>
-              <a:t>29/01/2024</a:t>
+              <a:t>05/02/2024</a:t>
             </a:fld>
             <a:endParaRPr lang="pt-BR"/>
           </a:p>
@@ -2163,7 +2163,7 @@
           <a:p>
             <a:fld id="{52231B9D-E9F6-4612-9B82-E89961B389AC}" type="datetimeFigureOut">
               <a:rPr lang="pt-BR" smtClean="0"/>
-              <a:t>29/01/2024</a:t>
+              <a:t>05/02/2024</a:t>
             </a:fld>
             <a:endParaRPr lang="pt-BR"/>
           </a:p>
@@ -2258,7 +2258,7 @@
           <a:p>
             <a:fld id="{52231B9D-E9F6-4612-9B82-E89961B389AC}" type="datetimeFigureOut">
               <a:rPr lang="pt-BR" smtClean="0"/>
-              <a:t>29/01/2024</a:t>
+              <a:t>05/02/2024</a:t>
             </a:fld>
             <a:endParaRPr lang="pt-BR"/>
           </a:p>
@@ -2535,7 +2535,7 @@
           <a:p>
             <a:fld id="{52231B9D-E9F6-4612-9B82-E89961B389AC}" type="datetimeFigureOut">
               <a:rPr lang="pt-BR" smtClean="0"/>
-              <a:t>29/01/2024</a:t>
+              <a:t>05/02/2024</a:t>
             </a:fld>
             <a:endParaRPr lang="pt-BR"/>
           </a:p>
@@ -2788,7 +2788,7 @@
           <a:p>
             <a:fld id="{52231B9D-E9F6-4612-9B82-E89961B389AC}" type="datetimeFigureOut">
               <a:rPr lang="pt-BR" smtClean="0"/>
-              <a:t>29/01/2024</a:t>
+              <a:t>05/02/2024</a:t>
             </a:fld>
             <a:endParaRPr lang="pt-BR"/>
           </a:p>
@@ -3001,7 +3001,7 @@
           <a:p>
             <a:fld id="{52231B9D-E9F6-4612-9B82-E89961B389AC}" type="datetimeFigureOut">
               <a:rPr lang="pt-BR" smtClean="0"/>
-              <a:t>29/01/2024</a:t>
+              <a:t>05/02/2024</a:t>
             </a:fld>
             <a:endParaRPr lang="pt-BR"/>
           </a:p>
@@ -3665,7 +3665,7 @@
                   </a:schemeClr>
                 </a:solidFill>
               </a:rPr>
-              <a:t>04</a:t>
+              <a:t>11</a:t>
             </a:r>
             <a:r>
               <a:rPr lang="pt-BR" sz="1600" dirty="0" smtClean="0">

</xml_diff>

<commit_message>
valor de folha para todas as verbas, estas agora iguais às do parâmetro
</commit_message>
<xml_diff>
--- a/tempimento.pptx
+++ b/tempimento.pptx
@@ -197,7 +197,7 @@
           <a:p>
             <a:fld id="{A584E3A2-E8EA-4705-A613-CFE9F6F5D3B4}" type="datetimeFigureOut">
               <a:rPr lang="pt-BR" smtClean="0"/>
-              <a:t>05/02/2024</a:t>
+              <a:t>21/02/2024</a:t>
             </a:fld>
             <a:endParaRPr lang="pt-BR"/>
           </a:p>
@@ -680,7 +680,7 @@
           <a:p>
             <a:fld id="{52231B9D-E9F6-4612-9B82-E89961B389AC}" type="datetimeFigureOut">
               <a:rPr lang="pt-BR" smtClean="0"/>
-              <a:t>05/02/2024</a:t>
+              <a:t>21/02/2024</a:t>
             </a:fld>
             <a:endParaRPr lang="pt-BR"/>
           </a:p>
@@ -850,7 +850,7 @@
           <a:p>
             <a:fld id="{52231B9D-E9F6-4612-9B82-E89961B389AC}" type="datetimeFigureOut">
               <a:rPr lang="pt-BR" smtClean="0"/>
-              <a:t>05/02/2024</a:t>
+              <a:t>21/02/2024</a:t>
             </a:fld>
             <a:endParaRPr lang="pt-BR"/>
           </a:p>
@@ -1030,7 +1030,7 @@
           <a:p>
             <a:fld id="{52231B9D-E9F6-4612-9B82-E89961B389AC}" type="datetimeFigureOut">
               <a:rPr lang="pt-BR" smtClean="0"/>
-              <a:t>05/02/2024</a:t>
+              <a:t>21/02/2024</a:t>
             </a:fld>
             <a:endParaRPr lang="pt-BR"/>
           </a:p>
@@ -1200,7 +1200,7 @@
           <a:p>
             <a:fld id="{52231B9D-E9F6-4612-9B82-E89961B389AC}" type="datetimeFigureOut">
               <a:rPr lang="pt-BR" smtClean="0"/>
-              <a:t>05/02/2024</a:t>
+              <a:t>21/02/2024</a:t>
             </a:fld>
             <a:endParaRPr lang="pt-BR"/>
           </a:p>
@@ -1446,7 +1446,7 @@
           <a:p>
             <a:fld id="{52231B9D-E9F6-4612-9B82-E89961B389AC}" type="datetimeFigureOut">
               <a:rPr lang="pt-BR" smtClean="0"/>
-              <a:t>05/02/2024</a:t>
+              <a:t>21/02/2024</a:t>
             </a:fld>
             <a:endParaRPr lang="pt-BR"/>
           </a:p>
@@ -1678,7 +1678,7 @@
           <a:p>
             <a:fld id="{52231B9D-E9F6-4612-9B82-E89961B389AC}" type="datetimeFigureOut">
               <a:rPr lang="pt-BR" smtClean="0"/>
-              <a:t>05/02/2024</a:t>
+              <a:t>21/02/2024</a:t>
             </a:fld>
             <a:endParaRPr lang="pt-BR"/>
           </a:p>
@@ -2045,7 +2045,7 @@
           <a:p>
             <a:fld id="{52231B9D-E9F6-4612-9B82-E89961B389AC}" type="datetimeFigureOut">
               <a:rPr lang="pt-BR" smtClean="0"/>
-              <a:t>05/02/2024</a:t>
+              <a:t>21/02/2024</a:t>
             </a:fld>
             <a:endParaRPr lang="pt-BR"/>
           </a:p>
@@ -2163,7 +2163,7 @@
           <a:p>
             <a:fld id="{52231B9D-E9F6-4612-9B82-E89961B389AC}" type="datetimeFigureOut">
               <a:rPr lang="pt-BR" smtClean="0"/>
-              <a:t>05/02/2024</a:t>
+              <a:t>21/02/2024</a:t>
             </a:fld>
             <a:endParaRPr lang="pt-BR"/>
           </a:p>
@@ -2258,7 +2258,7 @@
           <a:p>
             <a:fld id="{52231B9D-E9F6-4612-9B82-E89961B389AC}" type="datetimeFigureOut">
               <a:rPr lang="pt-BR" smtClean="0"/>
-              <a:t>05/02/2024</a:t>
+              <a:t>21/02/2024</a:t>
             </a:fld>
             <a:endParaRPr lang="pt-BR"/>
           </a:p>
@@ -2535,7 +2535,7 @@
           <a:p>
             <a:fld id="{52231B9D-E9F6-4612-9B82-E89961B389AC}" type="datetimeFigureOut">
               <a:rPr lang="pt-BR" smtClean="0"/>
-              <a:t>05/02/2024</a:t>
+              <a:t>21/02/2024</a:t>
             </a:fld>
             <a:endParaRPr lang="pt-BR"/>
           </a:p>
@@ -2788,7 +2788,7 @@
           <a:p>
             <a:fld id="{52231B9D-E9F6-4612-9B82-E89961B389AC}" type="datetimeFigureOut">
               <a:rPr lang="pt-BR" smtClean="0"/>
-              <a:t>05/02/2024</a:t>
+              <a:t>21/02/2024</a:t>
             </a:fld>
             <a:endParaRPr lang="pt-BR"/>
           </a:p>
@@ -3001,7 +3001,7 @@
           <a:p>
             <a:fld id="{52231B9D-E9F6-4612-9B82-E89961B389AC}" type="datetimeFigureOut">
               <a:rPr lang="pt-BR" smtClean="0"/>
-              <a:t>05/02/2024</a:t>
+              <a:t>21/02/2024</a:t>
             </a:fld>
             <a:endParaRPr lang="pt-BR"/>
           </a:p>
@@ -3665,17 +3665,7 @@
                   </a:schemeClr>
                 </a:solidFill>
               </a:rPr>
-              <a:t>11</a:t>
-            </a:r>
-            <a:r>
-              <a:rPr lang="pt-BR" sz="1600" dirty="0" smtClean="0">
-                <a:solidFill>
-                  <a:schemeClr val="bg2">
-                    <a:lumMod val="90000"/>
-                  </a:schemeClr>
-                </a:solidFill>
-              </a:rPr>
-              <a:t>/02/2024</a:t>
+              <a:t>03/03/2024</a:t>
             </a:r>
             <a:endParaRPr lang="pt-BR" sz="1600" dirty="0">
               <a:solidFill>

</xml_diff>

<commit_message>
add valor e dias aprov, tratamento solicitante
</commit_message>
<xml_diff>
--- a/tempimento.pptx
+++ b/tempimento.pptx
@@ -197,7 +197,7 @@
           <a:p>
             <a:fld id="{A584E3A2-E8EA-4705-A613-CFE9F6F5D3B4}" type="datetimeFigureOut">
               <a:rPr lang="pt-BR" smtClean="0"/>
-              <a:t>21/02/2024</a:t>
+              <a:t>13/03/2024</a:t>
             </a:fld>
             <a:endParaRPr lang="pt-BR"/>
           </a:p>
@@ -680,7 +680,7 @@
           <a:p>
             <a:fld id="{52231B9D-E9F6-4612-9B82-E89961B389AC}" type="datetimeFigureOut">
               <a:rPr lang="pt-BR" smtClean="0"/>
-              <a:t>21/02/2024</a:t>
+              <a:t>13/03/2024</a:t>
             </a:fld>
             <a:endParaRPr lang="pt-BR"/>
           </a:p>
@@ -850,7 +850,7 @@
           <a:p>
             <a:fld id="{52231B9D-E9F6-4612-9B82-E89961B389AC}" type="datetimeFigureOut">
               <a:rPr lang="pt-BR" smtClean="0"/>
-              <a:t>21/02/2024</a:t>
+              <a:t>13/03/2024</a:t>
             </a:fld>
             <a:endParaRPr lang="pt-BR"/>
           </a:p>
@@ -1030,7 +1030,7 @@
           <a:p>
             <a:fld id="{52231B9D-E9F6-4612-9B82-E89961B389AC}" type="datetimeFigureOut">
               <a:rPr lang="pt-BR" smtClean="0"/>
-              <a:t>21/02/2024</a:t>
+              <a:t>13/03/2024</a:t>
             </a:fld>
             <a:endParaRPr lang="pt-BR"/>
           </a:p>
@@ -1200,7 +1200,7 @@
           <a:p>
             <a:fld id="{52231B9D-E9F6-4612-9B82-E89961B389AC}" type="datetimeFigureOut">
               <a:rPr lang="pt-BR" smtClean="0"/>
-              <a:t>21/02/2024</a:t>
+              <a:t>13/03/2024</a:t>
             </a:fld>
             <a:endParaRPr lang="pt-BR"/>
           </a:p>
@@ -1446,7 +1446,7 @@
           <a:p>
             <a:fld id="{52231B9D-E9F6-4612-9B82-E89961B389AC}" type="datetimeFigureOut">
               <a:rPr lang="pt-BR" smtClean="0"/>
-              <a:t>21/02/2024</a:t>
+              <a:t>13/03/2024</a:t>
             </a:fld>
             <a:endParaRPr lang="pt-BR"/>
           </a:p>
@@ -1678,7 +1678,7 @@
           <a:p>
             <a:fld id="{52231B9D-E9F6-4612-9B82-E89961B389AC}" type="datetimeFigureOut">
               <a:rPr lang="pt-BR" smtClean="0"/>
-              <a:t>21/02/2024</a:t>
+              <a:t>13/03/2024</a:t>
             </a:fld>
             <a:endParaRPr lang="pt-BR"/>
           </a:p>
@@ -2045,7 +2045,7 @@
           <a:p>
             <a:fld id="{52231B9D-E9F6-4612-9B82-E89961B389AC}" type="datetimeFigureOut">
               <a:rPr lang="pt-BR" smtClean="0"/>
-              <a:t>21/02/2024</a:t>
+              <a:t>13/03/2024</a:t>
             </a:fld>
             <a:endParaRPr lang="pt-BR"/>
           </a:p>
@@ -2163,7 +2163,7 @@
           <a:p>
             <a:fld id="{52231B9D-E9F6-4612-9B82-E89961B389AC}" type="datetimeFigureOut">
               <a:rPr lang="pt-BR" smtClean="0"/>
-              <a:t>21/02/2024</a:t>
+              <a:t>13/03/2024</a:t>
             </a:fld>
             <a:endParaRPr lang="pt-BR"/>
           </a:p>
@@ -2258,7 +2258,7 @@
           <a:p>
             <a:fld id="{52231B9D-E9F6-4612-9B82-E89961B389AC}" type="datetimeFigureOut">
               <a:rPr lang="pt-BR" smtClean="0"/>
-              <a:t>21/02/2024</a:t>
+              <a:t>13/03/2024</a:t>
             </a:fld>
             <a:endParaRPr lang="pt-BR"/>
           </a:p>
@@ -2535,7 +2535,7 @@
           <a:p>
             <a:fld id="{52231B9D-E9F6-4612-9B82-E89961B389AC}" type="datetimeFigureOut">
               <a:rPr lang="pt-BR" smtClean="0"/>
-              <a:t>21/02/2024</a:t>
+              <a:t>13/03/2024</a:t>
             </a:fld>
             <a:endParaRPr lang="pt-BR"/>
           </a:p>
@@ -2788,7 +2788,7 @@
           <a:p>
             <a:fld id="{52231B9D-E9F6-4612-9B82-E89961B389AC}" type="datetimeFigureOut">
               <a:rPr lang="pt-BR" smtClean="0"/>
-              <a:t>21/02/2024</a:t>
+              <a:t>13/03/2024</a:t>
             </a:fld>
             <a:endParaRPr lang="pt-BR"/>
           </a:p>
@@ -3001,7 +3001,7 @@
           <a:p>
             <a:fld id="{52231B9D-E9F6-4612-9B82-E89961B389AC}" type="datetimeFigureOut">
               <a:rPr lang="pt-BR" smtClean="0"/>
-              <a:t>21/02/2024</a:t>
+              <a:t>13/03/2024</a:t>
             </a:fld>
             <a:endParaRPr lang="pt-BR"/>
           </a:p>
@@ -3665,7 +3665,17 @@
                   </a:schemeClr>
                 </a:solidFill>
               </a:rPr>
-              <a:t>03/03/2024</a:t>
+              <a:t>10</a:t>
+            </a:r>
+            <a:r>
+              <a:rPr lang="pt-BR" sz="1600" dirty="0" smtClean="0">
+                <a:solidFill>
+                  <a:schemeClr val="bg2">
+                    <a:lumMod val="90000"/>
+                  </a:schemeClr>
+                </a:solidFill>
+              </a:rPr>
+              <a:t>/03/2024</a:t>
             </a:r>
             <a:endParaRPr lang="pt-BR" sz="1600" dirty="0">
               <a:solidFill>

</xml_diff>

<commit_message>
add valor total do item, pela qtd recursos das horas apontadas
</commit_message>
<xml_diff>
--- a/tempimento.pptx
+++ b/tempimento.pptx
@@ -197,7 +197,7 @@
           <a:p>
             <a:fld id="{A584E3A2-E8EA-4705-A613-CFE9F6F5D3B4}" type="datetimeFigureOut">
               <a:rPr lang="pt-BR" smtClean="0"/>
-              <a:t>13/03/2024</a:t>
+              <a:t>18/03/2024</a:t>
             </a:fld>
             <a:endParaRPr lang="pt-BR"/>
           </a:p>
@@ -680,7 +680,7 @@
           <a:p>
             <a:fld id="{52231B9D-E9F6-4612-9B82-E89961B389AC}" type="datetimeFigureOut">
               <a:rPr lang="pt-BR" smtClean="0"/>
-              <a:t>13/03/2024</a:t>
+              <a:t>18/03/2024</a:t>
             </a:fld>
             <a:endParaRPr lang="pt-BR"/>
           </a:p>
@@ -850,7 +850,7 @@
           <a:p>
             <a:fld id="{52231B9D-E9F6-4612-9B82-E89961B389AC}" type="datetimeFigureOut">
               <a:rPr lang="pt-BR" smtClean="0"/>
-              <a:t>13/03/2024</a:t>
+              <a:t>18/03/2024</a:t>
             </a:fld>
             <a:endParaRPr lang="pt-BR"/>
           </a:p>
@@ -1030,7 +1030,7 @@
           <a:p>
             <a:fld id="{52231B9D-E9F6-4612-9B82-E89961B389AC}" type="datetimeFigureOut">
               <a:rPr lang="pt-BR" smtClean="0"/>
-              <a:t>13/03/2024</a:t>
+              <a:t>18/03/2024</a:t>
             </a:fld>
             <a:endParaRPr lang="pt-BR"/>
           </a:p>
@@ -1200,7 +1200,7 @@
           <a:p>
             <a:fld id="{52231B9D-E9F6-4612-9B82-E89961B389AC}" type="datetimeFigureOut">
               <a:rPr lang="pt-BR" smtClean="0"/>
-              <a:t>13/03/2024</a:t>
+              <a:t>18/03/2024</a:t>
             </a:fld>
             <a:endParaRPr lang="pt-BR"/>
           </a:p>
@@ -1446,7 +1446,7 @@
           <a:p>
             <a:fld id="{52231B9D-E9F6-4612-9B82-E89961B389AC}" type="datetimeFigureOut">
               <a:rPr lang="pt-BR" smtClean="0"/>
-              <a:t>13/03/2024</a:t>
+              <a:t>18/03/2024</a:t>
             </a:fld>
             <a:endParaRPr lang="pt-BR"/>
           </a:p>
@@ -1678,7 +1678,7 @@
           <a:p>
             <a:fld id="{52231B9D-E9F6-4612-9B82-E89961B389AC}" type="datetimeFigureOut">
               <a:rPr lang="pt-BR" smtClean="0"/>
-              <a:t>13/03/2024</a:t>
+              <a:t>18/03/2024</a:t>
             </a:fld>
             <a:endParaRPr lang="pt-BR"/>
           </a:p>
@@ -2045,7 +2045,7 @@
           <a:p>
             <a:fld id="{52231B9D-E9F6-4612-9B82-E89961B389AC}" type="datetimeFigureOut">
               <a:rPr lang="pt-BR" smtClean="0"/>
-              <a:t>13/03/2024</a:t>
+              <a:t>18/03/2024</a:t>
             </a:fld>
             <a:endParaRPr lang="pt-BR"/>
           </a:p>
@@ -2163,7 +2163,7 @@
           <a:p>
             <a:fld id="{52231B9D-E9F6-4612-9B82-E89961B389AC}" type="datetimeFigureOut">
               <a:rPr lang="pt-BR" smtClean="0"/>
-              <a:t>13/03/2024</a:t>
+              <a:t>18/03/2024</a:t>
             </a:fld>
             <a:endParaRPr lang="pt-BR"/>
           </a:p>
@@ -2258,7 +2258,7 @@
           <a:p>
             <a:fld id="{52231B9D-E9F6-4612-9B82-E89961B389AC}" type="datetimeFigureOut">
               <a:rPr lang="pt-BR" smtClean="0"/>
-              <a:t>13/03/2024</a:t>
+              <a:t>18/03/2024</a:t>
             </a:fld>
             <a:endParaRPr lang="pt-BR"/>
           </a:p>
@@ -2535,7 +2535,7 @@
           <a:p>
             <a:fld id="{52231B9D-E9F6-4612-9B82-E89961B389AC}" type="datetimeFigureOut">
               <a:rPr lang="pt-BR" smtClean="0"/>
-              <a:t>13/03/2024</a:t>
+              <a:t>18/03/2024</a:t>
             </a:fld>
             <a:endParaRPr lang="pt-BR"/>
           </a:p>
@@ -2788,7 +2788,7 @@
           <a:p>
             <a:fld id="{52231B9D-E9F6-4612-9B82-E89961B389AC}" type="datetimeFigureOut">
               <a:rPr lang="pt-BR" smtClean="0"/>
-              <a:t>13/03/2024</a:t>
+              <a:t>18/03/2024</a:t>
             </a:fld>
             <a:endParaRPr lang="pt-BR"/>
           </a:p>
@@ -3001,7 +3001,7 @@
           <a:p>
             <a:fld id="{52231B9D-E9F6-4612-9B82-E89961B389AC}" type="datetimeFigureOut">
               <a:rPr lang="pt-BR" smtClean="0"/>
-              <a:t>13/03/2024</a:t>
+              <a:t>18/03/2024</a:t>
             </a:fld>
             <a:endParaRPr lang="pt-BR"/>
           </a:p>
@@ -3665,17 +3665,7 @@
                   </a:schemeClr>
                 </a:solidFill>
               </a:rPr>
-              <a:t>10</a:t>
-            </a:r>
-            <a:r>
-              <a:rPr lang="pt-BR" sz="1600" dirty="0" smtClean="0">
-                <a:solidFill>
-                  <a:schemeClr val="bg2">
-                    <a:lumMod val="90000"/>
-                  </a:schemeClr>
-                </a:solidFill>
-              </a:rPr>
-              <a:t>/03/2024</a:t>
+              <a:t>17/03/2024</a:t>
             </a:r>
             <a:endParaRPr lang="pt-BR" sz="1600" dirty="0">
               <a:solidFill>

</xml_diff>

<commit_message>
add UF do fornecedor e qtd pedidos de compra
</commit_message>
<xml_diff>
--- a/tempimento.pptx
+++ b/tempimento.pptx
@@ -197,7 +197,7 @@
           <a:p>
             <a:fld id="{A584E3A2-E8EA-4705-A613-CFE9F6F5D3B4}" type="datetimeFigureOut">
               <a:rPr lang="pt-BR" smtClean="0"/>
-              <a:t>18/03/2024</a:t>
+              <a:t>26/03/2024</a:t>
             </a:fld>
             <a:endParaRPr lang="pt-BR"/>
           </a:p>
@@ -680,7 +680,7 @@
           <a:p>
             <a:fld id="{52231B9D-E9F6-4612-9B82-E89961B389AC}" type="datetimeFigureOut">
               <a:rPr lang="pt-BR" smtClean="0"/>
-              <a:t>18/03/2024</a:t>
+              <a:t>26/03/2024</a:t>
             </a:fld>
             <a:endParaRPr lang="pt-BR"/>
           </a:p>
@@ -850,7 +850,7 @@
           <a:p>
             <a:fld id="{52231B9D-E9F6-4612-9B82-E89961B389AC}" type="datetimeFigureOut">
               <a:rPr lang="pt-BR" smtClean="0"/>
-              <a:t>18/03/2024</a:t>
+              <a:t>26/03/2024</a:t>
             </a:fld>
             <a:endParaRPr lang="pt-BR"/>
           </a:p>
@@ -1030,7 +1030,7 @@
           <a:p>
             <a:fld id="{52231B9D-E9F6-4612-9B82-E89961B389AC}" type="datetimeFigureOut">
               <a:rPr lang="pt-BR" smtClean="0"/>
-              <a:t>18/03/2024</a:t>
+              <a:t>26/03/2024</a:t>
             </a:fld>
             <a:endParaRPr lang="pt-BR"/>
           </a:p>
@@ -1200,7 +1200,7 @@
           <a:p>
             <a:fld id="{52231B9D-E9F6-4612-9B82-E89961B389AC}" type="datetimeFigureOut">
               <a:rPr lang="pt-BR" smtClean="0"/>
-              <a:t>18/03/2024</a:t>
+              <a:t>26/03/2024</a:t>
             </a:fld>
             <a:endParaRPr lang="pt-BR"/>
           </a:p>
@@ -1446,7 +1446,7 @@
           <a:p>
             <a:fld id="{52231B9D-E9F6-4612-9B82-E89961B389AC}" type="datetimeFigureOut">
               <a:rPr lang="pt-BR" smtClean="0"/>
-              <a:t>18/03/2024</a:t>
+              <a:t>26/03/2024</a:t>
             </a:fld>
             <a:endParaRPr lang="pt-BR"/>
           </a:p>
@@ -1678,7 +1678,7 @@
           <a:p>
             <a:fld id="{52231B9D-E9F6-4612-9B82-E89961B389AC}" type="datetimeFigureOut">
               <a:rPr lang="pt-BR" smtClean="0"/>
-              <a:t>18/03/2024</a:t>
+              <a:t>26/03/2024</a:t>
             </a:fld>
             <a:endParaRPr lang="pt-BR"/>
           </a:p>
@@ -2045,7 +2045,7 @@
           <a:p>
             <a:fld id="{52231B9D-E9F6-4612-9B82-E89961B389AC}" type="datetimeFigureOut">
               <a:rPr lang="pt-BR" smtClean="0"/>
-              <a:t>18/03/2024</a:t>
+              <a:t>26/03/2024</a:t>
             </a:fld>
             <a:endParaRPr lang="pt-BR"/>
           </a:p>
@@ -2163,7 +2163,7 @@
           <a:p>
             <a:fld id="{52231B9D-E9F6-4612-9B82-E89961B389AC}" type="datetimeFigureOut">
               <a:rPr lang="pt-BR" smtClean="0"/>
-              <a:t>18/03/2024</a:t>
+              <a:t>26/03/2024</a:t>
             </a:fld>
             <a:endParaRPr lang="pt-BR"/>
           </a:p>
@@ -2258,7 +2258,7 @@
           <a:p>
             <a:fld id="{52231B9D-E9F6-4612-9B82-E89961B389AC}" type="datetimeFigureOut">
               <a:rPr lang="pt-BR" smtClean="0"/>
-              <a:t>18/03/2024</a:t>
+              <a:t>26/03/2024</a:t>
             </a:fld>
             <a:endParaRPr lang="pt-BR"/>
           </a:p>
@@ -2535,7 +2535,7 @@
           <a:p>
             <a:fld id="{52231B9D-E9F6-4612-9B82-E89961B389AC}" type="datetimeFigureOut">
               <a:rPr lang="pt-BR" smtClean="0"/>
-              <a:t>18/03/2024</a:t>
+              <a:t>26/03/2024</a:t>
             </a:fld>
             <a:endParaRPr lang="pt-BR"/>
           </a:p>
@@ -2788,7 +2788,7 @@
           <a:p>
             <a:fld id="{52231B9D-E9F6-4612-9B82-E89961B389AC}" type="datetimeFigureOut">
               <a:rPr lang="pt-BR" smtClean="0"/>
-              <a:t>18/03/2024</a:t>
+              <a:t>26/03/2024</a:t>
             </a:fld>
             <a:endParaRPr lang="pt-BR"/>
           </a:p>
@@ -3001,7 +3001,7 @@
           <a:p>
             <a:fld id="{52231B9D-E9F6-4612-9B82-E89961B389AC}" type="datetimeFigureOut">
               <a:rPr lang="pt-BR" smtClean="0"/>
-              <a:t>18/03/2024</a:t>
+              <a:t>26/03/2024</a:t>
             </a:fld>
             <a:endParaRPr lang="pt-BR"/>
           </a:p>
@@ -3665,7 +3665,7 @@
                   </a:schemeClr>
                 </a:solidFill>
               </a:rPr>
-              <a:t>17/03/2024</a:t>
+              <a:t>31/03/2024</a:t>
             </a:r>
             <a:endParaRPr lang="pt-BR" sz="1600" dirty="0">
               <a:solidFill>

</xml_diff>

<commit_message>
consultas dimensão para itens das OS portuárias
</commit_message>
<xml_diff>
--- a/tempimento.pptx
+++ b/tempimento.pptx
@@ -197,7 +197,7 @@
           <a:p>
             <a:fld id="{A584E3A2-E8EA-4705-A613-CFE9F6F5D3B4}" type="datetimeFigureOut">
               <a:rPr lang="pt-BR" smtClean="0"/>
-              <a:t>26/03/2024</a:t>
+              <a:t>11/04/2024</a:t>
             </a:fld>
             <a:endParaRPr lang="pt-BR"/>
           </a:p>
@@ -680,7 +680,7 @@
           <a:p>
             <a:fld id="{52231B9D-E9F6-4612-9B82-E89961B389AC}" type="datetimeFigureOut">
               <a:rPr lang="pt-BR" smtClean="0"/>
-              <a:t>26/03/2024</a:t>
+              <a:t>11/04/2024</a:t>
             </a:fld>
             <a:endParaRPr lang="pt-BR"/>
           </a:p>
@@ -850,7 +850,7 @@
           <a:p>
             <a:fld id="{52231B9D-E9F6-4612-9B82-E89961B389AC}" type="datetimeFigureOut">
               <a:rPr lang="pt-BR" smtClean="0"/>
-              <a:t>26/03/2024</a:t>
+              <a:t>11/04/2024</a:t>
             </a:fld>
             <a:endParaRPr lang="pt-BR"/>
           </a:p>
@@ -1030,7 +1030,7 @@
           <a:p>
             <a:fld id="{52231B9D-E9F6-4612-9B82-E89961B389AC}" type="datetimeFigureOut">
               <a:rPr lang="pt-BR" smtClean="0"/>
-              <a:t>26/03/2024</a:t>
+              <a:t>11/04/2024</a:t>
             </a:fld>
             <a:endParaRPr lang="pt-BR"/>
           </a:p>
@@ -1200,7 +1200,7 @@
           <a:p>
             <a:fld id="{52231B9D-E9F6-4612-9B82-E89961B389AC}" type="datetimeFigureOut">
               <a:rPr lang="pt-BR" smtClean="0"/>
-              <a:t>26/03/2024</a:t>
+              <a:t>11/04/2024</a:t>
             </a:fld>
             <a:endParaRPr lang="pt-BR"/>
           </a:p>
@@ -1446,7 +1446,7 @@
           <a:p>
             <a:fld id="{52231B9D-E9F6-4612-9B82-E89961B389AC}" type="datetimeFigureOut">
               <a:rPr lang="pt-BR" smtClean="0"/>
-              <a:t>26/03/2024</a:t>
+              <a:t>11/04/2024</a:t>
             </a:fld>
             <a:endParaRPr lang="pt-BR"/>
           </a:p>
@@ -1678,7 +1678,7 @@
           <a:p>
             <a:fld id="{52231B9D-E9F6-4612-9B82-E89961B389AC}" type="datetimeFigureOut">
               <a:rPr lang="pt-BR" smtClean="0"/>
-              <a:t>26/03/2024</a:t>
+              <a:t>11/04/2024</a:t>
             </a:fld>
             <a:endParaRPr lang="pt-BR"/>
           </a:p>
@@ -2045,7 +2045,7 @@
           <a:p>
             <a:fld id="{52231B9D-E9F6-4612-9B82-E89961B389AC}" type="datetimeFigureOut">
               <a:rPr lang="pt-BR" smtClean="0"/>
-              <a:t>26/03/2024</a:t>
+              <a:t>11/04/2024</a:t>
             </a:fld>
             <a:endParaRPr lang="pt-BR"/>
           </a:p>
@@ -2163,7 +2163,7 @@
           <a:p>
             <a:fld id="{52231B9D-E9F6-4612-9B82-E89961B389AC}" type="datetimeFigureOut">
               <a:rPr lang="pt-BR" smtClean="0"/>
-              <a:t>26/03/2024</a:t>
+              <a:t>11/04/2024</a:t>
             </a:fld>
             <a:endParaRPr lang="pt-BR"/>
           </a:p>
@@ -2258,7 +2258,7 @@
           <a:p>
             <a:fld id="{52231B9D-E9F6-4612-9B82-E89961B389AC}" type="datetimeFigureOut">
               <a:rPr lang="pt-BR" smtClean="0"/>
-              <a:t>26/03/2024</a:t>
+              <a:t>11/04/2024</a:t>
             </a:fld>
             <a:endParaRPr lang="pt-BR"/>
           </a:p>
@@ -2535,7 +2535,7 @@
           <a:p>
             <a:fld id="{52231B9D-E9F6-4612-9B82-E89961B389AC}" type="datetimeFigureOut">
               <a:rPr lang="pt-BR" smtClean="0"/>
-              <a:t>26/03/2024</a:t>
+              <a:t>11/04/2024</a:t>
             </a:fld>
             <a:endParaRPr lang="pt-BR"/>
           </a:p>
@@ -2788,7 +2788,7 @@
           <a:p>
             <a:fld id="{52231B9D-E9F6-4612-9B82-E89961B389AC}" type="datetimeFigureOut">
               <a:rPr lang="pt-BR" smtClean="0"/>
-              <a:t>26/03/2024</a:t>
+              <a:t>11/04/2024</a:t>
             </a:fld>
             <a:endParaRPr lang="pt-BR"/>
           </a:p>
@@ -3001,7 +3001,7 @@
           <a:p>
             <a:fld id="{52231B9D-E9F6-4612-9B82-E89961B389AC}" type="datetimeFigureOut">
               <a:rPr lang="pt-BR" smtClean="0"/>
-              <a:t>26/03/2024</a:t>
+              <a:t>11/04/2024</a:t>
             </a:fld>
             <a:endParaRPr lang="pt-BR"/>
           </a:p>
@@ -3665,7 +3665,7 @@
                   </a:schemeClr>
                 </a:solidFill>
               </a:rPr>
-              <a:t>31/03/2024</a:t>
+              <a:t>21/04/2024</a:t>
             </a:r>
             <a:endParaRPr lang="pt-BR" sz="1600" dirty="0">
               <a:solidFill>

</xml_diff>

<commit_message>
adição de datas de aprovação na fato de pedido de compra
</commit_message>
<xml_diff>
--- a/tempimento.pptx
+++ b/tempimento.pptx
@@ -197,7 +197,7 @@
           <a:p>
             <a:fld id="{A584E3A2-E8EA-4705-A613-CFE9F6F5D3B4}" type="datetimeFigureOut">
               <a:rPr lang="pt-BR" smtClean="0"/>
-              <a:t>11/04/2024</a:t>
+              <a:t>29/04/2024</a:t>
             </a:fld>
             <a:endParaRPr lang="pt-BR"/>
           </a:p>
@@ -680,7 +680,7 @@
           <a:p>
             <a:fld id="{52231B9D-E9F6-4612-9B82-E89961B389AC}" type="datetimeFigureOut">
               <a:rPr lang="pt-BR" smtClean="0"/>
-              <a:t>11/04/2024</a:t>
+              <a:t>29/04/2024</a:t>
             </a:fld>
             <a:endParaRPr lang="pt-BR"/>
           </a:p>
@@ -850,7 +850,7 @@
           <a:p>
             <a:fld id="{52231B9D-E9F6-4612-9B82-E89961B389AC}" type="datetimeFigureOut">
               <a:rPr lang="pt-BR" smtClean="0"/>
-              <a:t>11/04/2024</a:t>
+              <a:t>29/04/2024</a:t>
             </a:fld>
             <a:endParaRPr lang="pt-BR"/>
           </a:p>
@@ -1030,7 +1030,7 @@
           <a:p>
             <a:fld id="{52231B9D-E9F6-4612-9B82-E89961B389AC}" type="datetimeFigureOut">
               <a:rPr lang="pt-BR" smtClean="0"/>
-              <a:t>11/04/2024</a:t>
+              <a:t>29/04/2024</a:t>
             </a:fld>
             <a:endParaRPr lang="pt-BR"/>
           </a:p>
@@ -1200,7 +1200,7 @@
           <a:p>
             <a:fld id="{52231B9D-E9F6-4612-9B82-E89961B389AC}" type="datetimeFigureOut">
               <a:rPr lang="pt-BR" smtClean="0"/>
-              <a:t>11/04/2024</a:t>
+              <a:t>29/04/2024</a:t>
             </a:fld>
             <a:endParaRPr lang="pt-BR"/>
           </a:p>
@@ -1446,7 +1446,7 @@
           <a:p>
             <a:fld id="{52231B9D-E9F6-4612-9B82-E89961B389AC}" type="datetimeFigureOut">
               <a:rPr lang="pt-BR" smtClean="0"/>
-              <a:t>11/04/2024</a:t>
+              <a:t>29/04/2024</a:t>
             </a:fld>
             <a:endParaRPr lang="pt-BR"/>
           </a:p>
@@ -1678,7 +1678,7 @@
           <a:p>
             <a:fld id="{52231B9D-E9F6-4612-9B82-E89961B389AC}" type="datetimeFigureOut">
               <a:rPr lang="pt-BR" smtClean="0"/>
-              <a:t>11/04/2024</a:t>
+              <a:t>29/04/2024</a:t>
             </a:fld>
             <a:endParaRPr lang="pt-BR"/>
           </a:p>
@@ -2045,7 +2045,7 @@
           <a:p>
             <a:fld id="{52231B9D-E9F6-4612-9B82-E89961B389AC}" type="datetimeFigureOut">
               <a:rPr lang="pt-BR" smtClean="0"/>
-              <a:t>11/04/2024</a:t>
+              <a:t>29/04/2024</a:t>
             </a:fld>
             <a:endParaRPr lang="pt-BR"/>
           </a:p>
@@ -2163,7 +2163,7 @@
           <a:p>
             <a:fld id="{52231B9D-E9F6-4612-9B82-E89961B389AC}" type="datetimeFigureOut">
               <a:rPr lang="pt-BR" smtClean="0"/>
-              <a:t>11/04/2024</a:t>
+              <a:t>29/04/2024</a:t>
             </a:fld>
             <a:endParaRPr lang="pt-BR"/>
           </a:p>
@@ -2258,7 +2258,7 @@
           <a:p>
             <a:fld id="{52231B9D-E9F6-4612-9B82-E89961B389AC}" type="datetimeFigureOut">
               <a:rPr lang="pt-BR" smtClean="0"/>
-              <a:t>11/04/2024</a:t>
+              <a:t>29/04/2024</a:t>
             </a:fld>
             <a:endParaRPr lang="pt-BR"/>
           </a:p>
@@ -2535,7 +2535,7 @@
           <a:p>
             <a:fld id="{52231B9D-E9F6-4612-9B82-E89961B389AC}" type="datetimeFigureOut">
               <a:rPr lang="pt-BR" smtClean="0"/>
-              <a:t>11/04/2024</a:t>
+              <a:t>29/04/2024</a:t>
             </a:fld>
             <a:endParaRPr lang="pt-BR"/>
           </a:p>
@@ -2788,7 +2788,7 @@
           <a:p>
             <a:fld id="{52231B9D-E9F6-4612-9B82-E89961B389AC}" type="datetimeFigureOut">
               <a:rPr lang="pt-BR" smtClean="0"/>
-              <a:t>11/04/2024</a:t>
+              <a:t>29/04/2024</a:t>
             </a:fld>
             <a:endParaRPr lang="pt-BR"/>
           </a:p>
@@ -3001,7 +3001,7 @@
           <a:p>
             <a:fld id="{52231B9D-E9F6-4612-9B82-E89961B389AC}" type="datetimeFigureOut">
               <a:rPr lang="pt-BR" smtClean="0"/>
-              <a:t>11/04/2024</a:t>
+              <a:t>29/04/2024</a:t>
             </a:fld>
             <a:endParaRPr lang="pt-BR"/>
           </a:p>
@@ -3665,7 +3665,7 @@
                   </a:schemeClr>
                 </a:solidFill>
               </a:rPr>
-              <a:t>21/04/2024</a:t>
+              <a:t>28/04/2024</a:t>
             </a:r>
             <a:endParaRPr lang="pt-BR" sz="1600" dirty="0">
               <a:solidFill>

</xml_diff>

<commit_message>
consulta para análise da correção dos apontamentos de janeiro
</commit_message>
<xml_diff>
--- a/tempimento.pptx
+++ b/tempimento.pptx
@@ -197,7 +197,7 @@
           <a:p>
             <a:fld id="{A584E3A2-E8EA-4705-A613-CFE9F6F5D3B4}" type="datetimeFigureOut">
               <a:rPr lang="pt-BR" smtClean="0"/>
-              <a:t>29/04/2024</a:t>
+              <a:t>13/05/2024</a:t>
             </a:fld>
             <a:endParaRPr lang="pt-BR"/>
           </a:p>
@@ -680,7 +680,7 @@
           <a:p>
             <a:fld id="{52231B9D-E9F6-4612-9B82-E89961B389AC}" type="datetimeFigureOut">
               <a:rPr lang="pt-BR" smtClean="0"/>
-              <a:t>29/04/2024</a:t>
+              <a:t>13/05/2024</a:t>
             </a:fld>
             <a:endParaRPr lang="pt-BR"/>
           </a:p>
@@ -850,7 +850,7 @@
           <a:p>
             <a:fld id="{52231B9D-E9F6-4612-9B82-E89961B389AC}" type="datetimeFigureOut">
               <a:rPr lang="pt-BR" smtClean="0"/>
-              <a:t>29/04/2024</a:t>
+              <a:t>13/05/2024</a:t>
             </a:fld>
             <a:endParaRPr lang="pt-BR"/>
           </a:p>
@@ -1030,7 +1030,7 @@
           <a:p>
             <a:fld id="{52231B9D-E9F6-4612-9B82-E89961B389AC}" type="datetimeFigureOut">
               <a:rPr lang="pt-BR" smtClean="0"/>
-              <a:t>29/04/2024</a:t>
+              <a:t>13/05/2024</a:t>
             </a:fld>
             <a:endParaRPr lang="pt-BR"/>
           </a:p>
@@ -1200,7 +1200,7 @@
           <a:p>
             <a:fld id="{52231B9D-E9F6-4612-9B82-E89961B389AC}" type="datetimeFigureOut">
               <a:rPr lang="pt-BR" smtClean="0"/>
-              <a:t>29/04/2024</a:t>
+              <a:t>13/05/2024</a:t>
             </a:fld>
             <a:endParaRPr lang="pt-BR"/>
           </a:p>
@@ -1446,7 +1446,7 @@
           <a:p>
             <a:fld id="{52231B9D-E9F6-4612-9B82-E89961B389AC}" type="datetimeFigureOut">
               <a:rPr lang="pt-BR" smtClean="0"/>
-              <a:t>29/04/2024</a:t>
+              <a:t>13/05/2024</a:t>
             </a:fld>
             <a:endParaRPr lang="pt-BR"/>
           </a:p>
@@ -1678,7 +1678,7 @@
           <a:p>
             <a:fld id="{52231B9D-E9F6-4612-9B82-E89961B389AC}" type="datetimeFigureOut">
               <a:rPr lang="pt-BR" smtClean="0"/>
-              <a:t>29/04/2024</a:t>
+              <a:t>13/05/2024</a:t>
             </a:fld>
             <a:endParaRPr lang="pt-BR"/>
           </a:p>
@@ -2045,7 +2045,7 @@
           <a:p>
             <a:fld id="{52231B9D-E9F6-4612-9B82-E89961B389AC}" type="datetimeFigureOut">
               <a:rPr lang="pt-BR" smtClean="0"/>
-              <a:t>29/04/2024</a:t>
+              <a:t>13/05/2024</a:t>
             </a:fld>
             <a:endParaRPr lang="pt-BR"/>
           </a:p>
@@ -2163,7 +2163,7 @@
           <a:p>
             <a:fld id="{52231B9D-E9F6-4612-9B82-E89961B389AC}" type="datetimeFigureOut">
               <a:rPr lang="pt-BR" smtClean="0"/>
-              <a:t>29/04/2024</a:t>
+              <a:t>13/05/2024</a:t>
             </a:fld>
             <a:endParaRPr lang="pt-BR"/>
           </a:p>
@@ -2258,7 +2258,7 @@
           <a:p>
             <a:fld id="{52231B9D-E9F6-4612-9B82-E89961B389AC}" type="datetimeFigureOut">
               <a:rPr lang="pt-BR" smtClean="0"/>
-              <a:t>29/04/2024</a:t>
+              <a:t>13/05/2024</a:t>
             </a:fld>
             <a:endParaRPr lang="pt-BR"/>
           </a:p>
@@ -2535,7 +2535,7 @@
           <a:p>
             <a:fld id="{52231B9D-E9F6-4612-9B82-E89961B389AC}" type="datetimeFigureOut">
               <a:rPr lang="pt-BR" smtClean="0"/>
-              <a:t>29/04/2024</a:t>
+              <a:t>13/05/2024</a:t>
             </a:fld>
             <a:endParaRPr lang="pt-BR"/>
           </a:p>
@@ -2788,7 +2788,7 @@
           <a:p>
             <a:fld id="{52231B9D-E9F6-4612-9B82-E89961B389AC}" type="datetimeFigureOut">
               <a:rPr lang="pt-BR" smtClean="0"/>
-              <a:t>29/04/2024</a:t>
+              <a:t>13/05/2024</a:t>
             </a:fld>
             <a:endParaRPr lang="pt-BR"/>
           </a:p>
@@ -3001,7 +3001,7 @@
           <a:p>
             <a:fld id="{52231B9D-E9F6-4612-9B82-E89961B389AC}" type="datetimeFigureOut">
               <a:rPr lang="pt-BR" smtClean="0"/>
-              <a:t>29/04/2024</a:t>
+              <a:t>13/05/2024</a:t>
             </a:fld>
             <a:endParaRPr lang="pt-BR"/>
           </a:p>
@@ -3665,7 +3665,7 @@
                   </a:schemeClr>
                 </a:solidFill>
               </a:rPr>
-              <a:t>28/04/2024</a:t>
+              <a:t>12/05/2024</a:t>
             </a:r>
             <a:endParaRPr lang="pt-BR" sz="1600" dirty="0">
               <a:solidFill>

</xml_diff>

<commit_message>
add status do bem e período da movimentação de CC
</commit_message>
<xml_diff>
--- a/tempimento.pptx
+++ b/tempimento.pptx
@@ -197,7 +197,7 @@
           <a:p>
             <a:fld id="{A584E3A2-E8EA-4705-A613-CFE9F6F5D3B4}" type="datetimeFigureOut">
               <a:rPr lang="pt-BR" smtClean="0"/>
-              <a:t>24/05/2024</a:t>
+              <a:t>10/06/2024</a:t>
             </a:fld>
             <a:endParaRPr lang="pt-BR"/>
           </a:p>
@@ -680,7 +680,7 @@
           <a:p>
             <a:fld id="{52231B9D-E9F6-4612-9B82-E89961B389AC}" type="datetimeFigureOut">
               <a:rPr lang="pt-BR" smtClean="0"/>
-              <a:t>24/05/2024</a:t>
+              <a:t>10/06/2024</a:t>
             </a:fld>
             <a:endParaRPr lang="pt-BR"/>
           </a:p>
@@ -850,7 +850,7 @@
           <a:p>
             <a:fld id="{52231B9D-E9F6-4612-9B82-E89961B389AC}" type="datetimeFigureOut">
               <a:rPr lang="pt-BR" smtClean="0"/>
-              <a:t>24/05/2024</a:t>
+              <a:t>10/06/2024</a:t>
             </a:fld>
             <a:endParaRPr lang="pt-BR"/>
           </a:p>
@@ -1030,7 +1030,7 @@
           <a:p>
             <a:fld id="{52231B9D-E9F6-4612-9B82-E89961B389AC}" type="datetimeFigureOut">
               <a:rPr lang="pt-BR" smtClean="0"/>
-              <a:t>24/05/2024</a:t>
+              <a:t>10/06/2024</a:t>
             </a:fld>
             <a:endParaRPr lang="pt-BR"/>
           </a:p>
@@ -1200,7 +1200,7 @@
           <a:p>
             <a:fld id="{52231B9D-E9F6-4612-9B82-E89961B389AC}" type="datetimeFigureOut">
               <a:rPr lang="pt-BR" smtClean="0"/>
-              <a:t>24/05/2024</a:t>
+              <a:t>10/06/2024</a:t>
             </a:fld>
             <a:endParaRPr lang="pt-BR"/>
           </a:p>
@@ -1446,7 +1446,7 @@
           <a:p>
             <a:fld id="{52231B9D-E9F6-4612-9B82-E89961B389AC}" type="datetimeFigureOut">
               <a:rPr lang="pt-BR" smtClean="0"/>
-              <a:t>24/05/2024</a:t>
+              <a:t>10/06/2024</a:t>
             </a:fld>
             <a:endParaRPr lang="pt-BR"/>
           </a:p>
@@ -1678,7 +1678,7 @@
           <a:p>
             <a:fld id="{52231B9D-E9F6-4612-9B82-E89961B389AC}" type="datetimeFigureOut">
               <a:rPr lang="pt-BR" smtClean="0"/>
-              <a:t>24/05/2024</a:t>
+              <a:t>10/06/2024</a:t>
             </a:fld>
             <a:endParaRPr lang="pt-BR"/>
           </a:p>
@@ -2045,7 +2045,7 @@
           <a:p>
             <a:fld id="{52231B9D-E9F6-4612-9B82-E89961B389AC}" type="datetimeFigureOut">
               <a:rPr lang="pt-BR" smtClean="0"/>
-              <a:t>24/05/2024</a:t>
+              <a:t>10/06/2024</a:t>
             </a:fld>
             <a:endParaRPr lang="pt-BR"/>
           </a:p>
@@ -2163,7 +2163,7 @@
           <a:p>
             <a:fld id="{52231B9D-E9F6-4612-9B82-E89961B389AC}" type="datetimeFigureOut">
               <a:rPr lang="pt-BR" smtClean="0"/>
-              <a:t>24/05/2024</a:t>
+              <a:t>10/06/2024</a:t>
             </a:fld>
             <a:endParaRPr lang="pt-BR"/>
           </a:p>
@@ -2258,7 +2258,7 @@
           <a:p>
             <a:fld id="{52231B9D-E9F6-4612-9B82-E89961B389AC}" type="datetimeFigureOut">
               <a:rPr lang="pt-BR" smtClean="0"/>
-              <a:t>24/05/2024</a:t>
+              <a:t>10/06/2024</a:t>
             </a:fld>
             <a:endParaRPr lang="pt-BR"/>
           </a:p>
@@ -2535,7 +2535,7 @@
           <a:p>
             <a:fld id="{52231B9D-E9F6-4612-9B82-E89961B389AC}" type="datetimeFigureOut">
               <a:rPr lang="pt-BR" smtClean="0"/>
-              <a:t>24/05/2024</a:t>
+              <a:t>10/06/2024</a:t>
             </a:fld>
             <a:endParaRPr lang="pt-BR"/>
           </a:p>
@@ -2788,7 +2788,7 @@
           <a:p>
             <a:fld id="{52231B9D-E9F6-4612-9B82-E89961B389AC}" type="datetimeFigureOut">
               <a:rPr lang="pt-BR" smtClean="0"/>
-              <a:t>24/05/2024</a:t>
+              <a:t>10/06/2024</a:t>
             </a:fld>
             <a:endParaRPr lang="pt-BR"/>
           </a:p>
@@ -3001,7 +3001,7 @@
           <a:p>
             <a:fld id="{52231B9D-E9F6-4612-9B82-E89961B389AC}" type="datetimeFigureOut">
               <a:rPr lang="pt-BR" smtClean="0"/>
-              <a:t>24/05/2024</a:t>
+              <a:t>10/06/2024</a:t>
             </a:fld>
             <a:endParaRPr lang="pt-BR"/>
           </a:p>
@@ -3665,7 +3665,7 @@
                   </a:schemeClr>
                 </a:solidFill>
               </a:rPr>
-              <a:t>02/06/2024</a:t>
+              <a:t>09/06/2024</a:t>
             </a:r>
             <a:endParaRPr lang="pt-BR" sz="1600" dirty="0">
               <a:solidFill>

</xml_diff>

<commit_message>
consulta separada para equipamentos da telemetria autotrac
</commit_message>
<xml_diff>
--- a/tempimento.pptx
+++ b/tempimento.pptx
@@ -197,7 +197,7 @@
           <a:p>
             <a:fld id="{A584E3A2-E8EA-4705-A613-CFE9F6F5D3B4}" type="datetimeFigureOut">
               <a:rPr lang="pt-BR" smtClean="0"/>
-              <a:t>10/06/2024</a:t>
+              <a:t>22/06/2024</a:t>
             </a:fld>
             <a:endParaRPr lang="pt-BR"/>
           </a:p>
@@ -680,7 +680,7 @@
           <a:p>
             <a:fld id="{52231B9D-E9F6-4612-9B82-E89961B389AC}" type="datetimeFigureOut">
               <a:rPr lang="pt-BR" smtClean="0"/>
-              <a:t>10/06/2024</a:t>
+              <a:t>22/06/2024</a:t>
             </a:fld>
             <a:endParaRPr lang="pt-BR"/>
           </a:p>
@@ -850,7 +850,7 @@
           <a:p>
             <a:fld id="{52231B9D-E9F6-4612-9B82-E89961B389AC}" type="datetimeFigureOut">
               <a:rPr lang="pt-BR" smtClean="0"/>
-              <a:t>10/06/2024</a:t>
+              <a:t>22/06/2024</a:t>
             </a:fld>
             <a:endParaRPr lang="pt-BR"/>
           </a:p>
@@ -1030,7 +1030,7 @@
           <a:p>
             <a:fld id="{52231B9D-E9F6-4612-9B82-E89961B389AC}" type="datetimeFigureOut">
               <a:rPr lang="pt-BR" smtClean="0"/>
-              <a:t>10/06/2024</a:t>
+              <a:t>22/06/2024</a:t>
             </a:fld>
             <a:endParaRPr lang="pt-BR"/>
           </a:p>
@@ -1200,7 +1200,7 @@
           <a:p>
             <a:fld id="{52231B9D-E9F6-4612-9B82-E89961B389AC}" type="datetimeFigureOut">
               <a:rPr lang="pt-BR" smtClean="0"/>
-              <a:t>10/06/2024</a:t>
+              <a:t>22/06/2024</a:t>
             </a:fld>
             <a:endParaRPr lang="pt-BR"/>
           </a:p>
@@ -1446,7 +1446,7 @@
           <a:p>
             <a:fld id="{52231B9D-E9F6-4612-9B82-E89961B389AC}" type="datetimeFigureOut">
               <a:rPr lang="pt-BR" smtClean="0"/>
-              <a:t>10/06/2024</a:t>
+              <a:t>22/06/2024</a:t>
             </a:fld>
             <a:endParaRPr lang="pt-BR"/>
           </a:p>
@@ -1678,7 +1678,7 @@
           <a:p>
             <a:fld id="{52231B9D-E9F6-4612-9B82-E89961B389AC}" type="datetimeFigureOut">
               <a:rPr lang="pt-BR" smtClean="0"/>
-              <a:t>10/06/2024</a:t>
+              <a:t>22/06/2024</a:t>
             </a:fld>
             <a:endParaRPr lang="pt-BR"/>
           </a:p>
@@ -2045,7 +2045,7 @@
           <a:p>
             <a:fld id="{52231B9D-E9F6-4612-9B82-E89961B389AC}" type="datetimeFigureOut">
               <a:rPr lang="pt-BR" smtClean="0"/>
-              <a:t>10/06/2024</a:t>
+              <a:t>22/06/2024</a:t>
             </a:fld>
             <a:endParaRPr lang="pt-BR"/>
           </a:p>
@@ -2163,7 +2163,7 @@
           <a:p>
             <a:fld id="{52231B9D-E9F6-4612-9B82-E89961B389AC}" type="datetimeFigureOut">
               <a:rPr lang="pt-BR" smtClean="0"/>
-              <a:t>10/06/2024</a:t>
+              <a:t>22/06/2024</a:t>
             </a:fld>
             <a:endParaRPr lang="pt-BR"/>
           </a:p>
@@ -2258,7 +2258,7 @@
           <a:p>
             <a:fld id="{52231B9D-E9F6-4612-9B82-E89961B389AC}" type="datetimeFigureOut">
               <a:rPr lang="pt-BR" smtClean="0"/>
-              <a:t>10/06/2024</a:t>
+              <a:t>22/06/2024</a:t>
             </a:fld>
             <a:endParaRPr lang="pt-BR"/>
           </a:p>
@@ -2535,7 +2535,7 @@
           <a:p>
             <a:fld id="{52231B9D-E9F6-4612-9B82-E89961B389AC}" type="datetimeFigureOut">
               <a:rPr lang="pt-BR" smtClean="0"/>
-              <a:t>10/06/2024</a:t>
+              <a:t>22/06/2024</a:t>
             </a:fld>
             <a:endParaRPr lang="pt-BR"/>
           </a:p>
@@ -2788,7 +2788,7 @@
           <a:p>
             <a:fld id="{52231B9D-E9F6-4612-9B82-E89961B389AC}" type="datetimeFigureOut">
               <a:rPr lang="pt-BR" smtClean="0"/>
-              <a:t>10/06/2024</a:t>
+              <a:t>22/06/2024</a:t>
             </a:fld>
             <a:endParaRPr lang="pt-BR"/>
           </a:p>
@@ -3001,7 +3001,7 @@
           <a:p>
             <a:fld id="{52231B9D-E9F6-4612-9B82-E89961B389AC}" type="datetimeFigureOut">
               <a:rPr lang="pt-BR" smtClean="0"/>
-              <a:t>10/06/2024</a:t>
+              <a:t>22/06/2024</a:t>
             </a:fld>
             <a:endParaRPr lang="pt-BR"/>
           </a:p>
@@ -3665,7 +3665,17 @@
                   </a:schemeClr>
                 </a:solidFill>
               </a:rPr>
-              <a:t>09/06/2024</a:t>
+              <a:t>30</a:t>
+            </a:r>
+            <a:r>
+              <a:rPr lang="pt-BR" sz="1600" dirty="0" smtClean="0">
+                <a:solidFill>
+                  <a:schemeClr val="bg2">
+                    <a:lumMod val="90000"/>
+                  </a:schemeClr>
+                </a:solidFill>
+              </a:rPr>
+              <a:t>/06/2024</a:t>
             </a:r>
             <a:endParaRPr lang="pt-BR" sz="1600" dirty="0">
               <a:solidFill>

</xml_diff>

<commit_message>
consulta de validação pendente; referência atual é consulta do Rodrigo
</commit_message>
<xml_diff>
--- a/tempimento.pptx
+++ b/tempimento.pptx
@@ -197,7 +197,7 @@
           <a:p>
             <a:fld id="{A584E3A2-E8EA-4705-A613-CFE9F6F5D3B4}" type="datetimeFigureOut">
               <a:rPr lang="pt-BR" smtClean="0"/>
-              <a:t>22/06/2024</a:t>
+              <a:t>11/07/2024</a:t>
             </a:fld>
             <a:endParaRPr lang="pt-BR"/>
           </a:p>
@@ -680,7 +680,7 @@
           <a:p>
             <a:fld id="{52231B9D-E9F6-4612-9B82-E89961B389AC}" type="datetimeFigureOut">
               <a:rPr lang="pt-BR" smtClean="0"/>
-              <a:t>22/06/2024</a:t>
+              <a:t>11/07/2024</a:t>
             </a:fld>
             <a:endParaRPr lang="pt-BR"/>
           </a:p>
@@ -850,7 +850,7 @@
           <a:p>
             <a:fld id="{52231B9D-E9F6-4612-9B82-E89961B389AC}" type="datetimeFigureOut">
               <a:rPr lang="pt-BR" smtClean="0"/>
-              <a:t>22/06/2024</a:t>
+              <a:t>11/07/2024</a:t>
             </a:fld>
             <a:endParaRPr lang="pt-BR"/>
           </a:p>
@@ -1030,7 +1030,7 @@
           <a:p>
             <a:fld id="{52231B9D-E9F6-4612-9B82-E89961B389AC}" type="datetimeFigureOut">
               <a:rPr lang="pt-BR" smtClean="0"/>
-              <a:t>22/06/2024</a:t>
+              <a:t>11/07/2024</a:t>
             </a:fld>
             <a:endParaRPr lang="pt-BR"/>
           </a:p>
@@ -1200,7 +1200,7 @@
           <a:p>
             <a:fld id="{52231B9D-E9F6-4612-9B82-E89961B389AC}" type="datetimeFigureOut">
               <a:rPr lang="pt-BR" smtClean="0"/>
-              <a:t>22/06/2024</a:t>
+              <a:t>11/07/2024</a:t>
             </a:fld>
             <a:endParaRPr lang="pt-BR"/>
           </a:p>
@@ -1446,7 +1446,7 @@
           <a:p>
             <a:fld id="{52231B9D-E9F6-4612-9B82-E89961B389AC}" type="datetimeFigureOut">
               <a:rPr lang="pt-BR" smtClean="0"/>
-              <a:t>22/06/2024</a:t>
+              <a:t>11/07/2024</a:t>
             </a:fld>
             <a:endParaRPr lang="pt-BR"/>
           </a:p>
@@ -1678,7 +1678,7 @@
           <a:p>
             <a:fld id="{52231B9D-E9F6-4612-9B82-E89961B389AC}" type="datetimeFigureOut">
               <a:rPr lang="pt-BR" smtClean="0"/>
-              <a:t>22/06/2024</a:t>
+              <a:t>11/07/2024</a:t>
             </a:fld>
             <a:endParaRPr lang="pt-BR"/>
           </a:p>
@@ -2045,7 +2045,7 @@
           <a:p>
             <a:fld id="{52231B9D-E9F6-4612-9B82-E89961B389AC}" type="datetimeFigureOut">
               <a:rPr lang="pt-BR" smtClean="0"/>
-              <a:t>22/06/2024</a:t>
+              <a:t>11/07/2024</a:t>
             </a:fld>
             <a:endParaRPr lang="pt-BR"/>
           </a:p>
@@ -2163,7 +2163,7 @@
           <a:p>
             <a:fld id="{52231B9D-E9F6-4612-9B82-E89961B389AC}" type="datetimeFigureOut">
               <a:rPr lang="pt-BR" smtClean="0"/>
-              <a:t>22/06/2024</a:t>
+              <a:t>11/07/2024</a:t>
             </a:fld>
             <a:endParaRPr lang="pt-BR"/>
           </a:p>
@@ -2258,7 +2258,7 @@
           <a:p>
             <a:fld id="{52231B9D-E9F6-4612-9B82-E89961B389AC}" type="datetimeFigureOut">
               <a:rPr lang="pt-BR" smtClean="0"/>
-              <a:t>22/06/2024</a:t>
+              <a:t>11/07/2024</a:t>
             </a:fld>
             <a:endParaRPr lang="pt-BR"/>
           </a:p>
@@ -2535,7 +2535,7 @@
           <a:p>
             <a:fld id="{52231B9D-E9F6-4612-9B82-E89961B389AC}" type="datetimeFigureOut">
               <a:rPr lang="pt-BR" smtClean="0"/>
-              <a:t>22/06/2024</a:t>
+              <a:t>11/07/2024</a:t>
             </a:fld>
             <a:endParaRPr lang="pt-BR"/>
           </a:p>
@@ -2788,7 +2788,7 @@
           <a:p>
             <a:fld id="{52231B9D-E9F6-4612-9B82-E89961B389AC}" type="datetimeFigureOut">
               <a:rPr lang="pt-BR" smtClean="0"/>
-              <a:t>22/06/2024</a:t>
+              <a:t>11/07/2024</a:t>
             </a:fld>
             <a:endParaRPr lang="pt-BR"/>
           </a:p>
@@ -3001,7 +3001,7 @@
           <a:p>
             <a:fld id="{52231B9D-E9F6-4612-9B82-E89961B389AC}" type="datetimeFigureOut">
               <a:rPr lang="pt-BR" smtClean="0"/>
-              <a:t>22/06/2024</a:t>
+              <a:t>11/07/2024</a:t>
             </a:fld>
             <a:endParaRPr lang="pt-BR"/>
           </a:p>
@@ -3665,7 +3665,7 @@
                   </a:schemeClr>
                 </a:solidFill>
               </a:rPr>
-              <a:t>30</a:t>
+              <a:t>07</a:t>
             </a:r>
             <a:r>
               <a:rPr lang="pt-BR" sz="1600" dirty="0" smtClean="0">
@@ -3675,7 +3675,7 @@
                   </a:schemeClr>
                 </a:solidFill>
               </a:rPr>
-              <a:t>/06/2024</a:t>
+              <a:t>/07/2024</a:t>
             </a:r>
             <a:endParaRPr lang="pt-BR" sz="1600" dirty="0">
               <a:solidFill>

</xml_diff>

<commit_message>
alteração do tipo do arquivo com as descrições do evento
</commit_message>
<xml_diff>
--- a/tempimento.pptx
+++ b/tempimento.pptx
@@ -197,7 +197,7 @@
           <a:p>
             <a:fld id="{A584E3A2-E8EA-4705-A613-CFE9F6F5D3B4}" type="datetimeFigureOut">
               <a:rPr lang="pt-BR" smtClean="0"/>
-              <a:t>27/07/2024</a:t>
+              <a:t>09/08/2024</a:t>
             </a:fld>
             <a:endParaRPr lang="pt-BR"/>
           </a:p>
@@ -680,7 +680,7 @@
           <a:p>
             <a:fld id="{52231B9D-E9F6-4612-9B82-E89961B389AC}" type="datetimeFigureOut">
               <a:rPr lang="pt-BR" smtClean="0"/>
-              <a:t>27/07/2024</a:t>
+              <a:t>09/08/2024</a:t>
             </a:fld>
             <a:endParaRPr lang="pt-BR"/>
           </a:p>
@@ -850,7 +850,7 @@
           <a:p>
             <a:fld id="{52231B9D-E9F6-4612-9B82-E89961B389AC}" type="datetimeFigureOut">
               <a:rPr lang="pt-BR" smtClean="0"/>
-              <a:t>27/07/2024</a:t>
+              <a:t>09/08/2024</a:t>
             </a:fld>
             <a:endParaRPr lang="pt-BR"/>
           </a:p>
@@ -1030,7 +1030,7 @@
           <a:p>
             <a:fld id="{52231B9D-E9F6-4612-9B82-E89961B389AC}" type="datetimeFigureOut">
               <a:rPr lang="pt-BR" smtClean="0"/>
-              <a:t>27/07/2024</a:t>
+              <a:t>09/08/2024</a:t>
             </a:fld>
             <a:endParaRPr lang="pt-BR"/>
           </a:p>
@@ -1200,7 +1200,7 @@
           <a:p>
             <a:fld id="{52231B9D-E9F6-4612-9B82-E89961B389AC}" type="datetimeFigureOut">
               <a:rPr lang="pt-BR" smtClean="0"/>
-              <a:t>27/07/2024</a:t>
+              <a:t>09/08/2024</a:t>
             </a:fld>
             <a:endParaRPr lang="pt-BR"/>
           </a:p>
@@ -1446,7 +1446,7 @@
           <a:p>
             <a:fld id="{52231B9D-E9F6-4612-9B82-E89961B389AC}" type="datetimeFigureOut">
               <a:rPr lang="pt-BR" smtClean="0"/>
-              <a:t>27/07/2024</a:t>
+              <a:t>09/08/2024</a:t>
             </a:fld>
             <a:endParaRPr lang="pt-BR"/>
           </a:p>
@@ -1678,7 +1678,7 @@
           <a:p>
             <a:fld id="{52231B9D-E9F6-4612-9B82-E89961B389AC}" type="datetimeFigureOut">
               <a:rPr lang="pt-BR" smtClean="0"/>
-              <a:t>27/07/2024</a:t>
+              <a:t>09/08/2024</a:t>
             </a:fld>
             <a:endParaRPr lang="pt-BR"/>
           </a:p>
@@ -2045,7 +2045,7 @@
           <a:p>
             <a:fld id="{52231B9D-E9F6-4612-9B82-E89961B389AC}" type="datetimeFigureOut">
               <a:rPr lang="pt-BR" smtClean="0"/>
-              <a:t>27/07/2024</a:t>
+              <a:t>09/08/2024</a:t>
             </a:fld>
             <a:endParaRPr lang="pt-BR"/>
           </a:p>
@@ -2163,7 +2163,7 @@
           <a:p>
             <a:fld id="{52231B9D-E9F6-4612-9B82-E89961B389AC}" type="datetimeFigureOut">
               <a:rPr lang="pt-BR" smtClean="0"/>
-              <a:t>27/07/2024</a:t>
+              <a:t>09/08/2024</a:t>
             </a:fld>
             <a:endParaRPr lang="pt-BR"/>
           </a:p>
@@ -2258,7 +2258,7 @@
           <a:p>
             <a:fld id="{52231B9D-E9F6-4612-9B82-E89961B389AC}" type="datetimeFigureOut">
               <a:rPr lang="pt-BR" smtClean="0"/>
-              <a:t>27/07/2024</a:t>
+              <a:t>09/08/2024</a:t>
             </a:fld>
             <a:endParaRPr lang="pt-BR"/>
           </a:p>
@@ -2535,7 +2535,7 @@
           <a:p>
             <a:fld id="{52231B9D-E9F6-4612-9B82-E89961B389AC}" type="datetimeFigureOut">
               <a:rPr lang="pt-BR" smtClean="0"/>
-              <a:t>27/07/2024</a:t>
+              <a:t>09/08/2024</a:t>
             </a:fld>
             <a:endParaRPr lang="pt-BR"/>
           </a:p>
@@ -2788,7 +2788,7 @@
           <a:p>
             <a:fld id="{52231B9D-E9F6-4612-9B82-E89961B389AC}" type="datetimeFigureOut">
               <a:rPr lang="pt-BR" smtClean="0"/>
-              <a:t>27/07/2024</a:t>
+              <a:t>09/08/2024</a:t>
             </a:fld>
             <a:endParaRPr lang="pt-BR"/>
           </a:p>
@@ -3001,7 +3001,7 @@
           <a:p>
             <a:fld id="{52231B9D-E9F6-4612-9B82-E89961B389AC}" type="datetimeFigureOut">
               <a:rPr lang="pt-BR" smtClean="0"/>
-              <a:t>27/07/2024</a:t>
+              <a:t>09/08/2024</a:t>
             </a:fld>
             <a:endParaRPr lang="pt-BR"/>
           </a:p>
@@ -3665,7 +3665,17 @@
                   </a:schemeClr>
                 </a:solidFill>
               </a:rPr>
-              <a:t>28/07/2024</a:t>
+              <a:t>04</a:t>
+            </a:r>
+            <a:r>
+              <a:rPr lang="pt-BR" sz="1600" dirty="0" smtClean="0">
+                <a:solidFill>
+                  <a:schemeClr val="bg2">
+                    <a:lumMod val="90000"/>
+                  </a:schemeClr>
+                </a:solidFill>
+              </a:rPr>
+              <a:t>/08/2024</a:t>
             </a:r>
             <a:endParaRPr lang="pt-BR" sz="1600" dirty="0">
               <a:solidFill>

</xml_diff>

<commit_message>
item 11 a ser detalhado por fornecedor em vez de por produto
</commit_message>
<xml_diff>
--- a/tempimento.pptx
+++ b/tempimento.pptx
@@ -197,7 +197,7 @@
           <a:p>
             <a:fld id="{A584E3A2-E8EA-4705-A613-CFE9F6F5D3B4}" type="datetimeFigureOut">
               <a:rPr lang="pt-BR" smtClean="0"/>
-              <a:t>16/08/2024</a:t>
+              <a:t>30/08/2024</a:t>
             </a:fld>
             <a:endParaRPr lang="pt-BR"/>
           </a:p>
@@ -680,7 +680,7 @@
           <a:p>
             <a:fld id="{52231B9D-E9F6-4612-9B82-E89961B389AC}" type="datetimeFigureOut">
               <a:rPr lang="pt-BR" smtClean="0"/>
-              <a:t>16/08/2024</a:t>
+              <a:t>30/08/2024</a:t>
             </a:fld>
             <a:endParaRPr lang="pt-BR"/>
           </a:p>
@@ -850,7 +850,7 @@
           <a:p>
             <a:fld id="{52231B9D-E9F6-4612-9B82-E89961B389AC}" type="datetimeFigureOut">
               <a:rPr lang="pt-BR" smtClean="0"/>
-              <a:t>16/08/2024</a:t>
+              <a:t>30/08/2024</a:t>
             </a:fld>
             <a:endParaRPr lang="pt-BR"/>
           </a:p>
@@ -1030,7 +1030,7 @@
           <a:p>
             <a:fld id="{52231B9D-E9F6-4612-9B82-E89961B389AC}" type="datetimeFigureOut">
               <a:rPr lang="pt-BR" smtClean="0"/>
-              <a:t>16/08/2024</a:t>
+              <a:t>30/08/2024</a:t>
             </a:fld>
             <a:endParaRPr lang="pt-BR"/>
           </a:p>
@@ -1200,7 +1200,7 @@
           <a:p>
             <a:fld id="{52231B9D-E9F6-4612-9B82-E89961B389AC}" type="datetimeFigureOut">
               <a:rPr lang="pt-BR" smtClean="0"/>
-              <a:t>16/08/2024</a:t>
+              <a:t>30/08/2024</a:t>
             </a:fld>
             <a:endParaRPr lang="pt-BR"/>
           </a:p>
@@ -1446,7 +1446,7 @@
           <a:p>
             <a:fld id="{52231B9D-E9F6-4612-9B82-E89961B389AC}" type="datetimeFigureOut">
               <a:rPr lang="pt-BR" smtClean="0"/>
-              <a:t>16/08/2024</a:t>
+              <a:t>30/08/2024</a:t>
             </a:fld>
             <a:endParaRPr lang="pt-BR"/>
           </a:p>
@@ -1678,7 +1678,7 @@
           <a:p>
             <a:fld id="{52231B9D-E9F6-4612-9B82-E89961B389AC}" type="datetimeFigureOut">
               <a:rPr lang="pt-BR" smtClean="0"/>
-              <a:t>16/08/2024</a:t>
+              <a:t>30/08/2024</a:t>
             </a:fld>
             <a:endParaRPr lang="pt-BR"/>
           </a:p>
@@ -2045,7 +2045,7 @@
           <a:p>
             <a:fld id="{52231B9D-E9F6-4612-9B82-E89961B389AC}" type="datetimeFigureOut">
               <a:rPr lang="pt-BR" smtClean="0"/>
-              <a:t>16/08/2024</a:t>
+              <a:t>30/08/2024</a:t>
             </a:fld>
             <a:endParaRPr lang="pt-BR"/>
           </a:p>
@@ -2163,7 +2163,7 @@
           <a:p>
             <a:fld id="{52231B9D-E9F6-4612-9B82-E89961B389AC}" type="datetimeFigureOut">
               <a:rPr lang="pt-BR" smtClean="0"/>
-              <a:t>16/08/2024</a:t>
+              <a:t>30/08/2024</a:t>
             </a:fld>
             <a:endParaRPr lang="pt-BR"/>
           </a:p>
@@ -2258,7 +2258,7 @@
           <a:p>
             <a:fld id="{52231B9D-E9F6-4612-9B82-E89961B389AC}" type="datetimeFigureOut">
               <a:rPr lang="pt-BR" smtClean="0"/>
-              <a:t>16/08/2024</a:t>
+              <a:t>30/08/2024</a:t>
             </a:fld>
             <a:endParaRPr lang="pt-BR"/>
           </a:p>
@@ -2535,7 +2535,7 @@
           <a:p>
             <a:fld id="{52231B9D-E9F6-4612-9B82-E89961B389AC}" type="datetimeFigureOut">
               <a:rPr lang="pt-BR" smtClean="0"/>
-              <a:t>16/08/2024</a:t>
+              <a:t>30/08/2024</a:t>
             </a:fld>
             <a:endParaRPr lang="pt-BR"/>
           </a:p>
@@ -2788,7 +2788,7 @@
           <a:p>
             <a:fld id="{52231B9D-E9F6-4612-9B82-E89961B389AC}" type="datetimeFigureOut">
               <a:rPr lang="pt-BR" smtClean="0"/>
-              <a:t>16/08/2024</a:t>
+              <a:t>30/08/2024</a:t>
             </a:fld>
             <a:endParaRPr lang="pt-BR"/>
           </a:p>
@@ -3001,7 +3001,7 @@
           <a:p>
             <a:fld id="{52231B9D-E9F6-4612-9B82-E89961B389AC}" type="datetimeFigureOut">
               <a:rPr lang="pt-BR" smtClean="0"/>
-              <a:t>16/08/2024</a:t>
+              <a:t>30/08/2024</a:t>
             </a:fld>
             <a:endParaRPr lang="pt-BR"/>
           </a:p>
@@ -3665,7 +3665,7 @@
                   </a:schemeClr>
                 </a:solidFill>
               </a:rPr>
-              <a:t>18</a:t>
+              <a:t>25</a:t>
             </a:r>
             <a:r>
               <a:rPr lang="pt-BR" sz="1600" dirty="0" smtClean="0">

</xml_diff>

<commit_message>
ATT DO DIA 04/09/2024 11:20
</commit_message>
<xml_diff>
--- a/tempimento.pptx
+++ b/tempimento.pptx
@@ -197,7 +197,7 @@
           <a:p>
             <a:fld id="{A584E3A2-E8EA-4705-A613-CFE9F6F5D3B4}" type="datetimeFigureOut">
               <a:rPr lang="pt-BR" smtClean="0"/>
-              <a:t>30/08/2024</a:t>
+              <a:t>02/09/2024</a:t>
             </a:fld>
             <a:endParaRPr lang="pt-BR"/>
           </a:p>
@@ -680,7 +680,7 @@
           <a:p>
             <a:fld id="{52231B9D-E9F6-4612-9B82-E89961B389AC}" type="datetimeFigureOut">
               <a:rPr lang="pt-BR" smtClean="0"/>
-              <a:t>30/08/2024</a:t>
+              <a:t>02/09/2024</a:t>
             </a:fld>
             <a:endParaRPr lang="pt-BR"/>
           </a:p>
@@ -850,7 +850,7 @@
           <a:p>
             <a:fld id="{52231B9D-E9F6-4612-9B82-E89961B389AC}" type="datetimeFigureOut">
               <a:rPr lang="pt-BR" smtClean="0"/>
-              <a:t>30/08/2024</a:t>
+              <a:t>02/09/2024</a:t>
             </a:fld>
             <a:endParaRPr lang="pt-BR"/>
           </a:p>
@@ -1030,7 +1030,7 @@
           <a:p>
             <a:fld id="{52231B9D-E9F6-4612-9B82-E89961B389AC}" type="datetimeFigureOut">
               <a:rPr lang="pt-BR" smtClean="0"/>
-              <a:t>30/08/2024</a:t>
+              <a:t>02/09/2024</a:t>
             </a:fld>
             <a:endParaRPr lang="pt-BR"/>
           </a:p>
@@ -1200,7 +1200,7 @@
           <a:p>
             <a:fld id="{52231B9D-E9F6-4612-9B82-E89961B389AC}" type="datetimeFigureOut">
               <a:rPr lang="pt-BR" smtClean="0"/>
-              <a:t>30/08/2024</a:t>
+              <a:t>02/09/2024</a:t>
             </a:fld>
             <a:endParaRPr lang="pt-BR"/>
           </a:p>
@@ -1446,7 +1446,7 @@
           <a:p>
             <a:fld id="{52231B9D-E9F6-4612-9B82-E89961B389AC}" type="datetimeFigureOut">
               <a:rPr lang="pt-BR" smtClean="0"/>
-              <a:t>30/08/2024</a:t>
+              <a:t>02/09/2024</a:t>
             </a:fld>
             <a:endParaRPr lang="pt-BR"/>
           </a:p>
@@ -1678,7 +1678,7 @@
           <a:p>
             <a:fld id="{52231B9D-E9F6-4612-9B82-E89961B389AC}" type="datetimeFigureOut">
               <a:rPr lang="pt-BR" smtClean="0"/>
-              <a:t>30/08/2024</a:t>
+              <a:t>02/09/2024</a:t>
             </a:fld>
             <a:endParaRPr lang="pt-BR"/>
           </a:p>
@@ -2045,7 +2045,7 @@
           <a:p>
             <a:fld id="{52231B9D-E9F6-4612-9B82-E89961B389AC}" type="datetimeFigureOut">
               <a:rPr lang="pt-BR" smtClean="0"/>
-              <a:t>30/08/2024</a:t>
+              <a:t>02/09/2024</a:t>
             </a:fld>
             <a:endParaRPr lang="pt-BR"/>
           </a:p>
@@ -2163,7 +2163,7 @@
           <a:p>
             <a:fld id="{52231B9D-E9F6-4612-9B82-E89961B389AC}" type="datetimeFigureOut">
               <a:rPr lang="pt-BR" smtClean="0"/>
-              <a:t>30/08/2024</a:t>
+              <a:t>02/09/2024</a:t>
             </a:fld>
             <a:endParaRPr lang="pt-BR"/>
           </a:p>
@@ -2258,7 +2258,7 @@
           <a:p>
             <a:fld id="{52231B9D-E9F6-4612-9B82-E89961B389AC}" type="datetimeFigureOut">
               <a:rPr lang="pt-BR" smtClean="0"/>
-              <a:t>30/08/2024</a:t>
+              <a:t>02/09/2024</a:t>
             </a:fld>
             <a:endParaRPr lang="pt-BR"/>
           </a:p>
@@ -2535,7 +2535,7 @@
           <a:p>
             <a:fld id="{52231B9D-E9F6-4612-9B82-E89961B389AC}" type="datetimeFigureOut">
               <a:rPr lang="pt-BR" smtClean="0"/>
-              <a:t>30/08/2024</a:t>
+              <a:t>02/09/2024</a:t>
             </a:fld>
             <a:endParaRPr lang="pt-BR"/>
           </a:p>
@@ -2788,7 +2788,7 @@
           <a:p>
             <a:fld id="{52231B9D-E9F6-4612-9B82-E89961B389AC}" type="datetimeFigureOut">
               <a:rPr lang="pt-BR" smtClean="0"/>
-              <a:t>30/08/2024</a:t>
+              <a:t>02/09/2024</a:t>
             </a:fld>
             <a:endParaRPr lang="pt-BR"/>
           </a:p>
@@ -3001,7 +3001,7 @@
           <a:p>
             <a:fld id="{52231B9D-E9F6-4612-9B82-E89961B389AC}" type="datetimeFigureOut">
               <a:rPr lang="pt-BR" smtClean="0"/>
-              <a:t>30/08/2024</a:t>
+              <a:t>02/09/2024</a:t>
             </a:fld>
             <a:endParaRPr lang="pt-BR"/>
           </a:p>
@@ -3665,7 +3665,7 @@
                   </a:schemeClr>
                 </a:solidFill>
               </a:rPr>
-              <a:t>25</a:t>
+              <a:t>01</a:t>
             </a:r>
             <a:r>
               <a:rPr lang="pt-BR" sz="1600" dirty="0" smtClean="0">
@@ -3675,7 +3675,7 @@
                   </a:schemeClr>
                 </a:solidFill>
               </a:rPr>
-              <a:t>/08/2024</a:t>
+              <a:t>/09/2024</a:t>
             </a:r>
             <a:endParaRPr lang="pt-BR" sz="1600" dirty="0">
               <a:solidFill>

</xml_diff>

<commit_message>
remoção de caracteres de ENTER da OBS do pedido
</commit_message>
<xml_diff>
--- a/tempimento.pptx
+++ b/tempimento.pptx
@@ -197,7 +197,7 @@
           <a:p>
             <a:fld id="{A584E3A2-E8EA-4705-A613-CFE9F6F5D3B4}" type="datetimeFigureOut">
               <a:rPr lang="pt-BR" smtClean="0"/>
-              <a:t>10/09/2024</a:t>
+              <a:t>21/09/2024</a:t>
             </a:fld>
             <a:endParaRPr lang="pt-BR"/>
           </a:p>
@@ -680,7 +680,7 @@
           <a:p>
             <a:fld id="{52231B9D-E9F6-4612-9B82-E89961B389AC}" type="datetimeFigureOut">
               <a:rPr lang="pt-BR" smtClean="0"/>
-              <a:t>10/09/2024</a:t>
+              <a:t>21/09/2024</a:t>
             </a:fld>
             <a:endParaRPr lang="pt-BR"/>
           </a:p>
@@ -850,7 +850,7 @@
           <a:p>
             <a:fld id="{52231B9D-E9F6-4612-9B82-E89961B389AC}" type="datetimeFigureOut">
               <a:rPr lang="pt-BR" smtClean="0"/>
-              <a:t>10/09/2024</a:t>
+              <a:t>21/09/2024</a:t>
             </a:fld>
             <a:endParaRPr lang="pt-BR"/>
           </a:p>
@@ -1030,7 +1030,7 @@
           <a:p>
             <a:fld id="{52231B9D-E9F6-4612-9B82-E89961B389AC}" type="datetimeFigureOut">
               <a:rPr lang="pt-BR" smtClean="0"/>
-              <a:t>10/09/2024</a:t>
+              <a:t>21/09/2024</a:t>
             </a:fld>
             <a:endParaRPr lang="pt-BR"/>
           </a:p>
@@ -1200,7 +1200,7 @@
           <a:p>
             <a:fld id="{52231B9D-E9F6-4612-9B82-E89961B389AC}" type="datetimeFigureOut">
               <a:rPr lang="pt-BR" smtClean="0"/>
-              <a:t>10/09/2024</a:t>
+              <a:t>21/09/2024</a:t>
             </a:fld>
             <a:endParaRPr lang="pt-BR"/>
           </a:p>
@@ -1446,7 +1446,7 @@
           <a:p>
             <a:fld id="{52231B9D-E9F6-4612-9B82-E89961B389AC}" type="datetimeFigureOut">
               <a:rPr lang="pt-BR" smtClean="0"/>
-              <a:t>10/09/2024</a:t>
+              <a:t>21/09/2024</a:t>
             </a:fld>
             <a:endParaRPr lang="pt-BR"/>
           </a:p>
@@ -1678,7 +1678,7 @@
           <a:p>
             <a:fld id="{52231B9D-E9F6-4612-9B82-E89961B389AC}" type="datetimeFigureOut">
               <a:rPr lang="pt-BR" smtClean="0"/>
-              <a:t>10/09/2024</a:t>
+              <a:t>21/09/2024</a:t>
             </a:fld>
             <a:endParaRPr lang="pt-BR"/>
           </a:p>
@@ -2045,7 +2045,7 @@
           <a:p>
             <a:fld id="{52231B9D-E9F6-4612-9B82-E89961B389AC}" type="datetimeFigureOut">
               <a:rPr lang="pt-BR" smtClean="0"/>
-              <a:t>10/09/2024</a:t>
+              <a:t>21/09/2024</a:t>
             </a:fld>
             <a:endParaRPr lang="pt-BR"/>
           </a:p>
@@ -2163,7 +2163,7 @@
           <a:p>
             <a:fld id="{52231B9D-E9F6-4612-9B82-E89961B389AC}" type="datetimeFigureOut">
               <a:rPr lang="pt-BR" smtClean="0"/>
-              <a:t>10/09/2024</a:t>
+              <a:t>21/09/2024</a:t>
             </a:fld>
             <a:endParaRPr lang="pt-BR"/>
           </a:p>
@@ -2258,7 +2258,7 @@
           <a:p>
             <a:fld id="{52231B9D-E9F6-4612-9B82-E89961B389AC}" type="datetimeFigureOut">
               <a:rPr lang="pt-BR" smtClean="0"/>
-              <a:t>10/09/2024</a:t>
+              <a:t>21/09/2024</a:t>
             </a:fld>
             <a:endParaRPr lang="pt-BR"/>
           </a:p>
@@ -2535,7 +2535,7 @@
           <a:p>
             <a:fld id="{52231B9D-E9F6-4612-9B82-E89961B389AC}" type="datetimeFigureOut">
               <a:rPr lang="pt-BR" smtClean="0"/>
-              <a:t>10/09/2024</a:t>
+              <a:t>21/09/2024</a:t>
             </a:fld>
             <a:endParaRPr lang="pt-BR"/>
           </a:p>
@@ -2788,7 +2788,7 @@
           <a:p>
             <a:fld id="{52231B9D-E9F6-4612-9B82-E89961B389AC}" type="datetimeFigureOut">
               <a:rPr lang="pt-BR" smtClean="0"/>
-              <a:t>10/09/2024</a:t>
+              <a:t>21/09/2024</a:t>
             </a:fld>
             <a:endParaRPr lang="pt-BR"/>
           </a:p>
@@ -3001,7 +3001,7 @@
           <a:p>
             <a:fld id="{52231B9D-E9F6-4612-9B82-E89961B389AC}" type="datetimeFigureOut">
               <a:rPr lang="pt-BR" smtClean="0"/>
-              <a:t>10/09/2024</a:t>
+              <a:t>21/09/2024</a:t>
             </a:fld>
             <a:endParaRPr lang="pt-BR"/>
           </a:p>
@@ -3665,7 +3665,7 @@
                   </a:schemeClr>
                 </a:solidFill>
               </a:rPr>
-              <a:t>08/09/2024</a:t>
+              <a:t>22/09/2024</a:t>
             </a:r>
             <a:endParaRPr lang="pt-BR" sz="1600" dirty="0">
               <a:solidFill>

</xml_diff>

<commit_message>
dedução do rateio do custo improdutivo pela receita da OS; implantar
</commit_message>
<xml_diff>
--- a/tempimento.pptx
+++ b/tempimento.pptx
@@ -11,7 +11,7 @@
     <p:sldId id="256" r:id="rId2"/>
   </p:sldIdLst>
   <p:sldSz cx="12192000" cy="6858000"/>
-  <p:notesSz cx="6889750" cy="9671050"/>
+  <p:notesSz cx="6797675" cy="9926638"/>
   <p:defaultTextStyle>
     <a:defPPr>
       <a:defRPr lang="pt-BR"/>
@@ -150,7 +150,7 @@
         <p:spPr>
           <a:xfrm>
             <a:off x="6" y="1"/>
-            <a:ext cx="2985970" cy="484528"/>
+            <a:ext cx="2946065" cy="497333"/>
           </a:xfrm>
           <a:prstGeom prst="rect">
             <a:avLst/>
@@ -180,8 +180,8 @@
         </p:nvSpPr>
         <p:spPr>
           <a:xfrm>
-            <a:off x="3902247" y="1"/>
-            <a:ext cx="2985970" cy="484528"/>
+            <a:off x="3850097" y="1"/>
+            <a:ext cx="2946065" cy="497333"/>
           </a:xfrm>
           <a:prstGeom prst="rect">
             <a:avLst/>
@@ -197,7 +197,7 @@
           <a:p>
             <a:fld id="{A584E3A2-E8EA-4705-A613-CFE9F6F5D3B4}" type="datetimeFigureOut">
               <a:rPr lang="pt-BR" smtClean="0"/>
-              <a:t>21/09/2024</a:t>
+              <a:t>28/09/2024</a:t>
             </a:fld>
             <a:endParaRPr lang="pt-BR"/>
           </a:p>
@@ -215,8 +215,8 @@
         </p:nvSpPr>
         <p:spPr>
           <a:xfrm>
-            <a:off x="544513" y="1209675"/>
-            <a:ext cx="5800725" cy="3262313"/>
+            <a:off x="423863" y="1241425"/>
+            <a:ext cx="5949950" cy="3348038"/>
           </a:xfrm>
           <a:prstGeom prst="rect">
             <a:avLst/>
@@ -248,8 +248,8 @@
         </p:nvSpPr>
         <p:spPr>
           <a:xfrm>
-            <a:off x="688363" y="4654768"/>
-            <a:ext cx="5513032" cy="3807217"/>
+            <a:off x="679163" y="4777785"/>
+            <a:ext cx="5439356" cy="3907835"/>
           </a:xfrm>
           <a:prstGeom prst="rect">
             <a:avLst/>
@@ -308,8 +308,8 @@
         </p:nvSpPr>
         <p:spPr>
           <a:xfrm>
-            <a:off x="6" y="9186525"/>
-            <a:ext cx="2985970" cy="484528"/>
+            <a:off x="6" y="9429308"/>
+            <a:ext cx="2946065" cy="497333"/>
           </a:xfrm>
           <a:prstGeom prst="rect">
             <a:avLst/>
@@ -339,8 +339,8 @@
         </p:nvSpPr>
         <p:spPr>
           <a:xfrm>
-            <a:off x="3902247" y="9186525"/>
-            <a:ext cx="2985970" cy="484528"/>
+            <a:off x="3850097" y="9429308"/>
+            <a:ext cx="2946065" cy="497333"/>
           </a:xfrm>
           <a:prstGeom prst="rect">
             <a:avLst/>
@@ -680,7 +680,7 @@
           <a:p>
             <a:fld id="{52231B9D-E9F6-4612-9B82-E89961B389AC}" type="datetimeFigureOut">
               <a:rPr lang="pt-BR" smtClean="0"/>
-              <a:t>21/09/2024</a:t>
+              <a:t>28/09/2024</a:t>
             </a:fld>
             <a:endParaRPr lang="pt-BR"/>
           </a:p>
@@ -850,7 +850,7 @@
           <a:p>
             <a:fld id="{52231B9D-E9F6-4612-9B82-E89961B389AC}" type="datetimeFigureOut">
               <a:rPr lang="pt-BR" smtClean="0"/>
-              <a:t>21/09/2024</a:t>
+              <a:t>28/09/2024</a:t>
             </a:fld>
             <a:endParaRPr lang="pt-BR"/>
           </a:p>
@@ -1030,7 +1030,7 @@
           <a:p>
             <a:fld id="{52231B9D-E9F6-4612-9B82-E89961B389AC}" type="datetimeFigureOut">
               <a:rPr lang="pt-BR" smtClean="0"/>
-              <a:t>21/09/2024</a:t>
+              <a:t>28/09/2024</a:t>
             </a:fld>
             <a:endParaRPr lang="pt-BR"/>
           </a:p>
@@ -1200,7 +1200,7 @@
           <a:p>
             <a:fld id="{52231B9D-E9F6-4612-9B82-E89961B389AC}" type="datetimeFigureOut">
               <a:rPr lang="pt-BR" smtClean="0"/>
-              <a:t>21/09/2024</a:t>
+              <a:t>28/09/2024</a:t>
             </a:fld>
             <a:endParaRPr lang="pt-BR"/>
           </a:p>
@@ -1446,7 +1446,7 @@
           <a:p>
             <a:fld id="{52231B9D-E9F6-4612-9B82-E89961B389AC}" type="datetimeFigureOut">
               <a:rPr lang="pt-BR" smtClean="0"/>
-              <a:t>21/09/2024</a:t>
+              <a:t>28/09/2024</a:t>
             </a:fld>
             <a:endParaRPr lang="pt-BR"/>
           </a:p>
@@ -1678,7 +1678,7 @@
           <a:p>
             <a:fld id="{52231B9D-E9F6-4612-9B82-E89961B389AC}" type="datetimeFigureOut">
               <a:rPr lang="pt-BR" smtClean="0"/>
-              <a:t>21/09/2024</a:t>
+              <a:t>28/09/2024</a:t>
             </a:fld>
             <a:endParaRPr lang="pt-BR"/>
           </a:p>
@@ -2045,7 +2045,7 @@
           <a:p>
             <a:fld id="{52231B9D-E9F6-4612-9B82-E89961B389AC}" type="datetimeFigureOut">
               <a:rPr lang="pt-BR" smtClean="0"/>
-              <a:t>21/09/2024</a:t>
+              <a:t>28/09/2024</a:t>
             </a:fld>
             <a:endParaRPr lang="pt-BR"/>
           </a:p>
@@ -2163,7 +2163,7 @@
           <a:p>
             <a:fld id="{52231B9D-E9F6-4612-9B82-E89961B389AC}" type="datetimeFigureOut">
               <a:rPr lang="pt-BR" smtClean="0"/>
-              <a:t>21/09/2024</a:t>
+              <a:t>28/09/2024</a:t>
             </a:fld>
             <a:endParaRPr lang="pt-BR"/>
           </a:p>
@@ -2258,7 +2258,7 @@
           <a:p>
             <a:fld id="{52231B9D-E9F6-4612-9B82-E89961B389AC}" type="datetimeFigureOut">
               <a:rPr lang="pt-BR" smtClean="0"/>
-              <a:t>21/09/2024</a:t>
+              <a:t>28/09/2024</a:t>
             </a:fld>
             <a:endParaRPr lang="pt-BR"/>
           </a:p>
@@ -2535,7 +2535,7 @@
           <a:p>
             <a:fld id="{52231B9D-E9F6-4612-9B82-E89961B389AC}" type="datetimeFigureOut">
               <a:rPr lang="pt-BR" smtClean="0"/>
-              <a:t>21/09/2024</a:t>
+              <a:t>28/09/2024</a:t>
             </a:fld>
             <a:endParaRPr lang="pt-BR"/>
           </a:p>
@@ -2788,7 +2788,7 @@
           <a:p>
             <a:fld id="{52231B9D-E9F6-4612-9B82-E89961B389AC}" type="datetimeFigureOut">
               <a:rPr lang="pt-BR" smtClean="0"/>
-              <a:t>21/09/2024</a:t>
+              <a:t>28/09/2024</a:t>
             </a:fld>
             <a:endParaRPr lang="pt-BR"/>
           </a:p>
@@ -3001,7 +3001,7 @@
           <a:p>
             <a:fld id="{52231B9D-E9F6-4612-9B82-E89961B389AC}" type="datetimeFigureOut">
               <a:rPr lang="pt-BR" smtClean="0"/>
-              <a:t>21/09/2024</a:t>
+              <a:t>28/09/2024</a:t>
             </a:fld>
             <a:endParaRPr lang="pt-BR"/>
           </a:p>
@@ -3665,7 +3665,7 @@
                   </a:schemeClr>
                 </a:solidFill>
               </a:rPr>
-              <a:t>22/09/2024</a:t>
+              <a:t>29/09/2024</a:t>
             </a:r>
             <a:endParaRPr lang="pt-BR" sz="1600" dirty="0">
               <a:solidFill>

</xml_diff>